<commit_message>
Add abstract-level InSDN published-results check: data file, /new/literature page (frontend, explicit request), deck slide
</commit_message>
<xml_diff>
--- a/research/insdn_controller/PRESENTATION.pptx
+++ b/research/insdn_controller/PRESENTATION.pptx
@@ -16,6 +16,7 @@
     <p:sldId id="264" r:id="rId15"/>
     <p:sldId id="265" r:id="rId16"/>
     <p:sldId id="266" r:id="rId17"/>
+    <p:sldId id="267" r:id="rId18"/>
   </p:sldIdLst>
   <p:sldSz cx="12191695" cy="6858000" type="screen4x3"/>
   <p:notesSz cx="6858000" cy="9144000"/>
@@ -3618,7 +3619,7 @@
               </a:defRPr>
             </a:pPr>
             <a:r>
-              <a:t>CONTEXT</a:t>
+              <a:t>HONEST SCOPE</a:t>
             </a:r>
           </a:p>
         </p:txBody>
@@ -3653,7 +3654,7 @@
               </a:defRPr>
             </a:pPr>
             <a:r>
-              <a:t>The earlier Proteus system: a prototype, not a claim</a:t>
+              <a:t>What is not new, what we did not do, what is next</a:t>
             </a:r>
           </a:p>
         </p:txBody>
@@ -3667,7 +3668,7 @@
         <p:spPr>
           <a:xfrm>
             <a:off x="731520" y="1737360"/>
-            <a:ext cx="10789920" cy="4206240"/>
+            <a:ext cx="3474720" cy="548640"/>
           </a:xfrm>
           <a:prstGeom prst="rect">
             <a:avLst/>
@@ -3681,17 +3682,52 @@
           <a:lstStyle/>
           <a:p>
             <a:pPr>
+              <a:defRPr sz="2600" b="1">
+                <a:solidFill>
+                  <a:srgbClr val="F5B041"/>
+                </a:solidFill>
+              </a:defRPr>
+            </a:pPr>
+            <a:r>
+              <a:t>Not new</a:t>
+            </a:r>
+          </a:p>
+        </p:txBody>
+      </p:sp>
+      <p:sp>
+        <p:nvSpPr>
+          <p:cNvPr id="5" name="TextBox 4"/>
+          <p:cNvSpPr txBox="1"/>
+          <p:nvPr/>
+        </p:nvSpPr>
+        <p:spPr>
+          <a:xfrm>
+            <a:off x="731520" y="2468880"/>
+            <a:ext cx="3474720" cy="4206240"/>
+          </a:xfrm>
+          <a:prstGeom prst="rect">
+            <a:avLst/>
+          </a:prstGeom>
+          <a:noFill/>
+        </p:spPr>
+        <p:txBody>
+          <a:bodyPr wrap="square">
+            <a:spAutoFit/>
+          </a:bodyPr>
+          <a:lstStyle/>
+          <a:p>
+            <a:pPr>
               <a:spcAft>
                 <a:spcPts val="1600"/>
               </a:spcAft>
-              <a:defRPr sz="2100">
+              <a:defRPr sz="1700">
                 <a:solidFill>
                   <a:srgbClr val="F1F5F9"/>
                 </a:solidFill>
               </a:defRPr>
             </a:pPr>
             <a:r>
-              <a:t>•  Built: WGAN-GP synthetic attacks, KS drift test, MMD fidelity gate, drift-triggered retraining, versioned releases.</a:t>
+              <a:t>•  Control-plane telemetry for SDN IDS (LAN-SDN-NIDS, SDNFLow)</a:t>
             </a:r>
           </a:p>
           <a:p>
@@ -3699,14 +3735,14 @@
               <a:spcAft>
                 <a:spcPts val="1600"/>
               </a:spcAft>
-              <a:defRPr sz="2100">
+              <a:defRPr sz="1700">
                 <a:solidFill>
                   <a:srgbClr val="F1F5F9"/>
                 </a:solidFill>
               </a:defRPr>
             </a:pPr>
             <a:r>
-              <a:t>•  Close prior work exists (NetGuard 2025: generative adaptation for drifting, imbalanced IDS data).</a:t>
+              <a:t>•  The detector itself</a:t>
             </a:r>
           </a:p>
           <a:p>
@@ -3714,29 +3750,255 @@
               <a:spcAft>
                 <a:spcPts val="1600"/>
               </a:spcAft>
-              <a:defRPr sz="2100">
+              <a:defRPr sz="1700">
                 <a:solidFill>
                   <a:srgbClr val="F1F5F9"/>
                 </a:solidFill>
               </a:defRPr>
             </a:pPr>
             <a:r>
-              <a:t>•  Our own studies found no benefit from the generative step; the demo's gain came from oracle labels.</a:t>
-            </a:r>
-          </a:p>
+              <a:t>•  Stock Ryu behaviour</a:t>
+            </a:r>
+          </a:p>
+        </p:txBody>
+      </p:sp>
+      <p:sp>
+        <p:nvSpPr>
+          <p:cNvPr id="6" name="TextBox 5"/>
+          <p:cNvSpPr txBox="1"/>
+          <p:nvPr/>
+        </p:nvSpPr>
+        <p:spPr>
+          <a:xfrm>
+            <a:off x="4480559" y="1737360"/>
+            <a:ext cx="3474720" cy="548640"/>
+          </a:xfrm>
+          <a:prstGeom prst="rect">
+            <a:avLst/>
+          </a:prstGeom>
+          <a:noFill/>
+        </p:spPr>
+        <p:txBody>
+          <a:bodyPr wrap="square">
+            <a:spAutoFit/>
+          </a:bodyPr>
+          <a:lstStyle/>
+          <a:p>
+            <a:pPr>
+              <a:defRPr sz="2600" b="1">
+                <a:solidFill>
+                  <a:srgbClr val="F87171"/>
+                </a:solidFill>
+              </a:defRPr>
+            </a:pPr>
+            <a:r>
+              <a:t>Not done</a:t>
+            </a:r>
+          </a:p>
+        </p:txBody>
+      </p:sp>
+      <p:sp>
+        <p:nvSpPr>
+          <p:cNvPr id="7" name="TextBox 6"/>
+          <p:cNvSpPr txBox="1"/>
+          <p:nvPr/>
+        </p:nvSpPr>
+        <p:spPr>
+          <a:xfrm>
+            <a:off x="4480559" y="2468880"/>
+            <a:ext cx="3474720" cy="4206240"/>
+          </a:xfrm>
+          <a:prstGeom prst="rect">
+            <a:avLst/>
+          </a:prstGeom>
+          <a:noFill/>
+        </p:spPr>
+        <p:txBody>
+          <a:bodyPr wrap="square">
+            <a:spAutoFit/>
+          </a:bodyPr>
+          <a:lstStyle/>
           <a:p>
             <a:pPr>
               <a:spcAft>
                 <a:spcPts val="1600"/>
               </a:spcAft>
-              <a:defRPr sz="2100">
+              <a:defRPr sz="1700">
                 <a:solidFill>
                   <a:srgbClr val="F1F5F9"/>
                 </a:solidFill>
               </a:defRPr>
             </a:pPr>
             <a:r>
-              <a:t>•  So the research contribution is the InSDN study; Proteus is kept as context (/old console).</a:t>
+              <a:t>•  Benign + attack in one session</a:t>
+            </a:r>
+          </a:p>
+          <a:p>
+            <a:pPr>
+              <a:spcAft>
+                <a:spcPts val="1600"/>
+              </a:spcAft>
+              <a:defRPr sz="1700">
+                <a:solidFill>
+                  <a:srgbClr val="F1F5F9"/>
+                </a:solidFill>
+              </a:defRPr>
+            </a:pPr>
+            <a:r>
+              <a:t>•  OpenDaylight or another dataset</a:t>
+            </a:r>
+          </a:p>
+          <a:p>
+            <a:pPr>
+              <a:spcAft>
+                <a:spcPts val="1600"/>
+              </a:spcAft>
+              <a:defRPr sz="1700">
+                <a:solidFill>
+                  <a:srgbClr val="F1F5F9"/>
+                </a:solidFill>
+              </a:defRPr>
+            </a:pPr>
+            <a:r>
+              <a:t>•  A re-implemented published detector</a:t>
+            </a:r>
+          </a:p>
+        </p:txBody>
+      </p:sp>
+      <p:sp>
+        <p:nvSpPr>
+          <p:cNvPr id="8" name="TextBox 7"/>
+          <p:cNvSpPr txBox="1"/>
+          <p:nvPr/>
+        </p:nvSpPr>
+        <p:spPr>
+          <a:xfrm>
+            <a:off x="8229600" y="1737360"/>
+            <a:ext cx="3474720" cy="548640"/>
+          </a:xfrm>
+          <a:prstGeom prst="rect">
+            <a:avLst/>
+          </a:prstGeom>
+          <a:noFill/>
+        </p:spPr>
+        <p:txBody>
+          <a:bodyPr wrap="square">
+            <a:spAutoFit/>
+          </a:bodyPr>
+          <a:lstStyle/>
+          <a:p>
+            <a:pPr>
+              <a:defRPr sz="2600" b="1">
+                <a:solidFill>
+                  <a:srgbClr val="2DD4BF"/>
+                </a:solidFill>
+              </a:defRPr>
+            </a:pPr>
+            <a:r>
+              <a:t>Next</a:t>
+            </a:r>
+          </a:p>
+        </p:txBody>
+      </p:sp>
+      <p:sp>
+        <p:nvSpPr>
+          <p:cNvPr id="9" name="TextBox 8"/>
+          <p:cNvSpPr txBox="1"/>
+          <p:nvPr/>
+        </p:nvSpPr>
+        <p:spPr>
+          <a:xfrm>
+            <a:off x="8229600" y="2468880"/>
+            <a:ext cx="3474720" cy="4206240"/>
+          </a:xfrm>
+          <a:prstGeom prst="rect">
+            <a:avLst/>
+          </a:prstGeom>
+          <a:noFill/>
+        </p:spPr>
+        <p:txBody>
+          <a:bodyPr wrap="square">
+            <a:spAutoFit/>
+          </a:bodyPr>
+          <a:lstStyle/>
+          <a:p>
+            <a:pPr>
+              <a:spcAft>
+                <a:spcPts val="1600"/>
+              </a:spcAft>
+              <a:defRPr sz="1700">
+                <a:solidFill>
+                  <a:srgbClr val="F1F5F9"/>
+                </a:solidFill>
+              </a:defRPr>
+            </a:pPr>
+            <a:r>
+              <a:t>•  Interleave benign and attack traffic</a:t>
+            </a:r>
+          </a:p>
+          <a:p>
+            <a:pPr>
+              <a:spcAft>
+                <a:spcPts val="1600"/>
+              </a:spcAft>
+              <a:defRPr sz="1700">
+                <a:solidFill>
+                  <a:srgbClr val="F1F5F9"/>
+                </a:solidFill>
+              </a:defRPr>
+            </a:pPr>
+            <a:r>
+              <a:t>•  Gap on a second controller family</a:t>
+            </a:r>
+          </a:p>
+          <a:p>
+            <a:pPr>
+              <a:spcAft>
+                <a:spcPts val="1600"/>
+              </a:spcAft>
+              <a:defRPr sz="1700">
+                <a:solidFill>
+                  <a:srgbClr val="F1F5F9"/>
+                </a:solidFill>
+              </a:defRPr>
+            </a:pPr>
+            <a:r>
+              <a:t>•  In-fold oversampling for rare classes</a:t>
+            </a:r>
+          </a:p>
+        </p:txBody>
+      </p:sp>
+      <p:sp>
+        <p:nvSpPr>
+          <p:cNvPr id="10" name="TextBox 9"/>
+          <p:cNvSpPr txBox="1"/>
+          <p:nvPr/>
+        </p:nvSpPr>
+        <p:spPr>
+          <a:xfrm>
+            <a:off x="731520" y="5943600"/>
+            <a:ext cx="10972800" cy="457200"/>
+          </a:xfrm>
+          <a:prstGeom prst="rect">
+            <a:avLst/>
+          </a:prstGeom>
+          <a:noFill/>
+        </p:spPr>
+        <p:txBody>
+          <a:bodyPr wrap="square">
+            <a:spAutoFit/>
+          </a:bodyPr>
+          <a:lstStyle/>
+          <a:p>
+            <a:pPr>
+              <a:defRPr sz="1400" b="0">
+                <a:solidFill>
+                  <a:srgbClr val="9AA8BC"/>
+                </a:solidFill>
+              </a:defRPr>
+            </a:pPr>
+            <a:r>
+              <a:t>Venue: workshop / conference as is; lower-quartile journal after revision.</a:t>
             </a:r>
           </a:p>
         </p:txBody>
@@ -3797,6 +4059,185 @@
               </a:defRPr>
             </a:pPr>
             <a:r>
+              <a:t>CONTEXT</a:t>
+            </a:r>
+          </a:p>
+        </p:txBody>
+      </p:sp>
+      <p:sp>
+        <p:nvSpPr>
+          <p:cNvPr id="3" name="TextBox 2"/>
+          <p:cNvSpPr txBox="1"/>
+          <p:nvPr/>
+        </p:nvSpPr>
+        <p:spPr>
+          <a:xfrm>
+            <a:off x="548640" y="640080"/>
+            <a:ext cx="11155680" cy="822960"/>
+          </a:xfrm>
+          <a:prstGeom prst="rect">
+            <a:avLst/>
+          </a:prstGeom>
+          <a:noFill/>
+        </p:spPr>
+        <p:txBody>
+          <a:bodyPr wrap="square">
+            <a:spAutoFit/>
+          </a:bodyPr>
+          <a:lstStyle/>
+          <a:p>
+            <a:pPr>
+              <a:defRPr sz="2800" b="1">
+                <a:solidFill>
+                  <a:srgbClr val="F1F5F9"/>
+                </a:solidFill>
+              </a:defRPr>
+            </a:pPr>
+            <a:r>
+              <a:t>The earlier Proteus system: a prototype, not a claim</a:t>
+            </a:r>
+          </a:p>
+        </p:txBody>
+      </p:sp>
+      <p:sp>
+        <p:nvSpPr>
+          <p:cNvPr id="4" name="TextBox 3"/>
+          <p:cNvSpPr txBox="1"/>
+          <p:nvPr/>
+        </p:nvSpPr>
+        <p:spPr>
+          <a:xfrm>
+            <a:off x="731520" y="1737360"/>
+            <a:ext cx="10789920" cy="4206240"/>
+          </a:xfrm>
+          <a:prstGeom prst="rect">
+            <a:avLst/>
+          </a:prstGeom>
+          <a:noFill/>
+        </p:spPr>
+        <p:txBody>
+          <a:bodyPr wrap="square">
+            <a:spAutoFit/>
+          </a:bodyPr>
+          <a:lstStyle/>
+          <a:p>
+            <a:pPr>
+              <a:spcAft>
+                <a:spcPts val="1600"/>
+              </a:spcAft>
+              <a:defRPr sz="2100">
+                <a:solidFill>
+                  <a:srgbClr val="F1F5F9"/>
+                </a:solidFill>
+              </a:defRPr>
+            </a:pPr>
+            <a:r>
+              <a:t>•  Built: WGAN-GP synthetic attacks, KS drift test, MMD fidelity gate, drift-triggered retraining, versioned releases.</a:t>
+            </a:r>
+          </a:p>
+          <a:p>
+            <a:pPr>
+              <a:spcAft>
+                <a:spcPts val="1600"/>
+              </a:spcAft>
+              <a:defRPr sz="2100">
+                <a:solidFill>
+                  <a:srgbClr val="F1F5F9"/>
+                </a:solidFill>
+              </a:defRPr>
+            </a:pPr>
+            <a:r>
+              <a:t>•  Close prior work exists (NetGuard 2025: generative adaptation for drifting, imbalanced IDS data).</a:t>
+            </a:r>
+          </a:p>
+          <a:p>
+            <a:pPr>
+              <a:spcAft>
+                <a:spcPts val="1600"/>
+              </a:spcAft>
+              <a:defRPr sz="2100">
+                <a:solidFill>
+                  <a:srgbClr val="F1F5F9"/>
+                </a:solidFill>
+              </a:defRPr>
+            </a:pPr>
+            <a:r>
+              <a:t>•  Our own studies found no benefit from the generative step; the demo's gain came from oracle labels.</a:t>
+            </a:r>
+          </a:p>
+          <a:p>
+            <a:pPr>
+              <a:spcAft>
+                <a:spcPts val="1600"/>
+              </a:spcAft>
+              <a:defRPr sz="2100">
+                <a:solidFill>
+                  <a:srgbClr val="F1F5F9"/>
+                </a:solidFill>
+              </a:defRPr>
+            </a:pPr>
+            <a:r>
+              <a:t>•  So the research contribution is the InSDN study; Proteus is kept as context (/old console).</a:t>
+            </a:r>
+          </a:p>
+        </p:txBody>
+      </p:sp>
+    </p:spTree>
+  </p:cSld>
+  <p:clrMapOvr>
+    <a:masterClrMapping/>
+  </p:clrMapOvr>
+</p:sld>
+</file>
+
+<file path=ppt/slides/slide12.xml><?xml version="1.0" encoding="utf-8"?>
+<p:sld xmlns:a="http://schemas.openxmlformats.org/drawingml/2006/main" xmlns:p="http://schemas.openxmlformats.org/presentationml/2006/main" xmlns:r="http://schemas.openxmlformats.org/officeDocument/2006/relationships">
+  <p:cSld>
+    <p:bg>
+      <p:bgPr>
+        <a:solidFill>
+          <a:srgbClr val="0B1220"/>
+        </a:solidFill>
+        <a:effectLst/>
+      </p:bgPr>
+    </p:bg>
+    <p:spTree>
+      <p:nvGrpSpPr>
+        <p:cNvPr id="1" name=""/>
+        <p:cNvGrpSpPr/>
+        <p:nvPr/>
+      </p:nvGrpSpPr>
+      <p:grpSpPr/>
+      <p:sp>
+        <p:nvSpPr>
+          <p:cNvPr id="2" name="TextBox 1"/>
+          <p:cNvSpPr txBox="1"/>
+          <p:nvPr/>
+        </p:nvSpPr>
+        <p:spPr>
+          <a:xfrm>
+            <a:off x="548640" y="320040"/>
+            <a:ext cx="10972800" cy="365760"/>
+          </a:xfrm>
+          <a:prstGeom prst="rect">
+            <a:avLst/>
+          </a:prstGeom>
+          <a:noFill/>
+        </p:spPr>
+        <p:txBody>
+          <a:bodyPr wrap="square">
+            <a:spAutoFit/>
+          </a:bodyPr>
+          <a:lstStyle/>
+          <a:p>
+            <a:pPr>
+              <a:defRPr sz="1200" b="1">
+                <a:solidFill>
+                  <a:srgbClr val="2DD4BF"/>
+                </a:solidFill>
+              </a:defRPr>
+            </a:pPr>
+            <a:r>
               <a:t>CLOSE</a:t>
             </a:r>
           </a:p>
@@ -5097,7 +5538,7 @@
               </a:defRPr>
             </a:pPr>
             <a:r>
-              <a:t>METHOD</a:t>
+              <a:t>ABSTRACT-LEVEL CHECK, NOT A RE-RUN</a:t>
             </a:r>
           </a:p>
         </p:txBody>
@@ -5132,7 +5573,7 @@
               </a:defRPr>
             </a:pPr>
             <a:r>
-              <a:t>Novelty 4 and 5 · A caught pitfall, a rerunnable package</a:t>
+              <a:t>How published InSDN results compare</a:t>
             </a:r>
           </a:p>
         </p:txBody>
@@ -5145,7 +5586,7 @@
         </p:nvSpPr>
         <p:spPr>
           <a:xfrm>
-            <a:off x="731520" y="1737360"/>
+            <a:off x="731520" y="1600200"/>
             <a:ext cx="10789920" cy="4206240"/>
           </a:xfrm>
           <a:prstGeom prst="rect">
@@ -5163,14 +5604,14 @@
               <a:spcAft>
                 <a:spcPts val="1600"/>
               </a:spcAft>
-              <a:defRPr sz="2200">
+              <a:defRPr sz="1500">
                 <a:solidFill>
                   <a:srgbClr val="F1F5F9"/>
                 </a:solidFill>
               </a:defRPr>
             </a:pPr>
             <a:r>
-              <a:t>•  Our first test app let ping/ARP rules hide TCP: the effect looked like 4x instead of about 847x. We report both.</a:t>
+              <a:t>•  Intrusion detection in software defined network using deep learning approaches:  Transformer 99.02% (48 features); CNN-LSTM 99.01%, 99.19% with 6 features</a:t>
             </a:r>
           </a:p>
           <a:p>
@@ -5178,14 +5619,14 @@
               <a:spcAft>
                 <a:spcPts val="1600"/>
               </a:spcAft>
-              <a:defRPr sz="2200">
+              <a:defRPr sz="1500">
                 <a:solidFill>
                   <a:srgbClr val="F1F5F9"/>
                 </a:solidFill>
               </a:defRPr>
             </a:pPr>
             <a:r>
-              <a:t>•  Overlapping coarse rules can understate controller load by two orders of magnitude.</a:t>
+              <a:t>•  A Hybrid CNN-LSTM Based Approach for Anomaly Detection Systems in SDNs:  96.32% accuracy</a:t>
             </a:r>
           </a:p>
           <a:p>
@@ -5193,14 +5634,97 @@
               <a:spcAft>
                 <a:spcPts val="1600"/>
               </a:spcAft>
-              <a:defRPr sz="2200">
+              <a:defRPr sz="1500">
                 <a:solidFill>
                   <a:srgbClr val="F1F5F9"/>
                 </a:solidFill>
               </a:defRPr>
             </a:pPr>
             <a:r>
-              <a:t>•  One command rebuilds every result from hashed captures and checks the paper's numbers.</a:t>
+              <a:t>•  Early Detection of Intrusion in SDN:  Random forest 98.84% vs LSTM 85.31%</a:t>
+            </a:r>
+          </a:p>
+          <a:p>
+            <a:pPr>
+              <a:spcAft>
+                <a:spcPts val="1600"/>
+              </a:spcAft>
+              <a:defRPr sz="1500">
+                <a:solidFill>
+                  <a:srgbClr val="F1F5F9"/>
+                </a:solidFill>
+              </a:defRPr>
+            </a:pPr>
+            <a:r>
+              <a:t>•  Securing IoT and SDN systems using deep-learning based automatic intrusion detection:  99.73% accuracy, 98.6% detection rate</a:t>
+            </a:r>
+          </a:p>
+          <a:p>
+            <a:pPr>
+              <a:spcAft>
+                <a:spcPts val="1600"/>
+              </a:spcAft>
+              <a:defRPr sz="1500">
+                <a:solidFill>
+                  <a:srgbClr val="F1F5F9"/>
+                </a:solidFill>
+              </a:defRPr>
+            </a:pPr>
+            <a:r>
+              <a:t>•  Categorical Robustness Assessment for ML-based NIDS:  Random forest 99.98% accuracy; ARP spoofing fails (6 samples)</a:t>
+            </a:r>
+          </a:p>
+        </p:txBody>
+      </p:sp>
+      <p:sp>
+        <p:nvSpPr>
+          <p:cNvPr id="5" name="TextBox 4"/>
+          <p:cNvSpPr txBox="1"/>
+          <p:nvPr/>
+        </p:nvSpPr>
+        <p:spPr>
+          <a:xfrm>
+            <a:off x="731520" y="4572000"/>
+            <a:ext cx="10789920" cy="4206240"/>
+          </a:xfrm>
+          <a:prstGeom prst="rect">
+            <a:avLst/>
+          </a:prstGeom>
+          <a:noFill/>
+        </p:spPr>
+        <p:txBody>
+          <a:bodyPr wrap="square">
+            <a:spAutoFit/>
+          </a:bodyPr>
+          <a:lstStyle/>
+          <a:p>
+            <a:pPr>
+              <a:spcAft>
+                <a:spcPts val="1600"/>
+              </a:spcAft>
+              <a:defRPr sz="1700">
+                <a:solidFill>
+                  <a:srgbClr val="F1F5F9"/>
+                </a:solidFill>
+              </a:defRPr>
+            </a:pPr>
+            <a:r>
+              <a:t>•  Our host-side run on the same CSV (random row split): 0.9998. Our controller view: 0.946.</a:t>
+            </a:r>
+          </a:p>
+          <a:p>
+            <a:pPr>
+              <a:spcAft>
+                <a:spcPts val="1600"/>
+              </a:spcAft>
+              <a:defRPr sz="1700">
+                <a:solidFill>
+                  <a:srgbClr val="F1F5F9"/>
+                </a:solidFill>
+              </a:defRPr>
+            </a:pPr>
+            <a:r>
+              <a:t>•  We do not claim these papers are wrong: split protocols were not visible. We claim the benchmark cannot support a controller-side claim.</a:t>
             </a:r>
           </a:p>
         </p:txBody>
@@ -5261,7 +5785,7 @@
               </a:defRPr>
             </a:pPr>
             <a:r>
-              <a:t>PIPELINE</a:t>
+              <a:t>METHOD</a:t>
             </a:r>
           </a:p>
         </p:txBody>
@@ -5296,7 +5820,7 @@
               </a:defRPr>
             </a:pPr>
             <a:r>
-              <a:t>Study architecture: what goes in, what comes out</a:t>
+              <a:t>Novelty 4 and 5 · A caught pitfall, a rerunnable package</a:t>
             </a:r>
           </a:p>
         </p:txBody>
@@ -5309,8 +5833,8 @@
         </p:nvSpPr>
         <p:spPr>
           <a:xfrm>
-            <a:off x="548640" y="1417320"/>
-            <a:ext cx="5486400" cy="320040"/>
+            <a:off x="731520" y="1737360"/>
+            <a:ext cx="10789920" cy="4206240"/>
           </a:xfrm>
           <a:prstGeom prst="rect">
             <a:avLst/>
@@ -5324,1063 +5848,47 @@
           <a:lstStyle/>
           <a:p>
             <a:pPr>
-              <a:defRPr sz="1300" b="1">
-                <a:solidFill>
-                  <a:srgbClr val="2DD4BF"/>
-                </a:solidFill>
-              </a:defRPr>
-            </a:pPr>
-            <a:r>
-              <a:t>A · InSDN captures (recorded, offline)</a:t>
-            </a:r>
-          </a:p>
-        </p:txBody>
-      </p:sp>
-      <p:sp>
-        <p:nvSpPr>
-          <p:cNvPr id="5" name="Rounded Rectangle 4"/>
-          <p:cNvSpPr/>
-          <p:nvPr/>
-        </p:nvSpPr>
-        <p:spPr>
-          <a:xfrm>
-            <a:off x="548640" y="1737360"/>
-            <a:ext cx="1627632" cy="1371600"/>
-          </a:xfrm>
-          <a:prstGeom prst="roundRect">
-            <a:avLst/>
-          </a:prstGeom>
-          <a:solidFill>
-            <a:srgbClr val="141E33"/>
-          </a:solidFill>
-          <a:ln w="25400">
-            <a:solidFill>
-              <a:srgbClr val="2DD4BF"/>
-            </a:solidFill>
-          </a:ln>
-        </p:spPr>
-        <p:style>
-          <a:lnRef idx="1">
-            <a:schemeClr val="accent1"/>
-          </a:lnRef>
-          <a:fillRef idx="3">
-            <a:schemeClr val="accent1"/>
-          </a:fillRef>
-          <a:effectRef idx="2">
-            <a:schemeClr val="accent1"/>
-          </a:effectRef>
-          <a:fontRef idx="minor">
-            <a:schemeClr val="lt1"/>
-          </a:fontRef>
-        </p:style>
-        <p:txBody>
-          <a:bodyPr rtlCol="0" anchor="ctr" wrap="square" lIns="73152" rIns="73152"/>
-          <a:lstStyle/>
-          <a:p>
-            <a:pPr algn="ctr">
-              <a:defRPr sz="1500" b="1">
-                <a:solidFill>
-                  <a:srgbClr val="2DD4BF"/>
-                </a:solidFill>
-              </a:defRPr>
-            </a:pPr>
-            <a:r>
-              <a:t>44 pcaps</a:t>
-            </a:r>
-          </a:p>
-          <a:p>
-            <a:pPr algn="ctr">
-              <a:defRPr sz="1100">
+              <a:spcAft>
+                <a:spcPts val="1600"/>
+              </a:spcAft>
+              <a:defRPr sz="2200">
                 <a:solidFill>
                   <a:srgbClr val="F1F5F9"/>
                 </a:solidFill>
               </a:defRPr>
             </a:pPr>
             <a:r>
-              <a:t>in: ONOS TCP 6653</a:t>
-            </a:r>
-          </a:p>
-        </p:txBody>
-      </p:sp>
-      <p:cxnSp>
-        <p:nvCxnSpPr>
-          <p:cNvPr id="6" name="Connector 5"/>
-          <p:cNvCxnSpPr/>
-          <p:nvPr/>
-        </p:nvCxnSpPr>
-        <p:spPr>
-          <a:xfrm>
-            <a:off x="2203703" y="2423160"/>
-            <a:ext cx="201169" cy="0"/>
-          </a:xfrm>
-          <a:prstGeom prst="line">
-            <a:avLst/>
-          </a:prstGeom>
-          <a:ln w="28575">
-            <a:solidFill>
-              <a:srgbClr val="2DD4BF"/>
-            </a:solidFill>
-            <a:tailEnd type="triangle" w="lg" len="lg"/>
-          </a:ln>
-        </p:spPr>
-        <p:style>
-          <a:lnRef idx="2">
-            <a:schemeClr val="accent1"/>
-          </a:lnRef>
-          <a:fillRef idx="0">
-            <a:schemeClr val="accent1"/>
-          </a:fillRef>
-          <a:effectRef idx="1">
-            <a:schemeClr val="accent1"/>
-          </a:effectRef>
-          <a:fontRef idx="minor">
-            <a:schemeClr val="tx1"/>
-          </a:fontRef>
-        </p:style>
-      </p:cxnSp>
-      <p:sp>
-        <p:nvSpPr>
-          <p:cNvPr id="7" name="Rounded Rectangle 6"/>
-          <p:cNvSpPr/>
-          <p:nvPr/>
-        </p:nvSpPr>
-        <p:spPr>
-          <a:xfrm>
-            <a:off x="2432304" y="1737360"/>
-            <a:ext cx="1627632" cy="1371600"/>
-          </a:xfrm>
-          <a:prstGeom prst="roundRect">
-            <a:avLst/>
-          </a:prstGeom>
-          <a:solidFill>
-            <a:srgbClr val="141E33"/>
-          </a:solidFill>
-          <a:ln w="25400">
-            <a:solidFill>
-              <a:srgbClr val="2DD4BF"/>
-            </a:solidFill>
-          </a:ln>
-        </p:spPr>
-        <p:style>
-          <a:lnRef idx="1">
-            <a:schemeClr val="accent1"/>
-          </a:lnRef>
-          <a:fillRef idx="3">
-            <a:schemeClr val="accent1"/>
-          </a:fillRef>
-          <a:effectRef idx="2">
-            <a:schemeClr val="accent1"/>
-          </a:effectRef>
-          <a:fontRef idx="minor">
-            <a:schemeClr val="lt1"/>
-          </a:fontRef>
-        </p:style>
-        <p:txBody>
-          <a:bodyPr rtlCol="0" anchor="ctr" wrap="square" lIns="73152" rIns="73152"/>
-          <a:lstStyle/>
-          <a:p>
-            <a:pPr algn="ctr">
-              <a:defRPr sz="1500" b="1">
-                <a:solidFill>
-                  <a:srgbClr val="2DD4BF"/>
-                </a:solidFill>
-              </a:defRPr>
-            </a:pPr>
-            <a:r>
-              <a:t>Parser</a:t>
-            </a:r>
-          </a:p>
-          <a:p>
-            <a:pPr algn="ctr">
-              <a:defRPr sz="1100">
+              <a:t>•  Our first test app let ping/ARP rules hide TCP: the effect looked like 4x instead of about 847x. We report both.</a:t>
+            </a:r>
+          </a:p>
+          <a:p>
+            <a:pPr>
+              <a:spcAft>
+                <a:spcPts val="1600"/>
+              </a:spcAft>
+              <a:defRPr sz="2200">
                 <a:solidFill>
                   <a:srgbClr val="F1F5F9"/>
                 </a:solidFill>
               </a:defRPr>
             </a:pPr>
             <a:r>
-              <a:t>out: PacketIn, FlowMod, stats</a:t>
-            </a:r>
-          </a:p>
-        </p:txBody>
-      </p:sp>
-      <p:cxnSp>
-        <p:nvCxnSpPr>
-          <p:cNvPr id="8" name="Connector 7"/>
-          <p:cNvCxnSpPr/>
-          <p:nvPr/>
-        </p:nvCxnSpPr>
-        <p:spPr>
-          <a:xfrm>
-            <a:off x="4087368" y="2423160"/>
-            <a:ext cx="201168" cy="0"/>
-          </a:xfrm>
-          <a:prstGeom prst="line">
-            <a:avLst/>
-          </a:prstGeom>
-          <a:ln w="28575">
-            <a:solidFill>
-              <a:srgbClr val="2DD4BF"/>
-            </a:solidFill>
-            <a:tailEnd type="triangle" w="lg" len="lg"/>
-          </a:ln>
-        </p:spPr>
-        <p:style>
-          <a:lnRef idx="2">
-            <a:schemeClr val="accent1"/>
-          </a:lnRef>
-          <a:fillRef idx="0">
-            <a:schemeClr val="accent1"/>
-          </a:fillRef>
-          <a:effectRef idx="1">
-            <a:schemeClr val="accent1"/>
-          </a:effectRef>
-          <a:fontRef idx="minor">
-            <a:schemeClr val="tx1"/>
-          </a:fontRef>
-        </p:style>
-      </p:cxnSp>
-      <p:sp>
-        <p:nvSpPr>
-          <p:cNvPr id="9" name="Rounded Rectangle 8"/>
-          <p:cNvSpPr/>
-          <p:nvPr/>
-        </p:nvSpPr>
-        <p:spPr>
-          <a:xfrm>
-            <a:off x="4315968" y="1737360"/>
-            <a:ext cx="1627632" cy="1371600"/>
-          </a:xfrm>
-          <a:prstGeom prst="roundRect">
-            <a:avLst/>
-          </a:prstGeom>
-          <a:solidFill>
-            <a:srgbClr val="141E33"/>
-          </a:solidFill>
-          <a:ln w="25400">
-            <a:solidFill>
-              <a:srgbClr val="2DD4BF"/>
-            </a:solidFill>
-          </a:ln>
-        </p:spPr>
-        <p:style>
-          <a:lnRef idx="1">
-            <a:schemeClr val="accent1"/>
-          </a:lnRef>
-          <a:fillRef idx="3">
-            <a:schemeClr val="accent1"/>
-          </a:fillRef>
-          <a:effectRef idx="2">
-            <a:schemeClr val="accent1"/>
-          </a:effectRef>
-          <a:fontRef idx="minor">
-            <a:schemeClr val="lt1"/>
-          </a:fontRef>
-        </p:style>
-        <p:txBody>
-          <a:bodyPr rtlCol="0" anchor="ctr" wrap="square" lIns="73152" rIns="73152"/>
-          <a:lstStyle/>
-          <a:p>
-            <a:pPr algn="ctr">
-              <a:defRPr sz="1500" b="1">
-                <a:solidFill>
-                  <a:srgbClr val="2DD4BF"/>
-                </a:solidFill>
-              </a:defRPr>
-            </a:pPr>
-            <a:r>
-              <a:t>Labels</a:t>
-            </a:r>
-          </a:p>
-          <a:p>
-            <a:pPr algn="ctr">
-              <a:defRPr sz="1100">
+              <a:t>•  Overlapping coarse rules can understate controller load by two orders of magnitude.</a:t>
+            </a:r>
+          </a:p>
+          <a:p>
+            <a:pPr>
+              <a:spcAft>
+                <a:spcPts val="1600"/>
+              </a:spcAft>
+              <a:defRPr sz="2200">
                 <a:solidFill>
                   <a:srgbClr val="F1F5F9"/>
                 </a:solidFill>
               </a:defRPr>
             </a:pPr>
             <a:r>
-              <a:t>CSV flow IDs → tag per PacketIn</a:t>
-            </a:r>
-          </a:p>
-        </p:txBody>
-      </p:sp>
-      <p:cxnSp>
-        <p:nvCxnSpPr>
-          <p:cNvPr id="10" name="Connector 9"/>
-          <p:cNvCxnSpPr/>
-          <p:nvPr/>
-        </p:nvCxnSpPr>
-        <p:spPr>
-          <a:xfrm>
-            <a:off x="5971032" y="2423160"/>
-            <a:ext cx="201168" cy="0"/>
-          </a:xfrm>
-          <a:prstGeom prst="line">
-            <a:avLst/>
-          </a:prstGeom>
-          <a:ln w="28575">
-            <a:solidFill>
-              <a:srgbClr val="2DD4BF"/>
-            </a:solidFill>
-            <a:tailEnd type="triangle" w="lg" len="lg"/>
-          </a:ln>
-        </p:spPr>
-        <p:style>
-          <a:lnRef idx="2">
-            <a:schemeClr val="accent1"/>
-          </a:lnRef>
-          <a:fillRef idx="0">
-            <a:schemeClr val="accent1"/>
-          </a:fillRef>
-          <a:effectRef idx="1">
-            <a:schemeClr val="accent1"/>
-          </a:effectRef>
-          <a:fontRef idx="minor">
-            <a:schemeClr val="tx1"/>
-          </a:fontRef>
-        </p:style>
-      </p:cxnSp>
-      <p:sp>
-        <p:nvSpPr>
-          <p:cNvPr id="11" name="Rounded Rectangle 10"/>
-          <p:cNvSpPr/>
-          <p:nvPr/>
-        </p:nvSpPr>
-        <p:spPr>
-          <a:xfrm>
-            <a:off x="6199631" y="1737360"/>
-            <a:ext cx="1627632" cy="1371600"/>
-          </a:xfrm>
-          <a:prstGeom prst="roundRect">
-            <a:avLst/>
-          </a:prstGeom>
-          <a:solidFill>
-            <a:srgbClr val="141E33"/>
-          </a:solidFill>
-          <a:ln w="25400">
-            <a:solidFill>
-              <a:srgbClr val="2DD4BF"/>
-            </a:solidFill>
-          </a:ln>
-        </p:spPr>
-        <p:style>
-          <a:lnRef idx="1">
-            <a:schemeClr val="accent1"/>
-          </a:lnRef>
-          <a:fillRef idx="3">
-            <a:schemeClr val="accent1"/>
-          </a:fillRef>
-          <a:effectRef idx="2">
-            <a:schemeClr val="accent1"/>
-          </a:effectRef>
-          <a:fontRef idx="minor">
-            <a:schemeClr val="lt1"/>
-          </a:fontRef>
-        </p:style>
-        <p:txBody>
-          <a:bodyPr rtlCol="0" anchor="ctr" wrap="square" lIns="73152" rIns="73152"/>
-          <a:lstStyle/>
-          <a:p>
-            <a:pPr algn="ctr">
-              <a:defRPr sz="1500" b="1">
-                <a:solidFill>
-                  <a:srgbClr val="2DD4BF"/>
-                </a:solidFill>
-              </a:defRPr>
-            </a:pPr>
-            <a:r>
-              <a:t>Windows</a:t>
-            </a:r>
-          </a:p>
-          <a:p>
-            <a:pPr algn="ctr">
-              <a:defRPr sz="1100">
-                <a:solidFill>
-                  <a:srgbClr val="F1F5F9"/>
-                </a:solidFill>
-              </a:defRPr>
-            </a:pPr>
-            <a:r>
-              <a:t>22 features per 1–5 s</a:t>
-            </a:r>
-          </a:p>
-        </p:txBody>
-      </p:sp>
-      <p:cxnSp>
-        <p:nvCxnSpPr>
-          <p:cNvPr id="12" name="Connector 11"/>
-          <p:cNvCxnSpPr/>
-          <p:nvPr/>
-        </p:nvCxnSpPr>
-        <p:spPr>
-          <a:xfrm>
-            <a:off x="7854695" y="2423160"/>
-            <a:ext cx="201168" cy="0"/>
-          </a:xfrm>
-          <a:prstGeom prst="line">
-            <a:avLst/>
-          </a:prstGeom>
-          <a:ln w="28575">
-            <a:solidFill>
-              <a:srgbClr val="2DD4BF"/>
-            </a:solidFill>
-            <a:tailEnd type="triangle" w="lg" len="lg"/>
-          </a:ln>
-        </p:spPr>
-        <p:style>
-          <a:lnRef idx="2">
-            <a:schemeClr val="accent1"/>
-          </a:lnRef>
-          <a:fillRef idx="0">
-            <a:schemeClr val="accent1"/>
-          </a:fillRef>
-          <a:effectRef idx="1">
-            <a:schemeClr val="accent1"/>
-          </a:effectRef>
-          <a:fontRef idx="minor">
-            <a:schemeClr val="tx1"/>
-          </a:fontRef>
-        </p:style>
-      </p:cxnSp>
-      <p:sp>
-        <p:nvSpPr>
-          <p:cNvPr id="13" name="Rounded Rectangle 12"/>
-          <p:cNvSpPr/>
-          <p:nvPr/>
-        </p:nvSpPr>
-        <p:spPr>
-          <a:xfrm>
-            <a:off x="8083296" y="1737360"/>
-            <a:ext cx="1627632" cy="1371600"/>
-          </a:xfrm>
-          <a:prstGeom prst="roundRect">
-            <a:avLst/>
-          </a:prstGeom>
-          <a:solidFill>
-            <a:srgbClr val="141E33"/>
-          </a:solidFill>
-          <a:ln w="25400">
-            <a:solidFill>
-              <a:srgbClr val="2DD4BF"/>
-            </a:solidFill>
-          </a:ln>
-        </p:spPr>
-        <p:style>
-          <a:lnRef idx="1">
-            <a:schemeClr val="accent1"/>
-          </a:lnRef>
-          <a:fillRef idx="3">
-            <a:schemeClr val="accent1"/>
-          </a:fillRef>
-          <a:effectRef idx="2">
-            <a:schemeClr val="accent1"/>
-          </a:effectRef>
-          <a:fontRef idx="minor">
-            <a:schemeClr val="lt1"/>
-          </a:fontRef>
-        </p:style>
-        <p:txBody>
-          <a:bodyPr rtlCol="0" anchor="ctr" wrap="square" lIns="73152" rIns="73152"/>
-          <a:lstStyle/>
-          <a:p>
-            <a:pPr algn="ctr">
-              <a:defRPr sz="1500" b="1">
-                <a:solidFill>
-                  <a:srgbClr val="2DD4BF"/>
-                </a:solidFill>
-              </a:defRPr>
-            </a:pPr>
-            <a:r>
-              <a:t>History</a:t>
-            </a:r>
-          </a:p>
-          <a:p>
-            <a:pPr algn="ctr">
-              <a:defRPr sz="1100">
-                <a:solidFill>
-                  <a:srgbClr val="F1F5F9"/>
-                </a:solidFill>
-              </a:defRPr>
-            </a:pPr>
-            <a:r>
-              <a:t>88 inputs</a:t>
-            </a:r>
-          </a:p>
-        </p:txBody>
-      </p:sp>
-      <p:cxnSp>
-        <p:nvCxnSpPr>
-          <p:cNvPr id="14" name="Connector 13"/>
-          <p:cNvCxnSpPr/>
-          <p:nvPr/>
-        </p:nvCxnSpPr>
-        <p:spPr>
-          <a:xfrm>
-            <a:off x="9738359" y="2423160"/>
-            <a:ext cx="201169" cy="0"/>
-          </a:xfrm>
-          <a:prstGeom prst="line">
-            <a:avLst/>
-          </a:prstGeom>
-          <a:ln w="28575">
-            <a:solidFill>
-              <a:srgbClr val="2DD4BF"/>
-            </a:solidFill>
-            <a:tailEnd type="triangle" w="lg" len="lg"/>
-          </a:ln>
-        </p:spPr>
-        <p:style>
-          <a:lnRef idx="2">
-            <a:schemeClr val="accent1"/>
-          </a:lnRef>
-          <a:fillRef idx="0">
-            <a:schemeClr val="accent1"/>
-          </a:fillRef>
-          <a:effectRef idx="1">
-            <a:schemeClr val="accent1"/>
-          </a:effectRef>
-          <a:fontRef idx="minor">
-            <a:schemeClr val="tx1"/>
-          </a:fontRef>
-        </p:style>
-      </p:cxnSp>
-      <p:sp>
-        <p:nvSpPr>
-          <p:cNvPr id="15" name="Rounded Rectangle 14"/>
-          <p:cNvSpPr/>
-          <p:nvPr/>
-        </p:nvSpPr>
-        <p:spPr>
-          <a:xfrm>
-            <a:off x="9966960" y="1737360"/>
-            <a:ext cx="1627632" cy="1371600"/>
-          </a:xfrm>
-          <a:prstGeom prst="roundRect">
-            <a:avLst/>
-          </a:prstGeom>
-          <a:solidFill>
-            <a:srgbClr val="141E33"/>
-          </a:solidFill>
-          <a:ln w="25400">
-            <a:solidFill>
-              <a:srgbClr val="2DD4BF"/>
-            </a:solidFill>
-          </a:ln>
-        </p:spPr>
-        <p:style>
-          <a:lnRef idx="1">
-            <a:schemeClr val="accent1"/>
-          </a:lnRef>
-          <a:fillRef idx="3">
-            <a:schemeClr val="accent1"/>
-          </a:fillRef>
-          <a:effectRef idx="2">
-            <a:schemeClr val="accent1"/>
-          </a:effectRef>
-          <a:fontRef idx="minor">
-            <a:schemeClr val="lt1"/>
-          </a:fontRef>
-        </p:style>
-        <p:txBody>
-          <a:bodyPr rtlCol="0" anchor="ctr" wrap="square" lIns="73152" rIns="73152"/>
-          <a:lstStyle/>
-          <a:p>
-            <a:pPr algn="ctr">
-              <a:defRPr sz="1500" b="1">
-                <a:solidFill>
-                  <a:srgbClr val="2DD4BF"/>
-                </a:solidFill>
-              </a:defRPr>
-            </a:pPr>
-            <a:r>
-              <a:t>Models + tests</a:t>
-            </a:r>
-          </a:p>
-          <a:p>
-            <a:pPr algn="ctr">
-              <a:defRPr sz="1100">
-                <a:solidFill>
-                  <a:srgbClr val="F1F5F9"/>
-                </a:solidFill>
-              </a:defRPr>
-            </a:pPr>
-            <a:r>
-              <a:t>10 seeds, CI, trivial rule</a:t>
-            </a:r>
-          </a:p>
-        </p:txBody>
-      </p:sp>
-      <p:sp>
-        <p:nvSpPr>
-          <p:cNvPr id="16" name="TextBox 15"/>
-          <p:cNvSpPr txBox="1"/>
-          <p:nvPr/>
-        </p:nvSpPr>
-        <p:spPr>
-          <a:xfrm>
-            <a:off x="548640" y="3429000"/>
-            <a:ext cx="5486400" cy="320040"/>
-          </a:xfrm>
-          <a:prstGeom prst="rect">
-            <a:avLst/>
-          </a:prstGeom>
-          <a:noFill/>
-        </p:spPr>
-        <p:txBody>
-          <a:bodyPr wrap="square">
-            <a:spAutoFit/>
-          </a:bodyPr>
-          <a:lstStyle/>
-          <a:p>
-            <a:pPr>
-              <a:defRPr sz="1300" b="1">
-                <a:solidFill>
-                  <a:srgbClr val="F5B041"/>
-                </a:solidFill>
-              </a:defRPr>
-            </a:pPr>
-            <a:r>
-              <a:t>B · Live forwarding study (no InSDN data)</a:t>
-            </a:r>
-          </a:p>
-        </p:txBody>
-      </p:sp>
-      <p:sp>
-        <p:nvSpPr>
-          <p:cNvPr id="17" name="Rounded Rectangle 16"/>
-          <p:cNvSpPr/>
-          <p:nvPr/>
-        </p:nvSpPr>
-        <p:spPr>
-          <a:xfrm>
-            <a:off x="548640" y="3749039"/>
-            <a:ext cx="2377440" cy="1188720"/>
-          </a:xfrm>
-          <a:prstGeom prst="roundRect">
-            <a:avLst/>
-          </a:prstGeom>
-          <a:solidFill>
-            <a:srgbClr val="141E33"/>
-          </a:solidFill>
-          <a:ln w="25400">
-            <a:solidFill>
-              <a:srgbClr val="F5B041"/>
-            </a:solidFill>
-          </a:ln>
-        </p:spPr>
-        <p:style>
-          <a:lnRef idx="1">
-            <a:schemeClr val="accent1"/>
-          </a:lnRef>
-          <a:fillRef idx="3">
-            <a:schemeClr val="accent1"/>
-          </a:fillRef>
-          <a:effectRef idx="2">
-            <a:schemeClr val="accent1"/>
-          </a:effectRef>
-          <a:fontRef idx="minor">
-            <a:schemeClr val="lt1"/>
-          </a:fontRef>
-        </p:style>
-        <p:txBody>
-          <a:bodyPr rtlCol="0" anchor="ctr" wrap="square" lIns="73152" rIns="73152"/>
-          <a:lstStyle/>
-          <a:p>
-            <a:pPr algn="ctr">
-              <a:defRPr sz="1500" b="1">
-                <a:solidFill>
-                  <a:srgbClr val="F5B041"/>
-                </a:solidFill>
-              </a:defRPr>
-            </a:pPr>
-            <a:r>
-              <a:t>Ryu app</a:t>
-            </a:r>
-          </a:p>
-          <a:p>
-            <a:pPr algn="ctr">
-              <a:defRPr sz="1100">
-                <a:solidFill>
-                  <a:srgbClr val="F1F5F9"/>
-                </a:solidFill>
-              </a:defRPr>
-            </a:pPr>
-            <a:r>
-              <a:t>3 forwarding modes</a:t>
-            </a:r>
-          </a:p>
-        </p:txBody>
-      </p:sp>
-      <p:cxnSp>
-        <p:nvCxnSpPr>
-          <p:cNvPr id="18" name="Connector 17"/>
-          <p:cNvCxnSpPr/>
-          <p:nvPr/>
-        </p:nvCxnSpPr>
-        <p:spPr>
-          <a:xfrm>
-            <a:off x="2953512" y="4343400"/>
-            <a:ext cx="448056" cy="0"/>
-          </a:xfrm>
-          <a:prstGeom prst="line">
-            <a:avLst/>
-          </a:prstGeom>
-          <a:ln w="28575">
-            <a:solidFill>
-              <a:srgbClr val="F5B041"/>
-            </a:solidFill>
-            <a:tailEnd type="triangle" w="lg" len="lg"/>
-          </a:ln>
-        </p:spPr>
-        <p:style>
-          <a:lnRef idx="2">
-            <a:schemeClr val="accent1"/>
-          </a:lnRef>
-          <a:fillRef idx="0">
-            <a:schemeClr val="accent1"/>
-          </a:fillRef>
-          <a:effectRef idx="1">
-            <a:schemeClr val="accent1"/>
-          </a:effectRef>
-          <a:fontRef idx="minor">
-            <a:schemeClr val="tx1"/>
-          </a:fontRef>
-        </p:style>
-      </p:cxnSp>
-      <p:sp>
-        <p:nvSpPr>
-          <p:cNvPr id="19" name="Rounded Rectangle 18"/>
-          <p:cNvSpPr/>
-          <p:nvPr/>
-        </p:nvSpPr>
-        <p:spPr>
-          <a:xfrm>
-            <a:off x="3429000" y="3749039"/>
-            <a:ext cx="2377440" cy="1188720"/>
-          </a:xfrm>
-          <a:prstGeom prst="roundRect">
-            <a:avLst/>
-          </a:prstGeom>
-          <a:solidFill>
-            <a:srgbClr val="141E33"/>
-          </a:solidFill>
-          <a:ln w="25400">
-            <a:solidFill>
-              <a:srgbClr val="F5B041"/>
-            </a:solidFill>
-          </a:ln>
-        </p:spPr>
-        <p:style>
-          <a:lnRef idx="1">
-            <a:schemeClr val="accent1"/>
-          </a:lnRef>
-          <a:fillRef idx="3">
-            <a:schemeClr val="accent1"/>
-          </a:fillRef>
-          <a:effectRef idx="2">
-            <a:schemeClr val="accent1"/>
-          </a:effectRef>
-          <a:fontRef idx="minor">
-            <a:schemeClr val="lt1"/>
-          </a:fontRef>
-        </p:style>
-        <p:txBody>
-          <a:bodyPr rtlCol="0" anchor="ctr" wrap="square" lIns="73152" rIns="73152"/>
-          <a:lstStyle/>
-          <a:p>
-            <a:pPr algn="ctr">
-              <a:defRPr sz="1500" b="1">
-                <a:solidFill>
-                  <a:srgbClr val="F5B041"/>
-                </a:solidFill>
-              </a:defRPr>
-            </a:pPr>
-            <a:r>
-              <a:t>Mininet</a:t>
-            </a:r>
-          </a:p>
-          <a:p>
-            <a:pPr algn="ctr">
-              <a:defRPr sz="1100">
-                <a:solidFill>
-                  <a:srgbClr val="F1F5F9"/>
-                </a:solidFill>
-              </a:defRPr>
-            </a:pPr>
-            <a:r>
-              <a:t>1 or 3 switches, benign traffic</a:t>
-            </a:r>
-          </a:p>
-        </p:txBody>
-      </p:sp>
-      <p:cxnSp>
-        <p:nvCxnSpPr>
-          <p:cNvPr id="20" name="Connector 19"/>
-          <p:cNvCxnSpPr/>
-          <p:nvPr/>
-        </p:nvCxnSpPr>
-        <p:spPr>
-          <a:xfrm>
-            <a:off x="5833872" y="4343400"/>
-            <a:ext cx="448056" cy="0"/>
-          </a:xfrm>
-          <a:prstGeom prst="line">
-            <a:avLst/>
-          </a:prstGeom>
-          <a:ln w="28575">
-            <a:solidFill>
-              <a:srgbClr val="F5B041"/>
-            </a:solidFill>
-            <a:tailEnd type="triangle" w="lg" len="lg"/>
-          </a:ln>
-        </p:spPr>
-        <p:style>
-          <a:lnRef idx="2">
-            <a:schemeClr val="accent1"/>
-          </a:lnRef>
-          <a:fillRef idx="0">
-            <a:schemeClr val="accent1"/>
-          </a:fillRef>
-          <a:effectRef idx="1">
-            <a:schemeClr val="accent1"/>
-          </a:effectRef>
-          <a:fontRef idx="minor">
-            <a:schemeClr val="tx1"/>
-          </a:fontRef>
-        </p:style>
-      </p:cxnSp>
-      <p:sp>
-        <p:nvSpPr>
-          <p:cNvPr id="21" name="Rounded Rectangle 20"/>
-          <p:cNvSpPr/>
-          <p:nvPr/>
-        </p:nvSpPr>
-        <p:spPr>
-          <a:xfrm>
-            <a:off x="6309360" y="3749039"/>
-            <a:ext cx="2377440" cy="1188720"/>
-          </a:xfrm>
-          <a:prstGeom prst="roundRect">
-            <a:avLst/>
-          </a:prstGeom>
-          <a:solidFill>
-            <a:srgbClr val="141E33"/>
-          </a:solidFill>
-          <a:ln w="25400">
-            <a:solidFill>
-              <a:srgbClr val="F5B041"/>
-            </a:solidFill>
-          </a:ln>
-        </p:spPr>
-        <p:style>
-          <a:lnRef idx="1">
-            <a:schemeClr val="accent1"/>
-          </a:lnRef>
-          <a:fillRef idx="3">
-            <a:schemeClr val="accent1"/>
-          </a:fillRef>
-          <a:effectRef idx="2">
-            <a:schemeClr val="accent1"/>
-          </a:effectRef>
-          <a:fontRef idx="minor">
-            <a:schemeClr val="lt1"/>
-          </a:fontRef>
-        </p:style>
-        <p:txBody>
-          <a:bodyPr rtlCol="0" anchor="ctr" wrap="square" lIns="73152" rIns="73152"/>
-          <a:lstStyle/>
-          <a:p>
-            <a:pPr algn="ctr">
-              <a:defRPr sz="1500" b="1">
-                <a:solidFill>
-                  <a:srgbClr val="F5B041"/>
-                </a:solidFill>
-              </a:defRPr>
-            </a:pPr>
-            <a:r>
-              <a:t>Control-channel pcap</a:t>
-            </a:r>
-          </a:p>
-          <a:p>
-            <a:pPr algn="ctr">
-              <a:defRPr sz="1100">
-                <a:solidFill>
-                  <a:srgbClr val="F1F5F9"/>
-                </a:solidFill>
-              </a:defRPr>
-            </a:pPr>
-            <a:r>
-              <a:t>one per run</a:t>
-            </a:r>
-          </a:p>
-        </p:txBody>
-      </p:sp>
-      <p:cxnSp>
-        <p:nvCxnSpPr>
-          <p:cNvPr id="22" name="Connector 21"/>
-          <p:cNvCxnSpPr/>
-          <p:nvPr/>
-        </p:nvCxnSpPr>
-        <p:spPr>
-          <a:xfrm>
-            <a:off x="8714232" y="4343400"/>
-            <a:ext cx="448056" cy="0"/>
-          </a:xfrm>
-          <a:prstGeom prst="line">
-            <a:avLst/>
-          </a:prstGeom>
-          <a:ln w="28575">
-            <a:solidFill>
-              <a:srgbClr val="F5B041"/>
-            </a:solidFill>
-            <a:tailEnd type="triangle" w="lg" len="lg"/>
-          </a:ln>
-        </p:spPr>
-        <p:style>
-          <a:lnRef idx="2">
-            <a:schemeClr val="accent1"/>
-          </a:lnRef>
-          <a:fillRef idx="0">
-            <a:schemeClr val="accent1"/>
-          </a:fillRef>
-          <a:effectRef idx="1">
-            <a:schemeClr val="accent1"/>
-          </a:effectRef>
-          <a:fontRef idx="minor">
-            <a:schemeClr val="tx1"/>
-          </a:fontRef>
-        </p:style>
-      </p:cxnSp>
-      <p:sp>
-        <p:nvSpPr>
-          <p:cNvPr id="23" name="Rounded Rectangle 22"/>
-          <p:cNvSpPr/>
-          <p:nvPr/>
-        </p:nvSpPr>
-        <p:spPr>
-          <a:xfrm>
-            <a:off x="9189720" y="3749039"/>
-            <a:ext cx="2377440" cy="1188720"/>
-          </a:xfrm>
-          <a:prstGeom prst="roundRect">
-            <a:avLst/>
-          </a:prstGeom>
-          <a:solidFill>
-            <a:srgbClr val="141E33"/>
-          </a:solidFill>
-          <a:ln w="25400">
-            <a:solidFill>
-              <a:srgbClr val="F5B041"/>
-            </a:solidFill>
-          </a:ln>
-        </p:spPr>
-        <p:style>
-          <a:lnRef idx="1">
-            <a:schemeClr val="accent1"/>
-          </a:lnRef>
-          <a:fillRef idx="3">
-            <a:schemeClr val="accent1"/>
-          </a:fillRef>
-          <a:effectRef idx="2">
-            <a:schemeClr val="accent1"/>
-          </a:effectRef>
-          <a:fontRef idx="minor">
-            <a:schemeClr val="lt1"/>
-          </a:fontRef>
-        </p:style>
-        <p:txBody>
-          <a:bodyPr rtlCol="0" anchor="ctr" wrap="square" lIns="73152" rIns="73152"/>
-          <a:lstStyle/>
-          <a:p>
-            <a:pPr algn="ctr">
-              <a:defRPr sz="1500" b="1">
-                <a:solidFill>
-                  <a:srgbClr val="F5B041"/>
-                </a:solidFill>
-              </a:defRPr>
-            </a:pPr>
-            <a:r>
-              <a:t>Counts per mode</a:t>
-            </a:r>
-          </a:p>
-          <a:p>
-            <a:pPr algn="ctr">
-              <a:defRPr sz="1100">
-                <a:solidFill>
-                  <a:srgbClr val="F1F5F9"/>
-                </a:solidFill>
-              </a:defRPr>
-            </a:pPr>
-            <a:r>
-              <a:t>PacketIn, FlowMod, entries</a:t>
-            </a:r>
-          </a:p>
-        </p:txBody>
-      </p:sp>
-      <p:sp>
-        <p:nvSpPr>
-          <p:cNvPr id="24" name="Rounded Rectangle 23"/>
-          <p:cNvSpPr/>
-          <p:nvPr/>
-        </p:nvSpPr>
-        <p:spPr>
-          <a:xfrm>
-            <a:off x="548640" y="5257800"/>
-            <a:ext cx="11064240" cy="731520"/>
-          </a:xfrm>
-          <a:prstGeom prst="roundRect">
-            <a:avLst/>
-          </a:prstGeom>
-          <a:solidFill>
-            <a:srgbClr val="141E33"/>
-          </a:solidFill>
-          <a:ln w="25400">
-            <a:solidFill>
-              <a:srgbClr val="A78BFA"/>
-            </a:solidFill>
-          </a:ln>
-        </p:spPr>
-        <p:style>
-          <a:lnRef idx="1">
-            <a:schemeClr val="accent1"/>
-          </a:lnRef>
-          <a:fillRef idx="3">
-            <a:schemeClr val="accent1"/>
-          </a:fillRef>
-          <a:effectRef idx="2">
-            <a:schemeClr val="accent1"/>
-          </a:effectRef>
-          <a:fontRef idx="minor">
-            <a:schemeClr val="lt1"/>
-          </a:fontRef>
-        </p:style>
-        <p:txBody>
-          <a:bodyPr rtlCol="0" anchor="ctr" wrap="square" lIns="73152" rIns="73152"/>
-          <a:lstStyle/>
-          <a:p>
-            <a:pPr algn="ctr">
-              <a:defRPr sz="1500" b="1">
-                <a:solidFill>
-                  <a:srgbClr val="A78BFA"/>
-                </a:solidFill>
-              </a:defRPr>
-            </a:pPr>
-            <a:r>
-              <a:t>Both end as results/*.json → tables in the paper</a:t>
-            </a:r>
-          </a:p>
-          <a:p>
-            <a:pPr algn="ctr">
-              <a:defRPr sz="1200">
-                <a:solidFill>
-                  <a:srgbClr val="F1F5F9"/>
-                </a:solidFill>
-              </a:defRPr>
-            </a:pPr>
-            <a:r>
-              <a:t>model input: 88 numbers about a few seconds of controller messages · output: attack / not attack per window · the CSV only supplies labels</a:t>
+              <a:t>•  One command rebuilds every result from hashed captures and checks the paper's numbers.</a:t>
             </a:r>
           </a:p>
         </p:txBody>
@@ -6441,7 +5949,7 @@
               </a:defRPr>
             </a:pPr>
             <a:r>
-              <a:t>HONEST SCOPE</a:t>
+              <a:t>PIPELINE</a:t>
             </a:r>
           </a:p>
         </p:txBody>
@@ -6476,7 +5984,7 @@
               </a:defRPr>
             </a:pPr>
             <a:r>
-              <a:t>What is not new, what we did not do, what is next</a:t>
+              <a:t>Study architecture: what goes in, what comes out</a:t>
             </a:r>
           </a:p>
         </p:txBody>
@@ -6489,8 +5997,8 @@
         </p:nvSpPr>
         <p:spPr>
           <a:xfrm>
-            <a:off x="731520" y="1737360"/>
-            <a:ext cx="3474720" cy="548640"/>
+            <a:off x="548640" y="1417320"/>
+            <a:ext cx="5486400" cy="320040"/>
           </a:xfrm>
           <a:prstGeom prst="rect">
             <a:avLst/>
@@ -6504,28 +6012,604 @@
           <a:lstStyle/>
           <a:p>
             <a:pPr>
-              <a:defRPr sz="2600" b="1">
-                <a:solidFill>
-                  <a:srgbClr val="F5B041"/>
-                </a:solidFill>
-              </a:defRPr>
-            </a:pPr>
-            <a:r>
-              <a:t>Not new</a:t>
-            </a:r>
-          </a:p>
-        </p:txBody>
-      </p:sp>
-      <p:sp>
-        <p:nvSpPr>
-          <p:cNvPr id="5" name="TextBox 4"/>
+              <a:defRPr sz="1300" b="1">
+                <a:solidFill>
+                  <a:srgbClr val="2DD4BF"/>
+                </a:solidFill>
+              </a:defRPr>
+            </a:pPr>
+            <a:r>
+              <a:t>A · InSDN captures (recorded, offline)</a:t>
+            </a:r>
+          </a:p>
+        </p:txBody>
+      </p:sp>
+      <p:sp>
+        <p:nvSpPr>
+          <p:cNvPr id="5" name="Rounded Rectangle 4"/>
+          <p:cNvSpPr/>
+          <p:nvPr/>
+        </p:nvSpPr>
+        <p:spPr>
+          <a:xfrm>
+            <a:off x="548640" y="1737360"/>
+            <a:ext cx="1627632" cy="1371600"/>
+          </a:xfrm>
+          <a:prstGeom prst="roundRect">
+            <a:avLst/>
+          </a:prstGeom>
+          <a:solidFill>
+            <a:srgbClr val="141E33"/>
+          </a:solidFill>
+          <a:ln w="25400">
+            <a:solidFill>
+              <a:srgbClr val="2DD4BF"/>
+            </a:solidFill>
+          </a:ln>
+        </p:spPr>
+        <p:style>
+          <a:lnRef idx="1">
+            <a:schemeClr val="accent1"/>
+          </a:lnRef>
+          <a:fillRef idx="3">
+            <a:schemeClr val="accent1"/>
+          </a:fillRef>
+          <a:effectRef idx="2">
+            <a:schemeClr val="accent1"/>
+          </a:effectRef>
+          <a:fontRef idx="minor">
+            <a:schemeClr val="lt1"/>
+          </a:fontRef>
+        </p:style>
+        <p:txBody>
+          <a:bodyPr rtlCol="0" anchor="ctr" wrap="square" lIns="73152" rIns="73152"/>
+          <a:lstStyle/>
+          <a:p>
+            <a:pPr algn="ctr">
+              <a:defRPr sz="1500" b="1">
+                <a:solidFill>
+                  <a:srgbClr val="2DD4BF"/>
+                </a:solidFill>
+              </a:defRPr>
+            </a:pPr>
+            <a:r>
+              <a:t>44 pcaps</a:t>
+            </a:r>
+          </a:p>
+          <a:p>
+            <a:pPr algn="ctr">
+              <a:defRPr sz="1100">
+                <a:solidFill>
+                  <a:srgbClr val="F1F5F9"/>
+                </a:solidFill>
+              </a:defRPr>
+            </a:pPr>
+            <a:r>
+              <a:t>in: ONOS TCP 6653</a:t>
+            </a:r>
+          </a:p>
+        </p:txBody>
+      </p:sp>
+      <p:cxnSp>
+        <p:nvCxnSpPr>
+          <p:cNvPr id="6" name="Connector 5"/>
+          <p:cNvCxnSpPr/>
+          <p:nvPr/>
+        </p:nvCxnSpPr>
+        <p:spPr>
+          <a:xfrm>
+            <a:off x="2203703" y="2423160"/>
+            <a:ext cx="201169" cy="0"/>
+          </a:xfrm>
+          <a:prstGeom prst="line">
+            <a:avLst/>
+          </a:prstGeom>
+          <a:ln w="28575">
+            <a:solidFill>
+              <a:srgbClr val="2DD4BF"/>
+            </a:solidFill>
+            <a:tailEnd type="triangle" w="lg" len="lg"/>
+          </a:ln>
+        </p:spPr>
+        <p:style>
+          <a:lnRef idx="2">
+            <a:schemeClr val="accent1"/>
+          </a:lnRef>
+          <a:fillRef idx="0">
+            <a:schemeClr val="accent1"/>
+          </a:fillRef>
+          <a:effectRef idx="1">
+            <a:schemeClr val="accent1"/>
+          </a:effectRef>
+          <a:fontRef idx="minor">
+            <a:schemeClr val="tx1"/>
+          </a:fontRef>
+        </p:style>
+      </p:cxnSp>
+      <p:sp>
+        <p:nvSpPr>
+          <p:cNvPr id="7" name="Rounded Rectangle 6"/>
+          <p:cNvSpPr/>
+          <p:nvPr/>
+        </p:nvSpPr>
+        <p:spPr>
+          <a:xfrm>
+            <a:off x="2432304" y="1737360"/>
+            <a:ext cx="1627632" cy="1371600"/>
+          </a:xfrm>
+          <a:prstGeom prst="roundRect">
+            <a:avLst/>
+          </a:prstGeom>
+          <a:solidFill>
+            <a:srgbClr val="141E33"/>
+          </a:solidFill>
+          <a:ln w="25400">
+            <a:solidFill>
+              <a:srgbClr val="2DD4BF"/>
+            </a:solidFill>
+          </a:ln>
+        </p:spPr>
+        <p:style>
+          <a:lnRef idx="1">
+            <a:schemeClr val="accent1"/>
+          </a:lnRef>
+          <a:fillRef idx="3">
+            <a:schemeClr val="accent1"/>
+          </a:fillRef>
+          <a:effectRef idx="2">
+            <a:schemeClr val="accent1"/>
+          </a:effectRef>
+          <a:fontRef idx="minor">
+            <a:schemeClr val="lt1"/>
+          </a:fontRef>
+        </p:style>
+        <p:txBody>
+          <a:bodyPr rtlCol="0" anchor="ctr" wrap="square" lIns="73152" rIns="73152"/>
+          <a:lstStyle/>
+          <a:p>
+            <a:pPr algn="ctr">
+              <a:defRPr sz="1500" b="1">
+                <a:solidFill>
+                  <a:srgbClr val="2DD4BF"/>
+                </a:solidFill>
+              </a:defRPr>
+            </a:pPr>
+            <a:r>
+              <a:t>Parser</a:t>
+            </a:r>
+          </a:p>
+          <a:p>
+            <a:pPr algn="ctr">
+              <a:defRPr sz="1100">
+                <a:solidFill>
+                  <a:srgbClr val="F1F5F9"/>
+                </a:solidFill>
+              </a:defRPr>
+            </a:pPr>
+            <a:r>
+              <a:t>out: PacketIn, FlowMod, stats</a:t>
+            </a:r>
+          </a:p>
+        </p:txBody>
+      </p:sp>
+      <p:cxnSp>
+        <p:nvCxnSpPr>
+          <p:cNvPr id="8" name="Connector 7"/>
+          <p:cNvCxnSpPr/>
+          <p:nvPr/>
+        </p:nvCxnSpPr>
+        <p:spPr>
+          <a:xfrm>
+            <a:off x="4087368" y="2423160"/>
+            <a:ext cx="201168" cy="0"/>
+          </a:xfrm>
+          <a:prstGeom prst="line">
+            <a:avLst/>
+          </a:prstGeom>
+          <a:ln w="28575">
+            <a:solidFill>
+              <a:srgbClr val="2DD4BF"/>
+            </a:solidFill>
+            <a:tailEnd type="triangle" w="lg" len="lg"/>
+          </a:ln>
+        </p:spPr>
+        <p:style>
+          <a:lnRef idx="2">
+            <a:schemeClr val="accent1"/>
+          </a:lnRef>
+          <a:fillRef idx="0">
+            <a:schemeClr val="accent1"/>
+          </a:fillRef>
+          <a:effectRef idx="1">
+            <a:schemeClr val="accent1"/>
+          </a:effectRef>
+          <a:fontRef idx="minor">
+            <a:schemeClr val="tx1"/>
+          </a:fontRef>
+        </p:style>
+      </p:cxnSp>
+      <p:sp>
+        <p:nvSpPr>
+          <p:cNvPr id="9" name="Rounded Rectangle 8"/>
+          <p:cNvSpPr/>
+          <p:nvPr/>
+        </p:nvSpPr>
+        <p:spPr>
+          <a:xfrm>
+            <a:off x="4315968" y="1737360"/>
+            <a:ext cx="1627632" cy="1371600"/>
+          </a:xfrm>
+          <a:prstGeom prst="roundRect">
+            <a:avLst/>
+          </a:prstGeom>
+          <a:solidFill>
+            <a:srgbClr val="141E33"/>
+          </a:solidFill>
+          <a:ln w="25400">
+            <a:solidFill>
+              <a:srgbClr val="2DD4BF"/>
+            </a:solidFill>
+          </a:ln>
+        </p:spPr>
+        <p:style>
+          <a:lnRef idx="1">
+            <a:schemeClr val="accent1"/>
+          </a:lnRef>
+          <a:fillRef idx="3">
+            <a:schemeClr val="accent1"/>
+          </a:fillRef>
+          <a:effectRef idx="2">
+            <a:schemeClr val="accent1"/>
+          </a:effectRef>
+          <a:fontRef idx="minor">
+            <a:schemeClr val="lt1"/>
+          </a:fontRef>
+        </p:style>
+        <p:txBody>
+          <a:bodyPr rtlCol="0" anchor="ctr" wrap="square" lIns="73152" rIns="73152"/>
+          <a:lstStyle/>
+          <a:p>
+            <a:pPr algn="ctr">
+              <a:defRPr sz="1500" b="1">
+                <a:solidFill>
+                  <a:srgbClr val="2DD4BF"/>
+                </a:solidFill>
+              </a:defRPr>
+            </a:pPr>
+            <a:r>
+              <a:t>Labels</a:t>
+            </a:r>
+          </a:p>
+          <a:p>
+            <a:pPr algn="ctr">
+              <a:defRPr sz="1100">
+                <a:solidFill>
+                  <a:srgbClr val="F1F5F9"/>
+                </a:solidFill>
+              </a:defRPr>
+            </a:pPr>
+            <a:r>
+              <a:t>CSV flow IDs → tag per PacketIn</a:t>
+            </a:r>
+          </a:p>
+        </p:txBody>
+      </p:sp>
+      <p:cxnSp>
+        <p:nvCxnSpPr>
+          <p:cNvPr id="10" name="Connector 9"/>
+          <p:cNvCxnSpPr/>
+          <p:nvPr/>
+        </p:nvCxnSpPr>
+        <p:spPr>
+          <a:xfrm>
+            <a:off x="5971032" y="2423160"/>
+            <a:ext cx="201168" cy="0"/>
+          </a:xfrm>
+          <a:prstGeom prst="line">
+            <a:avLst/>
+          </a:prstGeom>
+          <a:ln w="28575">
+            <a:solidFill>
+              <a:srgbClr val="2DD4BF"/>
+            </a:solidFill>
+            <a:tailEnd type="triangle" w="lg" len="lg"/>
+          </a:ln>
+        </p:spPr>
+        <p:style>
+          <a:lnRef idx="2">
+            <a:schemeClr val="accent1"/>
+          </a:lnRef>
+          <a:fillRef idx="0">
+            <a:schemeClr val="accent1"/>
+          </a:fillRef>
+          <a:effectRef idx="1">
+            <a:schemeClr val="accent1"/>
+          </a:effectRef>
+          <a:fontRef idx="minor">
+            <a:schemeClr val="tx1"/>
+          </a:fontRef>
+        </p:style>
+      </p:cxnSp>
+      <p:sp>
+        <p:nvSpPr>
+          <p:cNvPr id="11" name="Rounded Rectangle 10"/>
+          <p:cNvSpPr/>
+          <p:nvPr/>
+        </p:nvSpPr>
+        <p:spPr>
+          <a:xfrm>
+            <a:off x="6199631" y="1737360"/>
+            <a:ext cx="1627632" cy="1371600"/>
+          </a:xfrm>
+          <a:prstGeom prst="roundRect">
+            <a:avLst/>
+          </a:prstGeom>
+          <a:solidFill>
+            <a:srgbClr val="141E33"/>
+          </a:solidFill>
+          <a:ln w="25400">
+            <a:solidFill>
+              <a:srgbClr val="2DD4BF"/>
+            </a:solidFill>
+          </a:ln>
+        </p:spPr>
+        <p:style>
+          <a:lnRef idx="1">
+            <a:schemeClr val="accent1"/>
+          </a:lnRef>
+          <a:fillRef idx="3">
+            <a:schemeClr val="accent1"/>
+          </a:fillRef>
+          <a:effectRef idx="2">
+            <a:schemeClr val="accent1"/>
+          </a:effectRef>
+          <a:fontRef idx="minor">
+            <a:schemeClr val="lt1"/>
+          </a:fontRef>
+        </p:style>
+        <p:txBody>
+          <a:bodyPr rtlCol="0" anchor="ctr" wrap="square" lIns="73152" rIns="73152"/>
+          <a:lstStyle/>
+          <a:p>
+            <a:pPr algn="ctr">
+              <a:defRPr sz="1500" b="1">
+                <a:solidFill>
+                  <a:srgbClr val="2DD4BF"/>
+                </a:solidFill>
+              </a:defRPr>
+            </a:pPr>
+            <a:r>
+              <a:t>Windows</a:t>
+            </a:r>
+          </a:p>
+          <a:p>
+            <a:pPr algn="ctr">
+              <a:defRPr sz="1100">
+                <a:solidFill>
+                  <a:srgbClr val="F1F5F9"/>
+                </a:solidFill>
+              </a:defRPr>
+            </a:pPr>
+            <a:r>
+              <a:t>22 features per 1–5 s</a:t>
+            </a:r>
+          </a:p>
+        </p:txBody>
+      </p:sp>
+      <p:cxnSp>
+        <p:nvCxnSpPr>
+          <p:cNvPr id="12" name="Connector 11"/>
+          <p:cNvCxnSpPr/>
+          <p:nvPr/>
+        </p:nvCxnSpPr>
+        <p:spPr>
+          <a:xfrm>
+            <a:off x="7854695" y="2423160"/>
+            <a:ext cx="201168" cy="0"/>
+          </a:xfrm>
+          <a:prstGeom prst="line">
+            <a:avLst/>
+          </a:prstGeom>
+          <a:ln w="28575">
+            <a:solidFill>
+              <a:srgbClr val="2DD4BF"/>
+            </a:solidFill>
+            <a:tailEnd type="triangle" w="lg" len="lg"/>
+          </a:ln>
+        </p:spPr>
+        <p:style>
+          <a:lnRef idx="2">
+            <a:schemeClr val="accent1"/>
+          </a:lnRef>
+          <a:fillRef idx="0">
+            <a:schemeClr val="accent1"/>
+          </a:fillRef>
+          <a:effectRef idx="1">
+            <a:schemeClr val="accent1"/>
+          </a:effectRef>
+          <a:fontRef idx="minor">
+            <a:schemeClr val="tx1"/>
+          </a:fontRef>
+        </p:style>
+      </p:cxnSp>
+      <p:sp>
+        <p:nvSpPr>
+          <p:cNvPr id="13" name="Rounded Rectangle 12"/>
+          <p:cNvSpPr/>
+          <p:nvPr/>
+        </p:nvSpPr>
+        <p:spPr>
+          <a:xfrm>
+            <a:off x="8083296" y="1737360"/>
+            <a:ext cx="1627632" cy="1371600"/>
+          </a:xfrm>
+          <a:prstGeom prst="roundRect">
+            <a:avLst/>
+          </a:prstGeom>
+          <a:solidFill>
+            <a:srgbClr val="141E33"/>
+          </a:solidFill>
+          <a:ln w="25400">
+            <a:solidFill>
+              <a:srgbClr val="2DD4BF"/>
+            </a:solidFill>
+          </a:ln>
+        </p:spPr>
+        <p:style>
+          <a:lnRef idx="1">
+            <a:schemeClr val="accent1"/>
+          </a:lnRef>
+          <a:fillRef idx="3">
+            <a:schemeClr val="accent1"/>
+          </a:fillRef>
+          <a:effectRef idx="2">
+            <a:schemeClr val="accent1"/>
+          </a:effectRef>
+          <a:fontRef idx="minor">
+            <a:schemeClr val="lt1"/>
+          </a:fontRef>
+        </p:style>
+        <p:txBody>
+          <a:bodyPr rtlCol="0" anchor="ctr" wrap="square" lIns="73152" rIns="73152"/>
+          <a:lstStyle/>
+          <a:p>
+            <a:pPr algn="ctr">
+              <a:defRPr sz="1500" b="1">
+                <a:solidFill>
+                  <a:srgbClr val="2DD4BF"/>
+                </a:solidFill>
+              </a:defRPr>
+            </a:pPr>
+            <a:r>
+              <a:t>History</a:t>
+            </a:r>
+          </a:p>
+          <a:p>
+            <a:pPr algn="ctr">
+              <a:defRPr sz="1100">
+                <a:solidFill>
+                  <a:srgbClr val="F1F5F9"/>
+                </a:solidFill>
+              </a:defRPr>
+            </a:pPr>
+            <a:r>
+              <a:t>88 inputs</a:t>
+            </a:r>
+          </a:p>
+        </p:txBody>
+      </p:sp>
+      <p:cxnSp>
+        <p:nvCxnSpPr>
+          <p:cNvPr id="14" name="Connector 13"/>
+          <p:cNvCxnSpPr/>
+          <p:nvPr/>
+        </p:nvCxnSpPr>
+        <p:spPr>
+          <a:xfrm>
+            <a:off x="9738359" y="2423160"/>
+            <a:ext cx="201169" cy="0"/>
+          </a:xfrm>
+          <a:prstGeom prst="line">
+            <a:avLst/>
+          </a:prstGeom>
+          <a:ln w="28575">
+            <a:solidFill>
+              <a:srgbClr val="2DD4BF"/>
+            </a:solidFill>
+            <a:tailEnd type="triangle" w="lg" len="lg"/>
+          </a:ln>
+        </p:spPr>
+        <p:style>
+          <a:lnRef idx="2">
+            <a:schemeClr val="accent1"/>
+          </a:lnRef>
+          <a:fillRef idx="0">
+            <a:schemeClr val="accent1"/>
+          </a:fillRef>
+          <a:effectRef idx="1">
+            <a:schemeClr val="accent1"/>
+          </a:effectRef>
+          <a:fontRef idx="minor">
+            <a:schemeClr val="tx1"/>
+          </a:fontRef>
+        </p:style>
+      </p:cxnSp>
+      <p:sp>
+        <p:nvSpPr>
+          <p:cNvPr id="15" name="Rounded Rectangle 14"/>
+          <p:cNvSpPr/>
+          <p:nvPr/>
+        </p:nvSpPr>
+        <p:spPr>
+          <a:xfrm>
+            <a:off x="9966960" y="1737360"/>
+            <a:ext cx="1627632" cy="1371600"/>
+          </a:xfrm>
+          <a:prstGeom prst="roundRect">
+            <a:avLst/>
+          </a:prstGeom>
+          <a:solidFill>
+            <a:srgbClr val="141E33"/>
+          </a:solidFill>
+          <a:ln w="25400">
+            <a:solidFill>
+              <a:srgbClr val="2DD4BF"/>
+            </a:solidFill>
+          </a:ln>
+        </p:spPr>
+        <p:style>
+          <a:lnRef idx="1">
+            <a:schemeClr val="accent1"/>
+          </a:lnRef>
+          <a:fillRef idx="3">
+            <a:schemeClr val="accent1"/>
+          </a:fillRef>
+          <a:effectRef idx="2">
+            <a:schemeClr val="accent1"/>
+          </a:effectRef>
+          <a:fontRef idx="minor">
+            <a:schemeClr val="lt1"/>
+          </a:fontRef>
+        </p:style>
+        <p:txBody>
+          <a:bodyPr rtlCol="0" anchor="ctr" wrap="square" lIns="73152" rIns="73152"/>
+          <a:lstStyle/>
+          <a:p>
+            <a:pPr algn="ctr">
+              <a:defRPr sz="1500" b="1">
+                <a:solidFill>
+                  <a:srgbClr val="2DD4BF"/>
+                </a:solidFill>
+              </a:defRPr>
+            </a:pPr>
+            <a:r>
+              <a:t>Models + tests</a:t>
+            </a:r>
+          </a:p>
+          <a:p>
+            <a:pPr algn="ctr">
+              <a:defRPr sz="1100">
+                <a:solidFill>
+                  <a:srgbClr val="F1F5F9"/>
+                </a:solidFill>
+              </a:defRPr>
+            </a:pPr>
+            <a:r>
+              <a:t>10 seeds, CI, trivial rule</a:t>
+            </a:r>
+          </a:p>
+        </p:txBody>
+      </p:sp>
+      <p:sp>
+        <p:nvSpPr>
+          <p:cNvPr id="16" name="TextBox 15"/>
           <p:cNvSpPr txBox="1"/>
           <p:nvPr/>
         </p:nvSpPr>
         <p:spPr>
           <a:xfrm>
-            <a:off x="731520" y="2468880"/>
-            <a:ext cx="3474720" cy="4206240"/>
+            <a:off x="548640" y="3429000"/>
+            <a:ext cx="5486400" cy="320040"/>
           </a:xfrm>
           <a:prstGeom prst="rect">
             <a:avLst/>
@@ -6539,288 +6623,452 @@
           <a:lstStyle/>
           <a:p>
             <a:pPr>
-              <a:spcAft>
-                <a:spcPts val="1600"/>
-              </a:spcAft>
-              <a:defRPr sz="1700">
+              <a:defRPr sz="1300" b="1">
+                <a:solidFill>
+                  <a:srgbClr val="F5B041"/>
+                </a:solidFill>
+              </a:defRPr>
+            </a:pPr>
+            <a:r>
+              <a:t>B · Live forwarding study (no InSDN data)</a:t>
+            </a:r>
+          </a:p>
+        </p:txBody>
+      </p:sp>
+      <p:sp>
+        <p:nvSpPr>
+          <p:cNvPr id="17" name="Rounded Rectangle 16"/>
+          <p:cNvSpPr/>
+          <p:nvPr/>
+        </p:nvSpPr>
+        <p:spPr>
+          <a:xfrm>
+            <a:off x="548640" y="3749039"/>
+            <a:ext cx="2377440" cy="1188720"/>
+          </a:xfrm>
+          <a:prstGeom prst="roundRect">
+            <a:avLst/>
+          </a:prstGeom>
+          <a:solidFill>
+            <a:srgbClr val="141E33"/>
+          </a:solidFill>
+          <a:ln w="25400">
+            <a:solidFill>
+              <a:srgbClr val="F5B041"/>
+            </a:solidFill>
+          </a:ln>
+        </p:spPr>
+        <p:style>
+          <a:lnRef idx="1">
+            <a:schemeClr val="accent1"/>
+          </a:lnRef>
+          <a:fillRef idx="3">
+            <a:schemeClr val="accent1"/>
+          </a:fillRef>
+          <a:effectRef idx="2">
+            <a:schemeClr val="accent1"/>
+          </a:effectRef>
+          <a:fontRef idx="minor">
+            <a:schemeClr val="lt1"/>
+          </a:fontRef>
+        </p:style>
+        <p:txBody>
+          <a:bodyPr rtlCol="0" anchor="ctr" wrap="square" lIns="73152" rIns="73152"/>
+          <a:lstStyle/>
+          <a:p>
+            <a:pPr algn="ctr">
+              <a:defRPr sz="1500" b="1">
+                <a:solidFill>
+                  <a:srgbClr val="F5B041"/>
+                </a:solidFill>
+              </a:defRPr>
+            </a:pPr>
+            <a:r>
+              <a:t>Ryu app</a:t>
+            </a:r>
+          </a:p>
+          <a:p>
+            <a:pPr algn="ctr">
+              <a:defRPr sz="1100">
                 <a:solidFill>
                   <a:srgbClr val="F1F5F9"/>
                 </a:solidFill>
               </a:defRPr>
             </a:pPr>
             <a:r>
-              <a:t>•  Control-plane telemetry for SDN IDS (LAN-SDN-NIDS, SDNFLow)</a:t>
-            </a:r>
-          </a:p>
-          <a:p>
-            <a:pPr>
-              <a:spcAft>
-                <a:spcPts val="1600"/>
-              </a:spcAft>
-              <a:defRPr sz="1700">
+              <a:t>3 forwarding modes</a:t>
+            </a:r>
+          </a:p>
+        </p:txBody>
+      </p:sp>
+      <p:cxnSp>
+        <p:nvCxnSpPr>
+          <p:cNvPr id="18" name="Connector 17"/>
+          <p:cNvCxnSpPr/>
+          <p:nvPr/>
+        </p:nvCxnSpPr>
+        <p:spPr>
+          <a:xfrm>
+            <a:off x="2953512" y="4343400"/>
+            <a:ext cx="448056" cy="0"/>
+          </a:xfrm>
+          <a:prstGeom prst="line">
+            <a:avLst/>
+          </a:prstGeom>
+          <a:ln w="28575">
+            <a:solidFill>
+              <a:srgbClr val="F5B041"/>
+            </a:solidFill>
+            <a:tailEnd type="triangle" w="lg" len="lg"/>
+          </a:ln>
+        </p:spPr>
+        <p:style>
+          <a:lnRef idx="2">
+            <a:schemeClr val="accent1"/>
+          </a:lnRef>
+          <a:fillRef idx="0">
+            <a:schemeClr val="accent1"/>
+          </a:fillRef>
+          <a:effectRef idx="1">
+            <a:schemeClr val="accent1"/>
+          </a:effectRef>
+          <a:fontRef idx="minor">
+            <a:schemeClr val="tx1"/>
+          </a:fontRef>
+        </p:style>
+      </p:cxnSp>
+      <p:sp>
+        <p:nvSpPr>
+          <p:cNvPr id="19" name="Rounded Rectangle 18"/>
+          <p:cNvSpPr/>
+          <p:nvPr/>
+        </p:nvSpPr>
+        <p:spPr>
+          <a:xfrm>
+            <a:off x="3429000" y="3749039"/>
+            <a:ext cx="2377440" cy="1188720"/>
+          </a:xfrm>
+          <a:prstGeom prst="roundRect">
+            <a:avLst/>
+          </a:prstGeom>
+          <a:solidFill>
+            <a:srgbClr val="141E33"/>
+          </a:solidFill>
+          <a:ln w="25400">
+            <a:solidFill>
+              <a:srgbClr val="F5B041"/>
+            </a:solidFill>
+          </a:ln>
+        </p:spPr>
+        <p:style>
+          <a:lnRef idx="1">
+            <a:schemeClr val="accent1"/>
+          </a:lnRef>
+          <a:fillRef idx="3">
+            <a:schemeClr val="accent1"/>
+          </a:fillRef>
+          <a:effectRef idx="2">
+            <a:schemeClr val="accent1"/>
+          </a:effectRef>
+          <a:fontRef idx="minor">
+            <a:schemeClr val="lt1"/>
+          </a:fontRef>
+        </p:style>
+        <p:txBody>
+          <a:bodyPr rtlCol="0" anchor="ctr" wrap="square" lIns="73152" rIns="73152"/>
+          <a:lstStyle/>
+          <a:p>
+            <a:pPr algn="ctr">
+              <a:defRPr sz="1500" b="1">
+                <a:solidFill>
+                  <a:srgbClr val="F5B041"/>
+                </a:solidFill>
+              </a:defRPr>
+            </a:pPr>
+            <a:r>
+              <a:t>Mininet</a:t>
+            </a:r>
+          </a:p>
+          <a:p>
+            <a:pPr algn="ctr">
+              <a:defRPr sz="1100">
                 <a:solidFill>
                   <a:srgbClr val="F1F5F9"/>
                 </a:solidFill>
               </a:defRPr>
             </a:pPr>
             <a:r>
-              <a:t>•  The detector itself</a:t>
-            </a:r>
-          </a:p>
-          <a:p>
-            <a:pPr>
-              <a:spcAft>
-                <a:spcPts val="1600"/>
-              </a:spcAft>
-              <a:defRPr sz="1700">
+              <a:t>1 or 3 switches, benign traffic</a:t>
+            </a:r>
+          </a:p>
+        </p:txBody>
+      </p:sp>
+      <p:cxnSp>
+        <p:nvCxnSpPr>
+          <p:cNvPr id="20" name="Connector 19"/>
+          <p:cNvCxnSpPr/>
+          <p:nvPr/>
+        </p:nvCxnSpPr>
+        <p:spPr>
+          <a:xfrm>
+            <a:off x="5833872" y="4343400"/>
+            <a:ext cx="448056" cy="0"/>
+          </a:xfrm>
+          <a:prstGeom prst="line">
+            <a:avLst/>
+          </a:prstGeom>
+          <a:ln w="28575">
+            <a:solidFill>
+              <a:srgbClr val="F5B041"/>
+            </a:solidFill>
+            <a:tailEnd type="triangle" w="lg" len="lg"/>
+          </a:ln>
+        </p:spPr>
+        <p:style>
+          <a:lnRef idx="2">
+            <a:schemeClr val="accent1"/>
+          </a:lnRef>
+          <a:fillRef idx="0">
+            <a:schemeClr val="accent1"/>
+          </a:fillRef>
+          <a:effectRef idx="1">
+            <a:schemeClr val="accent1"/>
+          </a:effectRef>
+          <a:fontRef idx="minor">
+            <a:schemeClr val="tx1"/>
+          </a:fontRef>
+        </p:style>
+      </p:cxnSp>
+      <p:sp>
+        <p:nvSpPr>
+          <p:cNvPr id="21" name="Rounded Rectangle 20"/>
+          <p:cNvSpPr/>
+          <p:nvPr/>
+        </p:nvSpPr>
+        <p:spPr>
+          <a:xfrm>
+            <a:off x="6309360" y="3749039"/>
+            <a:ext cx="2377440" cy="1188720"/>
+          </a:xfrm>
+          <a:prstGeom prst="roundRect">
+            <a:avLst/>
+          </a:prstGeom>
+          <a:solidFill>
+            <a:srgbClr val="141E33"/>
+          </a:solidFill>
+          <a:ln w="25400">
+            <a:solidFill>
+              <a:srgbClr val="F5B041"/>
+            </a:solidFill>
+          </a:ln>
+        </p:spPr>
+        <p:style>
+          <a:lnRef idx="1">
+            <a:schemeClr val="accent1"/>
+          </a:lnRef>
+          <a:fillRef idx="3">
+            <a:schemeClr val="accent1"/>
+          </a:fillRef>
+          <a:effectRef idx="2">
+            <a:schemeClr val="accent1"/>
+          </a:effectRef>
+          <a:fontRef idx="minor">
+            <a:schemeClr val="lt1"/>
+          </a:fontRef>
+        </p:style>
+        <p:txBody>
+          <a:bodyPr rtlCol="0" anchor="ctr" wrap="square" lIns="73152" rIns="73152"/>
+          <a:lstStyle/>
+          <a:p>
+            <a:pPr algn="ctr">
+              <a:defRPr sz="1500" b="1">
+                <a:solidFill>
+                  <a:srgbClr val="F5B041"/>
+                </a:solidFill>
+              </a:defRPr>
+            </a:pPr>
+            <a:r>
+              <a:t>Control-channel pcap</a:t>
+            </a:r>
+          </a:p>
+          <a:p>
+            <a:pPr algn="ctr">
+              <a:defRPr sz="1100">
                 <a:solidFill>
                   <a:srgbClr val="F1F5F9"/>
                 </a:solidFill>
               </a:defRPr>
             </a:pPr>
             <a:r>
-              <a:t>•  Stock Ryu behaviour</a:t>
-            </a:r>
-          </a:p>
-        </p:txBody>
-      </p:sp>
-      <p:sp>
-        <p:nvSpPr>
-          <p:cNvPr id="6" name="TextBox 5"/>
-          <p:cNvSpPr txBox="1"/>
+              <a:t>one per run</a:t>
+            </a:r>
+          </a:p>
+        </p:txBody>
+      </p:sp>
+      <p:cxnSp>
+        <p:nvCxnSpPr>
+          <p:cNvPr id="22" name="Connector 21"/>
+          <p:cNvCxnSpPr/>
           <p:nvPr/>
-        </p:nvSpPr>
-        <p:spPr>
-          <a:xfrm>
-            <a:off x="4480559" y="1737360"/>
-            <a:ext cx="3474720" cy="548640"/>
-          </a:xfrm>
-          <a:prstGeom prst="rect">
-            <a:avLst/>
-          </a:prstGeom>
-          <a:noFill/>
-        </p:spPr>
-        <p:txBody>
-          <a:bodyPr wrap="square">
-            <a:spAutoFit/>
-          </a:bodyPr>
-          <a:lstStyle/>
-          <a:p>
-            <a:pPr>
-              <a:defRPr sz="2600" b="1">
-                <a:solidFill>
-                  <a:srgbClr val="F87171"/>
-                </a:solidFill>
-              </a:defRPr>
-            </a:pPr>
-            <a:r>
-              <a:t>Not done</a:t>
-            </a:r>
-          </a:p>
-        </p:txBody>
-      </p:sp>
-      <p:sp>
-        <p:nvSpPr>
-          <p:cNvPr id="7" name="TextBox 6"/>
-          <p:cNvSpPr txBox="1"/>
+        </p:nvCxnSpPr>
+        <p:spPr>
+          <a:xfrm>
+            <a:off x="8714232" y="4343400"/>
+            <a:ext cx="448056" cy="0"/>
+          </a:xfrm>
+          <a:prstGeom prst="line">
+            <a:avLst/>
+          </a:prstGeom>
+          <a:ln w="28575">
+            <a:solidFill>
+              <a:srgbClr val="F5B041"/>
+            </a:solidFill>
+            <a:tailEnd type="triangle" w="lg" len="lg"/>
+          </a:ln>
+        </p:spPr>
+        <p:style>
+          <a:lnRef idx="2">
+            <a:schemeClr val="accent1"/>
+          </a:lnRef>
+          <a:fillRef idx="0">
+            <a:schemeClr val="accent1"/>
+          </a:fillRef>
+          <a:effectRef idx="1">
+            <a:schemeClr val="accent1"/>
+          </a:effectRef>
+          <a:fontRef idx="minor">
+            <a:schemeClr val="tx1"/>
+          </a:fontRef>
+        </p:style>
+      </p:cxnSp>
+      <p:sp>
+        <p:nvSpPr>
+          <p:cNvPr id="23" name="Rounded Rectangle 22"/>
+          <p:cNvSpPr/>
           <p:nvPr/>
         </p:nvSpPr>
         <p:spPr>
           <a:xfrm>
-            <a:off x="4480559" y="2468880"/>
-            <a:ext cx="3474720" cy="4206240"/>
-          </a:xfrm>
-          <a:prstGeom prst="rect">
-            <a:avLst/>
-          </a:prstGeom>
-          <a:noFill/>
-        </p:spPr>
-        <p:txBody>
-          <a:bodyPr wrap="square">
-            <a:spAutoFit/>
-          </a:bodyPr>
-          <a:lstStyle/>
-          <a:p>
-            <a:pPr>
-              <a:spcAft>
-                <a:spcPts val="1600"/>
-              </a:spcAft>
-              <a:defRPr sz="1700">
+            <a:off x="9189720" y="3749039"/>
+            <a:ext cx="2377440" cy="1188720"/>
+          </a:xfrm>
+          <a:prstGeom prst="roundRect">
+            <a:avLst/>
+          </a:prstGeom>
+          <a:solidFill>
+            <a:srgbClr val="141E33"/>
+          </a:solidFill>
+          <a:ln w="25400">
+            <a:solidFill>
+              <a:srgbClr val="F5B041"/>
+            </a:solidFill>
+          </a:ln>
+        </p:spPr>
+        <p:style>
+          <a:lnRef idx="1">
+            <a:schemeClr val="accent1"/>
+          </a:lnRef>
+          <a:fillRef idx="3">
+            <a:schemeClr val="accent1"/>
+          </a:fillRef>
+          <a:effectRef idx="2">
+            <a:schemeClr val="accent1"/>
+          </a:effectRef>
+          <a:fontRef idx="minor">
+            <a:schemeClr val="lt1"/>
+          </a:fontRef>
+        </p:style>
+        <p:txBody>
+          <a:bodyPr rtlCol="0" anchor="ctr" wrap="square" lIns="73152" rIns="73152"/>
+          <a:lstStyle/>
+          <a:p>
+            <a:pPr algn="ctr">
+              <a:defRPr sz="1500" b="1">
+                <a:solidFill>
+                  <a:srgbClr val="F5B041"/>
+                </a:solidFill>
+              </a:defRPr>
+            </a:pPr>
+            <a:r>
+              <a:t>Counts per mode</a:t>
+            </a:r>
+          </a:p>
+          <a:p>
+            <a:pPr algn="ctr">
+              <a:defRPr sz="1100">
                 <a:solidFill>
                   <a:srgbClr val="F1F5F9"/>
                 </a:solidFill>
               </a:defRPr>
             </a:pPr>
             <a:r>
-              <a:t>•  Benign + attack in one session</a:t>
-            </a:r>
-          </a:p>
-          <a:p>
-            <a:pPr>
-              <a:spcAft>
-                <a:spcPts val="1600"/>
-              </a:spcAft>
-              <a:defRPr sz="1700">
+              <a:t>PacketIn, FlowMod, entries</a:t>
+            </a:r>
+          </a:p>
+        </p:txBody>
+      </p:sp>
+      <p:sp>
+        <p:nvSpPr>
+          <p:cNvPr id="24" name="Rounded Rectangle 23"/>
+          <p:cNvSpPr/>
+          <p:nvPr/>
+        </p:nvSpPr>
+        <p:spPr>
+          <a:xfrm>
+            <a:off x="548640" y="5257800"/>
+            <a:ext cx="11064240" cy="731520"/>
+          </a:xfrm>
+          <a:prstGeom prst="roundRect">
+            <a:avLst/>
+          </a:prstGeom>
+          <a:solidFill>
+            <a:srgbClr val="141E33"/>
+          </a:solidFill>
+          <a:ln w="25400">
+            <a:solidFill>
+              <a:srgbClr val="A78BFA"/>
+            </a:solidFill>
+          </a:ln>
+        </p:spPr>
+        <p:style>
+          <a:lnRef idx="1">
+            <a:schemeClr val="accent1"/>
+          </a:lnRef>
+          <a:fillRef idx="3">
+            <a:schemeClr val="accent1"/>
+          </a:fillRef>
+          <a:effectRef idx="2">
+            <a:schemeClr val="accent1"/>
+          </a:effectRef>
+          <a:fontRef idx="minor">
+            <a:schemeClr val="lt1"/>
+          </a:fontRef>
+        </p:style>
+        <p:txBody>
+          <a:bodyPr rtlCol="0" anchor="ctr" wrap="square" lIns="73152" rIns="73152"/>
+          <a:lstStyle/>
+          <a:p>
+            <a:pPr algn="ctr">
+              <a:defRPr sz="1500" b="1">
+                <a:solidFill>
+                  <a:srgbClr val="A78BFA"/>
+                </a:solidFill>
+              </a:defRPr>
+            </a:pPr>
+            <a:r>
+              <a:t>Both end as results/*.json → tables in the paper</a:t>
+            </a:r>
+          </a:p>
+          <a:p>
+            <a:pPr algn="ctr">
+              <a:defRPr sz="1200">
                 <a:solidFill>
                   <a:srgbClr val="F1F5F9"/>
                 </a:solidFill>
               </a:defRPr>
             </a:pPr>
             <a:r>
-              <a:t>•  OpenDaylight or another dataset</a:t>
-            </a:r>
-          </a:p>
-          <a:p>
-            <a:pPr>
-              <a:spcAft>
-                <a:spcPts val="1600"/>
-              </a:spcAft>
-              <a:defRPr sz="1700">
-                <a:solidFill>
-                  <a:srgbClr val="F1F5F9"/>
-                </a:solidFill>
-              </a:defRPr>
-            </a:pPr>
-            <a:r>
-              <a:t>•  A re-implemented published detector</a:t>
-            </a:r>
-          </a:p>
-        </p:txBody>
-      </p:sp>
-      <p:sp>
-        <p:nvSpPr>
-          <p:cNvPr id="8" name="TextBox 7"/>
-          <p:cNvSpPr txBox="1"/>
-          <p:nvPr/>
-        </p:nvSpPr>
-        <p:spPr>
-          <a:xfrm>
-            <a:off x="8229600" y="1737360"/>
-            <a:ext cx="3474720" cy="548640"/>
-          </a:xfrm>
-          <a:prstGeom prst="rect">
-            <a:avLst/>
-          </a:prstGeom>
-          <a:noFill/>
-        </p:spPr>
-        <p:txBody>
-          <a:bodyPr wrap="square">
-            <a:spAutoFit/>
-          </a:bodyPr>
-          <a:lstStyle/>
-          <a:p>
-            <a:pPr>
-              <a:defRPr sz="2600" b="1">
-                <a:solidFill>
-                  <a:srgbClr val="2DD4BF"/>
-                </a:solidFill>
-              </a:defRPr>
-            </a:pPr>
-            <a:r>
-              <a:t>Next</a:t>
-            </a:r>
-          </a:p>
-        </p:txBody>
-      </p:sp>
-      <p:sp>
-        <p:nvSpPr>
-          <p:cNvPr id="9" name="TextBox 8"/>
-          <p:cNvSpPr txBox="1"/>
-          <p:nvPr/>
-        </p:nvSpPr>
-        <p:spPr>
-          <a:xfrm>
-            <a:off x="8229600" y="2468880"/>
-            <a:ext cx="3474720" cy="4206240"/>
-          </a:xfrm>
-          <a:prstGeom prst="rect">
-            <a:avLst/>
-          </a:prstGeom>
-          <a:noFill/>
-        </p:spPr>
-        <p:txBody>
-          <a:bodyPr wrap="square">
-            <a:spAutoFit/>
-          </a:bodyPr>
-          <a:lstStyle/>
-          <a:p>
-            <a:pPr>
-              <a:spcAft>
-                <a:spcPts val="1600"/>
-              </a:spcAft>
-              <a:defRPr sz="1700">
-                <a:solidFill>
-                  <a:srgbClr val="F1F5F9"/>
-                </a:solidFill>
-              </a:defRPr>
-            </a:pPr>
-            <a:r>
-              <a:t>•  Interleave benign and attack traffic</a:t>
-            </a:r>
-          </a:p>
-          <a:p>
-            <a:pPr>
-              <a:spcAft>
-                <a:spcPts val="1600"/>
-              </a:spcAft>
-              <a:defRPr sz="1700">
-                <a:solidFill>
-                  <a:srgbClr val="F1F5F9"/>
-                </a:solidFill>
-              </a:defRPr>
-            </a:pPr>
-            <a:r>
-              <a:t>•  Gap on a second controller family</a:t>
-            </a:r>
-          </a:p>
-          <a:p>
-            <a:pPr>
-              <a:spcAft>
-                <a:spcPts val="1600"/>
-              </a:spcAft>
-              <a:defRPr sz="1700">
-                <a:solidFill>
-                  <a:srgbClr val="F1F5F9"/>
-                </a:solidFill>
-              </a:defRPr>
-            </a:pPr>
-            <a:r>
-              <a:t>•  In-fold oversampling for rare classes</a:t>
-            </a:r>
-          </a:p>
-        </p:txBody>
-      </p:sp>
-      <p:sp>
-        <p:nvSpPr>
-          <p:cNvPr id="10" name="TextBox 9"/>
-          <p:cNvSpPr txBox="1"/>
-          <p:nvPr/>
-        </p:nvSpPr>
-        <p:spPr>
-          <a:xfrm>
-            <a:off x="731520" y="5943600"/>
-            <a:ext cx="10972800" cy="457200"/>
-          </a:xfrm>
-          <a:prstGeom prst="rect">
-            <a:avLst/>
-          </a:prstGeom>
-          <a:noFill/>
-        </p:spPr>
-        <p:txBody>
-          <a:bodyPr wrap="square">
-            <a:spAutoFit/>
-          </a:bodyPr>
-          <a:lstStyle/>
-          <a:p>
-            <a:pPr>
-              <a:defRPr sz="1400" b="0">
-                <a:solidFill>
-                  <a:srgbClr val="9AA8BC"/>
-                </a:solidFill>
-              </a:defRPr>
-            </a:pPr>
-            <a:r>
-              <a:t>Venue: workshop / conference as is; lower-quartile journal after revision.</a:t>
+              <a:t>model input: 88 numbers about a few seconds of controller messages · output: attack / not attack per window · the CSV only supplies labels</a:t>
             </a:r>
           </a:p>
         </p:txBody>

</xml_diff>

<commit_message>
Literature check: remove misattributed ACI-IoT paper, record verified facts (Towhid full text read), per-paper cards and slide
</commit_message>
<xml_diff>
--- a/research/insdn_controller/PRESENTATION.pptx
+++ b/research/insdn_controller/PRESENTATION.pptx
@@ -5538,7 +5538,7 @@
               </a:defRPr>
             </a:pPr>
             <a:r>
-              <a:t>ABSTRACT-LEVEL CHECK, NOT A RE-RUN</a:t>
+              <a:t>FOUR PAPERS, ONE FULL TEXT READ</a:t>
             </a:r>
           </a:p>
         </p:txBody>
@@ -5604,14 +5604,14 @@
               <a:spcAft>
                 <a:spcPts val="1600"/>
               </a:spcAft>
-              <a:defRPr sz="1500">
+              <a:defRPr sz="1600">
                 <a:solidFill>
                   <a:srgbClr val="F1F5F9"/>
                 </a:solidFill>
               </a:defRPr>
             </a:pPr>
             <a:r>
-              <a:t>•  Intrusion detection in software defined network using deep learning approaches:  Transformer 99.02% (48 features); CNN-LSTM 99.01%, 99.19% with 6 features</a:t>
+              <a:t>•  Early Detection of Intrusion in SDN:  Random forest 98.84% vs LSTM 85.31%</a:t>
             </a:r>
           </a:p>
           <a:p>
@@ -5619,14 +5619,14 @@
               <a:spcAft>
                 <a:spcPts val="1600"/>
               </a:spcAft>
-              <a:defRPr sz="1500">
+              <a:defRPr sz="1600">
                 <a:solidFill>
                   <a:srgbClr val="F1F5F9"/>
                 </a:solidFill>
               </a:defRPr>
             </a:pPr>
             <a:r>
-              <a:t>•  A Hybrid CNN-LSTM Based Approach for Anomaly Detection Systems in SDNs:  96.32% accuracy</a:t>
+              <a:t>•  Intrusion detection in software defined network using deep learning approaches:  Transformer 99.02%</a:t>
             </a:r>
           </a:p>
           <a:p>
@@ -5634,14 +5634,14 @@
               <a:spcAft>
                 <a:spcPts val="1600"/>
               </a:spcAft>
-              <a:defRPr sz="1500">
+              <a:defRPr sz="1600">
                 <a:solidFill>
                   <a:srgbClr val="F1F5F9"/>
                 </a:solidFill>
               </a:defRPr>
             </a:pPr>
             <a:r>
-              <a:t>•  Early Detection of Intrusion in SDN:  Random forest 98.84% vs LSTM 85.31%</a:t>
+              <a:t>•  A Hybrid CNN-LSTM Based Approach for Anomaly Detection Systems in SDNs:  96.32% accuracy</a:t>
             </a:r>
           </a:p>
           <a:p>
@@ -5649,7 +5649,7 @@
               <a:spcAft>
                 <a:spcPts val="1600"/>
               </a:spcAft>
-              <a:defRPr sz="1500">
+              <a:defRPr sz="1600">
                 <a:solidFill>
                   <a:srgbClr val="F1F5F9"/>
                 </a:solidFill>
@@ -5659,57 +5659,57 @@
               <a:t>•  Securing IoT and SDN systems using deep-learning based automatic intrusion detection:  99.73% accuracy, 98.6% detection rate</a:t>
             </a:r>
           </a:p>
+        </p:txBody>
+      </p:sp>
+      <p:sp>
+        <p:nvSpPr>
+          <p:cNvPr id="5" name="TextBox 4"/>
+          <p:cNvSpPr txBox="1"/>
+          <p:nvPr/>
+        </p:nvSpPr>
+        <p:spPr>
+          <a:xfrm>
+            <a:off x="731520" y="4023360"/>
+            <a:ext cx="10789920" cy="4206240"/>
+          </a:xfrm>
+          <a:prstGeom prst="rect">
+            <a:avLst/>
+          </a:prstGeom>
+          <a:noFill/>
+        </p:spPr>
+        <p:txBody>
+          <a:bodyPr wrap="square">
+            <a:spAutoFit/>
+          </a:bodyPr>
+          <a:lstStyle/>
           <a:p>
             <a:pPr>
               <a:spcAft>
                 <a:spcPts val="1600"/>
               </a:spcAft>
-              <a:defRPr sz="1500">
+              <a:defRPr sz="1600">
                 <a:solidFill>
                   <a:srgbClr val="F1F5F9"/>
                 </a:solidFill>
               </a:defRPr>
             </a:pPr>
             <a:r>
-              <a:t>•  Categorical Robustness Assessment for ML-based NIDS:  Random forest 99.98% accuracy; ARP spoofing fails (6 samples)</a:t>
-            </a:r>
-          </a:p>
-        </p:txBody>
-      </p:sp>
-      <p:sp>
-        <p:nvSpPr>
-          <p:cNvPr id="5" name="TextBox 4"/>
-          <p:cNvSpPr txBox="1"/>
-          <p:nvPr/>
-        </p:nvSpPr>
-        <p:spPr>
-          <a:xfrm>
-            <a:off x="731520" y="4572000"/>
-            <a:ext cx="10789920" cy="4206240"/>
-          </a:xfrm>
-          <a:prstGeom prst="rect">
-            <a:avLst/>
-          </a:prstGeom>
-          <a:noFill/>
-        </p:spPr>
-        <p:txBody>
-          <a:bodyPr wrap="square">
-            <a:spAutoFit/>
-          </a:bodyPr>
-          <a:lstStyle/>
+              <a:t>•  Towhid et al. (full text read): 9 packet-derived features, all flows split 70:30, no grouping by capture or session mentioned.</a:t>
+            </a:r>
+          </a:p>
           <a:p>
             <a:pPr>
               <a:spcAft>
                 <a:spcPts val="1600"/>
               </a:spcAft>
-              <a:defRPr sz="1700">
+              <a:defRPr sz="1600">
                 <a:solidFill>
                   <a:srgbClr val="F1F5F9"/>
                 </a:solidFill>
               </a:defRPr>
             </a:pPr>
             <a:r>
-              <a:t>•  Our host-side run on the same CSV (random row split): 0.9998. Our controller view: 0.946.</a:t>
+              <a:t>•  Our host-side run on InSDN with a random row split: 0.9998. Our controller view: 0.946.</a:t>
             </a:r>
           </a:p>
           <a:p>
@@ -5717,14 +5717,14 @@
               <a:spcAft>
                 <a:spcPts val="1600"/>
               </a:spcAft>
-              <a:defRPr sz="1700">
+              <a:defRPr sz="1600">
                 <a:solidFill>
                   <a:srgbClr val="F1F5F9"/>
                 </a:solidFill>
               </a:defRPr>
             </a:pPr>
             <a:r>
-              <a:t>•  We do not claim these papers are wrong: split protocols were not visible. We claim the benchmark cannot support a controller-side claim.</a:t>
+              <a:t>•  Not claimed: that these papers are wrong. Claimed: the benchmark cannot support a controller-side claim.</a:t>
             </a:r>
           </a:p>
         </p:txBody>

</xml_diff>

<commit_message>
Split-protocol experiment: random flow split vs held-out hosts on InSDN (GPU XGBoost, 10 seeds); add to reproduce.sh, literature page and deck
</commit_message>
<xml_diff>
--- a/research/insdn_controller/PRESENTATION.pptx
+++ b/research/insdn_controller/PRESENTATION.pptx
@@ -5709,7 +5709,7 @@
               </a:defRPr>
             </a:pPr>
             <a:r>
-              <a:t>•  Our host-side run on InSDN with a random row split: 0.9998. Our controller view: 0.946.</a:t>
+              <a:t>•  Our test, same classifier: random flow split 0.9998; held-out source hosts 0.907 ± 0.085; IPs and ports alone 1.000.</a:t>
             </a:r>
           </a:p>
           <a:p>
@@ -5724,7 +5724,7 @@
               </a:defRPr>
             </a:pPr>
             <a:r>
-              <a:t>•  Not claimed: that these papers are wrong. Claimed: the benchmark cannot support a controller-side claim.</a:t>
+              <a:t>•  Claimed: a random split overstates the score for unseen hosts by about 9 points. Not claimed: their exact numbers are wrong.</a:t>
             </a:r>
           </a:p>
         </p:txBody>

</xml_diff>

<commit_message>
Deck: two-dataset split audit, published-paper protocol table, known-vs-new contributions (16 slides)
</commit_message>
<xml_diff>
--- a/research/insdn_controller/PRESENTATION.pptx
+++ b/research/insdn_controller/PRESENTATION.pptx
@@ -20,6 +20,7 @@
     <p:sldId id="268" r:id="rId19"/>
     <p:sldId id="269" r:id="rId20"/>
     <p:sldId id="270" r:id="rId21"/>
+    <p:sldId id="271" r:id="rId22"/>
   </p:sldIdLst>
   <p:sldSz cx="12191695" cy="6858000" type="screen4x3"/>
   <p:notesSz cx="6858000" cy="9144000"/>
@@ -1671,7 +1672,7 @@
               <c:strCache>
                 <c:ptCount val="1"/>
                 <c:pt idx="0">
-                  <c:v>balanced accuracy</c:v>
+                  <c:v>InSDN</c:v>
                 </c:pt>
               </c:strCache>
             </c:strRef>
@@ -1681,126 +1682,6 @@
               <a:srgbClr val="0F766E"/>
             </a:solidFill>
           </c:spPr>
-          <c:dPt>
-            <c:idx val="0"/>
-            <c:spPr>
-              <a:solidFill>
-                <a:srgbClr val="9CA3AF"/>
-              </a:solidFill>
-            </c:spPr>
-          </c:dPt>
-          <c:dPt>
-            <c:idx val="1"/>
-            <c:spPr>
-              <a:solidFill>
-                <a:srgbClr val="0F766E"/>
-              </a:solidFill>
-            </c:spPr>
-          </c:dPt>
-          <c:dPt>
-            <c:idx val="2"/>
-            <c:spPr>
-              <a:solidFill>
-                <a:srgbClr val="B91C1C"/>
-              </a:solidFill>
-            </c:spPr>
-          </c:dPt>
-          <c:dLbls>
-            <c:dLbl>
-              <c:idx val="0"/>
-              <c:tx>
-                <c:rich>
-                  <a:bodyPr/>
-                  <a:lstStyle/>
-                  <a:p>
-                    <a:pPr>
-                      <a:defRPr sz="1300">
-                        <a:solidFill>
-                          <a:srgbClr val="111827"/>
-                        </a:solidFill>
-                        <a:latin typeface="Calibri"/>
-                      </a:defRPr>
-                    </a:pPr>
-                    <a:r>
-                      <a:t>0.9998</a:t>
-                    </a:r>
-                  </a:p>
-                </c:rich>
-              </c:tx>
-              <c:dLblPos val="outEnd"/>
-              <c:showLegendKey val="0"/>
-              <c:showVal val="1"/>
-              <c:showCatName val="0"/>
-              <c:showSerName val="0"/>
-              <c:showPercent val="0"/>
-              <c:showBubbleSize val="0"/>
-            </c:dLbl>
-            <c:dLbl>
-              <c:idx val="1"/>
-              <c:tx>
-                <c:rich>
-                  <a:bodyPr/>
-                  <a:lstStyle/>
-                  <a:p>
-                    <a:pPr>
-                      <a:defRPr sz="1300">
-                        <a:solidFill>
-                          <a:srgbClr val="111827"/>
-                        </a:solidFill>
-                        <a:latin typeface="Calibri"/>
-                      </a:defRPr>
-                    </a:pPr>
-                    <a:r>
-                      <a:t>0.907 ± 0.085</a:t>
-                    </a:r>
-                  </a:p>
-                </c:rich>
-              </c:tx>
-              <c:dLblPos val="outEnd"/>
-              <c:showLegendKey val="0"/>
-              <c:showVal val="1"/>
-              <c:showCatName val="0"/>
-              <c:showSerName val="0"/>
-              <c:showPercent val="0"/>
-              <c:showBubbleSize val="0"/>
-            </c:dLbl>
-            <c:dLbl>
-              <c:idx val="2"/>
-              <c:tx>
-                <c:rich>
-                  <a:bodyPr/>
-                  <a:lstStyle/>
-                  <a:p>
-                    <a:pPr>
-                      <a:defRPr sz="1300">
-                        <a:solidFill>
-                          <a:srgbClr val="111827"/>
-                        </a:solidFill>
-                        <a:latin typeface="Calibri"/>
-                      </a:defRPr>
-                    </a:pPr>
-                    <a:r>
-                      <a:t>1.000</a:t>
-                    </a:r>
-                  </a:p>
-                </c:rich>
-              </c:tx>
-              <c:dLblPos val="outEnd"/>
-              <c:showLegendKey val="0"/>
-              <c:showVal val="1"/>
-              <c:showCatName val="0"/>
-              <c:showSerName val="0"/>
-              <c:showPercent val="0"/>
-              <c:showBubbleSize val="0"/>
-            </c:dLbl>
-            <c:showLegendKey val="0"/>
-            <c:showVal val="0"/>
-            <c:showCatName val="0"/>
-            <c:showSerName val="0"/>
-            <c:showPercent val="0"/>
-            <c:showBubbleSize val="0"/>
-            <c:showLeaderLines val="1"/>
-          </c:dLbls>
           <c:cat>
             <c:strRef>
               <c:f>Sheet1!$A$2:$A$4</c:f>
@@ -1832,6 +1713,61 @@
                 </c:pt>
                 <c:pt idx="2">
                   <c:v>0.9999981848983543</c:v>
+                </c:pt>
+              </c:numCache>
+            </c:numRef>
+          </c:val>
+        </c:ser>
+        <c:ser>
+          <c:idx val="1"/>
+          <c:order val="1"/>
+          <c:tx>
+            <c:strRef>
+              <c:f>Sheet1!$C$1</c:f>
+              <c:strCache>
+                <c:ptCount val="1"/>
+                <c:pt idx="0">
+                  <c:v>CICIDS2017</c:v>
+                </c:pt>
+              </c:strCache>
+            </c:strRef>
+          </c:tx>
+          <c:spPr>
+            <a:solidFill>
+              <a:srgbClr val="9CA3AF"/>
+            </a:solidFill>
+          </c:spPr>
+          <c:cat>
+            <c:strRef>
+              <c:f>Sheet1!$A$2:$A$4</c:f>
+              <c:strCache>
+                <c:ptCount val="3"/>
+                <c:pt idx="0">
+                  <c:v>Random flow split</c:v>
+                </c:pt>
+                <c:pt idx="1">
+                  <c:v>Held-out source hosts</c:v>
+                </c:pt>
+                <c:pt idx="2">
+                  <c:v>IP addresses and ports only</c:v>
+                </c:pt>
+              </c:strCache>
+            </c:strRef>
+          </c:cat>
+          <c:val>
+            <c:numRef>
+              <c:f>Sheet1!$C$2:$C$4</c:f>
+              <c:numCache>
+                <c:formatCode>General</c:formatCode>
+                <c:ptCount val="3"/>
+                <c:pt idx="0">
+                  <c:v>0.991693753140841</c:v>
+                </c:pt>
+                <c:pt idx="1">
+                  <c:v>0.6407584964613721</c:v>
+                </c:pt>
+                <c:pt idx="2">
+                  <c:v>0.9999171559257845</c:v>
                 </c:pt>
               </c:numCache>
             </c:numRef>
@@ -1914,6 +1850,19 @@
         <c:crosses val="autoZero"/>
       </c:valAx>
     </c:plotArea>
+    <c:legend>
+      <c:legendPos val="b"/>
+      <c:overlay val="0"/>
+      <c:txPr>
+        <a:bodyPr/>
+        <a:lstStyle/>
+        <a:p>
+          <a:pPr>
+            <a:defRPr sz="1200"/>
+          </a:pPr>
+        </a:p>
+      </c:txPr>
+    </c:legend>
     <c:dispBlanksAs val="gap"/>
   </c:chart>
   <c:txPr>
@@ -6350,7 +6299,7 @@
               </a:defRPr>
             </a:pPr>
             <a:r>
-              <a:t>SPLIT-PROTOCOL EXPERIMENT</a:t>
+              <a:t>SPLIT-PROTOCOL AUDIT</a:t>
             </a:r>
           </a:p>
         </p:txBody>
@@ -6386,7 +6335,7 @@
               </a:defRPr>
             </a:pPr>
             <a:r>
-              <a:t>Evaluation protocol alone moves the score by about 9 points</a:t>
+              <a:t>Random splits inflate scores: 9 points on InSDN, 35 on CICIDS2017</a:t>
             </a:r>
           </a:p>
         </p:txBody>
@@ -6473,7 +6422,7 @@
         </p:nvGraphicFramePr>
         <p:xfrm>
           <a:off x="548640" y="1645920"/>
-          <a:ext cx="6766560" cy="4023360"/>
+          <a:ext cx="6949440" cy="4023360"/>
         </p:xfrm>
         <a:graphic>
           <a:graphicData uri="http://schemas.openxmlformats.org/drawingml/2006/chart">
@@ -6490,7 +6439,7 @@
         <p:spPr>
           <a:xfrm>
             <a:off x="548640" y="5669280"/>
-            <a:ext cx="6766560" cy="274320"/>
+            <a:ext cx="6949440" cy="274320"/>
           </a:xfrm>
           <a:prstGeom prst="rect">
             <a:avLst/>
@@ -6512,7 +6461,7 @@
               </a:defRPr>
             </a:pPr>
             <a:r>
-              <a:t>Same GPU XGBoost, 10 seeds, binary benign vs attack, 343,889 flows</a:t>
+              <a:t>Balanced accuracy, GPU XGBoost, 10 seeds, benign vs attack. 343,889 / 2,100,814 flows</a:t>
             </a:r>
           </a:p>
         </p:txBody>
@@ -6525,8 +6474,8 @@
         </p:nvSpPr>
         <p:spPr>
           <a:xfrm>
-            <a:off x="7680960" y="1828800"/>
-            <a:ext cx="3931920" cy="4114800"/>
+            <a:off x="7863840" y="1645920"/>
+            <a:ext cx="3840480" cy="914400"/>
           </a:xfrm>
           <a:prstGeom prst="rect">
             <a:avLst/>
@@ -6540,10 +6489,82 @@
           <a:lstStyle/>
           <a:p>
             <a:pPr>
+              <a:defRPr sz="4000" b="1">
+                <a:solidFill>
+                  <a:srgbClr val="B91C1C"/>
+                </a:solidFill>
+                <a:latin typeface="Calibri"/>
+              </a:defRPr>
+            </a:pPr>
+            <a:r>
+              <a:t>49% / 20%</a:t>
+            </a:r>
+          </a:p>
+        </p:txBody>
+      </p:sp>
+      <p:sp>
+        <p:nvSpPr>
+          <p:cNvPr id="9" name="TextBox 8"/>
+          <p:cNvSpPr txBox="1"/>
+          <p:nvPr/>
+        </p:nvSpPr>
+        <p:spPr>
+          <a:xfrm>
+            <a:off x="7863840" y="2606040"/>
+            <a:ext cx="3840480" cy="822960"/>
+          </a:xfrm>
+          <a:prstGeom prst="rect">
+            <a:avLst/>
+          </a:prstGeom>
+          <a:noFill/>
+        </p:spPr>
+        <p:txBody>
+          <a:bodyPr wrap="square" lIns="0" rIns="0" tIns="0" bIns="0">
+            <a:spAutoFit/>
+          </a:bodyPr>
+          <a:lstStyle/>
+          <a:p>
+            <a:pPr>
+              <a:defRPr sz="1600" b="0">
+                <a:solidFill>
+                  <a:srgbClr val="6B7280"/>
+                </a:solidFill>
+                <a:latin typeface="Calibri"/>
+              </a:defRPr>
+            </a:pPr>
+            <a:r>
+              <a:t>of random-split test rows are exact duplicates of a training row (InSDN / CICIDS2017)</a:t>
+            </a:r>
+          </a:p>
+        </p:txBody>
+      </p:sp>
+      <p:sp>
+        <p:nvSpPr>
+          <p:cNvPr id="10" name="TextBox 9"/>
+          <p:cNvSpPr txBox="1"/>
+          <p:nvPr/>
+        </p:nvSpPr>
+        <p:spPr>
+          <a:xfrm>
+            <a:off x="7863840" y="3657600"/>
+            <a:ext cx="3840480" cy="4114800"/>
+          </a:xfrm>
+          <a:prstGeom prst="rect">
+            <a:avLst/>
+          </a:prstGeom>
+          <a:noFill/>
+        </p:spPr>
+        <p:txBody>
+          <a:bodyPr wrap="square" lIns="0" rIns="0" tIns="0" bIns="0">
+            <a:spAutoFit/>
+          </a:bodyPr>
+          <a:lstStyle/>
+          <a:p>
+            <a:pPr>
               <a:spcAft>
-                <a:spcPts val="1200"/>
+                <a:spcPts val="800"/>
               </a:spcAft>
-              <a:defRPr sz="1500">
+              <a:defRPr sz="1300">
                 <a:solidFill>
                   <a:srgbClr val="111827"/>
                 </a:solidFill>
@@ -6551,15 +6572,15 @@
               </a:defRPr>
             </a:pPr>
             <a:r>
-              <a:t>Worst held-out split: 0.66.</a:t>
+              <a:t>Held-out hosts: 0.907 ± 0.085 (InSDN, worst seed 0.66), 0.641 ± 0.056 (CICIDS2017).</a:t>
             </a:r>
           </a:p>
           <a:p>
             <a:pPr>
               <a:spcAft>
-                <a:spcPts val="1200"/>
+                <a:spcPts val="800"/>
               </a:spcAft>
-              <a:defRPr sz="1500">
+              <a:defRPr sz="1300">
                 <a:solidFill>
                   <a:srgbClr val="111827"/>
                 </a:solidFill>
@@ -6567,15 +6588,15 @@
               </a:defRPr>
             </a:pPr>
             <a:r>
-              <a:t>Identifiers alone reach 1.000, so a random split rewards memorising hosts.</a:t>
+              <a:t>Identifiers alone reach 1.000 on both, so a random split rewards memorising hosts.</a:t>
             </a:r>
           </a:p>
           <a:p>
             <a:pPr>
               <a:spcAft>
-                <a:spcPts val="1200"/>
+                <a:spcPts val="800"/>
               </a:spcAft>
-              <a:defRPr sz="1500">
+              <a:defRPr sz="1300">
                 <a:solidFill>
                   <a:srgbClr val="111827"/>
                 </a:solidFill>
@@ -6583,23 +6604,7 @@
               </a:defRPr>
             </a:pPr>
             <a:r>
-              <a:t>Towhid et al. (full text read): all flows split 70:30, no grouping mentioned.</a:t>
-            </a:r>
-          </a:p>
-          <a:p>
-            <a:pPr>
-              <a:spcAft>
-                <a:spcPts val="1200"/>
-              </a:spcAft>
-              <a:defRPr sz="1500">
-                <a:solidFill>
-                  <a:srgbClr val="111827"/>
-                </a:solidFill>
-                <a:latin typeface="Calibri"/>
-              </a:defRPr>
-            </a:pPr>
-            <a:r>
-              <a:t>Detected: inflation under the random-split protocol. Not claimed: that any paper's exact numbers are wrong.</a:t>
+              <a:t>Known already: Engelen 2021, Flood 2024. New: the paired gap with CIs on an SDN dataset.</a:t>
             </a:r>
           </a:p>
         </p:txBody>
@@ -6661,7 +6666,7 @@
               </a:defRPr>
             </a:pPr>
             <a:r>
-              <a:t>HONEST SCOPE</a:t>
+              <a:t>PROTOCOL AUDIT OF THE LITERATURE</a:t>
             </a:r>
           </a:p>
         </p:txBody>
@@ -6697,7 +6702,7 @@
               </a:defRPr>
             </a:pPr>
             <a:r>
-              <a:t>Limitations we state ourselves</a:t>
+              <a:t>What published InSDN papers report vs how they split</a:t>
             </a:r>
           </a:p>
         </p:txBody>
@@ -6774,16 +6779,1265 @@
           </a:p>
         </p:txBody>
       </p:sp>
-      <p:sp>
-        <p:nvSpPr>
-          <p:cNvPr id="6" name="TextBox 5"/>
+      <p:graphicFrame>
+        <p:nvGraphicFramePr>
+          <p:cNvPr id="6" name="Table 5"/>
+          <p:cNvGraphicFramePr>
+            <a:graphicFrameLocks noGrp="1"/>
+          </p:cNvGraphicFramePr>
+          <p:nvPr/>
+        </p:nvGraphicFramePr>
+        <p:xfrm>
+          <a:off x="548640" y="1508760"/>
+          <a:ext cx="11064240" cy="3840480"/>
+        </p:xfrm>
+        <a:graphic>
+          <a:graphicData uri="http://schemas.openxmlformats.org/drawingml/2006/table">
+            <a:tbl>
+              <a:tblPr firstRow="1" bandRow="1">
+                <a:tableStyleId>{5C22544A-7EE6-4342-B048-85BDC9FD1C3A}</a:tableStyleId>
+              </a:tblPr>
+              <a:tblGrid>
+                <a:gridCol w="2377440"/>
+                <a:gridCol w="1554480"/>
+                <a:gridCol w="2743200"/>
+                <a:gridCol w="1828800"/>
+                <a:gridCol w="2560320"/>
+              </a:tblGrid>
+              <a:tr h="384048">
+                <a:tc>
+                  <a:txBody>
+                    <a:bodyPr/>
+                    <a:lstStyle/>
+                    <a:p>
+                      <a:pPr>
+                        <a:defRPr sz="1200" b="1">
+                          <a:solidFill>
+                            <a:srgbClr val="FFFFFF"/>
+                          </a:solidFill>
+                          <a:latin typeface="Calibri"/>
+                        </a:defRPr>
+                      </a:pPr>
+                      <a:r>
+                        <a:t>Paper</a:t>
+                      </a:r>
+                    </a:p>
+                  </a:txBody>
+                  <a:tcPr marT="27432" marB="27432" anchor="ctr">
+                    <a:solidFill>
+                      <a:srgbClr val="0F766E"/>
+                    </a:solidFill>
+                  </a:tcPr>
+                </a:tc>
+                <a:tc>
+                  <a:txBody>
+                    <a:bodyPr/>
+                    <a:lstStyle/>
+                    <a:p>
+                      <a:pPr>
+                        <a:defRPr sz="1200" b="1">
+                          <a:solidFill>
+                            <a:srgbClr val="FFFFFF"/>
+                          </a:solidFill>
+                          <a:latin typeface="Calibri"/>
+                        </a:defRPr>
+                      </a:pPr>
+                      <a:r>
+                        <a:t>Reported</a:t>
+                      </a:r>
+                    </a:p>
+                  </a:txBody>
+                  <a:tcPr marT="27432" marB="27432" anchor="ctr">
+                    <a:solidFill>
+                      <a:srgbClr val="0F766E"/>
+                    </a:solidFill>
+                  </a:tcPr>
+                </a:tc>
+                <a:tc>
+                  <a:txBody>
+                    <a:bodyPr/>
+                    <a:lstStyle/>
+                    <a:p>
+                      <a:pPr>
+                        <a:defRPr sz="1200" b="1">
+                          <a:solidFill>
+                            <a:srgbClr val="FFFFFF"/>
+                          </a:solidFill>
+                          <a:latin typeface="Calibri"/>
+                        </a:defRPr>
+                      </a:pPr>
+                      <a:r>
+                        <a:t>Split</a:t>
+                      </a:r>
+                    </a:p>
+                  </a:txBody>
+                  <a:tcPr marT="27432" marB="27432" anchor="ctr">
+                    <a:solidFill>
+                      <a:srgbClr val="0F766E"/>
+                    </a:solidFill>
+                  </a:tcPr>
+                </a:tc>
+                <a:tc>
+                  <a:txBody>
+                    <a:bodyPr/>
+                    <a:lstStyle/>
+                    <a:p>
+                      <a:pPr>
+                        <a:defRPr sz="1200" b="1">
+                          <a:solidFill>
+                            <a:srgbClr val="FFFFFF"/>
+                          </a:solidFill>
+                          <a:latin typeface="Calibri"/>
+                        </a:defRPr>
+                      </a:pPr>
+                      <a:r>
+                        <a:t>Grouped by host</a:t>
+                      </a:r>
+                    </a:p>
+                  </a:txBody>
+                  <a:tcPr marT="27432" marB="27432" anchor="ctr">
+                    <a:solidFill>
+                      <a:srgbClr val="0F766E"/>
+                    </a:solidFill>
+                  </a:tcPr>
+                </a:tc>
+                <a:tc>
+                  <a:txBody>
+                    <a:bodyPr/>
+                    <a:lstStyle/>
+                    <a:p>
+                      <a:pPr>
+                        <a:defRPr sz="1200" b="1">
+                          <a:solidFill>
+                            <a:srgbClr val="FFFFFF"/>
+                          </a:solidFill>
+                          <a:latin typeface="Calibri"/>
+                        </a:defRPr>
+                      </a:pPr>
+                      <a:r>
+                        <a:t>IDs / ports as inputs</a:t>
+                      </a:r>
+                    </a:p>
+                  </a:txBody>
+                  <a:tcPr marT="27432" marB="27432" anchor="ctr">
+                    <a:solidFill>
+                      <a:srgbClr val="0F766E"/>
+                    </a:solidFill>
+                  </a:tcPr>
+                </a:tc>
+              </a:tr>
+              <a:tr h="384048">
+                <a:tc>
+                  <a:txBody>
+                    <a:bodyPr/>
+                    <a:lstStyle/>
+                    <a:p>
+                      <a:pPr>
+                        <a:defRPr sz="1200" b="0">
+                          <a:solidFill>
+                            <a:srgbClr val="111827"/>
+                          </a:solidFill>
+                          <a:latin typeface="Calibri"/>
+                        </a:defRPr>
+                      </a:pPr>
+                      <a:r>
+                        <a:t>Towhid et al.</a:t>
+                      </a:r>
+                    </a:p>
+                  </a:txBody>
+                  <a:tcPr marT="27432" marB="27432" anchor="ctr">
+                    <a:solidFill>
+                      <a:srgbClr val="FFFFFF"/>
+                    </a:solidFill>
+                  </a:tcPr>
+                </a:tc>
+                <a:tc>
+                  <a:txBody>
+                    <a:bodyPr/>
+                    <a:lstStyle/>
+                    <a:p>
+                      <a:pPr>
+                        <a:defRPr sz="1200" b="0">
+                          <a:solidFill>
+                            <a:srgbClr val="111827"/>
+                          </a:solidFill>
+                          <a:latin typeface="Calibri"/>
+                        </a:defRPr>
+                      </a:pPr>
+                      <a:r>
+                        <a:t>RF 98.84%</a:t>
+                      </a:r>
+                    </a:p>
+                  </a:txBody>
+                  <a:tcPr marT="27432" marB="27432" anchor="ctr">
+                    <a:solidFill>
+                      <a:srgbClr val="FFFFFF"/>
+                    </a:solidFill>
+                  </a:tcPr>
+                </a:tc>
+                <a:tc>
+                  <a:txBody>
+                    <a:bodyPr/>
+                    <a:lstStyle/>
+                    <a:p>
+                      <a:pPr>
+                        <a:defRPr sz="1200" b="0">
+                          <a:solidFill>
+                            <a:srgbClr val="111827"/>
+                          </a:solidFill>
+                          <a:latin typeface="Calibri"/>
+                        </a:defRPr>
+                      </a:pPr>
+                      <a:r>
+                        <a:t>70:30, all flows</a:t>
+                      </a:r>
+                    </a:p>
+                  </a:txBody>
+                  <a:tcPr marT="27432" marB="27432" anchor="ctr">
+                    <a:solidFill>
+                      <a:srgbClr val="FFFFFF"/>
+                    </a:solidFill>
+                  </a:tcPr>
+                </a:tc>
+                <a:tc>
+                  <a:txBody>
+                    <a:bodyPr/>
+                    <a:lstStyle/>
+                    <a:p>
+                      <a:pPr>
+                        <a:defRPr sz="1200" b="0">
+                          <a:solidFill>
+                            <a:srgbClr val="111827"/>
+                          </a:solidFill>
+                          <a:latin typeface="Calibri"/>
+                        </a:defRPr>
+                      </a:pPr>
+                      <a:r>
+                        <a:t>No</a:t>
+                      </a:r>
+                    </a:p>
+                  </a:txBody>
+                  <a:tcPr marT="27432" marB="27432" anchor="ctr">
+                    <a:solidFill>
+                      <a:srgbClr val="FFFFFF"/>
+                    </a:solidFill>
+                  </a:tcPr>
+                </a:tc>
+                <a:tc>
+                  <a:txBody>
+                    <a:bodyPr/>
+                    <a:lstStyle/>
+                    <a:p>
+                      <a:pPr>
+                        <a:defRPr sz="1200" b="0">
+                          <a:solidFill>
+                            <a:srgbClr val="111827"/>
+                          </a:solidFill>
+                          <a:latin typeface="Calibri"/>
+                        </a:defRPr>
+                      </a:pPr>
+                      <a:r>
+                        <a:t>Not stated</a:t>
+                      </a:r>
+                    </a:p>
+                  </a:txBody>
+                  <a:tcPr marT="27432" marB="27432" anchor="ctr">
+                    <a:solidFill>
+                      <a:srgbClr val="FFFFFF"/>
+                    </a:solidFill>
+                  </a:tcPr>
+                </a:tc>
+              </a:tr>
+              <a:tr h="384048">
+                <a:tc>
+                  <a:txBody>
+                    <a:bodyPr/>
+                    <a:lstStyle/>
+                    <a:p>
+                      <a:pPr>
+                        <a:defRPr sz="1200" b="0">
+                          <a:solidFill>
+                            <a:srgbClr val="111827"/>
+                          </a:solidFill>
+                          <a:latin typeface="Calibri"/>
+                        </a:defRPr>
+                      </a:pPr>
+                      <a:r>
+                        <a:t>Ataa et al. 2024</a:t>
+                      </a:r>
+                    </a:p>
+                  </a:txBody>
+                  <a:tcPr marT="27432" marB="27432" anchor="ctr">
+                    <a:solidFill>
+                      <a:srgbClr val="F3F4F6"/>
+                    </a:solidFill>
+                  </a:tcPr>
+                </a:tc>
+                <a:tc>
+                  <a:txBody>
+                    <a:bodyPr/>
+                    <a:lstStyle/>
+                    <a:p>
+                      <a:pPr>
+                        <a:defRPr sz="1200" b="0">
+                          <a:solidFill>
+                            <a:srgbClr val="111827"/>
+                          </a:solidFill>
+                          <a:latin typeface="Calibri"/>
+                        </a:defRPr>
+                      </a:pPr>
+                      <a:r>
+                        <a:t>99.02%</a:t>
+                      </a:r>
+                    </a:p>
+                  </a:txBody>
+                  <a:tcPr marT="27432" marB="27432" anchor="ctr">
+                    <a:solidFill>
+                      <a:srgbClr val="F3F4F6"/>
+                    </a:solidFill>
+                  </a:tcPr>
+                </a:tc>
+                <a:tc>
+                  <a:txBody>
+                    <a:bodyPr/>
+                    <a:lstStyle/>
+                    <a:p>
+                      <a:pPr>
+                        <a:defRPr sz="1200" b="0">
+                          <a:solidFill>
+                            <a:srgbClr val="111827"/>
+                          </a:solidFill>
+                          <a:latin typeface="Calibri"/>
+                        </a:defRPr>
+                      </a:pPr>
+                      <a:r>
+                        <a:t>Not described (shuffled)</a:t>
+                      </a:r>
+                    </a:p>
+                  </a:txBody>
+                  <a:tcPr marT="27432" marB="27432" anchor="ctr">
+                    <a:solidFill>
+                      <a:srgbClr val="F3F4F6"/>
+                    </a:solidFill>
+                  </a:tcPr>
+                </a:tc>
+                <a:tc>
+                  <a:txBody>
+                    <a:bodyPr/>
+                    <a:lstStyle/>
+                    <a:p>
+                      <a:pPr>
+                        <a:defRPr sz="1200" b="0">
+                          <a:solidFill>
+                            <a:srgbClr val="111827"/>
+                          </a:solidFill>
+                          <a:latin typeface="Calibri"/>
+                        </a:defRPr>
+                      </a:pPr>
+                      <a:r>
+                        <a:t>Not stated</a:t>
+                      </a:r>
+                    </a:p>
+                  </a:txBody>
+                  <a:tcPr marT="27432" marB="27432" anchor="ctr">
+                    <a:solidFill>
+                      <a:srgbClr val="F3F4F6"/>
+                    </a:solidFill>
+                  </a:tcPr>
+                </a:tc>
+                <a:tc>
+                  <a:txBody>
+                    <a:bodyPr/>
+                    <a:lstStyle/>
+                    <a:p>
+                      <a:pPr>
+                        <a:defRPr sz="1200" b="0">
+                          <a:solidFill>
+                            <a:srgbClr val="111827"/>
+                          </a:solidFill>
+                          <a:latin typeface="Calibri"/>
+                        </a:defRPr>
+                      </a:pPr>
+                      <a:r>
+                        <a:t>No (stated)</a:t>
+                      </a:r>
+                    </a:p>
+                  </a:txBody>
+                  <a:tcPr marT="27432" marB="27432" anchor="ctr">
+                    <a:solidFill>
+                      <a:srgbClr val="F3F4F6"/>
+                    </a:solidFill>
+                  </a:tcPr>
+                </a:tc>
+              </a:tr>
+              <a:tr h="384048">
+                <a:tc>
+                  <a:txBody>
+                    <a:bodyPr/>
+                    <a:lstStyle/>
+                    <a:p>
+                      <a:pPr>
+                        <a:defRPr sz="1200" b="0">
+                          <a:solidFill>
+                            <a:srgbClr val="111827"/>
+                          </a:solidFill>
+                          <a:latin typeface="Calibri"/>
+                        </a:defRPr>
+                      </a:pPr>
+                      <a:r>
+                        <a:t>OptiXGB-IDS 2026</a:t>
+                      </a:r>
+                    </a:p>
+                  </a:txBody>
+                  <a:tcPr marT="27432" marB="27432" anchor="ctr">
+                    <a:solidFill>
+                      <a:srgbClr val="FFFFFF"/>
+                    </a:solidFill>
+                  </a:tcPr>
+                </a:tc>
+                <a:tc>
+                  <a:txBody>
+                    <a:bodyPr/>
+                    <a:lstStyle/>
+                    <a:p>
+                      <a:pPr>
+                        <a:defRPr sz="1200" b="0">
+                          <a:solidFill>
+                            <a:srgbClr val="111827"/>
+                          </a:solidFill>
+                          <a:latin typeface="Calibri"/>
+                        </a:defRPr>
+                      </a:pPr>
+                      <a:r>
+                        <a:t>99.87%</a:t>
+                      </a:r>
+                    </a:p>
+                  </a:txBody>
+                  <a:tcPr marT="27432" marB="27432" anchor="ctr">
+                    <a:solidFill>
+                      <a:srgbClr val="FFFFFF"/>
+                    </a:solidFill>
+                  </a:tcPr>
+                </a:tc>
+                <a:tc>
+                  <a:txBody>
+                    <a:bodyPr/>
+                    <a:lstStyle/>
+                    <a:p>
+                      <a:pPr>
+                        <a:defRPr sz="1200" b="0">
+                          <a:solidFill>
+                            <a:srgbClr val="111827"/>
+                          </a:solidFill>
+                          <a:latin typeface="Calibri"/>
+                        </a:defRPr>
+                      </a:pPr>
+                      <a:r>
+                        <a:t>80:20 random</a:t>
+                      </a:r>
+                    </a:p>
+                  </a:txBody>
+                  <a:tcPr marT="27432" marB="27432" anchor="ctr">
+                    <a:solidFill>
+                      <a:srgbClr val="FFFFFF"/>
+                    </a:solidFill>
+                  </a:tcPr>
+                </a:tc>
+                <a:tc>
+                  <a:txBody>
+                    <a:bodyPr/>
+                    <a:lstStyle/>
+                    <a:p>
+                      <a:pPr>
+                        <a:defRPr sz="1200" b="0">
+                          <a:solidFill>
+                            <a:srgbClr val="111827"/>
+                          </a:solidFill>
+                          <a:latin typeface="Calibri"/>
+                        </a:defRPr>
+                      </a:pPr>
+                      <a:r>
+                        <a:t>No</a:t>
+                      </a:r>
+                    </a:p>
+                  </a:txBody>
+                  <a:tcPr marT="27432" marB="27432" anchor="ctr">
+                    <a:solidFill>
+                      <a:srgbClr val="FFFFFF"/>
+                    </a:solidFill>
+                  </a:tcPr>
+                </a:tc>
+                <a:tc>
+                  <a:txBody>
+                    <a:bodyPr/>
+                    <a:lstStyle/>
+                    <a:p>
+                      <a:pPr>
+                        <a:defRPr sz="1200" b="0">
+                          <a:solidFill>
+                            <a:srgbClr val="B91C1C"/>
+                          </a:solidFill>
+                          <a:latin typeface="Calibri"/>
+                        </a:defRPr>
+                      </a:pPr>
+                      <a:r>
+                        <a:t>Ports</a:t>
+                      </a:r>
+                    </a:p>
+                  </a:txBody>
+                  <a:tcPr marT="27432" marB="27432" anchor="ctr">
+                    <a:solidFill>
+                      <a:srgbClr val="FFFFFF"/>
+                    </a:solidFill>
+                  </a:tcPr>
+                </a:tc>
+              </a:tr>
+              <a:tr h="384048">
+                <a:tc>
+                  <a:txBody>
+                    <a:bodyPr/>
+                    <a:lstStyle/>
+                    <a:p>
+                      <a:pPr>
+                        <a:defRPr sz="1200" b="0">
+                          <a:solidFill>
+                            <a:srgbClr val="111827"/>
+                          </a:solidFill>
+                          <a:latin typeface="Calibri"/>
+                        </a:defRPr>
+                      </a:pPr>
+                      <a:r>
+                        <a:t>PeerJ CS 2025</a:t>
+                      </a:r>
+                    </a:p>
+                  </a:txBody>
+                  <a:tcPr marT="27432" marB="27432" anchor="ctr">
+                    <a:solidFill>
+                      <a:srgbClr val="F3F4F6"/>
+                    </a:solidFill>
+                  </a:tcPr>
+                </a:tc>
+                <a:tc>
+                  <a:txBody>
+                    <a:bodyPr/>
+                    <a:lstStyle/>
+                    <a:p>
+                      <a:pPr>
+                        <a:defRPr sz="1200" b="0">
+                          <a:solidFill>
+                            <a:srgbClr val="111827"/>
+                          </a:solidFill>
+                          <a:latin typeface="Calibri"/>
+                        </a:defRPr>
+                      </a:pPr>
+                      <a:r>
+                        <a:t>99.93%</a:t>
+                      </a:r>
+                    </a:p>
+                  </a:txBody>
+                  <a:tcPr marT="27432" marB="27432" anchor="ctr">
+                    <a:solidFill>
+                      <a:srgbClr val="F3F4F6"/>
+                    </a:solidFill>
+                  </a:tcPr>
+                </a:tc>
+                <a:tc>
+                  <a:txBody>
+                    <a:bodyPr/>
+                    <a:lstStyle/>
+                    <a:p>
+                      <a:pPr>
+                        <a:defRPr sz="1200" b="0">
+                          <a:solidFill>
+                            <a:srgbClr val="111827"/>
+                          </a:solidFill>
+                          <a:latin typeface="Calibri"/>
+                        </a:defRPr>
+                      </a:pPr>
+                      <a:r>
+                        <a:t>train_test_split</a:t>
+                      </a:r>
+                    </a:p>
+                  </a:txBody>
+                  <a:tcPr marT="27432" marB="27432" anchor="ctr">
+                    <a:solidFill>
+                      <a:srgbClr val="F3F4F6"/>
+                    </a:solidFill>
+                  </a:tcPr>
+                </a:tc>
+                <a:tc>
+                  <a:txBody>
+                    <a:bodyPr/>
+                    <a:lstStyle/>
+                    <a:p>
+                      <a:pPr>
+                        <a:defRPr sz="1200" b="0">
+                          <a:solidFill>
+                            <a:srgbClr val="111827"/>
+                          </a:solidFill>
+                          <a:latin typeface="Calibri"/>
+                        </a:defRPr>
+                      </a:pPr>
+                      <a:r>
+                        <a:t>No</a:t>
+                      </a:r>
+                    </a:p>
+                  </a:txBody>
+                  <a:tcPr marT="27432" marB="27432" anchor="ctr">
+                    <a:solidFill>
+                      <a:srgbClr val="F3F4F6"/>
+                    </a:solidFill>
+                  </a:tcPr>
+                </a:tc>
+                <a:tc>
+                  <a:txBody>
+                    <a:bodyPr/>
+                    <a:lstStyle/>
+                    <a:p>
+                      <a:pPr>
+                        <a:defRPr sz="1200" b="0">
+                          <a:solidFill>
+                            <a:srgbClr val="111827"/>
+                          </a:solidFill>
+                          <a:latin typeface="Calibri"/>
+                        </a:defRPr>
+                      </a:pPr>
+                      <a:r>
+                        <a:t>Not stated</a:t>
+                      </a:r>
+                    </a:p>
+                  </a:txBody>
+                  <a:tcPr marT="27432" marB="27432" anchor="ctr">
+                    <a:solidFill>
+                      <a:srgbClr val="F3F4F6"/>
+                    </a:solidFill>
+                  </a:tcPr>
+                </a:tc>
+              </a:tr>
+              <a:tr h="384048">
+                <a:tc>
+                  <a:txBody>
+                    <a:bodyPr/>
+                    <a:lstStyle/>
+                    <a:p>
+                      <a:pPr>
+                        <a:defRPr sz="1200" b="0">
+                          <a:solidFill>
+                            <a:srgbClr val="111827"/>
+                          </a:solidFill>
+                          <a:latin typeface="Calibri"/>
+                        </a:defRPr>
+                      </a:pPr>
+                      <a:r>
+                        <a:t>Sajid et al. 2025</a:t>
+                      </a:r>
+                    </a:p>
+                  </a:txBody>
+                  <a:tcPr marT="27432" marB="27432" anchor="ctr">
+                    <a:solidFill>
+                      <a:srgbClr val="FFFFFF"/>
+                    </a:solidFill>
+                  </a:tcPr>
+                </a:tc>
+                <a:tc>
+                  <a:txBody>
+                    <a:bodyPr/>
+                    <a:lstStyle/>
+                    <a:p>
+                      <a:pPr>
+                        <a:defRPr sz="1200" b="0">
+                          <a:solidFill>
+                            <a:srgbClr val="111827"/>
+                          </a:solidFill>
+                          <a:latin typeface="Calibri"/>
+                        </a:defRPr>
+                      </a:pPr>
+                      <a:r>
+                        <a:t>99.98%</a:t>
+                      </a:r>
+                    </a:p>
+                  </a:txBody>
+                  <a:tcPr marT="27432" marB="27432" anchor="ctr">
+                    <a:solidFill>
+                      <a:srgbClr val="FFFFFF"/>
+                    </a:solidFill>
+                  </a:tcPr>
+                </a:tc>
+                <a:tc>
+                  <a:txBody>
+                    <a:bodyPr/>
+                    <a:lstStyle/>
+                    <a:p>
+                      <a:pPr>
+                        <a:defRPr sz="1200" b="0">
+                          <a:solidFill>
+                            <a:srgbClr val="111827"/>
+                          </a:solidFill>
+                          <a:latin typeface="Calibri"/>
+                        </a:defRPr>
+                      </a:pPr>
+                      <a:r>
+                        <a:t>Not described</a:t>
+                      </a:r>
+                    </a:p>
+                  </a:txBody>
+                  <a:tcPr marT="27432" marB="27432" anchor="ctr">
+                    <a:solidFill>
+                      <a:srgbClr val="FFFFFF"/>
+                    </a:solidFill>
+                  </a:tcPr>
+                </a:tc>
+                <a:tc>
+                  <a:txBody>
+                    <a:bodyPr/>
+                    <a:lstStyle/>
+                    <a:p>
+                      <a:pPr>
+                        <a:defRPr sz="1200" b="0">
+                          <a:solidFill>
+                            <a:srgbClr val="111827"/>
+                          </a:solidFill>
+                          <a:latin typeface="Calibri"/>
+                        </a:defRPr>
+                      </a:pPr>
+                      <a:r>
+                        <a:t>Not stated</a:t>
+                      </a:r>
+                    </a:p>
+                  </a:txBody>
+                  <a:tcPr marT="27432" marB="27432" anchor="ctr">
+                    <a:solidFill>
+                      <a:srgbClr val="FFFFFF"/>
+                    </a:solidFill>
+                  </a:tcPr>
+                </a:tc>
+                <a:tc>
+                  <a:txBody>
+                    <a:bodyPr/>
+                    <a:lstStyle/>
+                    <a:p>
+                      <a:pPr>
+                        <a:defRPr sz="1200" b="0">
+                          <a:solidFill>
+                            <a:srgbClr val="B91C1C"/>
+                          </a:solidFill>
+                          <a:latin typeface="Calibri"/>
+                        </a:defRPr>
+                      </a:pPr>
+                      <a:r>
+                        <a:t>Dst Port</a:t>
+                      </a:r>
+                    </a:p>
+                  </a:txBody>
+                  <a:tcPr marT="27432" marB="27432" anchor="ctr">
+                    <a:solidFill>
+                      <a:srgbClr val="FFFFFF"/>
+                    </a:solidFill>
+                  </a:tcPr>
+                </a:tc>
+              </a:tr>
+              <a:tr h="384048">
+                <a:tc>
+                  <a:txBody>
+                    <a:bodyPr/>
+                    <a:lstStyle/>
+                    <a:p>
+                      <a:pPr>
+                        <a:defRPr sz="1200" b="0">
+                          <a:solidFill>
+                            <a:srgbClr val="111827"/>
+                          </a:solidFill>
+                          <a:latin typeface="Calibri"/>
+                        </a:defRPr>
+                      </a:pPr>
+                      <a:r>
+                        <a:t>SDNGuardStack 2026</a:t>
+                      </a:r>
+                    </a:p>
+                  </a:txBody>
+                  <a:tcPr marT="27432" marB="27432" anchor="ctr">
+                    <a:solidFill>
+                      <a:srgbClr val="F3F4F6"/>
+                    </a:solidFill>
+                  </a:tcPr>
+                </a:tc>
+                <a:tc>
+                  <a:txBody>
+                    <a:bodyPr/>
+                    <a:lstStyle/>
+                    <a:p>
+                      <a:pPr>
+                        <a:defRPr sz="1200" b="0">
+                          <a:solidFill>
+                            <a:srgbClr val="111827"/>
+                          </a:solidFill>
+                          <a:latin typeface="Calibri"/>
+                        </a:defRPr>
+                      </a:pPr>
+                      <a:r>
+                        <a:t>99.98%</a:t>
+                      </a:r>
+                    </a:p>
+                  </a:txBody>
+                  <a:tcPr marT="27432" marB="27432" anchor="ctr">
+                    <a:solidFill>
+                      <a:srgbClr val="F3F4F6"/>
+                    </a:solidFill>
+                  </a:tcPr>
+                </a:tc>
+                <a:tc>
+                  <a:txBody>
+                    <a:bodyPr/>
+                    <a:lstStyle/>
+                    <a:p>
+                      <a:pPr>
+                        <a:defRPr sz="1200" b="0">
+                          <a:solidFill>
+                            <a:srgbClr val="111827"/>
+                          </a:solidFill>
+                          <a:latin typeface="Calibri"/>
+                        </a:defRPr>
+                      </a:pPr>
+                      <a:r>
+                        <a:t>80/20</a:t>
+                      </a:r>
+                    </a:p>
+                  </a:txBody>
+                  <a:tcPr marT="27432" marB="27432" anchor="ctr">
+                    <a:solidFill>
+                      <a:srgbClr val="F3F4F6"/>
+                    </a:solidFill>
+                  </a:tcPr>
+                </a:tc>
+                <a:tc>
+                  <a:txBody>
+                    <a:bodyPr/>
+                    <a:lstStyle/>
+                    <a:p>
+                      <a:pPr>
+                        <a:defRPr sz="1200" b="0">
+                          <a:solidFill>
+                            <a:srgbClr val="111827"/>
+                          </a:solidFill>
+                          <a:latin typeface="Calibri"/>
+                        </a:defRPr>
+                      </a:pPr>
+                      <a:r>
+                        <a:t>No</a:t>
+                      </a:r>
+                    </a:p>
+                  </a:txBody>
+                  <a:tcPr marT="27432" marB="27432" anchor="ctr">
+                    <a:solidFill>
+                      <a:srgbClr val="F3F4F6"/>
+                    </a:solidFill>
+                  </a:tcPr>
+                </a:tc>
+                <a:tc>
+                  <a:txBody>
+                    <a:bodyPr/>
+                    <a:lstStyle/>
+                    <a:p>
+                      <a:pPr>
+                        <a:defRPr sz="1200" b="0">
+                          <a:solidFill>
+                            <a:srgbClr val="B91C1C"/>
+                          </a:solidFill>
+                          <a:latin typeface="Calibri"/>
+                        </a:defRPr>
+                      </a:pPr>
+                      <a:r>
+                        <a:t>Flow ID, IPs, ports</a:t>
+                      </a:r>
+                    </a:p>
+                  </a:txBody>
+                  <a:tcPr marT="27432" marB="27432" anchor="ctr">
+                    <a:solidFill>
+                      <a:srgbClr val="F3F4F6"/>
+                    </a:solidFill>
+                  </a:tcPr>
+                </a:tc>
+              </a:tr>
+              <a:tr h="384048">
+                <a:tc>
+                  <a:txBody>
+                    <a:bodyPr/>
+                    <a:lstStyle/>
+                    <a:p>
+                      <a:pPr>
+                        <a:defRPr sz="1200" b="0">
+                          <a:solidFill>
+                            <a:srgbClr val="111827"/>
+                          </a:solidFill>
+                          <a:latin typeface="Calibri"/>
+                        </a:defRPr>
+                      </a:pPr>
+                      <a:r>
+                        <a:t>Malik et al. 2026</a:t>
+                      </a:r>
+                    </a:p>
+                  </a:txBody>
+                  <a:tcPr marT="27432" marB="27432" anchor="ctr">
+                    <a:solidFill>
+                      <a:srgbClr val="FFFFFF"/>
+                    </a:solidFill>
+                  </a:tcPr>
+                </a:tc>
+                <a:tc>
+                  <a:txBody>
+                    <a:bodyPr/>
+                    <a:lstStyle/>
+                    <a:p>
+                      <a:pPr>
+                        <a:defRPr sz="1200" b="0">
+                          <a:solidFill>
+                            <a:srgbClr val="111827"/>
+                          </a:solidFill>
+                          <a:latin typeface="Calibri"/>
+                        </a:defRPr>
+                      </a:pPr>
+                      <a:r>
+                        <a:t>81.60% (CV)</a:t>
+                      </a:r>
+                    </a:p>
+                  </a:txBody>
+                  <a:tcPr marT="27432" marB="27432" anchor="ctr">
+                    <a:solidFill>
+                      <a:srgbClr val="FFFFFF"/>
+                    </a:solidFill>
+                  </a:tcPr>
+                </a:tc>
+                <a:tc>
+                  <a:txBody>
+                    <a:bodyPr/>
+                    <a:lstStyle/>
+                    <a:p>
+                      <a:pPr>
+                        <a:defRPr sz="1200" b="0">
+                          <a:solidFill>
+                            <a:srgbClr val="111827"/>
+                          </a:solidFill>
+                          <a:latin typeface="Calibri"/>
+                        </a:defRPr>
+                      </a:pPr>
+                      <a:r>
+                        <a:t>Stratified 5-fold</a:t>
+                      </a:r>
+                    </a:p>
+                  </a:txBody>
+                  <a:tcPr marT="27432" marB="27432" anchor="ctr">
+                    <a:solidFill>
+                      <a:srgbClr val="FFFFFF"/>
+                    </a:solidFill>
+                  </a:tcPr>
+                </a:tc>
+                <a:tc>
+                  <a:txBody>
+                    <a:bodyPr/>
+                    <a:lstStyle/>
+                    <a:p>
+                      <a:pPr>
+                        <a:defRPr sz="1200" b="0">
+                          <a:solidFill>
+                            <a:srgbClr val="111827"/>
+                          </a:solidFill>
+                          <a:latin typeface="Calibri"/>
+                        </a:defRPr>
+                      </a:pPr>
+                      <a:r>
+                        <a:t>No</a:t>
+                      </a:r>
+                    </a:p>
+                  </a:txBody>
+                  <a:tcPr marT="27432" marB="27432" anchor="ctr">
+                    <a:solidFill>
+                      <a:srgbClr val="FFFFFF"/>
+                    </a:solidFill>
+                  </a:tcPr>
+                </a:tc>
+                <a:tc>
+                  <a:txBody>
+                    <a:bodyPr/>
+                    <a:lstStyle/>
+                    <a:p>
+                      <a:pPr>
+                        <a:defRPr sz="1200" b="0">
+                          <a:solidFill>
+                            <a:srgbClr val="111827"/>
+                          </a:solidFill>
+                          <a:latin typeface="Calibri"/>
+                        </a:defRPr>
+                      </a:pPr>
+                      <a:r>
+                        <a:t>Not stated</a:t>
+                      </a:r>
+                    </a:p>
+                  </a:txBody>
+                  <a:tcPr marT="27432" marB="27432" anchor="ctr">
+                    <a:solidFill>
+                      <a:srgbClr val="FFFFFF"/>
+                    </a:solidFill>
+                  </a:tcPr>
+                </a:tc>
+              </a:tr>
+              <a:tr h="384048">
+                <a:tc>
+                  <a:txBody>
+                    <a:bodyPr/>
+                    <a:lstStyle/>
+                    <a:p>
+                      <a:pPr>
+                        <a:defRPr sz="1200" b="0">
+                          <a:solidFill>
+                            <a:srgbClr val="111827"/>
+                          </a:solidFill>
+                          <a:latin typeface="Calibri"/>
+                        </a:defRPr>
+                      </a:pPr>
+                      <a:r>
+                        <a:t>LightIDS-SDN 2026</a:t>
+                      </a:r>
+                    </a:p>
+                  </a:txBody>
+                  <a:tcPr marT="27432" marB="27432" anchor="ctr">
+                    <a:solidFill>
+                      <a:srgbClr val="F3F4F6"/>
+                    </a:solidFill>
+                  </a:tcPr>
+                </a:tc>
+                <a:tc>
+                  <a:txBody>
+                    <a:bodyPr/>
+                    <a:lstStyle/>
+                    <a:p>
+                      <a:pPr>
+                        <a:defRPr sz="1200" b="0">
+                          <a:solidFill>
+                            <a:srgbClr val="111827"/>
+                          </a:solidFill>
+                          <a:latin typeface="Calibri"/>
+                        </a:defRPr>
+                      </a:pPr>
+                      <a:r>
+                        <a:t>98.73%</a:t>
+                      </a:r>
+                    </a:p>
+                  </a:txBody>
+                  <a:tcPr marT="27432" marB="27432" anchor="ctr">
+                    <a:solidFill>
+                      <a:srgbClr val="F3F4F6"/>
+                    </a:solidFill>
+                  </a:tcPr>
+                </a:tc>
+                <a:tc>
+                  <a:txBody>
+                    <a:bodyPr/>
+                    <a:lstStyle/>
+                    <a:p>
+                      <a:pPr>
+                        <a:defRPr sz="1200" b="0">
+                          <a:solidFill>
+                            <a:srgbClr val="111827"/>
+                          </a:solidFill>
+                          <a:latin typeface="Calibri"/>
+                        </a:defRPr>
+                      </a:pPr>
+                      <a:r>
+                        <a:t>Ratios 60:40 to 90:10</a:t>
+                      </a:r>
+                    </a:p>
+                  </a:txBody>
+                  <a:tcPr marT="27432" marB="27432" anchor="ctr">
+                    <a:solidFill>
+                      <a:srgbClr val="F3F4F6"/>
+                    </a:solidFill>
+                  </a:tcPr>
+                </a:tc>
+                <a:tc>
+                  <a:txBody>
+                    <a:bodyPr/>
+                    <a:lstStyle/>
+                    <a:p>
+                      <a:pPr>
+                        <a:defRPr sz="1200" b="0">
+                          <a:solidFill>
+                            <a:srgbClr val="111827"/>
+                          </a:solidFill>
+                          <a:latin typeface="Calibri"/>
+                        </a:defRPr>
+                      </a:pPr>
+                      <a:r>
+                        <a:t>No</a:t>
+                      </a:r>
+                    </a:p>
+                  </a:txBody>
+                  <a:tcPr marT="27432" marB="27432" anchor="ctr">
+                    <a:solidFill>
+                      <a:srgbClr val="F3F4F6"/>
+                    </a:solidFill>
+                  </a:tcPr>
+                </a:tc>
+                <a:tc>
+                  <a:txBody>
+                    <a:bodyPr/>
+                    <a:lstStyle/>
+                    <a:p>
+                      <a:pPr>
+                        <a:defRPr sz="1200" b="0">
+                          <a:solidFill>
+                            <a:srgbClr val="111827"/>
+                          </a:solidFill>
+                          <a:latin typeface="Calibri"/>
+                        </a:defRPr>
+                      </a:pPr>
+                      <a:r>
+                        <a:t>Not stated</a:t>
+                      </a:r>
+                    </a:p>
+                  </a:txBody>
+                  <a:tcPr marT="27432" marB="27432" anchor="ctr">
+                    <a:solidFill>
+                      <a:srgbClr val="F3F4F6"/>
+                    </a:solidFill>
+                  </a:tcPr>
+                </a:tc>
+              </a:tr>
+              <a:tr h="384048">
+                <a:tc>
+                  <a:txBody>
+                    <a:bodyPr/>
+                    <a:lstStyle/>
+                    <a:p>
+                      <a:pPr>
+                        <a:defRPr sz="1200" b="0">
+                          <a:solidFill>
+                            <a:srgbClr val="111827"/>
+                          </a:solidFill>
+                          <a:latin typeface="Calibri"/>
+                        </a:defRPr>
+                      </a:pPr>
+                      <a:r>
+                        <a:t>SICA 2026</a:t>
+                      </a:r>
+                    </a:p>
+                  </a:txBody>
+                  <a:tcPr marT="27432" marB="27432" anchor="ctr">
+                    <a:solidFill>
+                      <a:srgbClr val="FFFFFF"/>
+                    </a:solidFill>
+                  </a:tcPr>
+                </a:tc>
+                <a:tc>
+                  <a:txBody>
+                    <a:bodyPr/>
+                    <a:lstStyle/>
+                    <a:p>
+                      <a:pPr>
+                        <a:defRPr sz="1200" b="0">
+                          <a:solidFill>
+                            <a:srgbClr val="111827"/>
+                          </a:solidFill>
+                          <a:latin typeface="Calibri"/>
+                        </a:defRPr>
+                      </a:pPr>
+                      <a:r>
+                        <a:t>99.61%</a:t>
+                      </a:r>
+                    </a:p>
+                  </a:txBody>
+                  <a:tcPr marT="27432" marB="27432" anchor="ctr">
+                    <a:solidFill>
+                      <a:srgbClr val="FFFFFF"/>
+                    </a:solidFill>
+                  </a:tcPr>
+                </a:tc>
+                <a:tc>
+                  <a:txBody>
+                    <a:bodyPr/>
+                    <a:lstStyle/>
+                    <a:p>
+                      <a:pPr>
+                        <a:defRPr sz="1200" b="0">
+                          <a:solidFill>
+                            <a:srgbClr val="111827"/>
+                          </a:solidFill>
+                          <a:latin typeface="Calibri"/>
+                        </a:defRPr>
+                      </a:pPr>
+                      <a:r>
+                        <a:t>70/20/10</a:t>
+                      </a:r>
+                    </a:p>
+                  </a:txBody>
+                  <a:tcPr marT="27432" marB="27432" anchor="ctr">
+                    <a:solidFill>
+                      <a:srgbClr val="FFFFFF"/>
+                    </a:solidFill>
+                  </a:tcPr>
+                </a:tc>
+                <a:tc>
+                  <a:txBody>
+                    <a:bodyPr/>
+                    <a:lstStyle/>
+                    <a:p>
+                      <a:pPr>
+                        <a:defRPr sz="1200" b="0">
+                          <a:solidFill>
+                            <a:srgbClr val="111827"/>
+                          </a:solidFill>
+                          <a:latin typeface="Calibri"/>
+                        </a:defRPr>
+                      </a:pPr>
+                      <a:r>
+                        <a:t>No</a:t>
+                      </a:r>
+                    </a:p>
+                  </a:txBody>
+                  <a:tcPr marT="27432" marB="27432" anchor="ctr">
+                    <a:solidFill>
+                      <a:srgbClr val="FFFFFF"/>
+                    </a:solidFill>
+                  </a:tcPr>
+                </a:tc>
+                <a:tc>
+                  <a:txBody>
+                    <a:bodyPr/>
+                    <a:lstStyle/>
+                    <a:p>
+                      <a:pPr>
+                        <a:defRPr sz="1200" b="0">
+                          <a:solidFill>
+                            <a:srgbClr val="111827"/>
+                          </a:solidFill>
+                          <a:latin typeface="Calibri"/>
+                        </a:defRPr>
+                      </a:pPr>
+                      <a:r>
+                        <a:t>No (stated)</a:t>
+                      </a:r>
+                    </a:p>
+                  </a:txBody>
+                  <a:tcPr marT="27432" marB="27432" anchor="ctr">
+                    <a:solidFill>
+                      <a:srgbClr val="FFFFFF"/>
+                    </a:solidFill>
+                  </a:tcPr>
+                </a:tc>
+              </a:tr>
+            </a:tbl>
+          </a:graphicData>
+        </a:graphic>
+      </p:graphicFrame>
+      <p:sp>
+        <p:nvSpPr>
+          <p:cNvPr id="7" name="TextBox 6"/>
           <p:cNvSpPr txBox="1"/>
           <p:nvPr/>
         </p:nvSpPr>
         <p:spPr>
           <a:xfrm>
-            <a:off x="548640" y="1828800"/>
-            <a:ext cx="11064240" cy="4114800"/>
+            <a:off x="548640" y="5486400"/>
+            <a:ext cx="11064240" cy="822960"/>
           </a:xfrm>
           <a:prstGeom prst="rect">
             <a:avLst/>
@@ -6797,98 +8051,15 @@
           <a:lstStyle/>
           <a:p>
             <a:pPr>
-              <a:spcAft>
-                <a:spcPts val="1400"/>
-              </a:spcAft>
-              <a:defRPr sz="1800">
-                <a:solidFill>
-                  <a:srgbClr val="111827"/>
-                </a:solidFill>
-                <a:latin typeface="Calibri"/>
-              </a:defRPr>
-            </a:pPr>
-            <a:r>
-              <a:t>One dataset (InSDN) and one recorded controller (ONOS); Ryu is checked only on our own benign traffic.</a:t>
-            </a:r>
-          </a:p>
-          <a:p>
-            <a:pPr>
-              <a:spcAft>
-                <a:spcPts val="1400"/>
-              </a:spcAft>
-              <a:defRPr sz="1800">
-                <a:solidFill>
-                  <a:srgbClr val="111827"/>
-                </a:solidFill>
-                <a:latin typeface="Calibri"/>
-              </a:defRPr>
-            </a:pPr>
-            <a:r>
-              <a:t>We generated no attack traffic; benign and attack are never interleaved in one session.</a:t>
-            </a:r>
-          </a:p>
-          <a:p>
-            <a:pPr>
-              <a:spcAft>
-                <a:spcPts val="1400"/>
-              </a:spcAft>
-              <a:defRPr sz="1800">
-                <a:solidFill>
-                  <a:srgbClr val="111827"/>
-                </a:solidFill>
-                <a:latin typeface="Calibri"/>
-              </a:defRPr>
-            </a:pPr>
-            <a:r>
-              <a:t>Labels cover only part of the controller-visible traffic, so session identity and unlisted attacks cannot be separated.</a:t>
-            </a:r>
-          </a:p>
-          <a:p>
-            <a:pPr>
-              <a:spcAft>
-                <a:spcPts val="1400"/>
-              </a:spcAft>
-              <a:defRPr sz="1800">
-                <a:solidFill>
-                  <a:srgbClr val="111827"/>
-                </a:solidFill>
-                <a:latin typeface="Calibri"/>
-              </a:defRPr>
-            </a:pPr>
-            <a:r>
-              <a:t>Only one of the four published papers checked was read in full; the others are unverified and not counted.</a:t>
-            </a:r>
-          </a:p>
-          <a:p>
-            <a:pPr>
-              <a:spcAft>
-                <a:spcPts val="1400"/>
-              </a:spcAft>
-              <a:defRPr sz="1800">
-                <a:solidFill>
-                  <a:srgbClr val="111827"/>
-                </a:solidFill>
-                <a:latin typeface="Calibri"/>
-              </a:defRPr>
-            </a:pPr>
-            <a:r>
-              <a:t>Phase 1 figures come from archived studies and are not re-run here.</a:t>
-            </a:r>
-          </a:p>
-          <a:p>
-            <a:pPr>
-              <a:spcAft>
-                <a:spcPts val="1400"/>
-              </a:spcAft>
-              <a:defRPr sz="1800">
-                <a:solidFill>
-                  <a:srgbClr val="111827"/>
-                </a:solidFill>
-                <a:latin typeface="Calibri"/>
-              </a:defRPr>
-            </a:pPr>
-            <a:r>
-              <a:t>Our literature searches (October 2026) are evidence, not proof, that nothing similar exists.</a:t>
+              <a:defRPr sz="1300" b="0">
+                <a:solidFill>
+                  <a:srgbClr val="6B7280"/>
+                </a:solidFill>
+                <a:latin typeface="Calibri"/>
+              </a:defRPr>
+            </a:pPr>
+            <a:r>
+              <a:t>10 of 12 papers read in full; the 2 unread ones are not characterised. Table: the 9 read papers that use InSDN (one more read paper is not on InSDN). Numbers are the authors' own, not re-run. None groups by host; none evaluates a real controller.</a:t>
             </a:r>
           </a:p>
         </p:txBody>
@@ -6950,7 +8121,7 @@
               </a:defRPr>
             </a:pPr>
             <a:r>
-              <a:t>CLOSE</a:t>
+              <a:t>HONEST SCOPE</a:t>
             </a:r>
           </a:p>
         </p:txBody>
@@ -6986,7 +8157,7 @@
               </a:defRPr>
             </a:pPr>
             <a:r>
-              <a:t>Scope and takeaways</a:t>
+              <a:t>Limitations we state ourselves</a:t>
             </a:r>
           </a:p>
         </p:txBody>
@@ -7071,8 +8242,8 @@
         </p:nvSpPr>
         <p:spPr>
           <a:xfrm>
-            <a:off x="548640" y="1737360"/>
-            <a:ext cx="3474720" cy="457200"/>
+            <a:off x="548640" y="1828800"/>
+            <a:ext cx="11064240" cy="4114800"/>
           </a:xfrm>
           <a:prstGeom prst="rect">
             <a:avLst/>
@@ -7086,29 +8257,154 @@
           <a:lstStyle/>
           <a:p>
             <a:pPr>
-              <a:defRPr sz="2200" b="1">
-                <a:solidFill>
-                  <a:srgbClr val="6B7280"/>
-                </a:solidFill>
-                <a:latin typeface="Calibri"/>
-              </a:defRPr>
-            </a:pPr>
-            <a:r>
-              <a:t>Not new</a:t>
-            </a:r>
-          </a:p>
-        </p:txBody>
-      </p:sp>
-      <p:sp>
-        <p:nvSpPr>
-          <p:cNvPr id="7" name="TextBox 6"/>
+              <a:spcAft>
+                <a:spcPts val="1400"/>
+              </a:spcAft>
+              <a:defRPr sz="1800">
+                <a:solidFill>
+                  <a:srgbClr val="111827"/>
+                </a:solidFill>
+                <a:latin typeface="Calibri"/>
+              </a:defRPr>
+            </a:pPr>
+            <a:r>
+              <a:t>Controller study: one dataset (InSDN) and one recorded controller (ONOS); Ryu is checked only on our own benign traffic.</a:t>
+            </a:r>
+          </a:p>
+          <a:p>
+            <a:pPr>
+              <a:spcAft>
+                <a:spcPts val="1400"/>
+              </a:spcAft>
+              <a:defRPr sz="1800">
+                <a:solidFill>
+                  <a:srgbClr val="111827"/>
+                </a:solidFill>
+                <a:latin typeface="Calibri"/>
+              </a:defRPr>
+            </a:pPr>
+            <a:r>
+              <a:t>We generated no attack traffic; benign and attack are never interleaved in one session.</a:t>
+            </a:r>
+          </a:p>
+          <a:p>
+            <a:pPr>
+              <a:spcAft>
+                <a:spcPts val="1400"/>
+              </a:spcAft>
+              <a:defRPr sz="1800">
+                <a:solidFill>
+                  <a:srgbClr val="111827"/>
+                </a:solidFill>
+                <a:latin typeface="Calibri"/>
+              </a:defRPr>
+            </a:pPr>
+            <a:r>
+              <a:t>Labels cover only part of the controller-visible traffic, so session identity and unlisted attacks cannot be separated.</a:t>
+            </a:r>
+          </a:p>
+          <a:p>
+            <a:pPr>
+              <a:spcAft>
+                <a:spcPts val="1400"/>
+              </a:spcAft>
+              <a:defRPr sz="1800">
+                <a:solidFill>
+                  <a:srgbClr val="111827"/>
+                </a:solidFill>
+                <a:latin typeface="Calibri"/>
+              </a:defRPr>
+            </a:pPr>
+            <a:r>
+              <a:t>Literature check: 10 of 12 papers read in full; the rest are not characterised. Reported numbers are the authors' own.</a:t>
+            </a:r>
+          </a:p>
+          <a:p>
+            <a:pPr>
+              <a:spcAft>
+                <a:spcPts val="1400"/>
+              </a:spcAft>
+              <a:defRPr sz="1800">
+                <a:solidFill>
+                  <a:srgbClr val="111827"/>
+                </a:solidFill>
+                <a:latin typeface="Calibri"/>
+              </a:defRPr>
+            </a:pPr>
+            <a:r>
+              <a:t>The split audit covers two datasets, one model family (XGBoost) and binary labels; UKMDDoSDN has no benign class and was unusable.</a:t>
+            </a:r>
+          </a:p>
+          <a:p>
+            <a:pPr>
+              <a:spcAft>
+                <a:spcPts val="1400"/>
+              </a:spcAft>
+              <a:defRPr sz="1800">
+                <a:solidFill>
+                  <a:srgbClr val="111827"/>
+                </a:solidFill>
+                <a:latin typeface="Calibri"/>
+              </a:defRPr>
+            </a:pPr>
+            <a:r>
+              <a:t>Phase 1 figures come from archived studies and are not re-run here.</a:t>
+            </a:r>
+          </a:p>
+          <a:p>
+            <a:pPr>
+              <a:spcAft>
+                <a:spcPts val="1400"/>
+              </a:spcAft>
+              <a:defRPr sz="1800">
+                <a:solidFill>
+                  <a:srgbClr val="111827"/>
+                </a:solidFill>
+                <a:latin typeface="Calibri"/>
+              </a:defRPr>
+            </a:pPr>
+            <a:r>
+              <a:t>Our literature search (October 2026) is evidence, not proof, that no one has measured this on an SDN dataset.</a:t>
+            </a:r>
+          </a:p>
+        </p:txBody>
+      </p:sp>
+    </p:spTree>
+  </p:cSld>
+  <p:clrMapOvr>
+    <a:masterClrMapping/>
+  </p:clrMapOvr>
+</p:sld>
+</file>
+
+<file path=ppt/slides/slide16.xml><?xml version="1.0" encoding="utf-8"?>
+<p:sld xmlns:a="http://schemas.openxmlformats.org/drawingml/2006/main" xmlns:p="http://schemas.openxmlformats.org/presentationml/2006/main" xmlns:r="http://schemas.openxmlformats.org/officeDocument/2006/relationships">
+  <p:cSld>
+    <p:bg>
+      <p:bgPr>
+        <a:solidFill>
+          <a:srgbClr val="FFFFFF"/>
+        </a:solidFill>
+        <a:effectLst/>
+      </p:bgPr>
+    </p:bg>
+    <p:spTree>
+      <p:nvGrpSpPr>
+        <p:cNvPr id="1" name=""/>
+        <p:cNvGrpSpPr/>
+        <p:nvPr/>
+      </p:nvGrpSpPr>
+      <p:grpSpPr/>
+      <p:sp>
+        <p:nvSpPr>
+          <p:cNvPr id="2" name="TextBox 1"/>
           <p:cNvSpPr txBox="1"/>
           <p:nvPr/>
         </p:nvSpPr>
         <p:spPr>
           <a:xfrm>
-            <a:off x="548640" y="2377440"/>
-            <a:ext cx="3474720" cy="4114800"/>
+            <a:off x="548640" y="365760"/>
+            <a:ext cx="8229600" cy="274320"/>
           </a:xfrm>
           <a:prstGeom prst="rect">
             <a:avLst/>
@@ -7122,10 +8418,190 @@
           <a:lstStyle/>
           <a:p>
             <a:pPr>
+              <a:defRPr sz="1200" b="1">
+                <a:solidFill>
+                  <a:srgbClr val="0F766E"/>
+                </a:solidFill>
+                <a:latin typeface="Calibri"/>
+              </a:defRPr>
+            </a:pPr>
+            <a:r>
+              <a:t>NOVELTY AND SCOPE</a:t>
+            </a:r>
+          </a:p>
+        </p:txBody>
+      </p:sp>
+      <p:sp>
+        <p:nvSpPr>
+          <p:cNvPr id="3" name="TextBox 2"/>
+          <p:cNvSpPr txBox="1"/>
+          <p:nvPr/>
+        </p:nvSpPr>
+        <p:spPr>
+          <a:xfrm>
+            <a:off x="548640" y="658368"/>
+            <a:ext cx="11064240" cy="822960"/>
+          </a:xfrm>
+          <a:prstGeom prst="rect">
+            <a:avLst/>
+          </a:prstGeom>
+          <a:noFill/>
+        </p:spPr>
+        <p:txBody>
+          <a:bodyPr wrap="square" lIns="0" rIns="0" tIns="0" bIns="0">
+            <a:spAutoFit/>
+          </a:bodyPr>
+          <a:lstStyle/>
+          <a:p>
+            <a:pPr>
+              <a:defRPr sz="2800" b="1">
+                <a:solidFill>
+                  <a:srgbClr val="111827"/>
+                </a:solidFill>
+                <a:latin typeface="Calibri"/>
+              </a:defRPr>
+            </a:pPr>
+            <a:r>
+              <a:t>Contributions: what is new and what is known</a:t>
+            </a:r>
+          </a:p>
+        </p:txBody>
+      </p:sp>
+      <p:sp>
+        <p:nvSpPr>
+          <p:cNvPr id="4" name="TextBox 3"/>
+          <p:cNvSpPr txBox="1"/>
+          <p:nvPr/>
+        </p:nvSpPr>
+        <p:spPr>
+          <a:xfrm>
+            <a:off x="548640" y="6446520"/>
+            <a:ext cx="7315200" cy="228600"/>
+          </a:xfrm>
+          <a:prstGeom prst="rect">
+            <a:avLst/>
+          </a:prstGeom>
+          <a:noFill/>
+        </p:spPr>
+        <p:txBody>
+          <a:bodyPr wrap="square" lIns="0" rIns="0" tIns="0" bIns="0">
+            <a:spAutoFit/>
+          </a:bodyPr>
+          <a:lstStyle/>
+          <a:p>
+            <a:pPr>
+              <a:defRPr sz="1000" b="0">
+                <a:solidFill>
+                  <a:srgbClr val="6B7280"/>
+                </a:solidFill>
+                <a:latin typeface="Calibri"/>
+              </a:defRPr>
+            </a:pPr>
+            <a:r>
+              <a:t>Proteus · What an SDN controller can observe</a:t>
+            </a:r>
+          </a:p>
+        </p:txBody>
+      </p:sp>
+      <p:sp>
+        <p:nvSpPr>
+          <p:cNvPr id="5" name="TextBox 4"/>
+          <p:cNvSpPr txBox="1"/>
+          <p:nvPr/>
+        </p:nvSpPr>
+        <p:spPr>
+          <a:xfrm>
+            <a:off x="10972800" y="6446520"/>
+            <a:ext cx="667512" cy="228600"/>
+          </a:xfrm>
+          <a:prstGeom prst="rect">
+            <a:avLst/>
+          </a:prstGeom>
+          <a:noFill/>
+        </p:spPr>
+        <p:txBody>
+          <a:bodyPr wrap="square" lIns="0" rIns="0" tIns="0" bIns="0">
+            <a:spAutoFit/>
+          </a:bodyPr>
+          <a:lstStyle/>
+          <a:p>
+            <a:pPr algn="r">
+              <a:defRPr sz="1000" b="0">
+                <a:solidFill>
+                  <a:srgbClr val="6B7280"/>
+                </a:solidFill>
+                <a:latin typeface="Calibri"/>
+              </a:defRPr>
+            </a:pPr>
+            <a:r>
+              <a:t>16</a:t>
+            </a:r>
+          </a:p>
+        </p:txBody>
+      </p:sp>
+      <p:sp>
+        <p:nvSpPr>
+          <p:cNvPr id="6" name="TextBox 5"/>
+          <p:cNvSpPr txBox="1"/>
+          <p:nvPr/>
+        </p:nvSpPr>
+        <p:spPr>
+          <a:xfrm>
+            <a:off x="548640" y="1737360"/>
+            <a:ext cx="2651760" cy="457200"/>
+          </a:xfrm>
+          <a:prstGeom prst="rect">
+            <a:avLst/>
+          </a:prstGeom>
+          <a:noFill/>
+        </p:spPr>
+        <p:txBody>
+          <a:bodyPr wrap="square" lIns="0" rIns="0" tIns="0" bIns="0">
+            <a:spAutoFit/>
+          </a:bodyPr>
+          <a:lstStyle/>
+          <a:p>
+            <a:pPr>
+              <a:defRPr sz="2000" b="1">
+                <a:solidFill>
+                  <a:srgbClr val="6B7280"/>
+                </a:solidFill>
+                <a:latin typeface="Calibri"/>
+              </a:defRPr>
+            </a:pPr>
+            <a:r>
+              <a:t>Already known</a:t>
+            </a:r>
+          </a:p>
+        </p:txBody>
+      </p:sp>
+      <p:sp>
+        <p:nvSpPr>
+          <p:cNvPr id="7" name="TextBox 6"/>
+          <p:cNvSpPr txBox="1"/>
+          <p:nvPr/>
+        </p:nvSpPr>
+        <p:spPr>
+          <a:xfrm>
+            <a:off x="548640" y="2377440"/>
+            <a:ext cx="2606040" cy="4114800"/>
+          </a:xfrm>
+          <a:prstGeom prst="rect">
+            <a:avLst/>
+          </a:prstGeom>
+          <a:noFill/>
+        </p:spPr>
+        <p:txBody>
+          <a:bodyPr wrap="square" lIns="0" rIns="0" tIns="0" bIns="0">
+            <a:spAutoFit/>
+          </a:bodyPr>
+          <a:lstStyle/>
+          <a:p>
+            <a:pPr>
               <a:spcAft>
                 <a:spcPts val="1200"/>
               </a:spcAft>
-              <a:defRPr sz="1500">
+              <a:defRPr sz="1400">
                 <a:solidFill>
                   <a:srgbClr val="111827"/>
                 </a:solidFill>
@@ -7133,7 +8609,7 @@
               </a:defRPr>
             </a:pPr>
             <a:r>
-              <a:t>Control-plane telemetry for SDN IDS exists (LAN-SDN-NIDS, SDNFLow)</a:t>
+              <a:t>Identifier columns are shortcut features (Engelen 2021)</a:t>
             </a:r>
           </a:p>
           <a:p>
@@ -7141,7 +8617,7 @@
               <a:spcAft>
                 <a:spcPts val="1200"/>
               </a:spcAft>
-              <a:defRPr sz="1500">
+              <a:defRPr sz="1400">
                 <a:solidFill>
                   <a:srgbClr val="111827"/>
                 </a:solidFill>
@@ -7149,7 +8625,7 @@
               </a:defRPr>
             </a:pPr>
             <a:r>
-              <a:t>The detector itself</a:t>
+              <a:t>Random splits leak on NIDS data (Flood 2024)</a:t>
             </a:r>
           </a:p>
           <a:p>
@@ -7157,7 +8633,7 @@
               <a:spcAft>
                 <a:spcPts val="1200"/>
               </a:spcAft>
-              <a:defRPr sz="1500">
+              <a:defRPr sz="1400">
                 <a:solidFill>
                   <a:srgbClr val="111827"/>
                 </a:solidFill>
@@ -7165,7 +8641,7 @@
               </a:defRPr>
             </a:pPr>
             <a:r>
-              <a:t>Stock Ryu behaviour follows from its code</a:t>
+              <a:t>Control-plane telemetry for SDN IDS (LAN-SDN-NIDS, SDNFLow)</a:t>
             </a:r>
           </a:p>
         </p:txBody>
@@ -7178,8 +8654,8 @@
         </p:nvSpPr>
         <p:spPr>
           <a:xfrm>
-            <a:off x="4343400" y="1737360"/>
-            <a:ext cx="3474720" cy="457200"/>
+            <a:off x="3383280" y="1737360"/>
+            <a:ext cx="2651760" cy="457200"/>
           </a:xfrm>
           <a:prstGeom prst="rect">
             <a:avLst/>
@@ -7193,15 +8669,15 @@
           <a:lstStyle/>
           <a:p>
             <a:pPr>
-              <a:defRPr sz="2200" b="1">
-                <a:solidFill>
-                  <a:srgbClr val="B91C1C"/>
-                </a:solidFill>
-                <a:latin typeface="Calibri"/>
-              </a:defRPr>
-            </a:pPr>
-            <a:r>
-              <a:t>Next</a:t>
+              <a:defRPr sz="2000" b="1">
+                <a:solidFill>
+                  <a:srgbClr val="0F766E"/>
+                </a:solidFill>
+                <a:latin typeface="Calibri"/>
+              </a:defRPr>
+            </a:pPr>
+            <a:r>
+              <a:t>New here</a:t>
             </a:r>
           </a:p>
         </p:txBody>
@@ -7214,8 +8690,8 @@
         </p:nvSpPr>
         <p:spPr>
           <a:xfrm>
-            <a:off x="4343400" y="2377440"/>
-            <a:ext cx="3474720" cy="4114800"/>
+            <a:off x="3383280" y="2377440"/>
+            <a:ext cx="2606040" cy="4114800"/>
           </a:xfrm>
           <a:prstGeom prst="rect">
             <a:avLst/>
@@ -7232,7 +8708,7 @@
               <a:spcAft>
                 <a:spcPts val="1200"/>
               </a:spcAft>
-              <a:defRPr sz="1500">
+              <a:defRPr sz="1400">
                 <a:solidFill>
                   <a:srgbClr val="111827"/>
                 </a:solidFill>
@@ -7240,7 +8716,7 @@
               </a:defRPr>
             </a:pPr>
             <a:r>
-              <a:t>Interleave benign and attack traffic in one session</a:t>
+              <a:t>Paired random vs host-held-out gap on InSDN and CICIDS2017, 10 seeds, CIs</a:t>
             </a:r>
           </a:p>
           <a:p>
@@ -7248,7 +8724,7 @@
               <a:spcAft>
                 <a:spcPts val="1200"/>
               </a:spcAft>
-              <a:defRPr sz="1500">
+              <a:defRPr sz="1400">
                 <a:solidFill>
                   <a:srgbClr val="111827"/>
                 </a:solidFill>
@@ -7256,7 +8732,7 @@
               </a:defRPr>
             </a:pPr>
             <a:r>
-              <a:t>A second dataset or controller family</a:t>
+              <a:t>Audit of 9 published InSDN papers: none groups by host, none uses a real controller</a:t>
             </a:r>
           </a:p>
           <a:p>
@@ -7264,7 +8740,7 @@
               <a:spcAft>
                 <a:spcPts val="1200"/>
               </a:spcAft>
-              <a:defRPr sz="1500">
+              <a:defRPr sz="1400">
                 <a:solidFill>
                   <a:srgbClr val="111827"/>
                 </a:solidFill>
@@ -7272,7 +8748,7 @@
               </a:defRPr>
             </a:pPr>
             <a:r>
-              <a:t>Audit published papers under a preregistered protocol</a:t>
+              <a:t>Controller-telemetry gap: 0 FlowMods with IPs or ports</a:t>
             </a:r>
           </a:p>
         </p:txBody>
@@ -7285,8 +8761,8 @@
         </p:nvSpPr>
         <p:spPr>
           <a:xfrm>
-            <a:off x="8138160" y="1737360"/>
-            <a:ext cx="3474720" cy="457200"/>
+            <a:off x="6217920" y="1737360"/>
+            <a:ext cx="2651760" cy="457200"/>
           </a:xfrm>
           <a:prstGeom prst="rect">
             <a:avLst/>
@@ -7300,15 +8776,15 @@
           <a:lstStyle/>
           <a:p>
             <a:pPr>
-              <a:defRPr sz="2200" b="1">
-                <a:solidFill>
-                  <a:srgbClr val="0F766E"/>
-                </a:solidFill>
-                <a:latin typeface="Calibri"/>
-              </a:defRPr>
-            </a:pPr>
-            <a:r>
-              <a:t>Takeaways</a:t>
+              <a:defRPr sz="2000" b="1">
+                <a:solidFill>
+                  <a:srgbClr val="B91C1C"/>
+                </a:solidFill>
+                <a:latin typeface="Calibri"/>
+              </a:defRPr>
+            </a:pPr>
+            <a:r>
+              <a:t>Not done</a:t>
             </a:r>
           </a:p>
         </p:txBody>
@@ -7321,8 +8797,8 @@
         </p:nvSpPr>
         <p:spPr>
           <a:xfrm>
-            <a:off x="8138160" y="2377440"/>
-            <a:ext cx="3474720" cy="4114800"/>
+            <a:off x="6217920" y="2377440"/>
+            <a:ext cx="2606040" cy="4114800"/>
           </a:xfrm>
           <a:prstGeom prst="rect">
             <a:avLst/>
@@ -7339,7 +8815,7 @@
               <a:spcAft>
                 <a:spcPts val="1200"/>
               </a:spcAft>
-              <a:defRPr sz="1500">
+              <a:defRPr sz="1400">
                 <a:solidFill>
                   <a:srgbClr val="111827"/>
                 </a:solidFill>
@@ -7347,7 +8823,7 @@
               </a:defRPr>
             </a:pPr>
             <a:r>
-              <a:t>The controller never saw the labelled 5-tuples</a:t>
+              <a:t>Interleaved benign and attack traffic in one session</a:t>
             </a:r>
           </a:p>
           <a:p>
@@ -7355,7 +8831,7 @@
               <a:spcAft>
                 <a:spcPts val="1200"/>
               </a:spcAft>
-              <a:defRPr sz="1500">
+              <a:defRPr sz="1400">
                 <a:solidFill>
                   <a:srgbClr val="111827"/>
                 </a:solidFill>
@@ -7363,7 +8839,7 @@
               </a:defRPr>
             </a:pPr>
             <a:r>
-              <a:t>What it sees depends on the forwarding app</a:t>
+              <a:t>A second SDN dataset or controller family</a:t>
             </a:r>
           </a:p>
           <a:p>
@@ -7371,7 +8847,114 @@
               <a:spcAft>
                 <a:spcPts val="1200"/>
               </a:spcAft>
-              <a:defRPr sz="1500">
+              <a:defRPr sz="1400">
+                <a:solidFill>
+                  <a:srgbClr val="111827"/>
+                </a:solidFill>
+                <a:latin typeface="Calibri"/>
+              </a:defRPr>
+            </a:pPr>
+            <a:r>
+              <a:t>Unread InSDN papers not characterised</a:t>
+            </a:r>
+          </a:p>
+        </p:txBody>
+      </p:sp>
+      <p:sp>
+        <p:nvSpPr>
+          <p:cNvPr id="12" name="TextBox 11"/>
+          <p:cNvSpPr txBox="1"/>
+          <p:nvPr/>
+        </p:nvSpPr>
+        <p:spPr>
+          <a:xfrm>
+            <a:off x="9052560" y="1737360"/>
+            <a:ext cx="2651760" cy="457200"/>
+          </a:xfrm>
+          <a:prstGeom prst="rect">
+            <a:avLst/>
+          </a:prstGeom>
+          <a:noFill/>
+        </p:spPr>
+        <p:txBody>
+          <a:bodyPr wrap="square" lIns="0" rIns="0" tIns="0" bIns="0">
+            <a:spAutoFit/>
+          </a:bodyPr>
+          <a:lstStyle/>
+          <a:p>
+            <a:pPr>
+              <a:defRPr sz="2000" b="1">
+                <a:solidFill>
+                  <a:srgbClr val="111827"/>
+                </a:solidFill>
+                <a:latin typeface="Calibri"/>
+              </a:defRPr>
+            </a:pPr>
+            <a:r>
+              <a:t>Takeaways</a:t>
+            </a:r>
+          </a:p>
+        </p:txBody>
+      </p:sp>
+      <p:sp>
+        <p:nvSpPr>
+          <p:cNvPr id="13" name="TextBox 12"/>
+          <p:cNvSpPr txBox="1"/>
+          <p:nvPr/>
+        </p:nvSpPr>
+        <p:spPr>
+          <a:xfrm>
+            <a:off x="9052560" y="2377440"/>
+            <a:ext cx="2606040" cy="4114800"/>
+          </a:xfrm>
+          <a:prstGeom prst="rect">
+            <a:avLst/>
+          </a:prstGeom>
+          <a:noFill/>
+        </p:spPr>
+        <p:txBody>
+          <a:bodyPr wrap="square" lIns="0" rIns="0" tIns="0" bIns="0">
+            <a:spAutoFit/>
+          </a:bodyPr>
+          <a:lstStyle/>
+          <a:p>
+            <a:pPr>
+              <a:spcAft>
+                <a:spcPts val="1200"/>
+              </a:spcAft>
+              <a:defRPr sz="1400">
+                <a:solidFill>
+                  <a:srgbClr val="111827"/>
+                </a:solidFill>
+                <a:latin typeface="Calibri"/>
+              </a:defRPr>
+            </a:pPr>
+            <a:r>
+              <a:t>Random-split scores on InSDN do not measure detection</a:t>
+            </a:r>
+          </a:p>
+          <a:p>
+            <a:pPr>
+              <a:spcAft>
+                <a:spcPts val="1200"/>
+              </a:spcAft>
+              <a:defRPr sz="1400">
+                <a:solidFill>
+                  <a:srgbClr val="111827"/>
+                </a:solidFill>
+                <a:latin typeface="Calibri"/>
+              </a:defRPr>
+            </a:pPr>
+            <a:r>
+              <a:t>What a controller sees depends on the forwarding app</a:t>
+            </a:r>
+          </a:p>
+          <a:p>
+            <a:pPr>
+              <a:spcAft>
+                <a:spcPts val="1200"/>
+              </a:spcAft>
+              <a:defRPr sz="1400">
                 <a:solidFill>
                   <a:srgbClr val="111827"/>
                 </a:solidFill>
@@ -10062,7 +11645,7 @@
               </a:defRPr>
             </a:pPr>
             <a:r>
-              <a:t>Next</a:t>
+              <a:t>Then</a:t>
             </a:r>
           </a:p>
         </p:txBody>
@@ -10098,7 +11681,7 @@
               </a:defRPr>
             </a:pPr>
             <a:r>
-              <a:t>Run the same checks on published papers under a preregistered protocol</a:t>
+              <a:t>Split audit on InSDN and CICIDS2017, and a full read of 10 papers, 9 on InSDN (slides 13 to 14)</a:t>
             </a:r>
           </a:p>
         </p:txBody>

</xml_diff>

<commit_message>
Deck: published feature recipes slide and contributions bullet (17 slides)
</commit_message>
<xml_diff>
--- a/research/insdn_controller/PRESENTATION.pptx
+++ b/research/insdn_controller/PRESENTATION.pptx
@@ -21,6 +21,7 @@
     <p:sldId id="269" r:id="rId20"/>
     <p:sldId id="270" r:id="rId21"/>
     <p:sldId id="271" r:id="rId22"/>
+    <p:sldId id="272" r:id="rId23"/>
   </p:sldIdLst>
   <p:sldSz cx="12191695" cy="6858000" type="screen4x3"/>
   <p:notesSz cx="6858000" cy="9144000"/>
@@ -1775,6 +1776,250 @@
         </c:ser>
         <c:dLbls>
           <c:numFmt formatCode="0.000" sourceLinked="0"/>
+          <c:txPr>
+            <a:bodyPr/>
+            <a:lstStyle/>
+            <a:p>
+              <a:pPr>
+                <a:defRPr sz="1300">
+                  <a:solidFill>
+                    <a:srgbClr val="111827"/>
+                  </a:solidFill>
+                  <a:latin typeface="Calibri"/>
+                </a:defRPr>
+              </a:pPr>
+            </a:p>
+          </c:txPr>
+          <c:dLblPos val="outEnd"/>
+          <c:showLegendKey val="0"/>
+          <c:showVal val="1"/>
+          <c:showCatName val="0"/>
+          <c:showSerName val="0"/>
+          <c:showPercent val="0"/>
+          <c:showBubbleSize val="0"/>
+          <c:showLeaderLines val="1"/>
+        </c:dLbls>
+        <c:gapWidth val="60"/>
+        <c:axId val="-2068027336"/>
+        <c:axId val="-2113994440"/>
+      </c:barChart>
+      <c:catAx>
+        <c:axId val="-2068027336"/>
+        <c:scaling>
+          <c:orientation val="minMax"/>
+        </c:scaling>
+        <c:delete val="0"/>
+        <c:axPos val="b"/>
+        <c:majorTickMark val="out"/>
+        <c:minorTickMark val="none"/>
+        <c:tickLblPos val="nextTo"/>
+        <c:spPr>
+          <a:ln>
+            <a:solidFill>
+              <a:srgbClr val="D1D5DB"/>
+            </a:solidFill>
+          </a:ln>
+        </c:spPr>
+        <c:txPr>
+          <a:bodyPr/>
+          <a:lstStyle/>
+          <a:p>
+            <a:pPr>
+              <a:defRPr sz="1200"/>
+            </a:pPr>
+          </a:p>
+        </c:txPr>
+        <c:crossAx val="-2113994440"/>
+        <c:crosses val="autoZero"/>
+        <c:auto val="1"/>
+        <c:lblAlgn val="ctr"/>
+        <c:lblOffset val="100"/>
+        <c:noMultiLvlLbl val="0"/>
+      </c:catAx>
+      <c:valAx>
+        <c:axId val="-2113994440"/>
+        <c:scaling>
+          <c:max val="1.15"/>
+          <c:min val="0.0"/>
+        </c:scaling>
+        <c:delete/>
+        <c:axPos val="l"/>
+        <c:majorTickMark val="out"/>
+        <c:minorTickMark val="none"/>
+        <c:tickLblPos val="nextTo"/>
+        <c:crossAx val="-2068027336"/>
+        <c:crosses val="autoZero"/>
+      </c:valAx>
+    </c:plotArea>
+    <c:legend>
+      <c:legendPos val="b"/>
+      <c:overlay val="0"/>
+      <c:txPr>
+        <a:bodyPr/>
+        <a:lstStyle/>
+        <a:p>
+          <a:pPr>
+            <a:defRPr sz="1200"/>
+          </a:pPr>
+        </a:p>
+      </c:txPr>
+    </c:legend>
+    <c:dispBlanksAs val="gap"/>
+  </c:chart>
+  <c:txPr>
+    <a:bodyPr/>
+    <a:lstStyle/>
+    <a:p>
+      <a:pPr>
+        <a:defRPr sz="1200">
+          <a:solidFill>
+            <a:srgbClr val="111827"/>
+          </a:solidFill>
+          <a:latin typeface="Calibri"/>
+        </a:defRPr>
+      </a:pPr>
+      <a:endParaRPr lang="en-US"/>
+    </a:p>
+  </c:txPr>
+  <c:externalData r:id="rId1">
+    <c:autoUpdate val="0"/>
+  </c:externalData>
+</c:chartSpace>
+</file>
+
+<file path=ppt/charts/chart7.xml><?xml version="1.0" encoding="utf-8"?>
+<c:chartSpace xmlns:c="http://schemas.openxmlformats.org/drawingml/2006/chart" xmlns:a="http://schemas.openxmlformats.org/drawingml/2006/main" xmlns:r="http://schemas.openxmlformats.org/officeDocument/2006/relationships">
+  <c:date1904 val="0"/>
+  <c:chart>
+    <c:autoTitleDeleted val="1"/>
+    <c:plotArea>
+      <c:barChart>
+        <c:barDir val="col"/>
+        <c:grouping val="clustered"/>
+        <c:ser>
+          <c:idx val="0"/>
+          <c:order val="0"/>
+          <c:tx>
+            <c:strRef>
+              <c:f>Sheet1!$B$1</c:f>
+              <c:strCache>
+                <c:ptCount val="1"/>
+                <c:pt idx="0">
+                  <c:v>Random split</c:v>
+                </c:pt>
+              </c:strCache>
+            </c:strRef>
+          </c:tx>
+          <c:spPr>
+            <a:solidFill>
+              <a:srgbClr val="0F766E"/>
+            </a:solidFill>
+          </c:spPr>
+          <c:cat>
+            <c:strRef>
+              <c:f>Sheet1!$A$2:$A$5</c:f>
+              <c:strCache>
+                <c:ptCount val="4"/>
+                <c:pt idx="0">
+                  <c:v>Numeric flow features</c:v>
+                </c:pt>
+                <c:pt idx="1">
+                  <c:v>Numeric + ports</c:v>
+                </c:pt>
+                <c:pt idx="2">
+                  <c:v>All columns incl. IDs</c:v>
+                </c:pt>
+                <c:pt idx="3">
+                  <c:v>Top-15 by mutual info</c:v>
+                </c:pt>
+              </c:strCache>
+            </c:strRef>
+          </c:cat>
+          <c:val>
+            <c:numRef>
+              <c:f>Sheet1!$B$2:$B$5</c:f>
+              <c:numCache>
+                <c:formatCode>General</c:formatCode>
+                <c:ptCount val="4"/>
+                <c:pt idx="0">
+                  <c:v>0.9991407136002792</c:v>
+                </c:pt>
+                <c:pt idx="1">
+                  <c:v>0.9998342493239116</c:v>
+                </c:pt>
+                <c:pt idx="2">
+                  <c:v>0.999922940475152</c:v>
+                </c:pt>
+                <c:pt idx="3">
+                  <c:v>0.9998982232690686</c:v>
+                </c:pt>
+              </c:numCache>
+            </c:numRef>
+          </c:val>
+        </c:ser>
+        <c:ser>
+          <c:idx val="1"/>
+          <c:order val="1"/>
+          <c:tx>
+            <c:strRef>
+              <c:f>Sheet1!$C$1</c:f>
+              <c:strCache>
+                <c:ptCount val="1"/>
+                <c:pt idx="0">
+                  <c:v>Held-out source hosts</c:v>
+                </c:pt>
+              </c:strCache>
+            </c:strRef>
+          </c:tx>
+          <c:spPr>
+            <a:solidFill>
+              <a:srgbClr val="B91C1C"/>
+            </a:solidFill>
+          </c:spPr>
+          <c:cat>
+            <c:strRef>
+              <c:f>Sheet1!$A$2:$A$5</c:f>
+              <c:strCache>
+                <c:ptCount val="4"/>
+                <c:pt idx="0">
+                  <c:v>Numeric flow features</c:v>
+                </c:pt>
+                <c:pt idx="1">
+                  <c:v>Numeric + ports</c:v>
+                </c:pt>
+                <c:pt idx="2">
+                  <c:v>All columns incl. IDs</c:v>
+                </c:pt>
+                <c:pt idx="3">
+                  <c:v>Top-15 by mutual info</c:v>
+                </c:pt>
+              </c:strCache>
+            </c:strRef>
+          </c:cat>
+          <c:val>
+            <c:numRef>
+              <c:f>Sheet1!$C$2:$C$5</c:f>
+              <c:numCache>
+                <c:formatCode>General</c:formatCode>
+                <c:ptCount val="4"/>
+                <c:pt idx="0">
+                  <c:v>0.7877265798306605</c:v>
+                </c:pt>
+                <c:pt idx="1">
+                  <c:v>0.6869505545011194</c:v>
+                </c:pt>
+                <c:pt idx="2">
+                  <c:v>0.8037272416576785</c:v>
+                </c:pt>
+                <c:pt idx="3">
+                  <c:v>0.8351672108611826</c:v>
+                </c:pt>
+              </c:numCache>
+            </c:numRef>
+          </c:val>
+        </c:ser>
+        <c:dLbls>
+          <c:numFmt formatCode="0.0000" sourceLinked="0"/>
           <c:txPr>
             <a:bodyPr/>
             <a:lstStyle/>
@@ -8121,7 +8366,7 @@
               </a:defRPr>
             </a:pPr>
             <a:r>
-              <a:t>HONEST SCOPE</a:t>
+              <a:t>RECIPE REPLICATION ON INSDN</a:t>
             </a:r>
           </a:p>
         </p:txBody>
@@ -8157,7 +8402,7 @@
               </a:defRPr>
             </a:pPr>
             <a:r>
-              <a:t>Limitations we state ourselves</a:t>
+              <a:t>Published feature recipes, two splits</a:t>
             </a:r>
           </a:p>
         </p:txBody>
@@ -8234,16 +8479,34 @@
           </a:p>
         </p:txBody>
       </p:sp>
-      <p:sp>
-        <p:nvSpPr>
-          <p:cNvPr id="6" name="TextBox 5"/>
+      <p:graphicFrame>
+        <p:nvGraphicFramePr>
+          <p:cNvPr id="6" name="Chart 5"/>
+          <p:cNvGraphicFramePr>
+            <a:graphicFrameLocks noGrp="1"/>
+          </p:cNvGraphicFramePr>
+          <p:nvPr/>
+        </p:nvGraphicFramePr>
+        <p:xfrm>
+          <a:off x="548640" y="1554480"/>
+          <a:ext cx="7132320" cy="4023360"/>
+        </p:xfrm>
+        <a:graphic>
+          <a:graphicData uri="http://schemas.openxmlformats.org/drawingml/2006/chart">
+            <c:chart xmlns:c="http://schemas.openxmlformats.org/drawingml/2006/chart" r:id="rId2"/>
+          </a:graphicData>
+        </a:graphic>
+      </p:graphicFrame>
+      <p:sp>
+        <p:nvSpPr>
+          <p:cNvPr id="7" name="TextBox 6"/>
           <p:cNvSpPr txBox="1"/>
           <p:nvPr/>
         </p:nvSpPr>
         <p:spPr>
           <a:xfrm>
-            <a:off x="548640" y="1828800"/>
-            <a:ext cx="11064240" cy="4114800"/>
+            <a:off x="548640" y="5623560"/>
+            <a:ext cx="7132320" cy="274320"/>
           </a:xfrm>
           <a:prstGeom prst="rect">
             <a:avLst/>
@@ -8256,11 +8519,47 @@
           </a:bodyPr>
           <a:lstStyle/>
           <a:p>
+            <a:pPr algn="ctr">
+              <a:defRPr sz="1200" b="0">
+                <a:solidFill>
+                  <a:srgbClr val="6B7280"/>
+                </a:solidFill>
+                <a:latin typeface="Calibri"/>
+              </a:defRPr>
+            </a:pPr>
+            <a:r>
+              <a:t>8-class accuracy, GPU XGBoost, 80:20, 10 seeds, 343,889 flows</a:t>
+            </a:r>
+          </a:p>
+        </p:txBody>
+      </p:sp>
+      <p:sp>
+        <p:nvSpPr>
+          <p:cNvPr id="8" name="TextBox 7"/>
+          <p:cNvSpPr txBox="1"/>
+          <p:nvPr/>
+        </p:nvSpPr>
+        <p:spPr>
+          <a:xfrm>
+            <a:off x="8046720" y="1737360"/>
+            <a:ext cx="3657600" cy="4114800"/>
+          </a:xfrm>
+          <a:prstGeom prst="rect">
+            <a:avLst/>
+          </a:prstGeom>
+          <a:noFill/>
+        </p:spPr>
+        <p:txBody>
+          <a:bodyPr wrap="square" lIns="0" rIns="0" tIns="0" bIns="0">
+            <a:spAutoFit/>
+          </a:bodyPr>
+          <a:lstStyle/>
+          <a:p>
             <a:pPr>
               <a:spcAft>
-                <a:spcPts val="1400"/>
+                <a:spcPts val="1200"/>
               </a:spcAft>
-              <a:defRPr sz="1800">
+              <a:defRPr sz="1500">
                 <a:solidFill>
                   <a:srgbClr val="111827"/>
                 </a:solidFill>
@@ -8268,15 +8567,15 @@
               </a:defRPr>
             </a:pPr>
             <a:r>
-              <a:t>Controller study: one dataset (InSDN) and one recorded controller (ONOS); Ryu is checked only on our own benign traffic.</a:t>
+              <a:t>Random split: at least 0.999 for every recipe.</a:t>
             </a:r>
           </a:p>
           <a:p>
             <a:pPr>
               <a:spcAft>
-                <a:spcPts val="1400"/>
+                <a:spcPts val="1200"/>
               </a:spcAft>
-              <a:defRPr sz="1800">
+              <a:defRPr sz="1500">
                 <a:solidFill>
                   <a:srgbClr val="111827"/>
                 </a:solidFill>
@@ -8284,15 +8583,15 @@
               </a:defRPr>
             </a:pPr>
             <a:r>
-              <a:t>We generated no attack traffic; benign and attack are never interleaved in one session.</a:t>
+              <a:t>Held-out hosts: 0.69 to 0.84, with 95% CIs of ±0.18 to ±0.24.</a:t>
             </a:r>
           </a:p>
           <a:p>
             <a:pPr>
               <a:spcAft>
-                <a:spcPts val="1400"/>
+                <a:spcPts val="1200"/>
               </a:spcAft>
-              <a:defRPr sz="1800">
+              <a:defRPr sz="1500">
                 <a:solidFill>
                   <a:srgbClr val="111827"/>
                 </a:solidFill>
@@ -8300,71 +8599,43 @@
               </a:defRPr>
             </a:pPr>
             <a:r>
-              <a:t>Labels cover only part of the controller-visible traffic, so session identity and unlisted attacks cannot be separated.</a:t>
-            </a:r>
-          </a:p>
-          <a:p>
-            <a:pPr>
-              <a:spcAft>
-                <a:spcPts val="1400"/>
-              </a:spcAft>
-              <a:defRPr sz="1800">
-                <a:solidFill>
-                  <a:srgbClr val="111827"/>
-                </a:solidFill>
-                <a:latin typeface="Calibri"/>
-              </a:defRPr>
-            </a:pPr>
-            <a:r>
-              <a:t>Literature check: 10 of 12 papers read in full; the rest are not characterised. Reported numbers are the authors' own.</a:t>
-            </a:r>
-          </a:p>
-          <a:p>
-            <a:pPr>
-              <a:spcAft>
-                <a:spcPts val="1400"/>
-              </a:spcAft>
-              <a:defRPr sz="1800">
-                <a:solidFill>
-                  <a:srgbClr val="111827"/>
-                </a:solidFill>
-                <a:latin typeface="Calibri"/>
-              </a:defRPr>
-            </a:pPr>
-            <a:r>
-              <a:t>The split audit covers two datasets, one model family (XGBoost) and binary labels; UKMDDoSDN has no benign class and was unusable.</a:t>
-            </a:r>
-          </a:p>
-          <a:p>
-            <a:pPr>
-              <a:spcAft>
-                <a:spcPts val="1400"/>
-              </a:spcAft>
-              <a:defRPr sz="1800">
-                <a:solidFill>
-                  <a:srgbClr val="111827"/>
-                </a:solidFill>
-                <a:latin typeface="Calibri"/>
-              </a:defRPr>
-            </a:pPr>
-            <a:r>
-              <a:t>Phase 1 figures come from archived studies and are not re-run here.</a:t>
-            </a:r>
-          </a:p>
-          <a:p>
-            <a:pPr>
-              <a:spcAft>
-                <a:spcPts val="1400"/>
-              </a:spcAft>
-              <a:defRPr sz="1800">
-                <a:solidFill>
-                  <a:srgbClr val="111827"/>
-                </a:solidFill>
-                <a:latin typeface="Calibri"/>
-              </a:defRPr>
-            </a:pPr>
-            <a:r>
-              <a:t>Our literature search (October 2026) is evidence, not proof, that no one has measured this on an SDN dataset.</a:t>
+              <a:t>Adding ports lowers the held-out-host score (0.79 to 0.69) while the random-split score rises.</a:t>
+            </a:r>
+          </a:p>
+        </p:txBody>
+      </p:sp>
+      <p:sp>
+        <p:nvSpPr>
+          <p:cNvPr id="9" name="TextBox 8"/>
+          <p:cNvSpPr txBox="1"/>
+          <p:nvPr/>
+        </p:nvSpPr>
+        <p:spPr>
+          <a:xfrm>
+            <a:off x="548640" y="5943600"/>
+            <a:ext cx="11064240" cy="457200"/>
+          </a:xfrm>
+          <a:prstGeom prst="rect">
+            <a:avLst/>
+          </a:prstGeom>
+          <a:noFill/>
+        </p:spPr>
+        <p:txBody>
+          <a:bodyPr wrap="square" lIns="0" rIns="0" tIns="0" bIns="0">
+            <a:spAutoFit/>
+          </a:bodyPr>
+          <a:lstStyle/>
+          <a:p>
+            <a:pPr>
+              <a:defRPr sz="1200" b="0">
+                <a:solidFill>
+                  <a:srgbClr val="6B7280"/>
+                </a:solidFill>
+                <a:latin typeface="Calibri"/>
+              </a:defRPr>
+            </a:pPr>
+            <a:r>
+              <a:t>Caveat: one classifier (XGBoost) and approximate recipes of the published feature choices, not the papers' models or code. Grouping by source host is a stress test, not a deployment estimate.</a:t>
             </a:r>
           </a:p>
         </p:txBody>
@@ -8426,7 +8697,7 @@
               </a:defRPr>
             </a:pPr>
             <a:r>
-              <a:t>NOVELTY AND SCOPE</a:t>
+              <a:t>HONEST SCOPE</a:t>
             </a:r>
           </a:p>
         </p:txBody>
@@ -8462,7 +8733,7 @@
               </a:defRPr>
             </a:pPr>
             <a:r>
-              <a:t>Contributions: what is new and what is known</a:t>
+              <a:t>Limitations we state ourselves</a:t>
             </a:r>
           </a:p>
         </p:txBody>
@@ -8547,8 +8818,8 @@
         </p:nvSpPr>
         <p:spPr>
           <a:xfrm>
-            <a:off x="548640" y="1737360"/>
-            <a:ext cx="2651760" cy="457200"/>
+            <a:off x="548640" y="1828800"/>
+            <a:ext cx="11064240" cy="4114800"/>
           </a:xfrm>
           <a:prstGeom prst="rect">
             <a:avLst/>
@@ -8562,29 +8833,154 @@
           <a:lstStyle/>
           <a:p>
             <a:pPr>
-              <a:defRPr sz="2000" b="1">
-                <a:solidFill>
-                  <a:srgbClr val="6B7280"/>
-                </a:solidFill>
-                <a:latin typeface="Calibri"/>
-              </a:defRPr>
-            </a:pPr>
-            <a:r>
-              <a:t>Already known</a:t>
-            </a:r>
-          </a:p>
-        </p:txBody>
-      </p:sp>
-      <p:sp>
-        <p:nvSpPr>
-          <p:cNvPr id="7" name="TextBox 6"/>
+              <a:spcAft>
+                <a:spcPts val="1400"/>
+              </a:spcAft>
+              <a:defRPr sz="1800">
+                <a:solidFill>
+                  <a:srgbClr val="111827"/>
+                </a:solidFill>
+                <a:latin typeface="Calibri"/>
+              </a:defRPr>
+            </a:pPr>
+            <a:r>
+              <a:t>Controller study: one dataset (InSDN) and one recorded controller (ONOS); Ryu is checked only on our own benign traffic.</a:t>
+            </a:r>
+          </a:p>
+          <a:p>
+            <a:pPr>
+              <a:spcAft>
+                <a:spcPts val="1400"/>
+              </a:spcAft>
+              <a:defRPr sz="1800">
+                <a:solidFill>
+                  <a:srgbClr val="111827"/>
+                </a:solidFill>
+                <a:latin typeface="Calibri"/>
+              </a:defRPr>
+            </a:pPr>
+            <a:r>
+              <a:t>We generated no attack traffic; benign and attack are never interleaved in one session.</a:t>
+            </a:r>
+          </a:p>
+          <a:p>
+            <a:pPr>
+              <a:spcAft>
+                <a:spcPts val="1400"/>
+              </a:spcAft>
+              <a:defRPr sz="1800">
+                <a:solidFill>
+                  <a:srgbClr val="111827"/>
+                </a:solidFill>
+                <a:latin typeface="Calibri"/>
+              </a:defRPr>
+            </a:pPr>
+            <a:r>
+              <a:t>Labels cover only part of the controller-visible traffic, so session identity and unlisted attacks cannot be separated.</a:t>
+            </a:r>
+          </a:p>
+          <a:p>
+            <a:pPr>
+              <a:spcAft>
+                <a:spcPts val="1400"/>
+              </a:spcAft>
+              <a:defRPr sz="1800">
+                <a:solidFill>
+                  <a:srgbClr val="111827"/>
+                </a:solidFill>
+                <a:latin typeface="Calibri"/>
+              </a:defRPr>
+            </a:pPr>
+            <a:r>
+              <a:t>Literature check: 10 of 12 papers read in full; the rest are not characterised. Reported numbers are the authors' own.</a:t>
+            </a:r>
+          </a:p>
+          <a:p>
+            <a:pPr>
+              <a:spcAft>
+                <a:spcPts val="1400"/>
+              </a:spcAft>
+              <a:defRPr sz="1800">
+                <a:solidFill>
+                  <a:srgbClr val="111827"/>
+                </a:solidFill>
+                <a:latin typeface="Calibri"/>
+              </a:defRPr>
+            </a:pPr>
+            <a:r>
+              <a:t>The split audit covers two datasets, one model family (XGBoost) and binary labels; UKMDDoSDN has no benign class and was unusable.</a:t>
+            </a:r>
+          </a:p>
+          <a:p>
+            <a:pPr>
+              <a:spcAft>
+                <a:spcPts val="1400"/>
+              </a:spcAft>
+              <a:defRPr sz="1800">
+                <a:solidFill>
+                  <a:srgbClr val="111827"/>
+                </a:solidFill>
+                <a:latin typeface="Calibri"/>
+              </a:defRPr>
+            </a:pPr>
+            <a:r>
+              <a:t>Phase 1 figures come from archived studies and are not re-run here.</a:t>
+            </a:r>
+          </a:p>
+          <a:p>
+            <a:pPr>
+              <a:spcAft>
+                <a:spcPts val="1400"/>
+              </a:spcAft>
+              <a:defRPr sz="1800">
+                <a:solidFill>
+                  <a:srgbClr val="111827"/>
+                </a:solidFill>
+                <a:latin typeface="Calibri"/>
+              </a:defRPr>
+            </a:pPr>
+            <a:r>
+              <a:t>Our literature search (October 2026) is evidence, not proof, that no one has measured this on an SDN dataset.</a:t>
+            </a:r>
+          </a:p>
+        </p:txBody>
+      </p:sp>
+    </p:spTree>
+  </p:cSld>
+  <p:clrMapOvr>
+    <a:masterClrMapping/>
+  </p:clrMapOvr>
+</p:sld>
+</file>
+
+<file path=ppt/slides/slide17.xml><?xml version="1.0" encoding="utf-8"?>
+<p:sld xmlns:a="http://schemas.openxmlformats.org/drawingml/2006/main" xmlns:p="http://schemas.openxmlformats.org/presentationml/2006/main" xmlns:r="http://schemas.openxmlformats.org/officeDocument/2006/relationships">
+  <p:cSld>
+    <p:bg>
+      <p:bgPr>
+        <a:solidFill>
+          <a:srgbClr val="FFFFFF"/>
+        </a:solidFill>
+        <a:effectLst/>
+      </p:bgPr>
+    </p:bg>
+    <p:spTree>
+      <p:nvGrpSpPr>
+        <p:cNvPr id="1" name=""/>
+        <p:cNvGrpSpPr/>
+        <p:nvPr/>
+      </p:nvGrpSpPr>
+      <p:grpSpPr/>
+      <p:sp>
+        <p:nvSpPr>
+          <p:cNvPr id="2" name="TextBox 1"/>
           <p:cNvSpPr txBox="1"/>
           <p:nvPr/>
         </p:nvSpPr>
         <p:spPr>
           <a:xfrm>
-            <a:off x="548640" y="2377440"/>
-            <a:ext cx="2606040" cy="4114800"/>
+            <a:off x="548640" y="365760"/>
+            <a:ext cx="8229600" cy="274320"/>
           </a:xfrm>
           <a:prstGeom prst="rect">
             <a:avLst/>
@@ -8598,64 +8994,29 @@
           <a:lstStyle/>
           <a:p>
             <a:pPr>
-              <a:spcAft>
-                <a:spcPts val="1200"/>
-              </a:spcAft>
-              <a:defRPr sz="1400">
-                <a:solidFill>
-                  <a:srgbClr val="111827"/>
-                </a:solidFill>
-                <a:latin typeface="Calibri"/>
-              </a:defRPr>
-            </a:pPr>
-            <a:r>
-              <a:t>Identifier columns are shortcut features (Engelen 2021)</a:t>
-            </a:r>
-          </a:p>
-          <a:p>
-            <a:pPr>
-              <a:spcAft>
-                <a:spcPts val="1200"/>
-              </a:spcAft>
-              <a:defRPr sz="1400">
-                <a:solidFill>
-                  <a:srgbClr val="111827"/>
-                </a:solidFill>
-                <a:latin typeface="Calibri"/>
-              </a:defRPr>
-            </a:pPr>
-            <a:r>
-              <a:t>Random splits leak on NIDS data (Flood 2024)</a:t>
-            </a:r>
-          </a:p>
-          <a:p>
-            <a:pPr>
-              <a:spcAft>
-                <a:spcPts val="1200"/>
-              </a:spcAft>
-              <a:defRPr sz="1400">
-                <a:solidFill>
-                  <a:srgbClr val="111827"/>
-                </a:solidFill>
-                <a:latin typeface="Calibri"/>
-              </a:defRPr>
-            </a:pPr>
-            <a:r>
-              <a:t>Control-plane telemetry for SDN IDS (LAN-SDN-NIDS, SDNFLow)</a:t>
-            </a:r>
-          </a:p>
-        </p:txBody>
-      </p:sp>
-      <p:sp>
-        <p:nvSpPr>
-          <p:cNvPr id="8" name="TextBox 7"/>
+              <a:defRPr sz="1200" b="1">
+                <a:solidFill>
+                  <a:srgbClr val="0F766E"/>
+                </a:solidFill>
+                <a:latin typeface="Calibri"/>
+              </a:defRPr>
+            </a:pPr>
+            <a:r>
+              <a:t>NOVELTY AND SCOPE</a:t>
+            </a:r>
+          </a:p>
+        </p:txBody>
+      </p:sp>
+      <p:sp>
+        <p:nvSpPr>
+          <p:cNvPr id="3" name="TextBox 2"/>
           <p:cNvSpPr txBox="1"/>
           <p:nvPr/>
         </p:nvSpPr>
         <p:spPr>
           <a:xfrm>
-            <a:off x="3383280" y="1737360"/>
-            <a:ext cx="2651760" cy="457200"/>
+            <a:off x="548640" y="658368"/>
+            <a:ext cx="11064240" cy="822960"/>
           </a:xfrm>
           <a:prstGeom prst="rect">
             <a:avLst/>
@@ -8669,29 +9030,29 @@
           <a:lstStyle/>
           <a:p>
             <a:pPr>
-              <a:defRPr sz="2000" b="1">
-                <a:solidFill>
-                  <a:srgbClr val="0F766E"/>
-                </a:solidFill>
-                <a:latin typeface="Calibri"/>
-              </a:defRPr>
-            </a:pPr>
-            <a:r>
-              <a:t>New here</a:t>
-            </a:r>
-          </a:p>
-        </p:txBody>
-      </p:sp>
-      <p:sp>
-        <p:nvSpPr>
-          <p:cNvPr id="9" name="TextBox 8"/>
+              <a:defRPr sz="2800" b="1">
+                <a:solidFill>
+                  <a:srgbClr val="111827"/>
+                </a:solidFill>
+                <a:latin typeface="Calibri"/>
+              </a:defRPr>
+            </a:pPr>
+            <a:r>
+              <a:t>Contributions: what is new and what is known</a:t>
+            </a:r>
+          </a:p>
+        </p:txBody>
+      </p:sp>
+      <p:sp>
+        <p:nvSpPr>
+          <p:cNvPr id="4" name="TextBox 3"/>
           <p:cNvSpPr txBox="1"/>
           <p:nvPr/>
         </p:nvSpPr>
         <p:spPr>
           <a:xfrm>
-            <a:off x="3383280" y="2377440"/>
-            <a:ext cx="2606040" cy="4114800"/>
+            <a:off x="548640" y="6446520"/>
+            <a:ext cx="7315200" cy="228600"/>
           </a:xfrm>
           <a:prstGeom prst="rect">
             <a:avLst/>
@@ -8705,64 +9066,29 @@
           <a:lstStyle/>
           <a:p>
             <a:pPr>
-              <a:spcAft>
-                <a:spcPts val="1200"/>
-              </a:spcAft>
-              <a:defRPr sz="1400">
-                <a:solidFill>
-                  <a:srgbClr val="111827"/>
-                </a:solidFill>
-                <a:latin typeface="Calibri"/>
-              </a:defRPr>
-            </a:pPr>
-            <a:r>
-              <a:t>Paired random vs host-held-out gap on InSDN and CICIDS2017, 10 seeds, CIs</a:t>
-            </a:r>
-          </a:p>
-          <a:p>
-            <a:pPr>
-              <a:spcAft>
-                <a:spcPts val="1200"/>
-              </a:spcAft>
-              <a:defRPr sz="1400">
-                <a:solidFill>
-                  <a:srgbClr val="111827"/>
-                </a:solidFill>
-                <a:latin typeface="Calibri"/>
-              </a:defRPr>
-            </a:pPr>
-            <a:r>
-              <a:t>Audit of 9 published InSDN papers: none groups by host, none uses a real controller</a:t>
-            </a:r>
-          </a:p>
-          <a:p>
-            <a:pPr>
-              <a:spcAft>
-                <a:spcPts val="1200"/>
-              </a:spcAft>
-              <a:defRPr sz="1400">
-                <a:solidFill>
-                  <a:srgbClr val="111827"/>
-                </a:solidFill>
-                <a:latin typeface="Calibri"/>
-              </a:defRPr>
-            </a:pPr>
-            <a:r>
-              <a:t>Controller-telemetry gap: 0 FlowMods with IPs or ports</a:t>
-            </a:r>
-          </a:p>
-        </p:txBody>
-      </p:sp>
-      <p:sp>
-        <p:nvSpPr>
-          <p:cNvPr id="10" name="TextBox 9"/>
+              <a:defRPr sz="1000" b="0">
+                <a:solidFill>
+                  <a:srgbClr val="6B7280"/>
+                </a:solidFill>
+                <a:latin typeface="Calibri"/>
+              </a:defRPr>
+            </a:pPr>
+            <a:r>
+              <a:t>Proteus · What an SDN controller can observe</a:t>
+            </a:r>
+          </a:p>
+        </p:txBody>
+      </p:sp>
+      <p:sp>
+        <p:nvSpPr>
+          <p:cNvPr id="5" name="TextBox 4"/>
           <p:cNvSpPr txBox="1"/>
           <p:nvPr/>
         </p:nvSpPr>
         <p:spPr>
           <a:xfrm>
-            <a:off x="6217920" y="1737360"/>
-            <a:ext cx="2651760" cy="457200"/>
+            <a:off x="10972800" y="6446520"/>
+            <a:ext cx="667512" cy="228600"/>
           </a:xfrm>
           <a:prstGeom prst="rect">
             <a:avLst/>
@@ -8775,30 +9101,30 @@
           </a:bodyPr>
           <a:lstStyle/>
           <a:p>
-            <a:pPr>
-              <a:defRPr sz="2000" b="1">
-                <a:solidFill>
-                  <a:srgbClr val="B91C1C"/>
-                </a:solidFill>
-                <a:latin typeface="Calibri"/>
-              </a:defRPr>
-            </a:pPr>
-            <a:r>
-              <a:t>Not done</a:t>
-            </a:r>
-          </a:p>
-        </p:txBody>
-      </p:sp>
-      <p:sp>
-        <p:nvSpPr>
-          <p:cNvPr id="11" name="TextBox 10"/>
+            <a:pPr algn="r">
+              <a:defRPr sz="1000" b="0">
+                <a:solidFill>
+                  <a:srgbClr val="6B7280"/>
+                </a:solidFill>
+                <a:latin typeface="Calibri"/>
+              </a:defRPr>
+            </a:pPr>
+            <a:r>
+              <a:t>17</a:t>
+            </a:r>
+          </a:p>
+        </p:txBody>
+      </p:sp>
+      <p:sp>
+        <p:nvSpPr>
+          <p:cNvPr id="6" name="TextBox 5"/>
           <p:cNvSpPr txBox="1"/>
           <p:nvPr/>
         </p:nvSpPr>
         <p:spPr>
           <a:xfrm>
-            <a:off x="6217920" y="2377440"/>
-            <a:ext cx="2606040" cy="4114800"/>
+            <a:off x="548640" y="1737360"/>
+            <a:ext cx="2651760" cy="457200"/>
           </a:xfrm>
           <a:prstGeom prst="rect">
             <a:avLst/>
@@ -8812,64 +9138,29 @@
           <a:lstStyle/>
           <a:p>
             <a:pPr>
-              <a:spcAft>
-                <a:spcPts val="1200"/>
-              </a:spcAft>
-              <a:defRPr sz="1400">
-                <a:solidFill>
-                  <a:srgbClr val="111827"/>
-                </a:solidFill>
-                <a:latin typeface="Calibri"/>
-              </a:defRPr>
-            </a:pPr>
-            <a:r>
-              <a:t>Interleaved benign and attack traffic in one session</a:t>
-            </a:r>
-          </a:p>
-          <a:p>
-            <a:pPr>
-              <a:spcAft>
-                <a:spcPts val="1200"/>
-              </a:spcAft>
-              <a:defRPr sz="1400">
-                <a:solidFill>
-                  <a:srgbClr val="111827"/>
-                </a:solidFill>
-                <a:latin typeface="Calibri"/>
-              </a:defRPr>
-            </a:pPr>
-            <a:r>
-              <a:t>A second SDN dataset or controller family</a:t>
-            </a:r>
-          </a:p>
-          <a:p>
-            <a:pPr>
-              <a:spcAft>
-                <a:spcPts val="1200"/>
-              </a:spcAft>
-              <a:defRPr sz="1400">
-                <a:solidFill>
-                  <a:srgbClr val="111827"/>
-                </a:solidFill>
-                <a:latin typeface="Calibri"/>
-              </a:defRPr>
-            </a:pPr>
-            <a:r>
-              <a:t>Unread InSDN papers not characterised</a:t>
-            </a:r>
-          </a:p>
-        </p:txBody>
-      </p:sp>
-      <p:sp>
-        <p:nvSpPr>
-          <p:cNvPr id="12" name="TextBox 11"/>
+              <a:defRPr sz="2000" b="1">
+                <a:solidFill>
+                  <a:srgbClr val="6B7280"/>
+                </a:solidFill>
+                <a:latin typeface="Calibri"/>
+              </a:defRPr>
+            </a:pPr>
+            <a:r>
+              <a:t>Already known</a:t>
+            </a:r>
+          </a:p>
+        </p:txBody>
+      </p:sp>
+      <p:sp>
+        <p:nvSpPr>
+          <p:cNvPr id="7" name="TextBox 6"/>
           <p:cNvSpPr txBox="1"/>
           <p:nvPr/>
         </p:nvSpPr>
         <p:spPr>
           <a:xfrm>
-            <a:off x="9052560" y="1737360"/>
-            <a:ext cx="2651760" cy="457200"/>
+            <a:off x="548640" y="2377440"/>
+            <a:ext cx="2606040" cy="4114800"/>
           </a:xfrm>
           <a:prstGeom prst="rect">
             <a:avLst/>
@@ -8883,7 +9174,10 @@
           <a:lstStyle/>
           <a:p>
             <a:pPr>
-              <a:defRPr sz="2000" b="1">
+              <a:spcAft>
+                <a:spcPts val="1000"/>
+              </a:spcAft>
+              <a:defRPr sz="1300">
                 <a:solidFill>
                   <a:srgbClr val="111827"/>
                 </a:solidFill>
@@ -8891,21 +9185,53 @@
               </a:defRPr>
             </a:pPr>
             <a:r>
-              <a:t>Takeaways</a:t>
-            </a:r>
-          </a:p>
-        </p:txBody>
-      </p:sp>
-      <p:sp>
-        <p:nvSpPr>
-          <p:cNvPr id="13" name="TextBox 12"/>
+              <a:t>Identifier columns are shortcut features (Engelen 2021)</a:t>
+            </a:r>
+          </a:p>
+          <a:p>
+            <a:pPr>
+              <a:spcAft>
+                <a:spcPts val="1000"/>
+              </a:spcAft>
+              <a:defRPr sz="1300">
+                <a:solidFill>
+                  <a:srgbClr val="111827"/>
+                </a:solidFill>
+                <a:latin typeface="Calibri"/>
+              </a:defRPr>
+            </a:pPr>
+            <a:r>
+              <a:t>Random splits leak on NIDS data (Flood 2024)</a:t>
+            </a:r>
+          </a:p>
+          <a:p>
+            <a:pPr>
+              <a:spcAft>
+                <a:spcPts val="1000"/>
+              </a:spcAft>
+              <a:defRPr sz="1300">
+                <a:solidFill>
+                  <a:srgbClr val="111827"/>
+                </a:solidFill>
+                <a:latin typeface="Calibri"/>
+              </a:defRPr>
+            </a:pPr>
+            <a:r>
+              <a:t>Control-plane telemetry for SDN IDS (LAN-SDN-NIDS, SDNFLow)</a:t>
+            </a:r>
+          </a:p>
+        </p:txBody>
+      </p:sp>
+      <p:sp>
+        <p:nvSpPr>
+          <p:cNvPr id="8" name="TextBox 7"/>
           <p:cNvSpPr txBox="1"/>
           <p:nvPr/>
         </p:nvSpPr>
         <p:spPr>
           <a:xfrm>
-            <a:off x="9052560" y="2377440"/>
-            <a:ext cx="2606040" cy="4114800"/>
+            <a:off x="3383280" y="1737360"/>
+            <a:ext cx="2651760" cy="457200"/>
           </a:xfrm>
           <a:prstGeom prst="rect">
             <a:avLst/>
@@ -8919,10 +9245,46 @@
           <a:lstStyle/>
           <a:p>
             <a:pPr>
+              <a:defRPr sz="2000" b="1">
+                <a:solidFill>
+                  <a:srgbClr val="0F766E"/>
+                </a:solidFill>
+                <a:latin typeface="Calibri"/>
+              </a:defRPr>
+            </a:pPr>
+            <a:r>
+              <a:t>New here</a:t>
+            </a:r>
+          </a:p>
+        </p:txBody>
+      </p:sp>
+      <p:sp>
+        <p:nvSpPr>
+          <p:cNvPr id="9" name="TextBox 8"/>
+          <p:cNvSpPr txBox="1"/>
+          <p:nvPr/>
+        </p:nvSpPr>
+        <p:spPr>
+          <a:xfrm>
+            <a:off x="3383280" y="2377440"/>
+            <a:ext cx="2606040" cy="4114800"/>
+          </a:xfrm>
+          <a:prstGeom prst="rect">
+            <a:avLst/>
+          </a:prstGeom>
+          <a:noFill/>
+        </p:spPr>
+        <p:txBody>
+          <a:bodyPr wrap="square" lIns="0" rIns="0" tIns="0" bIns="0">
+            <a:spAutoFit/>
+          </a:bodyPr>
+          <a:lstStyle/>
+          <a:p>
+            <a:pPr>
               <a:spcAft>
-                <a:spcPts val="1200"/>
+                <a:spcPts val="1000"/>
               </a:spcAft>
-              <a:defRPr sz="1400">
+              <a:defRPr sz="1300">
                 <a:solidFill>
                   <a:srgbClr val="111827"/>
                 </a:solidFill>
@@ -8930,15 +9292,245 @@
               </a:defRPr>
             </a:pPr>
             <a:r>
+              <a:t>Paired random vs host-held-out gap on InSDN and CICIDS2017, 10 seeds, CIs</a:t>
+            </a:r>
+          </a:p>
+          <a:p>
+            <a:pPr>
+              <a:spcAft>
+                <a:spcPts val="1000"/>
+              </a:spcAft>
+              <a:defRPr sz="1300">
+                <a:solidFill>
+                  <a:srgbClr val="111827"/>
+                </a:solidFill>
+                <a:latin typeface="Calibri"/>
+              </a:defRPr>
+            </a:pPr>
+            <a:r>
+              <a:t>Audit of 9 published InSDN papers: none groups by host, none uses a real controller</a:t>
+            </a:r>
+          </a:p>
+          <a:p>
+            <a:pPr>
+              <a:spcAft>
+                <a:spcPts val="1000"/>
+              </a:spcAft>
+              <a:defRPr sz="1300">
+                <a:solidFill>
+                  <a:srgbClr val="111827"/>
+                </a:solidFill>
+                <a:latin typeface="Calibri"/>
+              </a:defRPr>
+            </a:pPr>
+            <a:r>
+              <a:t>Published feature recipes on InSDN: ~0.999 random vs 0.69 to 0.84 held-out hosts</a:t>
+            </a:r>
+          </a:p>
+          <a:p>
+            <a:pPr>
+              <a:spcAft>
+                <a:spcPts val="1000"/>
+              </a:spcAft>
+              <a:defRPr sz="1300">
+                <a:solidFill>
+                  <a:srgbClr val="111827"/>
+                </a:solidFill>
+                <a:latin typeface="Calibri"/>
+              </a:defRPr>
+            </a:pPr>
+            <a:r>
+              <a:t>Controller-telemetry gap: 0 FlowMods with IPs or ports</a:t>
+            </a:r>
+          </a:p>
+        </p:txBody>
+      </p:sp>
+      <p:sp>
+        <p:nvSpPr>
+          <p:cNvPr id="10" name="TextBox 9"/>
+          <p:cNvSpPr txBox="1"/>
+          <p:nvPr/>
+        </p:nvSpPr>
+        <p:spPr>
+          <a:xfrm>
+            <a:off x="6217920" y="1737360"/>
+            <a:ext cx="2651760" cy="457200"/>
+          </a:xfrm>
+          <a:prstGeom prst="rect">
+            <a:avLst/>
+          </a:prstGeom>
+          <a:noFill/>
+        </p:spPr>
+        <p:txBody>
+          <a:bodyPr wrap="square" lIns="0" rIns="0" tIns="0" bIns="0">
+            <a:spAutoFit/>
+          </a:bodyPr>
+          <a:lstStyle/>
+          <a:p>
+            <a:pPr>
+              <a:defRPr sz="2000" b="1">
+                <a:solidFill>
+                  <a:srgbClr val="B91C1C"/>
+                </a:solidFill>
+                <a:latin typeface="Calibri"/>
+              </a:defRPr>
+            </a:pPr>
+            <a:r>
+              <a:t>Not done</a:t>
+            </a:r>
+          </a:p>
+        </p:txBody>
+      </p:sp>
+      <p:sp>
+        <p:nvSpPr>
+          <p:cNvPr id="11" name="TextBox 10"/>
+          <p:cNvSpPr txBox="1"/>
+          <p:nvPr/>
+        </p:nvSpPr>
+        <p:spPr>
+          <a:xfrm>
+            <a:off x="6217920" y="2377440"/>
+            <a:ext cx="2606040" cy="4114800"/>
+          </a:xfrm>
+          <a:prstGeom prst="rect">
+            <a:avLst/>
+          </a:prstGeom>
+          <a:noFill/>
+        </p:spPr>
+        <p:txBody>
+          <a:bodyPr wrap="square" lIns="0" rIns="0" tIns="0" bIns="0">
+            <a:spAutoFit/>
+          </a:bodyPr>
+          <a:lstStyle/>
+          <a:p>
+            <a:pPr>
+              <a:spcAft>
+                <a:spcPts val="1000"/>
+              </a:spcAft>
+              <a:defRPr sz="1300">
+                <a:solidFill>
+                  <a:srgbClr val="111827"/>
+                </a:solidFill>
+                <a:latin typeface="Calibri"/>
+              </a:defRPr>
+            </a:pPr>
+            <a:r>
+              <a:t>Interleaved benign and attack traffic in one session</a:t>
+            </a:r>
+          </a:p>
+          <a:p>
+            <a:pPr>
+              <a:spcAft>
+                <a:spcPts val="1000"/>
+              </a:spcAft>
+              <a:defRPr sz="1300">
+                <a:solidFill>
+                  <a:srgbClr val="111827"/>
+                </a:solidFill>
+                <a:latin typeface="Calibri"/>
+              </a:defRPr>
+            </a:pPr>
+            <a:r>
+              <a:t>A second SDN dataset or controller family</a:t>
+            </a:r>
+          </a:p>
+          <a:p>
+            <a:pPr>
+              <a:spcAft>
+                <a:spcPts val="1000"/>
+              </a:spcAft>
+              <a:defRPr sz="1300">
+                <a:solidFill>
+                  <a:srgbClr val="111827"/>
+                </a:solidFill>
+                <a:latin typeface="Calibri"/>
+              </a:defRPr>
+            </a:pPr>
+            <a:r>
+              <a:t>Unread InSDN papers not characterised</a:t>
+            </a:r>
+          </a:p>
+        </p:txBody>
+      </p:sp>
+      <p:sp>
+        <p:nvSpPr>
+          <p:cNvPr id="12" name="TextBox 11"/>
+          <p:cNvSpPr txBox="1"/>
+          <p:nvPr/>
+        </p:nvSpPr>
+        <p:spPr>
+          <a:xfrm>
+            <a:off x="9052560" y="1737360"/>
+            <a:ext cx="2651760" cy="457200"/>
+          </a:xfrm>
+          <a:prstGeom prst="rect">
+            <a:avLst/>
+          </a:prstGeom>
+          <a:noFill/>
+        </p:spPr>
+        <p:txBody>
+          <a:bodyPr wrap="square" lIns="0" rIns="0" tIns="0" bIns="0">
+            <a:spAutoFit/>
+          </a:bodyPr>
+          <a:lstStyle/>
+          <a:p>
+            <a:pPr>
+              <a:defRPr sz="2000" b="1">
+                <a:solidFill>
+                  <a:srgbClr val="111827"/>
+                </a:solidFill>
+                <a:latin typeface="Calibri"/>
+              </a:defRPr>
+            </a:pPr>
+            <a:r>
+              <a:t>Takeaways</a:t>
+            </a:r>
+          </a:p>
+        </p:txBody>
+      </p:sp>
+      <p:sp>
+        <p:nvSpPr>
+          <p:cNvPr id="13" name="TextBox 12"/>
+          <p:cNvSpPr txBox="1"/>
+          <p:nvPr/>
+        </p:nvSpPr>
+        <p:spPr>
+          <a:xfrm>
+            <a:off x="9052560" y="2377440"/>
+            <a:ext cx="2606040" cy="4114800"/>
+          </a:xfrm>
+          <a:prstGeom prst="rect">
+            <a:avLst/>
+          </a:prstGeom>
+          <a:noFill/>
+        </p:spPr>
+        <p:txBody>
+          <a:bodyPr wrap="square" lIns="0" rIns="0" tIns="0" bIns="0">
+            <a:spAutoFit/>
+          </a:bodyPr>
+          <a:lstStyle/>
+          <a:p>
+            <a:pPr>
+              <a:spcAft>
+                <a:spcPts val="1000"/>
+              </a:spcAft>
+              <a:defRPr sz="1300">
+                <a:solidFill>
+                  <a:srgbClr val="111827"/>
+                </a:solidFill>
+                <a:latin typeface="Calibri"/>
+              </a:defRPr>
+            </a:pPr>
+            <a:r>
               <a:t>Random-split scores on InSDN do not measure detection</a:t>
             </a:r>
           </a:p>
           <a:p>
             <a:pPr>
               <a:spcAft>
-                <a:spcPts val="1200"/>
+                <a:spcPts val="1000"/>
               </a:spcAft>
-              <a:defRPr sz="1400">
+              <a:defRPr sz="1300">
                 <a:solidFill>
                   <a:srgbClr val="111827"/>
                 </a:solidFill>
@@ -8952,9 +9544,9 @@
           <a:p>
             <a:pPr>
               <a:spcAft>
-                <a:spcPts val="1200"/>
+                <a:spcPts val="1000"/>
               </a:spcAft>
-              <a:defRPr sz="1400">
+              <a:defRPr sz="1300">
                 <a:solidFill>
                   <a:srgbClr val="111827"/>
                 </a:solidFill>
@@ -11681,7 +12273,7 @@
               </a:defRPr>
             </a:pPr>
             <a:r>
-              <a:t>Split audit on InSDN and CICIDS2017, and a full read of 10 papers, 9 on InSDN (slides 13 to 14)</a:t>
+              <a:t>Split audit on InSDN and CICIDS2017, and a full read of 10 papers, 9 on InSDN (slides 13 to 15)</a:t>
             </a:r>
           </a:p>
         </p:txBody>

</xml_diff>

<commit_message>
Deck: host-structure and leave-one-host-out slide, replication callout (18 slides)
</commit_message>
<xml_diff>
--- a/research/insdn_controller/PRESENTATION.pptx
+++ b/research/insdn_controller/PRESENTATION.pptx
@@ -22,6 +22,7 @@
     <p:sldId id="270" r:id="rId21"/>
     <p:sldId id="271" r:id="rId22"/>
     <p:sldId id="272" r:id="rId23"/>
+    <p:sldId id="273" r:id="rId24"/>
   </p:sldIdLst>
   <p:sldSz cx="12191695" cy="6858000" type="screen4x3"/>
   <p:notesSz cx="6858000" cy="9144000"/>
@@ -2108,6 +2109,278 @@
         </a:p>
       </c:txPr>
     </c:legend>
+    <c:dispBlanksAs val="gap"/>
+  </c:chart>
+  <c:txPr>
+    <a:bodyPr/>
+    <a:lstStyle/>
+    <a:p>
+      <a:pPr>
+        <a:defRPr sz="1200">
+          <a:solidFill>
+            <a:srgbClr val="111827"/>
+          </a:solidFill>
+          <a:latin typeface="Calibri"/>
+        </a:defRPr>
+      </a:pPr>
+      <a:endParaRPr lang="en-US"/>
+    </a:p>
+  </c:txPr>
+  <c:externalData r:id="rId1">
+    <c:autoUpdate val="0"/>
+  </c:externalData>
+</c:chartSpace>
+</file>
+
+<file path=ppt/charts/chart8.xml><?xml version="1.0" encoding="utf-8"?>
+<c:chartSpace xmlns:c="http://schemas.openxmlformats.org/drawingml/2006/chart" xmlns:a="http://schemas.openxmlformats.org/drawingml/2006/main" xmlns:r="http://schemas.openxmlformats.org/officeDocument/2006/relationships">
+  <c:date1904 val="0"/>
+  <c:chart>
+    <c:autoTitleDeleted val="1"/>
+    <c:plotArea>
+      <c:barChart>
+        <c:barDir val="bar"/>
+        <c:grouping val="clustered"/>
+        <c:ser>
+          <c:idx val="0"/>
+          <c:order val="0"/>
+          <c:tx>
+            <c:strRef>
+              <c:f>Sheet1!$B$1</c:f>
+              <c:strCache>
+                <c:ptCount val="1"/>
+                <c:pt idx="0">
+                  <c:v>Held-out host</c:v>
+                </c:pt>
+              </c:strCache>
+            </c:strRef>
+          </c:tx>
+          <c:spPr>
+            <a:solidFill>
+              <a:srgbClr val="0F766E"/>
+            </a:solidFill>
+          </c:spPr>
+          <c:dPt>
+            <c:idx val="0"/>
+            <c:spPr>
+              <a:solidFill>
+                <a:srgbClr val="B91C1C"/>
+              </a:solidFill>
+            </c:spPr>
+          </c:dPt>
+          <c:dPt>
+            <c:idx val="1"/>
+            <c:spPr>
+              <a:solidFill>
+                <a:srgbClr val="0F766E"/>
+              </a:solidFill>
+            </c:spPr>
+          </c:dPt>
+          <c:dPt>
+            <c:idx val="2"/>
+            <c:spPr>
+              <a:solidFill>
+                <a:srgbClr val="0F766E"/>
+              </a:solidFill>
+            </c:spPr>
+          </c:dPt>
+          <c:dPt>
+            <c:idx val="3"/>
+            <c:spPr>
+              <a:solidFill>
+                <a:srgbClr val="B91C1C"/>
+              </a:solidFill>
+            </c:spPr>
+          </c:dPt>
+          <c:dPt>
+            <c:idx val="4"/>
+            <c:spPr>
+              <a:solidFill>
+                <a:srgbClr val="9CA3AF"/>
+              </a:solidFill>
+            </c:spPr>
+          </c:dPt>
+          <c:dPt>
+            <c:idx val="5"/>
+            <c:spPr>
+              <a:solidFill>
+                <a:srgbClr val="9CA3AF"/>
+              </a:solidFill>
+            </c:spPr>
+          </c:dPt>
+          <c:dPt>
+            <c:idx val="6"/>
+            <c:spPr>
+              <a:solidFill>
+                <a:srgbClr val="9CA3AF"/>
+              </a:solidFill>
+            </c:spPr>
+          </c:dPt>
+          <c:dPt>
+            <c:idx val="7"/>
+            <c:spPr>
+              <a:solidFill>
+                <a:srgbClr val="9CA3AF"/>
+              </a:solidFill>
+            </c:spPr>
+          </c:dPt>
+          <c:dPt>
+            <c:idx val="8"/>
+            <c:spPr>
+              <a:solidFill>
+                <a:srgbClr val="9CA3AF"/>
+              </a:solidFill>
+            </c:spPr>
+          </c:dPt>
+          <c:cat>
+            <c:strRef>
+              <c:f>Sheet1!$A$2:$A$10</c:f>
+              <c:strCache>
+                <c:ptCount val="9"/>
+                <c:pt idx="0">
+                  <c:v>200.175.2.130 (attack recall)</c:v>
+                </c:pt>
+                <c:pt idx="1">
+                  <c:v>192.168.3.130 (attack recall)</c:v>
+                </c:pt>
+                <c:pt idx="2">
+                  <c:v>192.168.20.134 (attack recall)</c:v>
+                </c:pt>
+                <c:pt idx="3">
+                  <c:v>192.168.20.133 (benign FPR)</c:v>
+                </c:pt>
+                <c:pt idx="4">
+                  <c:v>192.168.3.130 (benign FPR)</c:v>
+                </c:pt>
+                <c:pt idx="5">
+                  <c:v>185.127.17.56 (benign FPR)</c:v>
+                </c:pt>
+                <c:pt idx="6">
+                  <c:v>192.168.20.2 (benign FPR)</c:v>
+                </c:pt>
+                <c:pt idx="7">
+                  <c:v>192.168.20.1 (benign FPR)</c:v>
+                </c:pt>
+                <c:pt idx="8">
+                  <c:v>74.125.168.10 (benign FPR)</c:v>
+                </c:pt>
+              </c:strCache>
+            </c:strRef>
+          </c:cat>
+          <c:val>
+            <c:numRef>
+              <c:f>Sheet1!$B$2:$B$10</c:f>
+              <c:numCache>
+                <c:formatCode>General</c:formatCode>
+                <c:ptCount val="9"/>
+                <c:pt idx="0">
+                  <c:v>0.5162320959575447</c:v>
+                </c:pt>
+                <c:pt idx="1">
+                  <c:v>0.9968684759916493</c:v>
+                </c:pt>
+                <c:pt idx="2">
+                  <c:v>0.9380375293197811</c:v>
+                </c:pt>
+                <c:pt idx="3">
+                  <c:v>0.37891801450083656</c:v>
+                </c:pt>
+                <c:pt idx="4">
+                  <c:v>0.8333333333333334</c:v>
+                </c:pt>
+                <c:pt idx="5">
+                  <c:v>0.0</c:v>
+                </c:pt>
+                <c:pt idx="6">
+                  <c:v>0.0</c:v>
+                </c:pt>
+                <c:pt idx="7">
+                  <c:v>0.18823529411764706</c:v>
+                </c:pt>
+                <c:pt idx="8">
+                  <c:v>0.0</c:v>
+                </c:pt>
+              </c:numCache>
+            </c:numRef>
+          </c:val>
+        </c:ser>
+        <c:dLbls>
+          <c:numFmt formatCode="0.00" sourceLinked="0"/>
+          <c:txPr>
+            <a:bodyPr/>
+            <a:lstStyle/>
+            <a:p>
+              <a:pPr>
+                <a:defRPr sz="1300">
+                  <a:solidFill>
+                    <a:srgbClr val="111827"/>
+                  </a:solidFill>
+                  <a:latin typeface="Calibri"/>
+                </a:defRPr>
+              </a:pPr>
+            </a:p>
+          </c:txPr>
+          <c:dLblPos val="outEnd"/>
+          <c:showLegendKey val="0"/>
+          <c:showVal val="1"/>
+          <c:showCatName val="0"/>
+          <c:showSerName val="0"/>
+          <c:showPercent val="0"/>
+          <c:showBubbleSize val="0"/>
+          <c:showLeaderLines val="1"/>
+        </c:dLbls>
+        <c:gapWidth val="60"/>
+        <c:axId val="-2068027336"/>
+        <c:axId val="-2113994440"/>
+      </c:barChart>
+      <c:catAx>
+        <c:axId val="-2068027336"/>
+        <c:scaling>
+          <c:orientation val="maxMin"/>
+        </c:scaling>
+        <c:delete val="0"/>
+        <c:axPos val="l"/>
+        <c:majorTickMark val="out"/>
+        <c:minorTickMark val="none"/>
+        <c:tickLblPos val="nextTo"/>
+        <c:spPr>
+          <a:ln>
+            <a:solidFill>
+              <a:srgbClr val="D1D5DB"/>
+            </a:solidFill>
+          </a:ln>
+        </c:spPr>
+        <c:txPr>
+          <a:bodyPr/>
+          <a:lstStyle/>
+          <a:p>
+            <a:pPr>
+              <a:defRPr sz="1200"/>
+            </a:pPr>
+          </a:p>
+        </c:txPr>
+        <c:crossAx val="-2113994440"/>
+        <c:crosses val="autoZero"/>
+        <c:auto val="1"/>
+        <c:lblAlgn val="ctr"/>
+        <c:lblOffset val="100"/>
+        <c:noMultiLvlLbl val="0"/>
+      </c:catAx>
+      <c:valAx>
+        <c:axId val="-2113994440"/>
+        <c:scaling>
+          <c:max val="1.2"/>
+          <c:min val="0.0"/>
+        </c:scaling>
+        <c:delete/>
+        <c:axPos val="b"/>
+        <c:majorTickMark val="out"/>
+        <c:minorTickMark val="none"/>
+        <c:tickLblPos val="nextTo"/>
+        <c:crossAx val="-2068027336"/>
+        <c:crosses val="autoZero"/>
+      </c:valAx>
+    </c:plotArea>
     <c:dispBlanksAs val="gap"/>
   </c:chart>
   <c:txPr>
@@ -8697,7 +8970,7 @@
               </a:defRPr>
             </a:pPr>
             <a:r>
-              <a:t>HONEST SCOPE</a:t>
+              <a:t>HOST STRUCTURE AND LEAVE-ONE-HOST-OUT</a:t>
             </a:r>
           </a:p>
         </p:txBody>
@@ -8733,7 +9006,7 @@
               </a:defRPr>
             </a:pPr>
             <a:r>
-              <a:t>Limitations we state ourselves</a:t>
+              <a:t>Only about 3 attacker hosts: held-out-host detection collapses</a:t>
             </a:r>
           </a:p>
         </p:txBody>
@@ -8818,8 +9091,8 @@
         </p:nvSpPr>
         <p:spPr>
           <a:xfrm>
-            <a:off x="548640" y="1828800"/>
-            <a:ext cx="11064240" cy="4114800"/>
+            <a:off x="548640" y="1371600"/>
+            <a:ext cx="11064240" cy="365760"/>
           </a:xfrm>
           <a:prstGeom prst="rect">
             <a:avLst/>
@@ -8833,10 +9106,97 @@
           <a:lstStyle/>
           <a:p>
             <a:pPr>
-              <a:spcAft>
-                <a:spcPts val="1400"/>
-              </a:spcAft>
-              <a:defRPr sz="1800">
+              <a:defRPr sz="1400" b="0">
+                <a:solidFill>
+                  <a:srgbClr val="6B7280"/>
+                </a:solidFill>
+                <a:latin typeface="Calibri"/>
+              </a:defRPr>
+            </a:pPr>
+            <a:r>
+              <a:t>122,868 source IPs, 122,307 with a single flow; 8 hosts with 500 or more flows hold 215,404 of 343,889 rows.</a:t>
+            </a:r>
+          </a:p>
+        </p:txBody>
+      </p:sp>
+      <p:graphicFrame>
+        <p:nvGraphicFramePr>
+          <p:cNvPr id="7" name="Chart 6"/>
+          <p:cNvGraphicFramePr>
+            <a:graphicFrameLocks noGrp="1"/>
+          </p:cNvGraphicFramePr>
+          <p:nvPr/>
+        </p:nvGraphicFramePr>
+        <p:xfrm>
+          <a:off x="548640" y="1783080"/>
+          <a:ext cx="6766560" cy="4069080"/>
+        </p:xfrm>
+        <a:graphic>
+          <a:graphicData uri="http://schemas.openxmlformats.org/drawingml/2006/chart">
+            <c:chart xmlns:c="http://schemas.openxmlformats.org/drawingml/2006/chart" r:id="rId2"/>
+          </a:graphicData>
+        </a:graphic>
+      </p:graphicFrame>
+      <p:sp>
+        <p:nvSpPr>
+          <p:cNvPr id="8" name="TextBox 7"/>
+          <p:cNvSpPr txBox="1"/>
+          <p:nvPr/>
+        </p:nvSpPr>
+        <p:spPr>
+          <a:xfrm>
+            <a:off x="548640" y="5897880"/>
+            <a:ext cx="6766560" cy="457200"/>
+          </a:xfrm>
+          <a:prstGeom prst="rect">
+            <a:avLst/>
+          </a:prstGeom>
+          <a:noFill/>
+        </p:spPr>
+        <p:txBody>
+          <a:bodyPr wrap="square" lIns="0" rIns="0" tIns="0" bIns="0">
+            <a:spAutoFit/>
+          </a:bodyPr>
+          <a:lstStyle/>
+          <a:p>
+            <a:pPr>
+              <a:defRPr sz="1100" b="0">
+                <a:solidFill>
+                  <a:srgbClr val="6B7280"/>
+                </a:solidFill>
+                <a:latin typeface="Calibri"/>
+              </a:defRPr>
+            </a:pPr>
+            <a:r>
+              <a:t>Train on all other hosts, test on the held-out host. Teal: attack recall; grey: benign false-positive rate; red: highlighted.</a:t>
+            </a:r>
+          </a:p>
+        </p:txBody>
+      </p:sp>
+      <p:sp>
+        <p:nvSpPr>
+          <p:cNvPr id="9" name="TextBox 8"/>
+          <p:cNvSpPr txBox="1"/>
+          <p:nvPr/>
+        </p:nvSpPr>
+        <p:spPr>
+          <a:xfrm>
+            <a:off x="7680960" y="1783080"/>
+            <a:ext cx="4023360" cy="822960"/>
+          </a:xfrm>
+          <a:prstGeom prst="rect">
+            <a:avLst/>
+          </a:prstGeom>
+          <a:noFill/>
+        </p:spPr>
+        <p:txBody>
+          <a:bodyPr wrap="square" lIns="0" rIns="0" tIns="0" bIns="0">
+            <a:spAutoFit/>
+          </a:bodyPr>
+          <a:lstStyle/>
+          <a:p>
+            <a:pPr>
+              <a:defRPr sz="1400" b="0">
                 <a:solidFill>
                   <a:srgbClr val="111827"/>
                 </a:solidFill>
@@ -8844,15 +9204,287 @@
               </a:defRPr>
             </a:pPr>
             <a:r>
-              <a:t>Controller study: one dataset (InSDN) and one recorded controller (ONOS); Ryu is checked only on our own benign traffic.</a:t>
-            </a:r>
-          </a:p>
-          <a:p>
-            <a:pPr>
-              <a:spcAft>
-                <a:spcPts val="1400"/>
-              </a:spcAft>
-              <a:defRPr sz="1800">
+              <a:t>Duplicates are not the mechanism: dropping 46% exact duplicates leaves random-split BAcc at 0.9998.</a:t>
+            </a:r>
+          </a:p>
+        </p:txBody>
+      </p:sp>
+      <p:sp>
+        <p:nvSpPr>
+          <p:cNvPr id="10" name="TextBox 9"/>
+          <p:cNvSpPr txBox="1"/>
+          <p:nvPr/>
+        </p:nvSpPr>
+        <p:spPr>
+          <a:xfrm>
+            <a:off x="7680960" y="2743200"/>
+            <a:ext cx="4023360" cy="320040"/>
+          </a:xfrm>
+          <a:prstGeom prst="rect">
+            <a:avLst/>
+          </a:prstGeom>
+          <a:noFill/>
+        </p:spPr>
+        <p:txBody>
+          <a:bodyPr wrap="square" lIns="0" rIns="0" tIns="0" bIns="0">
+            <a:spAutoFit/>
+          </a:bodyPr>
+          <a:lstStyle/>
+          <a:p>
+            <a:pPr>
+              <a:defRPr sz="1400" b="1">
+                <a:solidFill>
+                  <a:srgbClr val="0F766E"/>
+                </a:solidFill>
+                <a:latin typeface="Calibri"/>
+              </a:defRPr>
+            </a:pPr>
+            <a:r>
+              <a:t>SDNGuardStack approximation (5 seeds)</a:t>
+            </a:r>
+          </a:p>
+        </p:txBody>
+      </p:sp>
+      <p:sp>
+        <p:nvSpPr>
+          <p:cNvPr id="11" name="TextBox 10"/>
+          <p:cNvSpPr txBox="1"/>
+          <p:nvPr/>
+        </p:nvSpPr>
+        <p:spPr>
+          <a:xfrm>
+            <a:off x="7680960" y="3154680"/>
+            <a:ext cx="1920240" cy="548640"/>
+          </a:xfrm>
+          <a:prstGeom prst="rect">
+            <a:avLst/>
+          </a:prstGeom>
+          <a:noFill/>
+        </p:spPr>
+        <p:txBody>
+          <a:bodyPr wrap="square" lIns="0" rIns="0" tIns="0" bIns="0">
+            <a:spAutoFit/>
+          </a:bodyPr>
+          <a:lstStyle/>
+          <a:p>
+            <a:pPr>
+              <a:defRPr sz="2200" b="1">
+                <a:solidFill>
+                  <a:srgbClr val="0F766E"/>
+                </a:solidFill>
+                <a:latin typeface="Calibri"/>
+              </a:defRPr>
+            </a:pPr>
+            <a:r>
+              <a:t>0.9999</a:t>
+            </a:r>
+          </a:p>
+        </p:txBody>
+      </p:sp>
+      <p:sp>
+        <p:nvSpPr>
+          <p:cNvPr id="12" name="TextBox 11"/>
+          <p:cNvSpPr txBox="1"/>
+          <p:nvPr/>
+        </p:nvSpPr>
+        <p:spPr>
+          <a:xfrm>
+            <a:off x="9646920" y="3227832"/>
+            <a:ext cx="2103120" cy="548640"/>
+          </a:xfrm>
+          <a:prstGeom prst="rect">
+            <a:avLst/>
+          </a:prstGeom>
+          <a:noFill/>
+        </p:spPr>
+        <p:txBody>
+          <a:bodyPr wrap="square" lIns="0" rIns="0" tIns="0" bIns="0">
+            <a:spAutoFit/>
+          </a:bodyPr>
+          <a:lstStyle/>
+          <a:p>
+            <a:pPr>
+              <a:defRPr sz="1200" b="0">
+                <a:solidFill>
+                  <a:srgbClr val="6B7280"/>
+                </a:solidFill>
+                <a:latin typeface="Calibri"/>
+              </a:defRPr>
+            </a:pPr>
+            <a:r>
+              <a:t>Random split (reported 99.98%)</a:t>
+            </a:r>
+          </a:p>
+        </p:txBody>
+      </p:sp>
+      <p:sp>
+        <p:nvSpPr>
+          <p:cNvPr id="13" name="TextBox 12"/>
+          <p:cNvSpPr txBox="1"/>
+          <p:nvPr/>
+        </p:nvSpPr>
+        <p:spPr>
+          <a:xfrm>
+            <a:off x="7680960" y="3840480"/>
+            <a:ext cx="1920240" cy="548640"/>
+          </a:xfrm>
+          <a:prstGeom prst="rect">
+            <a:avLst/>
+          </a:prstGeom>
+          <a:noFill/>
+        </p:spPr>
+        <p:txBody>
+          <a:bodyPr wrap="square" lIns="0" rIns="0" tIns="0" bIns="0">
+            <a:spAutoFit/>
+          </a:bodyPr>
+          <a:lstStyle/>
+          <a:p>
+            <a:pPr>
+              <a:defRPr sz="2200" b="1">
+                <a:solidFill>
+                  <a:srgbClr val="B91C1C"/>
+                </a:solidFill>
+                <a:latin typeface="Calibri"/>
+              </a:defRPr>
+            </a:pPr>
+            <a:r>
+              <a:t>0.72 to 0.78</a:t>
+            </a:r>
+          </a:p>
+        </p:txBody>
+      </p:sp>
+      <p:sp>
+        <p:nvSpPr>
+          <p:cNvPr id="14" name="TextBox 13"/>
+          <p:cNvSpPr txBox="1"/>
+          <p:nvPr/>
+        </p:nvSpPr>
+        <p:spPr>
+          <a:xfrm>
+            <a:off x="9646920" y="3913632"/>
+            <a:ext cx="2103120" cy="548640"/>
+          </a:xfrm>
+          <a:prstGeom prst="rect">
+            <a:avLst/>
+          </a:prstGeom>
+          <a:noFill/>
+        </p:spPr>
+        <p:txBody>
+          <a:bodyPr wrap="square" lIns="0" rIns="0" tIns="0" bIns="0">
+            <a:spAutoFit/>
+          </a:bodyPr>
+          <a:lstStyle/>
+          <a:p>
+            <a:pPr>
+              <a:defRPr sz="1200" b="0">
+                <a:solidFill>
+                  <a:srgbClr val="6B7280"/>
+                </a:solidFill>
+                <a:latin typeface="Calibri"/>
+              </a:defRPr>
+            </a:pPr>
+            <a:r>
+              <a:t>Source-IP grouped</a:t>
+            </a:r>
+          </a:p>
+        </p:txBody>
+      </p:sp>
+      <p:sp>
+        <p:nvSpPr>
+          <p:cNvPr id="15" name="TextBox 14"/>
+          <p:cNvSpPr txBox="1"/>
+          <p:nvPr/>
+        </p:nvSpPr>
+        <p:spPr>
+          <a:xfrm>
+            <a:off x="7680960" y="4526280"/>
+            <a:ext cx="1920240" cy="548640"/>
+          </a:xfrm>
+          <a:prstGeom prst="rect">
+            <a:avLst/>
+          </a:prstGeom>
+          <a:noFill/>
+        </p:spPr>
+        <p:txBody>
+          <a:bodyPr wrap="square" lIns="0" rIns="0" tIns="0" bIns="0">
+            <a:spAutoFit/>
+          </a:bodyPr>
+          <a:lstStyle/>
+          <a:p>
+            <a:pPr>
+              <a:defRPr sz="2200" b="1">
+                <a:solidFill>
+                  <a:srgbClr val="9CA3AF"/>
+                </a:solidFill>
+                <a:latin typeface="Calibri"/>
+              </a:defRPr>
+            </a:pPr>
+            <a:r>
+              <a:t>±0.39</a:t>
+            </a:r>
+          </a:p>
+        </p:txBody>
+      </p:sp>
+      <p:sp>
+        <p:nvSpPr>
+          <p:cNvPr id="16" name="TextBox 15"/>
+          <p:cNvSpPr txBox="1"/>
+          <p:nvPr/>
+        </p:nvSpPr>
+        <p:spPr>
+          <a:xfrm>
+            <a:off x="9646920" y="4599432"/>
+            <a:ext cx="2103120" cy="548640"/>
+          </a:xfrm>
+          <a:prstGeom prst="rect">
+            <a:avLst/>
+          </a:prstGeom>
+          <a:noFill/>
+        </p:spPr>
+        <p:txBody>
+          <a:bodyPr wrap="square" lIns="0" rIns="0" tIns="0" bIns="0">
+            <a:spAutoFit/>
+          </a:bodyPr>
+          <a:lstStyle/>
+          <a:p>
+            <a:pPr>
+              <a:defRPr sz="1200" b="0">
+                <a:solidFill>
+                  <a:srgbClr val="6B7280"/>
+                </a:solidFill>
+                <a:latin typeface="Calibri"/>
+              </a:defRPr>
+            </a:pPr>
+            <a:r>
+              <a:t>Largest 95% CI, grouped</a:t>
+            </a:r>
+          </a:p>
+        </p:txBody>
+      </p:sp>
+      <p:sp>
+        <p:nvSpPr>
+          <p:cNvPr id="17" name="TextBox 16"/>
+          <p:cNvSpPr txBox="1"/>
+          <p:nvPr/>
+        </p:nvSpPr>
+        <p:spPr>
+          <a:xfrm>
+            <a:off x="7680960" y="5303520"/>
+            <a:ext cx="4023360" cy="548640"/>
+          </a:xfrm>
+          <a:prstGeom prst="rect">
+            <a:avLst/>
+          </a:prstGeom>
+          <a:noFill/>
+        </p:spPr>
+        <p:txBody>
+          <a:bodyPr wrap="square" lIns="0" rIns="0" tIns="0" bIns="0">
+            <a:spAutoFit/>
+          </a:bodyPr>
+          <a:lstStyle/>
+          <a:p>
+            <a:pPr>
+              <a:defRPr sz="1400" b="1">
                 <a:solidFill>
                   <a:srgbClr val="111827"/>
                 </a:solidFill>
@@ -8860,87 +9492,7 @@
               </a:defRPr>
             </a:pPr>
             <a:r>
-              <a:t>We generated no attack traffic; benign and attack are never interleaved in one session.</a:t>
-            </a:r>
-          </a:p>
-          <a:p>
-            <a:pPr>
-              <a:spcAft>
-                <a:spcPts val="1400"/>
-              </a:spcAft>
-              <a:defRPr sz="1800">
-                <a:solidFill>
-                  <a:srgbClr val="111827"/>
-                </a:solidFill>
-                <a:latin typeface="Calibri"/>
-              </a:defRPr>
-            </a:pPr>
-            <a:r>
-              <a:t>Labels cover only part of the controller-visible traffic, so session identity and unlisted attacks cannot be separated.</a:t>
-            </a:r>
-          </a:p>
-          <a:p>
-            <a:pPr>
-              <a:spcAft>
-                <a:spcPts val="1400"/>
-              </a:spcAft>
-              <a:defRPr sz="1800">
-                <a:solidFill>
-                  <a:srgbClr val="111827"/>
-                </a:solidFill>
-                <a:latin typeface="Calibri"/>
-              </a:defRPr>
-            </a:pPr>
-            <a:r>
-              <a:t>Literature check: 10 of 12 papers read in full; the rest are not characterised. Reported numbers are the authors' own.</a:t>
-            </a:r>
-          </a:p>
-          <a:p>
-            <a:pPr>
-              <a:spcAft>
-                <a:spcPts val="1400"/>
-              </a:spcAft>
-              <a:defRPr sz="1800">
-                <a:solidFill>
-                  <a:srgbClr val="111827"/>
-                </a:solidFill>
-                <a:latin typeface="Calibri"/>
-              </a:defRPr>
-            </a:pPr>
-            <a:r>
-              <a:t>The split audit covers two datasets, one model family (XGBoost) and binary labels; UKMDDoSDN has no benign class and was unusable.</a:t>
-            </a:r>
-          </a:p>
-          <a:p>
-            <a:pPr>
-              <a:spcAft>
-                <a:spcPts val="1400"/>
-              </a:spcAft>
-              <a:defRPr sz="1800">
-                <a:solidFill>
-                  <a:srgbClr val="111827"/>
-                </a:solidFill>
-                <a:latin typeface="Calibri"/>
-              </a:defRPr>
-            </a:pPr>
-            <a:r>
-              <a:t>Phase 1 figures come from archived studies and are not re-run here.</a:t>
-            </a:r>
-          </a:p>
-          <a:p>
-            <a:pPr>
-              <a:spcAft>
-                <a:spcPts val="1400"/>
-              </a:spcAft>
-              <a:defRPr sz="1800">
-                <a:solidFill>
-                  <a:srgbClr val="111827"/>
-                </a:solidFill>
-                <a:latin typeface="Calibri"/>
-              </a:defRPr>
-            </a:pPr>
-            <a:r>
-              <a:t>Our literature search (October 2026) is evidence, not proof, that no one has measured this on an SDN dataset.</a:t>
+              <a:t>Reproduces under its own protocol; does not hold for unseen hosts.</a:t>
             </a:r>
           </a:p>
         </p:txBody>
@@ -9002,7 +9554,7 @@
               </a:defRPr>
             </a:pPr>
             <a:r>
-              <a:t>NOVELTY AND SCOPE</a:t>
+              <a:t>HONEST SCOPE</a:t>
             </a:r>
           </a:p>
         </p:txBody>
@@ -9038,7 +9590,7 @@
               </a:defRPr>
             </a:pPr>
             <a:r>
-              <a:t>Contributions: what is new and what is known</a:t>
+              <a:t>Limitations we state ourselves</a:t>
             </a:r>
           </a:p>
         </p:txBody>
@@ -9111,6 +9663,311 @@
             </a:pPr>
             <a:r>
               <a:t>17</a:t>
+            </a:r>
+          </a:p>
+        </p:txBody>
+      </p:sp>
+      <p:sp>
+        <p:nvSpPr>
+          <p:cNvPr id="6" name="TextBox 5"/>
+          <p:cNvSpPr txBox="1"/>
+          <p:nvPr/>
+        </p:nvSpPr>
+        <p:spPr>
+          <a:xfrm>
+            <a:off x="548640" y="1828800"/>
+            <a:ext cx="11064240" cy="4114800"/>
+          </a:xfrm>
+          <a:prstGeom prst="rect">
+            <a:avLst/>
+          </a:prstGeom>
+          <a:noFill/>
+        </p:spPr>
+        <p:txBody>
+          <a:bodyPr wrap="square" lIns="0" rIns="0" tIns="0" bIns="0">
+            <a:spAutoFit/>
+          </a:bodyPr>
+          <a:lstStyle/>
+          <a:p>
+            <a:pPr>
+              <a:spcAft>
+                <a:spcPts val="1400"/>
+              </a:spcAft>
+              <a:defRPr sz="1800">
+                <a:solidFill>
+                  <a:srgbClr val="111827"/>
+                </a:solidFill>
+                <a:latin typeface="Calibri"/>
+              </a:defRPr>
+            </a:pPr>
+            <a:r>
+              <a:t>Controller study: one dataset (InSDN) and one recorded controller (ONOS); Ryu is checked only on our own benign traffic.</a:t>
+            </a:r>
+          </a:p>
+          <a:p>
+            <a:pPr>
+              <a:spcAft>
+                <a:spcPts val="1400"/>
+              </a:spcAft>
+              <a:defRPr sz="1800">
+                <a:solidFill>
+                  <a:srgbClr val="111827"/>
+                </a:solidFill>
+                <a:latin typeface="Calibri"/>
+              </a:defRPr>
+            </a:pPr>
+            <a:r>
+              <a:t>We generated no attack traffic; benign and attack are never interleaved in one session.</a:t>
+            </a:r>
+          </a:p>
+          <a:p>
+            <a:pPr>
+              <a:spcAft>
+                <a:spcPts val="1400"/>
+              </a:spcAft>
+              <a:defRPr sz="1800">
+                <a:solidFill>
+                  <a:srgbClr val="111827"/>
+                </a:solidFill>
+                <a:latin typeface="Calibri"/>
+              </a:defRPr>
+            </a:pPr>
+            <a:r>
+              <a:t>Labels cover only part of the controller-visible traffic, so session identity and unlisted attacks cannot be separated.</a:t>
+            </a:r>
+          </a:p>
+          <a:p>
+            <a:pPr>
+              <a:spcAft>
+                <a:spcPts val="1400"/>
+              </a:spcAft>
+              <a:defRPr sz="1800">
+                <a:solidFill>
+                  <a:srgbClr val="111827"/>
+                </a:solidFill>
+                <a:latin typeface="Calibri"/>
+              </a:defRPr>
+            </a:pPr>
+            <a:r>
+              <a:t>Literature check: 10 of 12 papers read in full; the rest are not characterised. Reported numbers are the authors' own.</a:t>
+            </a:r>
+          </a:p>
+          <a:p>
+            <a:pPr>
+              <a:spcAft>
+                <a:spcPts val="1400"/>
+              </a:spcAft>
+              <a:defRPr sz="1800">
+                <a:solidFill>
+                  <a:srgbClr val="111827"/>
+                </a:solidFill>
+                <a:latin typeface="Calibri"/>
+              </a:defRPr>
+            </a:pPr>
+            <a:r>
+              <a:t>The split audit covers two datasets, one model family (XGBoost) and binary labels; UKMDDoSDN has no benign class and was unusable.</a:t>
+            </a:r>
+          </a:p>
+          <a:p>
+            <a:pPr>
+              <a:spcAft>
+                <a:spcPts val="1400"/>
+              </a:spcAft>
+              <a:defRPr sz="1800">
+                <a:solidFill>
+                  <a:srgbClr val="111827"/>
+                </a:solidFill>
+                <a:latin typeface="Calibri"/>
+              </a:defRPr>
+            </a:pPr>
+            <a:r>
+              <a:t>Phase 1 figures come from archived studies and are not re-run here.</a:t>
+            </a:r>
+          </a:p>
+          <a:p>
+            <a:pPr>
+              <a:spcAft>
+                <a:spcPts val="1400"/>
+              </a:spcAft>
+              <a:defRPr sz="1800">
+                <a:solidFill>
+                  <a:srgbClr val="111827"/>
+                </a:solidFill>
+                <a:latin typeface="Calibri"/>
+              </a:defRPr>
+            </a:pPr>
+            <a:r>
+              <a:t>Our literature search (October 2026) is evidence, not proof, that no one has measured this on an SDN dataset.</a:t>
+            </a:r>
+          </a:p>
+        </p:txBody>
+      </p:sp>
+    </p:spTree>
+  </p:cSld>
+  <p:clrMapOvr>
+    <a:masterClrMapping/>
+  </p:clrMapOvr>
+</p:sld>
+</file>
+
+<file path=ppt/slides/slide18.xml><?xml version="1.0" encoding="utf-8"?>
+<p:sld xmlns:a="http://schemas.openxmlformats.org/drawingml/2006/main" xmlns:p="http://schemas.openxmlformats.org/presentationml/2006/main" xmlns:r="http://schemas.openxmlformats.org/officeDocument/2006/relationships">
+  <p:cSld>
+    <p:bg>
+      <p:bgPr>
+        <a:solidFill>
+          <a:srgbClr val="FFFFFF"/>
+        </a:solidFill>
+        <a:effectLst/>
+      </p:bgPr>
+    </p:bg>
+    <p:spTree>
+      <p:nvGrpSpPr>
+        <p:cNvPr id="1" name=""/>
+        <p:cNvGrpSpPr/>
+        <p:nvPr/>
+      </p:nvGrpSpPr>
+      <p:grpSpPr/>
+      <p:sp>
+        <p:nvSpPr>
+          <p:cNvPr id="2" name="TextBox 1"/>
+          <p:cNvSpPr txBox="1"/>
+          <p:nvPr/>
+        </p:nvSpPr>
+        <p:spPr>
+          <a:xfrm>
+            <a:off x="548640" y="365760"/>
+            <a:ext cx="8229600" cy="274320"/>
+          </a:xfrm>
+          <a:prstGeom prst="rect">
+            <a:avLst/>
+          </a:prstGeom>
+          <a:noFill/>
+        </p:spPr>
+        <p:txBody>
+          <a:bodyPr wrap="square" lIns="0" rIns="0" tIns="0" bIns="0">
+            <a:spAutoFit/>
+          </a:bodyPr>
+          <a:lstStyle/>
+          <a:p>
+            <a:pPr>
+              <a:defRPr sz="1200" b="1">
+                <a:solidFill>
+                  <a:srgbClr val="0F766E"/>
+                </a:solidFill>
+                <a:latin typeface="Calibri"/>
+              </a:defRPr>
+            </a:pPr>
+            <a:r>
+              <a:t>NOVELTY AND SCOPE</a:t>
+            </a:r>
+          </a:p>
+        </p:txBody>
+      </p:sp>
+      <p:sp>
+        <p:nvSpPr>
+          <p:cNvPr id="3" name="TextBox 2"/>
+          <p:cNvSpPr txBox="1"/>
+          <p:nvPr/>
+        </p:nvSpPr>
+        <p:spPr>
+          <a:xfrm>
+            <a:off x="548640" y="658368"/>
+            <a:ext cx="11064240" cy="822960"/>
+          </a:xfrm>
+          <a:prstGeom prst="rect">
+            <a:avLst/>
+          </a:prstGeom>
+          <a:noFill/>
+        </p:spPr>
+        <p:txBody>
+          <a:bodyPr wrap="square" lIns="0" rIns="0" tIns="0" bIns="0">
+            <a:spAutoFit/>
+          </a:bodyPr>
+          <a:lstStyle/>
+          <a:p>
+            <a:pPr>
+              <a:defRPr sz="2800" b="1">
+                <a:solidFill>
+                  <a:srgbClr val="111827"/>
+                </a:solidFill>
+                <a:latin typeface="Calibri"/>
+              </a:defRPr>
+            </a:pPr>
+            <a:r>
+              <a:t>Contributions: what is new and what is known</a:t>
+            </a:r>
+          </a:p>
+        </p:txBody>
+      </p:sp>
+      <p:sp>
+        <p:nvSpPr>
+          <p:cNvPr id="4" name="TextBox 3"/>
+          <p:cNvSpPr txBox="1"/>
+          <p:nvPr/>
+        </p:nvSpPr>
+        <p:spPr>
+          <a:xfrm>
+            <a:off x="548640" y="6446520"/>
+            <a:ext cx="7315200" cy="228600"/>
+          </a:xfrm>
+          <a:prstGeom prst="rect">
+            <a:avLst/>
+          </a:prstGeom>
+          <a:noFill/>
+        </p:spPr>
+        <p:txBody>
+          <a:bodyPr wrap="square" lIns="0" rIns="0" tIns="0" bIns="0">
+            <a:spAutoFit/>
+          </a:bodyPr>
+          <a:lstStyle/>
+          <a:p>
+            <a:pPr>
+              <a:defRPr sz="1000" b="0">
+                <a:solidFill>
+                  <a:srgbClr val="6B7280"/>
+                </a:solidFill>
+                <a:latin typeface="Calibri"/>
+              </a:defRPr>
+            </a:pPr>
+            <a:r>
+              <a:t>Proteus · What an SDN controller can observe</a:t>
+            </a:r>
+          </a:p>
+        </p:txBody>
+      </p:sp>
+      <p:sp>
+        <p:nvSpPr>
+          <p:cNvPr id="5" name="TextBox 4"/>
+          <p:cNvSpPr txBox="1"/>
+          <p:nvPr/>
+        </p:nvSpPr>
+        <p:spPr>
+          <a:xfrm>
+            <a:off x="10972800" y="6446520"/>
+            <a:ext cx="667512" cy="228600"/>
+          </a:xfrm>
+          <a:prstGeom prst="rect">
+            <a:avLst/>
+          </a:prstGeom>
+          <a:noFill/>
+        </p:spPr>
+        <p:txBody>
+          <a:bodyPr wrap="square" lIns="0" rIns="0" tIns="0" bIns="0">
+            <a:spAutoFit/>
+          </a:bodyPr>
+          <a:lstStyle/>
+          <a:p>
+            <a:pPr algn="r">
+              <a:defRPr sz="1000" b="0">
+                <a:solidFill>
+                  <a:srgbClr val="6B7280"/>
+                </a:solidFill>
+                <a:latin typeface="Calibri"/>
+              </a:defRPr>
+            </a:pPr>
+            <a:r>
+              <a:t>18</a:t>
             </a:r>
           </a:p>
         </p:txBody>
@@ -9325,6 +10182,22 @@
             </a:pPr>
             <a:r>
               <a:t>Published feature recipes on InSDN: ~0.999 random vs 0.69 to 0.84 held-out hosts</a:t>
+            </a:r>
+          </a:p>
+          <a:p>
+            <a:pPr>
+              <a:spcAft>
+                <a:spcPts val="1000"/>
+              </a:spcAft>
+              <a:defRPr sz="1300">
+                <a:solidFill>
+                  <a:srgbClr val="111827"/>
+                </a:solidFill>
+                <a:latin typeface="Calibri"/>
+              </a:defRPr>
+            </a:pPr>
+            <a:r>
+              <a:t>Host structure and leave-one-host-out: about 3 attacker hosts</a:t>
             </a:r>
           </a:p>
           <a:p>
@@ -12273,7 +13146,7 @@
               </a:defRPr>
             </a:pPr>
             <a:r>
-              <a:t>Split audit on InSDN and CICIDS2017, and a full read of 10 papers, 9 on InSDN (slides 13 to 15)</a:t>
+              <a:t>Split audit on InSDN and CICIDS2017, and a full read of 10 papers, 9 on InSDN (slides 13 to 16)</a:t>
             </a:r>
           </a:p>
         </p:txBody>

</xml_diff>

<commit_message>
Deck: rebuild as 14 slides mirroring the paper (contributions, pipeline, audit, host structure on two datasets, limitations)
</commit_message>
<xml_diff>
--- a/research/insdn_controller/PRESENTATION.pptx
+++ b/research/insdn_controller/PRESENTATION.pptx
@@ -7,22 +7,18 @@
   <p:sldIdLst>
     <p:sldId id="256" r:id="rId7"/>
     <p:sldId id="257" r:id="rId8"/>
-    <p:sldId id="258" r:id="rId9"/>
-    <p:sldId id="259" r:id="rId10"/>
-    <p:sldId id="260" r:id="rId11"/>
-    <p:sldId id="261" r:id="rId12"/>
+    <p:sldId id="277" r:id="rId28"/>
+    <p:sldId id="274" r:id="rId25"/>
     <p:sldId id="262" r:id="rId13"/>
-    <p:sldId id="263" r:id="rId14"/>
-    <p:sldId id="264" r:id="rId15"/>
-    <p:sldId id="265" r:id="rId16"/>
     <p:sldId id="266" r:id="rId17"/>
-    <p:sldId id="267" r:id="rId18"/>
     <p:sldId id="268" r:id="rId19"/>
+    <p:sldId id="271" r:id="rId22"/>
+    <p:sldId id="273" r:id="rId24"/>
     <p:sldId id="269" r:id="rId20"/>
     <p:sldId id="270" r:id="rId21"/>
-    <p:sldId id="271" r:id="rId22"/>
     <p:sldId id="272" r:id="rId23"/>
-    <p:sldId id="273" r:id="rId24"/>
+    <p:sldId id="276" r:id="rId27"/>
+    <p:sldId id="275" r:id="rId26"/>
   </p:sldIdLst>
   <p:sldSz cx="12191695" cy="6858000" type="screen4x3"/>
   <p:notesSz cx="6858000" cy="9144000"/>
@@ -2404,6 +2400,333 @@
 </c:chartSpace>
 </file>
 
+<file path=ppt/charts/chart9.xml><?xml version="1.0" encoding="utf-8"?>
+<c:chartSpace xmlns:c="http://schemas.openxmlformats.org/drawingml/2006/chart" xmlns:a="http://schemas.openxmlformats.org/drawingml/2006/main" xmlns:r="http://schemas.openxmlformats.org/officeDocument/2006/relationships">
+  <c:date1904 val="0"/>
+  <c:chart>
+    <c:autoTitleDeleted val="1"/>
+    <c:plotArea>
+      <c:barChart>
+        <c:barDir val="bar"/>
+        <c:grouping val="clustered"/>
+        <c:ser>
+          <c:idx val="0"/>
+          <c:order val="0"/>
+          <c:tx>
+            <c:strRef>
+              <c:f>Sheet1!$B$1</c:f>
+              <c:strCache>
+                <c:ptCount val="1"/>
+                <c:pt idx="0">
+                  <c:v>balanced accuracy</c:v>
+                </c:pt>
+              </c:strCache>
+            </c:strRef>
+          </c:tx>
+          <c:spPr>
+            <a:solidFill>
+              <a:srgbClr val="0F766E"/>
+            </a:solidFill>
+          </c:spPr>
+          <c:dPt>
+            <c:idx val="0"/>
+            <c:spPr>
+              <a:solidFill>
+                <a:srgbClr val="0F766E"/>
+              </a:solidFill>
+            </c:spPr>
+          </c:dPt>
+          <c:dPt>
+            <c:idx val="1"/>
+            <c:spPr>
+              <a:solidFill>
+                <a:srgbClr val="0F766E"/>
+              </a:solidFill>
+            </c:spPr>
+          </c:dPt>
+          <c:dPt>
+            <c:idx val="2"/>
+            <c:spPr>
+              <a:solidFill>
+                <a:srgbClr val="B91C1C"/>
+              </a:solidFill>
+            </c:spPr>
+          </c:dPt>
+          <c:dPt>
+            <c:idx val="3"/>
+            <c:spPr>
+              <a:solidFill>
+                <a:srgbClr val="B91C1C"/>
+              </a:solidFill>
+            </c:spPr>
+          </c:dPt>
+          <c:dLbls>
+            <c:dLbl>
+              <c:idx val="0"/>
+              <c:tx>
+                <c:rich>
+                  <a:bodyPr/>
+                  <a:lstStyle/>
+                  <a:p>
+                    <a:pPr>
+                      <a:defRPr sz="1300">
+                        <a:solidFill>
+                          <a:srgbClr val="111827"/>
+                        </a:solidFill>
+                        <a:latin typeface="Calibri"/>
+                      </a:defRPr>
+                    </a:pPr>
+                    <a:r>
+                      <a:t>1.000</a:t>
+                    </a:r>
+                  </a:p>
+                </c:rich>
+              </c:tx>
+              <c:dLblPos val="outEnd"/>
+              <c:showLegendKey val="0"/>
+              <c:showVal val="1"/>
+              <c:showCatName val="0"/>
+              <c:showSerName val="0"/>
+              <c:showPercent val="0"/>
+              <c:showBubbleSize val="0"/>
+            </c:dLbl>
+            <c:dLbl>
+              <c:idx val="1"/>
+              <c:tx>
+                <c:rich>
+                  <a:bodyPr/>
+                  <a:lstStyle/>
+                  <a:p>
+                    <a:pPr>
+                      <a:defRPr sz="1300">
+                        <a:solidFill>
+                          <a:srgbClr val="111827"/>
+                        </a:solidFill>
+                        <a:latin typeface="Calibri"/>
+                      </a:defRPr>
+                    </a:pPr>
+                    <a:r>
+                      <a:t>1.000</a:t>
+                    </a:r>
+                  </a:p>
+                </c:rich>
+              </c:tx>
+              <c:dLblPos val="outEnd"/>
+              <c:showLegendKey val="0"/>
+              <c:showVal val="1"/>
+              <c:showCatName val="0"/>
+              <c:showSerName val="0"/>
+              <c:showPercent val="0"/>
+              <c:showBubbleSize val="0"/>
+            </c:dLbl>
+            <c:dLbl>
+              <c:idx val="2"/>
+              <c:tx>
+                <c:rich>
+                  <a:bodyPr/>
+                  <a:lstStyle/>
+                  <a:p>
+                    <a:pPr>
+                      <a:defRPr sz="1300">
+                        <a:solidFill>
+                          <a:srgbClr val="111827"/>
+                        </a:solidFill>
+                        <a:latin typeface="Calibri"/>
+                      </a:defRPr>
+                    </a:pPr>
+                    <a:r>
+                      <a:t>0.939</a:t>
+                    </a:r>
+                  </a:p>
+                </c:rich>
+              </c:tx>
+              <c:dLblPos val="outEnd"/>
+              <c:showLegendKey val="0"/>
+              <c:showVal val="1"/>
+              <c:showCatName val="0"/>
+              <c:showSerName val="0"/>
+              <c:showPercent val="0"/>
+              <c:showBubbleSize val="0"/>
+            </c:dLbl>
+            <c:dLbl>
+              <c:idx val="3"/>
+              <c:tx>
+                <c:rich>
+                  <a:bodyPr/>
+                  <a:lstStyle/>
+                  <a:p>
+                    <a:pPr>
+                      <a:defRPr sz="1300">
+                        <a:solidFill>
+                          <a:srgbClr val="111827"/>
+                        </a:solidFill>
+                        <a:latin typeface="Calibri"/>
+                      </a:defRPr>
+                    </a:pPr>
+                    <a:r>
+                      <a:t>0.812</a:t>
+                    </a:r>
+                  </a:p>
+                </c:rich>
+              </c:tx>
+              <c:dLblPos val="outEnd"/>
+              <c:showLegendKey val="0"/>
+              <c:showVal val="1"/>
+              <c:showCatName val="0"/>
+              <c:showSerName val="0"/>
+              <c:showPercent val="0"/>
+              <c:showBubbleSize val="0"/>
+            </c:dLbl>
+            <c:showLegendKey val="0"/>
+            <c:showVal val="0"/>
+            <c:showCatName val="0"/>
+            <c:showSerName val="0"/>
+            <c:showPercent val="0"/>
+            <c:showBubbleSize val="0"/>
+            <c:showLeaderLines val="1"/>
+          </c:dLbls>
+          <c:cat>
+            <c:strRef>
+              <c:f>Sheet1!$A$2:$A$5</c:f>
+              <c:strCache>
+                <c:ptCount val="4"/>
+                <c:pt idx="0">
+                  <c:v>Random split</c:v>
+                </c:pt>
+                <c:pt idx="1">
+                  <c:v>Random, deduplicated</c:v>
+                </c:pt>
+                <c:pt idx="2">
+                  <c:v>Host-held-out, class-covered</c:v>
+                </c:pt>
+                <c:pt idx="3">
+                  <c:v>Host-held-out, class-covered, deduplicated</c:v>
+                </c:pt>
+              </c:strCache>
+            </c:strRef>
+          </c:cat>
+          <c:val>
+            <c:numRef>
+              <c:f>Sheet1!$B$2:$B$5</c:f>
+              <c:numCache>
+                <c:formatCode>General</c:formatCode>
+                <c:ptCount val="4"/>
+                <c:pt idx="0">
+                  <c:v>0.9998167871515384</c:v>
+                </c:pt>
+                <c:pt idx="1">
+                  <c:v>0.9997715901183806</c:v>
+                </c:pt>
+                <c:pt idx="2">
+                  <c:v>0.9391899772037873</c:v>
+                </c:pt>
+                <c:pt idx="3">
+                  <c:v>0.8119448415185637</c:v>
+                </c:pt>
+              </c:numCache>
+            </c:numRef>
+          </c:val>
+        </c:ser>
+        <c:dLbls>
+          <c:numFmt formatCode="0.000" sourceLinked="0"/>
+          <c:txPr>
+            <a:bodyPr/>
+            <a:lstStyle/>
+            <a:p>
+              <a:pPr>
+                <a:defRPr sz="1300">
+                  <a:solidFill>
+                    <a:srgbClr val="111827"/>
+                  </a:solidFill>
+                  <a:latin typeface="Calibri"/>
+                </a:defRPr>
+              </a:pPr>
+            </a:p>
+          </c:txPr>
+          <c:dLblPos val="outEnd"/>
+          <c:showLegendKey val="0"/>
+          <c:showVal val="1"/>
+          <c:showCatName val="0"/>
+          <c:showSerName val="0"/>
+          <c:showPercent val="0"/>
+          <c:showBubbleSize val="0"/>
+          <c:showLeaderLines val="1"/>
+        </c:dLbls>
+        <c:gapWidth val="60"/>
+        <c:axId val="-2068027336"/>
+        <c:axId val="-2113994440"/>
+      </c:barChart>
+      <c:catAx>
+        <c:axId val="-2068027336"/>
+        <c:scaling>
+          <c:orientation val="maxMin"/>
+        </c:scaling>
+        <c:delete val="0"/>
+        <c:axPos val="l"/>
+        <c:majorTickMark val="out"/>
+        <c:minorTickMark val="none"/>
+        <c:tickLblPos val="nextTo"/>
+        <c:spPr>
+          <a:ln>
+            <a:solidFill>
+              <a:srgbClr val="D1D5DB"/>
+            </a:solidFill>
+          </a:ln>
+        </c:spPr>
+        <c:txPr>
+          <a:bodyPr/>
+          <a:lstStyle/>
+          <a:p>
+            <a:pPr>
+              <a:defRPr sz="1200"/>
+            </a:pPr>
+          </a:p>
+        </c:txPr>
+        <c:crossAx val="-2113994440"/>
+        <c:crosses val="autoZero"/>
+        <c:auto val="1"/>
+        <c:lblAlgn val="ctr"/>
+        <c:lblOffset val="100"/>
+        <c:noMultiLvlLbl val="0"/>
+      </c:catAx>
+      <c:valAx>
+        <c:axId val="-2113994440"/>
+        <c:scaling>
+          <c:max val="1.2"/>
+          <c:min val="0.0"/>
+        </c:scaling>
+        <c:delete/>
+        <c:axPos val="b"/>
+        <c:majorTickMark val="out"/>
+        <c:minorTickMark val="none"/>
+        <c:tickLblPos val="nextTo"/>
+        <c:crossAx val="-2068027336"/>
+        <c:crosses val="autoZero"/>
+      </c:valAx>
+    </c:plotArea>
+    <c:dispBlanksAs val="gap"/>
+  </c:chart>
+  <c:txPr>
+    <a:bodyPr/>
+    <a:lstStyle/>
+    <a:p>
+      <a:pPr>
+        <a:defRPr sz="1200">
+          <a:solidFill>
+            <a:srgbClr val="111827"/>
+          </a:solidFill>
+          <a:latin typeface="Calibri"/>
+        </a:defRPr>
+      </a:pPr>
+      <a:endParaRPr lang="en-US"/>
+    </a:p>
+  </c:txPr>
+  <c:externalData r:id="rId1">
+    <c:autoUpdate val="0"/>
+  </c:externalData>
+</c:chartSpace>
+</file>
+
 <file path=ppt/slideLayouts/slideLayout1.xml><?xml version="1.0" encoding="utf-8"?>
 <p:sldLayout xmlns:a="http://schemas.openxmlformats.org/drawingml/2006/main" xmlns:r="http://schemas.openxmlformats.org/officeDocument/2006/relationships" xmlns:p="http://schemas.openxmlformats.org/presentationml/2006/main" type="title" preserve="1">
   <p:cSld name="Title Slide">
@@ -5445,21 +5768,21 @@
         <p:spPr>
           <a:xfrm>
             <a:off x="731520" y="2011680"/>
-            <a:ext cx="10515600" cy="1463040"/>
-          </a:xfrm>
-          <a:prstGeom prst="rect">
-            <a:avLst/>
-          </a:prstGeom>
-          <a:noFill/>
-        </p:spPr>
-        <p:txBody>
-          <a:bodyPr wrap="square" lIns="0" rIns="0" tIns="0" bIns="0">
-            <a:spAutoFit/>
-          </a:bodyPr>
-          <a:lstStyle/>
-          <a:p>
-            <a:pPr>
-              <a:defRPr sz="4200" b="1">
+            <a:ext cx="10698480" cy="1737360"/>
+          </a:xfrm>
+          <a:prstGeom prst="rect">
+            <a:avLst/>
+          </a:prstGeom>
+          <a:noFill/>
+        </p:spPr>
+        <p:txBody>
+          <a:bodyPr wrap="square" lIns="0" rIns="0" tIns="0" bIns="0">
+            <a:spAutoFit/>
+          </a:bodyPr>
+          <a:lstStyle/>
+          <a:p>
+            <a:pPr>
+              <a:defRPr sz="3400" b="1">
                 <a:solidFill>
                   <a:srgbClr val="111827"/>
                 </a:solidFill>
@@ -5467,7 +5790,7 @@
               </a:defRPr>
             </a:pPr>
             <a:r>
-              <a:t>What an SDN Controller Can Actually Observe</a:t>
+              <a:t>Evaluation Validity in SDN Intrusion Detection: Controller Observability and Held-Out-Host Generalization on InSDN</a:t>
             </a:r>
           </a:p>
         </p:txBody>
@@ -5480,7 +5803,7 @@
         </p:nvSpPr>
         <p:spPr>
           <a:xfrm>
-            <a:off x="731520" y="3566160"/>
+            <a:off x="731520" y="3931920"/>
             <a:ext cx="10515600" cy="548640"/>
           </a:xfrm>
           <a:prstGeom prst="rect">
@@ -5503,7 +5826,7 @@
               </a:defRPr>
             </a:pPr>
             <a:r>
-              <a:t>A measurement and validity study of the InSDN OpenFlow control channel</a:t>
+              <a:t>A measurement and evaluation-protocol study</a:t>
             </a:r>
           </a:p>
         </p:txBody>
@@ -5709,7 +6032,7 @@
               </a:defRPr>
             </a:pPr>
             <a:r>
-              <a:t>Proteus · What an SDN controller can observe</a:t>
+              <a:t>Evaluation Validity in SDN Intrusion Detection</a:t>
             </a:r>
           </a:p>
         </p:txBody>
@@ -5984,7 +6307,7 @@
               </a:defRPr>
             </a:pPr>
             <a:r>
-              <a:t>Contribution 5 · The forwarding app sets the view</a:t>
+              <a:t>The forwarding app sets what the controller observes</a:t>
             </a:r>
           </a:p>
         </p:txBody>
@@ -6020,7 +6343,7 @@
               </a:defRPr>
             </a:pPr>
             <a:r>
-              <a:t>Proteus · What an SDN controller can observe</a:t>
+              <a:t>Evaluation Validity in SDN Intrusion Detection</a:t>
             </a:r>
           </a:p>
         </p:txBody>
@@ -6056,7 +6379,7 @@
               </a:defRPr>
             </a:pPr>
             <a:r>
-              <a:t>11</a:t>
+              <a:t>6</a:t>
             </a:r>
           </a:p>
         </p:txBody>
@@ -6371,7 +6694,7 @@
               </a:defRPr>
             </a:pPr>
             <a:r>
-              <a:t>Proteus · What an SDN controller can observe</a:t>
+              <a:t>Evaluation Validity in SDN Intrusion Detection</a:t>
             </a:r>
           </a:p>
         </p:txBody>
@@ -6853,7 +7176,7 @@
               </a:defRPr>
             </a:pPr>
             <a:r>
-              <a:t>Random splits inflate scores: 9 points on InSDN, 35 on CICIDS2017</a:t>
+              <a:t>Random splits inflate scores: 9 points (InSDN), 35 (CICIDS2017)</a:t>
             </a:r>
           </a:p>
         </p:txBody>
@@ -6889,7 +7212,7 @@
               </a:defRPr>
             </a:pPr>
             <a:r>
-              <a:t>Proteus · What an SDN controller can observe</a:t>
+              <a:t>Evaluation Validity in SDN Intrusion Detection</a:t>
             </a:r>
           </a:p>
         </p:txBody>
@@ -6925,7 +7248,7 @@
               </a:defRPr>
             </a:pPr>
             <a:r>
-              <a:t>13</a:t>
+              <a:t>7</a:t>
             </a:r>
           </a:p>
         </p:txBody>
@@ -7220,7 +7543,7 @@
               </a:defRPr>
             </a:pPr>
             <a:r>
-              <a:t>What published InSDN papers report vs how they split</a:t>
+              <a:t>Published papers rarely describe their split</a:t>
             </a:r>
           </a:p>
         </p:txBody>
@@ -7256,7 +7579,7 @@
               </a:defRPr>
             </a:pPr>
             <a:r>
-              <a:t>Proteus · What an SDN controller can observe</a:t>
+              <a:t>Evaluation Validity in SDN Intrusion Detection</a:t>
             </a:r>
           </a:p>
         </p:txBody>
@@ -7292,7 +7615,7 @@
               </a:defRPr>
             </a:pPr>
             <a:r>
-              <a:t>14</a:t>
+              <a:t>10</a:t>
             </a:r>
           </a:p>
         </p:txBody>
@@ -8577,7 +8900,7 @@
               </a:defRPr>
             </a:pPr>
             <a:r>
-              <a:t>10 of 12 papers read in full; the 2 unread ones are not characterised. Table: the 9 read papers that use InSDN (one more read paper is not on InSDN). Numbers are the authors' own, not re-run. None groups by host; none evaluates a real controller.</a:t>
+              <a:t>Ten papers read in full; most do not describe their split; none reports a host-grouped one. Table: the read papers that use InSDN; numbers are the authors' own, not re-run.</a:t>
             </a:r>
           </a:p>
         </p:txBody>
@@ -8711,7 +9034,7 @@
               </a:defRPr>
             </a:pPr>
             <a:r>
-              <a:t>Proteus · What an SDN controller can observe</a:t>
+              <a:t>Evaluation Validity in SDN Intrusion Detection</a:t>
             </a:r>
           </a:p>
         </p:txBody>
@@ -8747,7 +9070,7 @@
               </a:defRPr>
             </a:pPr>
             <a:r>
-              <a:t>15</a:t>
+              <a:t>11</a:t>
             </a:r>
           </a:p>
         </p:txBody>
@@ -9006,7 +9329,7 @@
               </a:defRPr>
             </a:pPr>
             <a:r>
-              <a:t>Only about 3 attacker hosts: held-out-host detection collapses</a:t>
+              <a:t>Held-out attacker hosts are poorly detected, on both datasets</a:t>
             </a:r>
           </a:p>
         </p:txBody>
@@ -9042,7 +9365,7 @@
               </a:defRPr>
             </a:pPr>
             <a:r>
-              <a:t>Proteus · What an SDN controller can observe</a:t>
+              <a:t>Evaluation Validity in SDN Intrusion Detection</a:t>
             </a:r>
           </a:p>
         </p:txBody>
@@ -9078,7 +9401,7 @@
               </a:defRPr>
             </a:pPr>
             <a:r>
-              <a:t>16</a:t>
+              <a:t>8</a:t>
             </a:r>
           </a:p>
         </p:txBody>
@@ -9168,7 +9491,7 @@
               </a:defRPr>
             </a:pPr>
             <a:r>
-              <a:t>Train on all other hosts, test on the held-out host. Teal: attack recall; grey: benign false-positive rate; red: highlighted.</a:t>
+              <a:t>Train on all other hosts, test on the held-out host. Green bars: attack recall; grey: benign false-positive rate; red: weak held-out host.</a:t>
             </a:r>
           </a:p>
         </p:txBody>
@@ -9182,6 +9505,114 @@
         <p:spPr>
           <a:xfrm>
             <a:off x="7680960" y="1783080"/>
+            <a:ext cx="4023360" cy="320040"/>
+          </a:xfrm>
+          <a:prstGeom prst="rect">
+            <a:avLst/>
+          </a:prstGeom>
+          <a:noFill/>
+        </p:spPr>
+        <p:txBody>
+          <a:bodyPr wrap="square" lIns="0" rIns="0" tIns="0" bIns="0">
+            <a:spAutoFit/>
+          </a:bodyPr>
+          <a:lstStyle/>
+          <a:p>
+            <a:pPr>
+              <a:defRPr sz="1400" b="1">
+                <a:solidFill>
+                  <a:srgbClr val="0F766E"/>
+                </a:solidFill>
+                <a:latin typeface="Calibri"/>
+              </a:defRPr>
+            </a:pPr>
+            <a:r>
+              <a:t>CICIDS2017</a:t>
+            </a:r>
+          </a:p>
+        </p:txBody>
+      </p:sp>
+      <p:sp>
+        <p:nvSpPr>
+          <p:cNvPr id="10" name="TextBox 9"/>
+          <p:cNvSpPr txBox="1"/>
+          <p:nvPr/>
+        </p:nvSpPr>
+        <p:spPr>
+          <a:xfrm>
+            <a:off x="7680960" y="2148840"/>
+            <a:ext cx="4023360" cy="731520"/>
+          </a:xfrm>
+          <a:prstGeom prst="rect">
+            <a:avLst/>
+          </a:prstGeom>
+          <a:noFill/>
+        </p:spPr>
+        <p:txBody>
+          <a:bodyPr wrap="square" lIns="0" rIns="0" tIns="0" bIns="0">
+            <a:spAutoFit/>
+          </a:bodyPr>
+          <a:lstStyle/>
+          <a:p>
+            <a:pPr>
+              <a:defRPr sz="1300" b="0">
+                <a:solidFill>
+                  <a:srgbClr val="6B7280"/>
+                </a:solidFill>
+                <a:latin typeface="Calibri"/>
+              </a:defRPr>
+            </a:pPr>
+            <a:r>
+              <a:t>48 source IPs, 19 with a single flow; 15 hosts hold nearly all 2,100,814 rows.</a:t>
+            </a:r>
+          </a:p>
+        </p:txBody>
+      </p:sp>
+      <p:sp>
+        <p:nvSpPr>
+          <p:cNvPr id="11" name="TextBox 10"/>
+          <p:cNvSpPr txBox="1"/>
+          <p:nvPr/>
+        </p:nvSpPr>
+        <p:spPr>
+          <a:xfrm>
+            <a:off x="7680960" y="2926080"/>
+            <a:ext cx="4023360" cy="914400"/>
+          </a:xfrm>
+          <a:prstGeom prst="rect">
+            <a:avLst/>
+          </a:prstGeom>
+          <a:noFill/>
+        </p:spPr>
+        <p:txBody>
+          <a:bodyPr wrap="square" lIns="0" rIns="0" tIns="0" bIns="0">
+            <a:spAutoFit/>
+          </a:bodyPr>
+          <a:lstStyle/>
+          <a:p>
+            <a:pPr>
+              <a:defRPr sz="4800" b="1">
+                <a:solidFill>
+                  <a:srgbClr val="B91C1C"/>
+                </a:solidFill>
+                <a:latin typeface="Calibri"/>
+              </a:defRPr>
+            </a:pPr>
+            <a:r>
+              <a:t>0.28</a:t>
+            </a:r>
+          </a:p>
+        </p:txBody>
+      </p:sp>
+      <p:sp>
+        <p:nvSpPr>
+          <p:cNvPr id="12" name="TextBox 11"/>
+          <p:cNvSpPr txBox="1"/>
+          <p:nvPr/>
+        </p:nvSpPr>
+        <p:spPr>
+          <a:xfrm>
+            <a:off x="7680960" y="3886200"/>
             <a:ext cx="4023360" cy="822960"/>
           </a:xfrm>
           <a:prstGeom prst="rect">
@@ -9196,7 +9627,43 @@
           <a:lstStyle/>
           <a:p>
             <a:pPr>
-              <a:defRPr sz="1400" b="0">
+              <a:defRPr sz="1600" b="0">
+                <a:solidFill>
+                  <a:srgbClr val="6B7280"/>
+                </a:solidFill>
+                <a:latin typeface="Calibri"/>
+              </a:defRPr>
+            </a:pPr>
+            <a:r>
+              <a:t>attack recall when the main attacker 172.16.0.1 is held out</a:t>
+            </a:r>
+          </a:p>
+        </p:txBody>
+      </p:sp>
+      <p:sp>
+        <p:nvSpPr>
+          <p:cNvPr id="13" name="TextBox 12"/>
+          <p:cNvSpPr txBox="1"/>
+          <p:nvPr/>
+        </p:nvSpPr>
+        <p:spPr>
+          <a:xfrm>
+            <a:off x="7680960" y="4572000"/>
+            <a:ext cx="4023360" cy="822960"/>
+          </a:xfrm>
+          <a:prstGeom prst="rect">
+            <a:avLst/>
+          </a:prstGeom>
+          <a:noFill/>
+        </p:spPr>
+        <p:txBody>
+          <a:bodyPr wrap="square" lIns="0" rIns="0" tIns="0" bIns="0">
+            <a:spAutoFit/>
+          </a:bodyPr>
+          <a:lstStyle/>
+          <a:p>
+            <a:pPr>
+              <a:defRPr sz="1300" b="0">
                 <a:solidFill>
                   <a:srgbClr val="111827"/>
                 </a:solidFill>
@@ -9204,295 +9671,7 @@
               </a:defRPr>
             </a:pPr>
             <a:r>
-              <a:t>Duplicates are not the mechanism: dropping 46% exact duplicates leaves random-split BAcc at 0.9998.</a:t>
-            </a:r>
-          </a:p>
-        </p:txBody>
-      </p:sp>
-      <p:sp>
-        <p:nvSpPr>
-          <p:cNvPr id="10" name="TextBox 9"/>
-          <p:cNvSpPr txBox="1"/>
-          <p:nvPr/>
-        </p:nvSpPr>
-        <p:spPr>
-          <a:xfrm>
-            <a:off x="7680960" y="2743200"/>
-            <a:ext cx="4023360" cy="320040"/>
-          </a:xfrm>
-          <a:prstGeom prst="rect">
-            <a:avLst/>
-          </a:prstGeom>
-          <a:noFill/>
-        </p:spPr>
-        <p:txBody>
-          <a:bodyPr wrap="square" lIns="0" rIns="0" tIns="0" bIns="0">
-            <a:spAutoFit/>
-          </a:bodyPr>
-          <a:lstStyle/>
-          <a:p>
-            <a:pPr>
-              <a:defRPr sz="1400" b="1">
-                <a:solidFill>
-                  <a:srgbClr val="0F766E"/>
-                </a:solidFill>
-                <a:latin typeface="Calibri"/>
-              </a:defRPr>
-            </a:pPr>
-            <a:r>
-              <a:t>SDNGuardStack approximation (5 seeds)</a:t>
-            </a:r>
-          </a:p>
-        </p:txBody>
-      </p:sp>
-      <p:sp>
-        <p:nvSpPr>
-          <p:cNvPr id="11" name="TextBox 10"/>
-          <p:cNvSpPr txBox="1"/>
-          <p:nvPr/>
-        </p:nvSpPr>
-        <p:spPr>
-          <a:xfrm>
-            <a:off x="7680960" y="3154680"/>
-            <a:ext cx="1920240" cy="548640"/>
-          </a:xfrm>
-          <a:prstGeom prst="rect">
-            <a:avLst/>
-          </a:prstGeom>
-          <a:noFill/>
-        </p:spPr>
-        <p:txBody>
-          <a:bodyPr wrap="square" lIns="0" rIns="0" tIns="0" bIns="0">
-            <a:spAutoFit/>
-          </a:bodyPr>
-          <a:lstStyle/>
-          <a:p>
-            <a:pPr>
-              <a:defRPr sz="2200" b="1">
-                <a:solidFill>
-                  <a:srgbClr val="0F766E"/>
-                </a:solidFill>
-                <a:latin typeface="Calibri"/>
-              </a:defRPr>
-            </a:pPr>
-            <a:r>
-              <a:t>0.9999</a:t>
-            </a:r>
-          </a:p>
-        </p:txBody>
-      </p:sp>
-      <p:sp>
-        <p:nvSpPr>
-          <p:cNvPr id="12" name="TextBox 11"/>
-          <p:cNvSpPr txBox="1"/>
-          <p:nvPr/>
-        </p:nvSpPr>
-        <p:spPr>
-          <a:xfrm>
-            <a:off x="9646920" y="3227832"/>
-            <a:ext cx="2103120" cy="548640"/>
-          </a:xfrm>
-          <a:prstGeom prst="rect">
-            <a:avLst/>
-          </a:prstGeom>
-          <a:noFill/>
-        </p:spPr>
-        <p:txBody>
-          <a:bodyPr wrap="square" lIns="0" rIns="0" tIns="0" bIns="0">
-            <a:spAutoFit/>
-          </a:bodyPr>
-          <a:lstStyle/>
-          <a:p>
-            <a:pPr>
-              <a:defRPr sz="1200" b="0">
-                <a:solidFill>
-                  <a:srgbClr val="6B7280"/>
-                </a:solidFill>
-                <a:latin typeface="Calibri"/>
-              </a:defRPr>
-            </a:pPr>
-            <a:r>
-              <a:t>Random split (reported 99.98%)</a:t>
-            </a:r>
-          </a:p>
-        </p:txBody>
-      </p:sp>
-      <p:sp>
-        <p:nvSpPr>
-          <p:cNvPr id="13" name="TextBox 12"/>
-          <p:cNvSpPr txBox="1"/>
-          <p:nvPr/>
-        </p:nvSpPr>
-        <p:spPr>
-          <a:xfrm>
-            <a:off x="7680960" y="3840480"/>
-            <a:ext cx="1920240" cy="548640"/>
-          </a:xfrm>
-          <a:prstGeom prst="rect">
-            <a:avLst/>
-          </a:prstGeom>
-          <a:noFill/>
-        </p:spPr>
-        <p:txBody>
-          <a:bodyPr wrap="square" lIns="0" rIns="0" tIns="0" bIns="0">
-            <a:spAutoFit/>
-          </a:bodyPr>
-          <a:lstStyle/>
-          <a:p>
-            <a:pPr>
-              <a:defRPr sz="2200" b="1">
-                <a:solidFill>
-                  <a:srgbClr val="B91C1C"/>
-                </a:solidFill>
-                <a:latin typeface="Calibri"/>
-              </a:defRPr>
-            </a:pPr>
-            <a:r>
-              <a:t>0.72 to 0.78</a:t>
-            </a:r>
-          </a:p>
-        </p:txBody>
-      </p:sp>
-      <p:sp>
-        <p:nvSpPr>
-          <p:cNvPr id="14" name="TextBox 13"/>
-          <p:cNvSpPr txBox="1"/>
-          <p:nvPr/>
-        </p:nvSpPr>
-        <p:spPr>
-          <a:xfrm>
-            <a:off x="9646920" y="3913632"/>
-            <a:ext cx="2103120" cy="548640"/>
-          </a:xfrm>
-          <a:prstGeom prst="rect">
-            <a:avLst/>
-          </a:prstGeom>
-          <a:noFill/>
-        </p:spPr>
-        <p:txBody>
-          <a:bodyPr wrap="square" lIns="0" rIns="0" tIns="0" bIns="0">
-            <a:spAutoFit/>
-          </a:bodyPr>
-          <a:lstStyle/>
-          <a:p>
-            <a:pPr>
-              <a:defRPr sz="1200" b="0">
-                <a:solidFill>
-                  <a:srgbClr val="6B7280"/>
-                </a:solidFill>
-                <a:latin typeface="Calibri"/>
-              </a:defRPr>
-            </a:pPr>
-            <a:r>
-              <a:t>Source-IP grouped</a:t>
-            </a:r>
-          </a:p>
-        </p:txBody>
-      </p:sp>
-      <p:sp>
-        <p:nvSpPr>
-          <p:cNvPr id="15" name="TextBox 14"/>
-          <p:cNvSpPr txBox="1"/>
-          <p:nvPr/>
-        </p:nvSpPr>
-        <p:spPr>
-          <a:xfrm>
-            <a:off x="7680960" y="4526280"/>
-            <a:ext cx="1920240" cy="548640"/>
-          </a:xfrm>
-          <a:prstGeom prst="rect">
-            <a:avLst/>
-          </a:prstGeom>
-          <a:noFill/>
-        </p:spPr>
-        <p:txBody>
-          <a:bodyPr wrap="square" lIns="0" rIns="0" tIns="0" bIns="0">
-            <a:spAutoFit/>
-          </a:bodyPr>
-          <a:lstStyle/>
-          <a:p>
-            <a:pPr>
-              <a:defRPr sz="2200" b="1">
-                <a:solidFill>
-                  <a:srgbClr val="9CA3AF"/>
-                </a:solidFill>
-                <a:latin typeface="Calibri"/>
-              </a:defRPr>
-            </a:pPr>
-            <a:r>
-              <a:t>±0.39</a:t>
-            </a:r>
-          </a:p>
-        </p:txBody>
-      </p:sp>
-      <p:sp>
-        <p:nvSpPr>
-          <p:cNvPr id="16" name="TextBox 15"/>
-          <p:cNvSpPr txBox="1"/>
-          <p:nvPr/>
-        </p:nvSpPr>
-        <p:spPr>
-          <a:xfrm>
-            <a:off x="9646920" y="4599432"/>
-            <a:ext cx="2103120" cy="548640"/>
-          </a:xfrm>
-          <a:prstGeom prst="rect">
-            <a:avLst/>
-          </a:prstGeom>
-          <a:noFill/>
-        </p:spPr>
-        <p:txBody>
-          <a:bodyPr wrap="square" lIns="0" rIns="0" tIns="0" bIns="0">
-            <a:spAutoFit/>
-          </a:bodyPr>
-          <a:lstStyle/>
-          <a:p>
-            <a:pPr>
-              <a:defRPr sz="1200" b="0">
-                <a:solidFill>
-                  <a:srgbClr val="6B7280"/>
-                </a:solidFill>
-                <a:latin typeface="Calibri"/>
-              </a:defRPr>
-            </a:pPr>
-            <a:r>
-              <a:t>Largest 95% CI, grouped</a:t>
-            </a:r>
-          </a:p>
-        </p:txBody>
-      </p:sp>
-      <p:sp>
-        <p:nvSpPr>
-          <p:cNvPr id="17" name="TextBox 16"/>
-          <p:cNvSpPr txBox="1"/>
-          <p:nvPr/>
-        </p:nvSpPr>
-        <p:spPr>
-          <a:xfrm>
-            <a:off x="7680960" y="5303520"/>
-            <a:ext cx="4023360" cy="548640"/>
-          </a:xfrm>
-          <a:prstGeom prst="rect">
-            <a:avLst/>
-          </a:prstGeom>
-          <a:noFill/>
-        </p:spPr>
-        <p:txBody>
-          <a:bodyPr wrap="square" lIns="0" rIns="0" tIns="0" bIns="0">
-            <a:spAutoFit/>
-          </a:bodyPr>
-          <a:lstStyle/>
-          <a:p>
-            <a:pPr>
-              <a:defRPr sz="1400" b="1">
-                <a:solidFill>
-                  <a:srgbClr val="111827"/>
-                </a:solidFill>
-                <a:latin typeface="Calibri"/>
-              </a:defRPr>
-            </a:pPr>
-            <a:r>
-              <a:t>Reproduces under its own protocol; does not hold for unseen hosts.</a:t>
+              <a:t>0.54 of its benign flows are flagged. Training on all other hosts, XGBoost, 3 model seeds.</a:t>
             </a:r>
           </a:p>
         </p:txBody>
@@ -9554,7 +9733,7 @@
               </a:defRPr>
             </a:pPr>
             <a:r>
-              <a:t>HONEST SCOPE</a:t>
+              <a:t>PARTIAL REPLICATION</a:t>
             </a:r>
           </a:p>
         </p:txBody>
@@ -9590,7 +9769,7 @@
               </a:defRPr>
             </a:pPr>
             <a:r>
-              <a:t>Limitations we state ourselves</a:t>
+              <a:t>SDNGuardStack fails on unseen hosts</a:t>
             </a:r>
           </a:p>
         </p:txBody>
@@ -9626,7 +9805,7 @@
               </a:defRPr>
             </a:pPr>
             <a:r>
-              <a:t>Proteus · What an SDN controller can observe</a:t>
+              <a:t>Evaluation Validity in SDN Intrusion Detection</a:t>
             </a:r>
           </a:p>
         </p:txBody>
@@ -9662,7 +9841,7 @@
               </a:defRPr>
             </a:pPr>
             <a:r>
-              <a:t>17</a:t>
+              <a:t>12</a:t>
             </a:r>
           </a:p>
         </p:txBody>
@@ -9675,25 +9854,58 @@
         </p:nvSpPr>
         <p:spPr>
           <a:xfrm>
-            <a:off x="548640" y="1828800"/>
-            <a:ext cx="11064240" cy="4114800"/>
-          </a:xfrm>
-          <a:prstGeom prst="rect">
-            <a:avLst/>
-          </a:prstGeom>
-          <a:noFill/>
-        </p:spPr>
-        <p:txBody>
-          <a:bodyPr wrap="square" lIns="0" rIns="0" tIns="0" bIns="0">
-            <a:spAutoFit/>
-          </a:bodyPr>
-          <a:lstStyle/>
-          <a:p>
-            <a:pPr>
-              <a:spcAft>
-                <a:spcPts val="1400"/>
-              </a:spcAft>
-              <a:defRPr sz="1800">
+            <a:off x="548640" y="1737360"/>
+            <a:ext cx="3840480" cy="731520"/>
+          </a:xfrm>
+          <a:prstGeom prst="rect">
+            <a:avLst/>
+          </a:prstGeom>
+          <a:noFill/>
+        </p:spPr>
+        <p:txBody>
+          <a:bodyPr wrap="square" lIns="0" rIns="0" tIns="0" bIns="0">
+            <a:spAutoFit/>
+          </a:bodyPr>
+          <a:lstStyle/>
+          <a:p>
+            <a:pPr>
+              <a:defRPr sz="4000" b="1">
+                <a:solidFill>
+                  <a:srgbClr val="0F766E"/>
+                </a:solidFill>
+                <a:latin typeface="Calibri"/>
+              </a:defRPr>
+            </a:pPr>
+            <a:r>
+              <a:t>0.9999</a:t>
+            </a:r>
+          </a:p>
+        </p:txBody>
+      </p:sp>
+      <p:sp>
+        <p:nvSpPr>
+          <p:cNvPr id="7" name="TextBox 6"/>
+          <p:cNvSpPr txBox="1"/>
+          <p:nvPr/>
+        </p:nvSpPr>
+        <p:spPr>
+          <a:xfrm>
+            <a:off x="4572000" y="1874519"/>
+            <a:ext cx="6949440" cy="731520"/>
+          </a:xfrm>
+          <a:prstGeom prst="rect">
+            <a:avLst/>
+          </a:prstGeom>
+          <a:noFill/>
+        </p:spPr>
+        <p:txBody>
+          <a:bodyPr wrap="square" lIns="0" rIns="0" tIns="0" bIns="0">
+            <a:spAutoFit/>
+          </a:bodyPr>
+          <a:lstStyle/>
+          <a:p>
+            <a:pPr>
+              <a:defRPr sz="1800" b="0">
                 <a:solidFill>
                   <a:srgbClr val="111827"/>
                 </a:solidFill>
@@ -9701,15 +9913,71 @@
               </a:defRPr>
             </a:pPr>
             <a:r>
-              <a:t>Controller study: one dataset (InSDN) and one recorded controller (ONOS); Ryu is checked only on our own benign traffic.</a:t>
-            </a:r>
-          </a:p>
-          <a:p>
-            <a:pPr>
-              <a:spcAft>
-                <a:spcPts val="1400"/>
-              </a:spcAft>
-              <a:defRPr sz="1800">
+              <a:t>Random split, our approximation (paper reports 99.98%)</a:t>
+            </a:r>
+          </a:p>
+        </p:txBody>
+      </p:sp>
+      <p:sp>
+        <p:nvSpPr>
+          <p:cNvPr id="8" name="TextBox 7"/>
+          <p:cNvSpPr txBox="1"/>
+          <p:nvPr/>
+        </p:nvSpPr>
+        <p:spPr>
+          <a:xfrm>
+            <a:off x="548640" y="2971800"/>
+            <a:ext cx="3840480" cy="731520"/>
+          </a:xfrm>
+          <a:prstGeom prst="rect">
+            <a:avLst/>
+          </a:prstGeom>
+          <a:noFill/>
+        </p:spPr>
+        <p:txBody>
+          <a:bodyPr wrap="square" lIns="0" rIns="0" tIns="0" bIns="0">
+            <a:spAutoFit/>
+          </a:bodyPr>
+          <a:lstStyle/>
+          <a:p>
+            <a:pPr>
+              <a:defRPr sz="4000" b="1">
+                <a:solidFill>
+                  <a:srgbClr val="B91C1C"/>
+                </a:solidFill>
+                <a:latin typeface="Calibri"/>
+              </a:defRPr>
+            </a:pPr>
+            <a:r>
+              <a:t>0.72 to 0.78</a:t>
+            </a:r>
+          </a:p>
+        </p:txBody>
+      </p:sp>
+      <p:sp>
+        <p:nvSpPr>
+          <p:cNvPr id="9" name="TextBox 8"/>
+          <p:cNvSpPr txBox="1"/>
+          <p:nvPr/>
+        </p:nvSpPr>
+        <p:spPr>
+          <a:xfrm>
+            <a:off x="4572000" y="3108960"/>
+            <a:ext cx="6949440" cy="731520"/>
+          </a:xfrm>
+          <a:prstGeom prst="rect">
+            <a:avLst/>
+          </a:prstGeom>
+          <a:noFill/>
+        </p:spPr>
+        <p:txBody>
+          <a:bodyPr wrap="square" lIns="0" rIns="0" tIns="0" bIns="0">
+            <a:spAutoFit/>
+          </a:bodyPr>
+          <a:lstStyle/>
+          <a:p>
+            <a:pPr>
+              <a:defRPr sz="1800" b="0">
                 <a:solidFill>
                   <a:srgbClr val="111827"/>
                 </a:solidFill>
@@ -9717,15 +9985,71 @@
               </a:defRPr>
             </a:pPr>
             <a:r>
-              <a:t>We generated no attack traffic; benign and attack are never interleaved in one session.</a:t>
-            </a:r>
-          </a:p>
-          <a:p>
-            <a:pPr>
-              <a:spcAft>
-                <a:spcPts val="1400"/>
-              </a:spcAft>
-              <a:defRPr sz="1800">
+              <a:t>Source-IP grouped split, two training variants</a:t>
+            </a:r>
+          </a:p>
+        </p:txBody>
+      </p:sp>
+      <p:sp>
+        <p:nvSpPr>
+          <p:cNvPr id="10" name="TextBox 9"/>
+          <p:cNvSpPr txBox="1"/>
+          <p:nvPr/>
+        </p:nvSpPr>
+        <p:spPr>
+          <a:xfrm>
+            <a:off x="548640" y="4206240"/>
+            <a:ext cx="3840480" cy="731520"/>
+          </a:xfrm>
+          <a:prstGeom prst="rect">
+            <a:avLst/>
+          </a:prstGeom>
+          <a:noFill/>
+        </p:spPr>
+        <p:txBody>
+          <a:bodyPr wrap="square" lIns="0" rIns="0" tIns="0" bIns="0">
+            <a:spAutoFit/>
+          </a:bodyPr>
+          <a:lstStyle/>
+          <a:p>
+            <a:pPr>
+              <a:defRPr sz="4000" b="1">
+                <a:solidFill>
+                  <a:srgbClr val="9CA3AF"/>
+                </a:solidFill>
+                <a:latin typeface="Calibri"/>
+              </a:defRPr>
+            </a:pPr>
+            <a:r>
+              <a:t>±0.39</a:t>
+            </a:r>
+          </a:p>
+        </p:txBody>
+      </p:sp>
+      <p:sp>
+        <p:nvSpPr>
+          <p:cNvPr id="11" name="TextBox 10"/>
+          <p:cNvSpPr txBox="1"/>
+          <p:nvPr/>
+        </p:nvSpPr>
+        <p:spPr>
+          <a:xfrm>
+            <a:off x="4572000" y="4343400"/>
+            <a:ext cx="6949440" cy="731520"/>
+          </a:xfrm>
+          <a:prstGeom prst="rect">
+            <a:avLst/>
+          </a:prstGeom>
+          <a:noFill/>
+        </p:spPr>
+        <p:txBody>
+          <a:bodyPr wrap="square" lIns="0" rIns="0" tIns="0" bIns="0">
+            <a:spAutoFit/>
+          </a:bodyPr>
+          <a:lstStyle/>
+          <a:p>
+            <a:pPr>
+              <a:defRPr sz="1800" b="0">
                 <a:solidFill>
                   <a:srgbClr val="111827"/>
                 </a:solidFill>
@@ -9733,71 +10057,43 @@
               </a:defRPr>
             </a:pPr>
             <a:r>
-              <a:t>Labels cover only part of the controller-visible traffic, so session identity and unlisted attacks cannot be separated.</a:t>
-            </a:r>
-          </a:p>
-          <a:p>
-            <a:pPr>
-              <a:spcAft>
-                <a:spcPts val="1400"/>
-              </a:spcAft>
-              <a:defRPr sz="1800">
-                <a:solidFill>
-                  <a:srgbClr val="111827"/>
-                </a:solidFill>
-                <a:latin typeface="Calibri"/>
-              </a:defRPr>
-            </a:pPr>
-            <a:r>
-              <a:t>Literature check: 10 of 12 papers read in full; the rest are not characterised. Reported numbers are the authors' own.</a:t>
-            </a:r>
-          </a:p>
-          <a:p>
-            <a:pPr>
-              <a:spcAft>
-                <a:spcPts val="1400"/>
-              </a:spcAft>
-              <a:defRPr sz="1800">
-                <a:solidFill>
-                  <a:srgbClr val="111827"/>
-                </a:solidFill>
-                <a:latin typeface="Calibri"/>
-              </a:defRPr>
-            </a:pPr>
-            <a:r>
-              <a:t>The split audit covers two datasets, one model family (XGBoost) and binary labels; UKMDDoSDN has no benign class and was unusable.</a:t>
-            </a:r>
-          </a:p>
-          <a:p>
-            <a:pPr>
-              <a:spcAft>
-                <a:spcPts val="1400"/>
-              </a:spcAft>
-              <a:defRPr sz="1800">
-                <a:solidFill>
-                  <a:srgbClr val="111827"/>
-                </a:solidFill>
-                <a:latin typeface="Calibri"/>
-              </a:defRPr>
-            </a:pPr>
-            <a:r>
-              <a:t>Phase 1 figures come from archived studies and are not re-run here.</a:t>
-            </a:r>
-          </a:p>
-          <a:p>
-            <a:pPr>
-              <a:spcAft>
-                <a:spcPts val="1400"/>
-              </a:spcAft>
-              <a:defRPr sz="1800">
-                <a:solidFill>
-                  <a:srgbClr val="111827"/>
-                </a:solidFill>
-                <a:latin typeface="Calibri"/>
-              </a:defRPr>
-            </a:pPr>
-            <a:r>
-              <a:t>Our literature search (October 2026) is evidence, not proof, that no one has measured this on an SDN dataset.</a:t>
+              <a:t>Largest 95% CI across seeds on the grouped split</a:t>
+            </a:r>
+          </a:p>
+        </p:txBody>
+      </p:sp>
+      <p:sp>
+        <p:nvSpPr>
+          <p:cNvPr id="12" name="TextBox 11"/>
+          <p:cNvSpPr txBox="1"/>
+          <p:nvPr/>
+        </p:nvSpPr>
+        <p:spPr>
+          <a:xfrm>
+            <a:off x="548640" y="5577840"/>
+            <a:ext cx="11064240" cy="640080"/>
+          </a:xfrm>
+          <a:prstGeom prst="rect">
+            <a:avLst/>
+          </a:prstGeom>
+          <a:noFill/>
+        </p:spPr>
+        <p:txBody>
+          <a:bodyPr wrap="square" lIns="0" rIns="0" tIns="0" bIns="0">
+            <a:spAutoFit/>
+          </a:bodyPr>
+          <a:lstStyle/>
+          <a:p>
+            <a:pPr>
+              <a:defRPr sz="1400" b="0">
+                <a:solidFill>
+                  <a:srgbClr val="6B7280"/>
+                </a:solidFill>
+                <a:latin typeface="Calibri"/>
+              </a:defRPr>
+            </a:pPr>
+            <a:r>
+              <a:t>Partial replication: 5 seeds, an approximation of the paper's model and features, not its code. Grouping by host is a stress test, not a deployment estimate.</a:t>
             </a:r>
           </a:p>
         </p:txBody>
@@ -9859,7 +10155,7 @@
               </a:defRPr>
             </a:pPr>
             <a:r>
-              <a:t>NOVELTY AND SCOPE</a:t>
+              <a:t>CONTROLS</a:t>
             </a:r>
           </a:p>
         </p:txBody>
@@ -9895,7 +10191,7 @@
               </a:defRPr>
             </a:pPr>
             <a:r>
-              <a:t>Contributions: what is new and what is known</a:t>
+              <a:t>Duplicates and class absence do not explain the drop</a:t>
             </a:r>
           </a:p>
         </p:txBody>
@@ -9931,7 +10227,7 @@
               </a:defRPr>
             </a:pPr>
             <a:r>
-              <a:t>Proteus · What an SDN controller can observe</a:t>
+              <a:t>Evaluation Validity in SDN Intrusion Detection</a:t>
             </a:r>
           </a:p>
         </p:txBody>
@@ -9967,35 +10263,53 @@
               </a:defRPr>
             </a:pPr>
             <a:r>
-              <a:t>18</a:t>
-            </a:r>
-          </a:p>
-        </p:txBody>
-      </p:sp>
-      <p:sp>
-        <p:nvSpPr>
-          <p:cNvPr id="6" name="TextBox 5"/>
-          <p:cNvSpPr txBox="1"/>
-          <p:nvPr/>
-        </p:nvSpPr>
-        <p:spPr>
-          <a:xfrm>
-            <a:off x="548640" y="1737360"/>
-            <a:ext cx="2651760" cy="457200"/>
-          </a:xfrm>
-          <a:prstGeom prst="rect">
-            <a:avLst/>
-          </a:prstGeom>
-          <a:noFill/>
-        </p:spPr>
-        <p:txBody>
-          <a:bodyPr wrap="square" lIns="0" rIns="0" tIns="0" bIns="0">
-            <a:spAutoFit/>
-          </a:bodyPr>
-          <a:lstStyle/>
-          <a:p>
-            <a:pPr>
-              <a:defRPr sz="2000" b="1">
+              <a:t>9</a:t>
+            </a:r>
+          </a:p>
+        </p:txBody>
+      </p:sp>
+      <p:graphicFrame>
+        <p:nvGraphicFramePr>
+          <p:cNvPr id="6" name="Chart 5"/>
+          <p:cNvGraphicFramePr>
+            <a:graphicFrameLocks noGrp="1"/>
+          </p:cNvGraphicFramePr>
+          <p:nvPr/>
+        </p:nvGraphicFramePr>
+        <p:xfrm>
+          <a:off x="548640" y="1645920"/>
+          <a:ext cx="6949440" cy="4023360"/>
+        </p:xfrm>
+        <a:graphic>
+          <a:graphicData uri="http://schemas.openxmlformats.org/drawingml/2006/chart">
+            <c:chart xmlns:c="http://schemas.openxmlformats.org/drawingml/2006/chart" r:id="rId2"/>
+          </a:graphicData>
+        </a:graphic>
+      </p:graphicFrame>
+      <p:sp>
+        <p:nvSpPr>
+          <p:cNvPr id="7" name="TextBox 6"/>
+          <p:cNvSpPr txBox="1"/>
+          <p:nvPr/>
+        </p:nvSpPr>
+        <p:spPr>
+          <a:xfrm>
+            <a:off x="548640" y="5669280"/>
+            <a:ext cx="6949440" cy="274320"/>
+          </a:xfrm>
+          <a:prstGeom prst="rect">
+            <a:avLst/>
+          </a:prstGeom>
+          <a:noFill/>
+        </p:spPr>
+        <p:txBody>
+          <a:bodyPr wrap="square" lIns="0" rIns="0" tIns="0" bIns="0">
+            <a:spAutoFit/>
+          </a:bodyPr>
+          <a:lstStyle/>
+          <a:p>
+            <a:pPr algn="ctr">
+              <a:defRPr sz="1200" b="0">
                 <a:solidFill>
                   <a:srgbClr val="6B7280"/>
                 </a:solidFill>
@@ -10003,21 +10317,21 @@
               </a:defRPr>
             </a:pPr>
             <a:r>
-              <a:t>Already known</a:t>
-            </a:r>
-          </a:p>
-        </p:txBody>
-      </p:sp>
-      <p:sp>
-        <p:nvSpPr>
-          <p:cNvPr id="7" name="TextBox 6"/>
-          <p:cNvSpPr txBox="1"/>
-          <p:nvPr/>
-        </p:nvSpPr>
-        <p:spPr>
-          <a:xfrm>
-            <a:off x="548640" y="2377440"/>
-            <a:ext cx="2606040" cy="4114800"/>
+              <a:t>InSDN balanced accuracy, XGBoost, 10 seeds</a:t>
+            </a:r>
+          </a:p>
+        </p:txBody>
+      </p:sp>
+      <p:sp>
+        <p:nvSpPr>
+          <p:cNvPr id="8" name="TextBox 7"/>
+          <p:cNvSpPr txBox="1"/>
+          <p:nvPr/>
+        </p:nvSpPr>
+        <p:spPr>
+          <a:xfrm>
+            <a:off x="7863840" y="1828800"/>
+            <a:ext cx="3840480" cy="4114800"/>
           </a:xfrm>
           <a:prstGeom prst="rect">
             <a:avLst/>
@@ -10032,9 +10346,9 @@
           <a:p>
             <a:pPr>
               <a:spcAft>
-                <a:spcPts val="1000"/>
+                <a:spcPts val="1200"/>
               </a:spcAft>
-              <a:defRPr sz="1300">
+              <a:defRPr sz="1500">
                 <a:solidFill>
                   <a:srgbClr val="111827"/>
                 </a:solidFill>
@@ -10042,15 +10356,15 @@
               </a:defRPr>
             </a:pPr>
             <a:r>
-              <a:t>Identifier columns are shortcut features (Engelen 2021)</a:t>
+              <a:t>Removing exact duplicates (46% of rows) leaves the random split at 0.9998.</a:t>
             </a:r>
           </a:p>
           <a:p>
             <a:pPr>
               <a:spcAft>
-                <a:spcPts val="1000"/>
+                <a:spcPts val="1200"/>
               </a:spcAft>
-              <a:defRPr sz="1300">
+              <a:defRPr sz="1500">
                 <a:solidFill>
                   <a:srgbClr val="111827"/>
                 </a:solidFill>
@@ -10058,15 +10372,15 @@
               </a:defRPr>
             </a:pPr>
             <a:r>
-              <a:t>Random splits leak on NIDS data (Flood 2024)</a:t>
+              <a:t>Keeping only splits where every attack class is in training still gives 0.939 (CI ±0.06).</a:t>
             </a:r>
           </a:p>
           <a:p>
             <a:pPr>
               <a:spcAft>
-                <a:spcPts val="1000"/>
+                <a:spcPts val="1200"/>
               </a:spcAft>
-              <a:defRPr sz="1300">
+              <a:defRPr sz="1500">
                 <a:solidFill>
                   <a:srgbClr val="111827"/>
                 </a:solidFill>
@@ -10074,35 +10388,61 @@
               </a:defRPr>
             </a:pPr>
             <a:r>
-              <a:t>Control-plane telemetry for SDN IDS (LAN-SDN-NIDS, SDNFLow)</a:t>
-            </a:r>
-          </a:p>
-        </p:txBody>
-      </p:sp>
-      <p:sp>
-        <p:nvSpPr>
-          <p:cNvPr id="8" name="TextBox 7"/>
-          <p:cNvSpPr txBox="1"/>
-          <p:nvPr/>
-        </p:nvSpPr>
-        <p:spPr>
-          <a:xfrm>
-            <a:off x="3383280" y="1737360"/>
-            <a:ext cx="2651760" cy="457200"/>
-          </a:xfrm>
-          <a:prstGeom prst="rect">
-            <a:avLst/>
-          </a:prstGeom>
-          <a:noFill/>
-        </p:spPr>
-        <p:txBody>
-          <a:bodyPr wrap="square" lIns="0" rIns="0" tIns="0" bIns="0">
-            <a:spAutoFit/>
-          </a:bodyPr>
-          <a:lstStyle/>
-          <a:p>
-            <a:pPr>
-              <a:defRPr sz="2000" b="1">
+              <a:t>Class-covered and deduplicated: wide CI, so we report it as a stress test.</a:t>
+            </a:r>
+          </a:p>
+        </p:txBody>
+      </p:sp>
+    </p:spTree>
+  </p:cSld>
+  <p:clrMapOvr>
+    <a:masterClrMapping/>
+  </p:clrMapOvr>
+</p:sld>
+</file>
+
+<file path=ppt/slides/slide19.xml><?xml version="1.0" encoding="utf-8"?>
+<p:sld xmlns:a="http://schemas.openxmlformats.org/drawingml/2006/main" xmlns:p="http://schemas.openxmlformats.org/presentationml/2006/main" xmlns:r="http://schemas.openxmlformats.org/officeDocument/2006/relationships">
+  <p:cSld>
+    <p:bg>
+      <p:bgPr>
+        <a:solidFill>
+          <a:srgbClr val="FFFFFF"/>
+        </a:solidFill>
+        <a:effectLst/>
+      </p:bgPr>
+    </p:bg>
+    <p:spTree>
+      <p:nvGrpSpPr>
+        <p:cNvPr id="1" name=""/>
+        <p:cNvGrpSpPr/>
+        <p:nvPr/>
+      </p:nvGrpSpPr>
+      <p:grpSpPr/>
+      <p:sp>
+        <p:nvSpPr>
+          <p:cNvPr id="2" name="TextBox 1"/>
+          <p:cNvSpPr txBox="1"/>
+          <p:nvPr/>
+        </p:nvSpPr>
+        <p:spPr>
+          <a:xfrm>
+            <a:off x="548640" y="365760"/>
+            <a:ext cx="8229600" cy="274320"/>
+          </a:xfrm>
+          <a:prstGeom prst="rect">
+            <a:avLst/>
+          </a:prstGeom>
+          <a:noFill/>
+        </p:spPr>
+        <p:txBody>
+          <a:bodyPr wrap="square" lIns="0" rIns="0" tIns="0" bIns="0">
+            <a:spAutoFit/>
+          </a:bodyPr>
+          <a:lstStyle/>
+          <a:p>
+            <a:pPr>
+              <a:defRPr sz="1200" b="1">
                 <a:solidFill>
                   <a:srgbClr val="0F766E"/>
                 </a:solidFill>
@@ -10110,38 +10450,35 @@
               </a:defRPr>
             </a:pPr>
             <a:r>
-              <a:t>New here</a:t>
-            </a:r>
-          </a:p>
-        </p:txBody>
-      </p:sp>
-      <p:sp>
-        <p:nvSpPr>
-          <p:cNvPr id="9" name="TextBox 8"/>
-          <p:cNvSpPr txBox="1"/>
-          <p:nvPr/>
-        </p:nvSpPr>
-        <p:spPr>
-          <a:xfrm>
-            <a:off x="3383280" y="2377440"/>
-            <a:ext cx="2606040" cy="4114800"/>
-          </a:xfrm>
-          <a:prstGeom prst="rect">
-            <a:avLst/>
-          </a:prstGeom>
-          <a:noFill/>
-        </p:spPr>
-        <p:txBody>
-          <a:bodyPr wrap="square" lIns="0" rIns="0" tIns="0" bIns="0">
-            <a:spAutoFit/>
-          </a:bodyPr>
-          <a:lstStyle/>
-          <a:p>
-            <a:pPr>
-              <a:spcAft>
-                <a:spcPts val="1000"/>
-              </a:spcAft>
-              <a:defRPr sz="1300">
+              <a:t>ARCHITECTURE</a:t>
+            </a:r>
+          </a:p>
+        </p:txBody>
+      </p:sp>
+      <p:sp>
+        <p:nvSpPr>
+          <p:cNvPr id="3" name="TextBox 2"/>
+          <p:cNvSpPr txBox="1"/>
+          <p:nvPr/>
+        </p:nvSpPr>
+        <p:spPr>
+          <a:xfrm>
+            <a:off x="548640" y="658368"/>
+            <a:ext cx="11064240" cy="822960"/>
+          </a:xfrm>
+          <a:prstGeom prst="rect">
+            <a:avLst/>
+          </a:prstGeom>
+          <a:noFill/>
+        </p:spPr>
+        <p:txBody>
+          <a:bodyPr wrap="square" lIns="0" rIns="0" tIns="0" bIns="0">
+            <a:spAutoFit/>
+          </a:bodyPr>
+          <a:lstStyle/>
+          <a:p>
+            <a:pPr>
+              <a:defRPr sz="2800" b="1">
                 <a:solidFill>
                   <a:srgbClr val="111827"/>
                 </a:solidFill>
@@ -10149,15 +10486,127 @@
               </a:defRPr>
             </a:pPr>
             <a:r>
-              <a:t>Paired random vs host-held-out gap on InSDN and CICIDS2017, 10 seeds, CIs</a:t>
-            </a:r>
-          </a:p>
-          <a:p>
-            <a:pPr>
-              <a:spcAft>
-                <a:spcPts val="1000"/>
-              </a:spcAft>
-              <a:defRPr sz="1300">
+              <a:t>Pipeline: data, controller view, split protocols, audit</a:t>
+            </a:r>
+          </a:p>
+        </p:txBody>
+      </p:sp>
+      <p:sp>
+        <p:nvSpPr>
+          <p:cNvPr id="4" name="TextBox 3"/>
+          <p:cNvSpPr txBox="1"/>
+          <p:nvPr/>
+        </p:nvSpPr>
+        <p:spPr>
+          <a:xfrm>
+            <a:off x="548640" y="6446520"/>
+            <a:ext cx="7315200" cy="228600"/>
+          </a:xfrm>
+          <a:prstGeom prst="rect">
+            <a:avLst/>
+          </a:prstGeom>
+          <a:noFill/>
+        </p:spPr>
+        <p:txBody>
+          <a:bodyPr wrap="square" lIns="0" rIns="0" tIns="0" bIns="0">
+            <a:spAutoFit/>
+          </a:bodyPr>
+          <a:lstStyle/>
+          <a:p>
+            <a:pPr>
+              <a:defRPr sz="1000" b="0">
+                <a:solidFill>
+                  <a:srgbClr val="6B7280"/>
+                </a:solidFill>
+                <a:latin typeface="Calibri"/>
+              </a:defRPr>
+            </a:pPr>
+            <a:r>
+              <a:t>Evaluation Validity in SDN Intrusion Detection</a:t>
+            </a:r>
+          </a:p>
+        </p:txBody>
+      </p:sp>
+      <p:sp>
+        <p:nvSpPr>
+          <p:cNvPr id="5" name="TextBox 4"/>
+          <p:cNvSpPr txBox="1"/>
+          <p:nvPr/>
+        </p:nvSpPr>
+        <p:spPr>
+          <a:xfrm>
+            <a:off x="10972800" y="6446520"/>
+            <a:ext cx="667512" cy="228600"/>
+          </a:xfrm>
+          <a:prstGeom prst="rect">
+            <a:avLst/>
+          </a:prstGeom>
+          <a:noFill/>
+        </p:spPr>
+        <p:txBody>
+          <a:bodyPr wrap="square" lIns="0" rIns="0" tIns="0" bIns="0">
+            <a:spAutoFit/>
+          </a:bodyPr>
+          <a:lstStyle/>
+          <a:p>
+            <a:pPr algn="r">
+              <a:defRPr sz="1000" b="0">
+                <a:solidFill>
+                  <a:srgbClr val="6B7280"/>
+                </a:solidFill>
+                <a:latin typeface="Calibri"/>
+              </a:defRPr>
+            </a:pPr>
+            <a:r>
+              <a:t>4</a:t>
+            </a:r>
+          </a:p>
+        </p:txBody>
+      </p:sp>
+      <p:sp>
+        <p:nvSpPr>
+          <p:cNvPr id="6" name="Rectangle 5"/>
+          <p:cNvSpPr/>
+          <p:nvPr/>
+        </p:nvSpPr>
+        <p:spPr>
+          <a:xfrm>
+            <a:off x="548640" y="2194560"/>
+            <a:ext cx="2468880" cy="1737360"/>
+          </a:xfrm>
+          <a:prstGeom prst="rect">
+            <a:avLst/>
+          </a:prstGeom>
+          <a:solidFill>
+            <a:srgbClr val="F3F4F6"/>
+          </a:solidFill>
+          <a:ln w="15875">
+            <a:solidFill>
+              <a:srgbClr val="0F766E"/>
+            </a:solidFill>
+          </a:ln>
+          <a:effectLst/>
+        </p:spPr>
+        <p:style>
+          <a:lnRef idx="1">
+            <a:schemeClr val="accent1"/>
+          </a:lnRef>
+          <a:fillRef idx="3">
+            <a:schemeClr val="accent1"/>
+          </a:fillRef>
+          <a:effectRef idx="2">
+            <a:schemeClr val="accent1"/>
+          </a:effectRef>
+          <a:fontRef idx="minor">
+            <a:schemeClr val="lt1"/>
+          </a:fontRef>
+        </p:style>
+        <p:txBody>
+          <a:bodyPr rtlCol="0" anchor="ctr" wrap="square" lIns="73152" rIns="73152"/>
+          <a:lstStyle/>
+          <a:p>
+            <a:pPr algn="ctr">
+              <a:defRPr sz="1600" b="1">
                 <a:solidFill>
                   <a:srgbClr val="111827"/>
                 </a:solidFill>
@@ -10165,15 +10614,108 @@
               </a:defRPr>
             </a:pPr>
             <a:r>
-              <a:t>Audit of 9 published InSDN papers: none groups by host, none uses a real controller</a:t>
-            </a:r>
-          </a:p>
-          <a:p>
-            <a:pPr>
-              <a:spcAft>
-                <a:spcPts val="1000"/>
-              </a:spcAft>
-              <a:defRPr sz="1300">
+              <a:t>Data</a:t>
+            </a:r>
+          </a:p>
+          <a:p>
+            <a:pPr algn="ctr">
+              <a:defRPr sz="1200">
+                <a:solidFill>
+                  <a:srgbClr val="6B7280"/>
+                </a:solidFill>
+                <a:latin typeface="Calibri"/>
+              </a:defRPr>
+            </a:pPr>
+            <a:r>
+              <a:t>InSDN CSV + 44 ONOS pcaps</a:t>
+            </a:r>
+            <a:br/>
+            <a:r>
+              <a:t>CICIDS2017</a:t>
+            </a:r>
+          </a:p>
+        </p:txBody>
+      </p:sp>
+      <p:cxnSp>
+        <p:nvCxnSpPr>
+          <p:cNvPr id="7" name="Connector 6"/>
+          <p:cNvCxnSpPr/>
+          <p:nvPr/>
+        </p:nvCxnSpPr>
+        <p:spPr>
+          <a:xfrm>
+            <a:off x="3054096" y="3063240"/>
+            <a:ext cx="338328" cy="0"/>
+          </a:xfrm>
+          <a:prstGeom prst="line">
+            <a:avLst/>
+          </a:prstGeom>
+          <a:ln w="19050">
+            <a:solidFill>
+              <a:srgbClr val="9CA3AF"/>
+            </a:solidFill>
+            <a:tailEnd type="triangle" w="med" len="med"/>
+          </a:ln>
+        </p:spPr>
+        <p:style>
+          <a:lnRef idx="2">
+            <a:schemeClr val="accent1"/>
+          </a:lnRef>
+          <a:fillRef idx="0">
+            <a:schemeClr val="accent1"/>
+          </a:fillRef>
+          <a:effectRef idx="1">
+            <a:schemeClr val="accent1"/>
+          </a:effectRef>
+          <a:fontRef idx="minor">
+            <a:schemeClr val="tx1"/>
+          </a:fontRef>
+        </p:style>
+      </p:cxnSp>
+      <p:sp>
+        <p:nvSpPr>
+          <p:cNvPr id="8" name="Rectangle 7"/>
+          <p:cNvSpPr/>
+          <p:nvPr/>
+        </p:nvSpPr>
+        <p:spPr>
+          <a:xfrm>
+            <a:off x="3429000" y="2194560"/>
+            <a:ext cx="2468880" cy="1737360"/>
+          </a:xfrm>
+          <a:prstGeom prst="rect">
+            <a:avLst/>
+          </a:prstGeom>
+          <a:solidFill>
+            <a:srgbClr val="F3F4F6"/>
+          </a:solidFill>
+          <a:ln w="15875">
+            <a:solidFill>
+              <a:srgbClr val="0F766E"/>
+            </a:solidFill>
+          </a:ln>
+          <a:effectLst/>
+        </p:spPr>
+        <p:style>
+          <a:lnRef idx="1">
+            <a:schemeClr val="accent1"/>
+          </a:lnRef>
+          <a:fillRef idx="3">
+            <a:schemeClr val="accent1"/>
+          </a:fillRef>
+          <a:effectRef idx="2">
+            <a:schemeClr val="accent1"/>
+          </a:effectRef>
+          <a:fontRef idx="minor">
+            <a:schemeClr val="lt1"/>
+          </a:fontRef>
+        </p:style>
+        <p:txBody>
+          <a:bodyPr rtlCol="0" anchor="ctr" wrap="square" lIns="73152" rIns="73152"/>
+          <a:lstStyle/>
+          <a:p>
+            <a:pPr algn="ctr">
+              <a:defRPr sz="1600" b="1">
                 <a:solidFill>
                   <a:srgbClr val="111827"/>
                 </a:solidFill>
@@ -10181,15 +10723,108 @@
               </a:defRPr>
             </a:pPr>
             <a:r>
-              <a:t>Published feature recipes on InSDN: ~0.999 random vs 0.69 to 0.84 held-out hosts</a:t>
-            </a:r>
-          </a:p>
-          <a:p>
-            <a:pPr>
-              <a:spcAft>
-                <a:spcPts val="1000"/>
-              </a:spcAft>
-              <a:defRPr sz="1300">
+              <a:t>Features / telemetry</a:t>
+            </a:r>
+          </a:p>
+          <a:p>
+            <a:pPr algn="ctr">
+              <a:defRPr sz="1200">
+                <a:solidFill>
+                  <a:srgbClr val="6B7280"/>
+                </a:solidFill>
+                <a:latin typeface="Calibri"/>
+              </a:defRPr>
+            </a:pPr>
+            <a:r>
+              <a:t>CICFlowMeter flow records</a:t>
+            </a:r>
+            <a:br/>
+            <a:r>
+              <a:t>controller-visible OpenFlow</a:t>
+            </a:r>
+          </a:p>
+        </p:txBody>
+      </p:sp>
+      <p:cxnSp>
+        <p:nvCxnSpPr>
+          <p:cNvPr id="9" name="Connector 8"/>
+          <p:cNvCxnSpPr/>
+          <p:nvPr/>
+        </p:nvCxnSpPr>
+        <p:spPr>
+          <a:xfrm>
+            <a:off x="5934456" y="3063240"/>
+            <a:ext cx="338327" cy="0"/>
+          </a:xfrm>
+          <a:prstGeom prst="line">
+            <a:avLst/>
+          </a:prstGeom>
+          <a:ln w="19050">
+            <a:solidFill>
+              <a:srgbClr val="9CA3AF"/>
+            </a:solidFill>
+            <a:tailEnd type="triangle" w="med" len="med"/>
+          </a:ln>
+        </p:spPr>
+        <p:style>
+          <a:lnRef idx="2">
+            <a:schemeClr val="accent1"/>
+          </a:lnRef>
+          <a:fillRef idx="0">
+            <a:schemeClr val="accent1"/>
+          </a:fillRef>
+          <a:effectRef idx="1">
+            <a:schemeClr val="accent1"/>
+          </a:effectRef>
+          <a:fontRef idx="minor">
+            <a:schemeClr val="tx1"/>
+          </a:fontRef>
+        </p:style>
+      </p:cxnSp>
+      <p:sp>
+        <p:nvSpPr>
+          <p:cNvPr id="10" name="Rectangle 9"/>
+          <p:cNvSpPr/>
+          <p:nvPr/>
+        </p:nvSpPr>
+        <p:spPr>
+          <a:xfrm>
+            <a:off x="6309359" y="2194560"/>
+            <a:ext cx="2468880" cy="1737360"/>
+          </a:xfrm>
+          <a:prstGeom prst="rect">
+            <a:avLst/>
+          </a:prstGeom>
+          <a:solidFill>
+            <a:srgbClr val="F3F4F6"/>
+          </a:solidFill>
+          <a:ln w="15875">
+            <a:solidFill>
+              <a:srgbClr val="0F766E"/>
+            </a:solidFill>
+          </a:ln>
+          <a:effectLst/>
+        </p:spPr>
+        <p:style>
+          <a:lnRef idx="1">
+            <a:schemeClr val="accent1"/>
+          </a:lnRef>
+          <a:fillRef idx="3">
+            <a:schemeClr val="accent1"/>
+          </a:fillRef>
+          <a:effectRef idx="2">
+            <a:schemeClr val="accent1"/>
+          </a:effectRef>
+          <a:fontRef idx="minor">
+            <a:schemeClr val="lt1"/>
+          </a:fontRef>
+        </p:style>
+        <p:txBody>
+          <a:bodyPr rtlCol="0" anchor="ctr" wrap="square" lIns="73152" rIns="73152"/>
+          <a:lstStyle/>
+          <a:p>
+            <a:pPr algn="ctr">
+              <a:defRPr sz="1600" b="1">
                 <a:solidFill>
                   <a:srgbClr val="111827"/>
                 </a:solidFill>
@@ -10197,15 +10832,108 @@
               </a:defRPr>
             </a:pPr>
             <a:r>
-              <a:t>Host structure and leave-one-host-out: about 3 attacker hosts</a:t>
-            </a:r>
-          </a:p>
-          <a:p>
-            <a:pPr>
-              <a:spcAft>
-                <a:spcPts val="1000"/>
-              </a:spcAft>
-              <a:defRPr sz="1300">
+              <a:t>Split protocols</a:t>
+            </a:r>
+          </a:p>
+          <a:p>
+            <a:pPr algn="ctr">
+              <a:defRPr sz="1200">
+                <a:solidFill>
+                  <a:srgbClr val="6B7280"/>
+                </a:solidFill>
+                <a:latin typeface="Calibri"/>
+              </a:defRPr>
+            </a:pPr>
+            <a:r>
+              <a:t>random flow split</a:t>
+            </a:r>
+            <a:br/>
+            <a:r>
+              <a:t>held-out source hosts</a:t>
+            </a:r>
+          </a:p>
+        </p:txBody>
+      </p:sp>
+      <p:cxnSp>
+        <p:nvCxnSpPr>
+          <p:cNvPr id="11" name="Connector 10"/>
+          <p:cNvCxnSpPr/>
+          <p:nvPr/>
+        </p:nvCxnSpPr>
+        <p:spPr>
+          <a:xfrm>
+            <a:off x="8814816" y="3063240"/>
+            <a:ext cx="338328" cy="0"/>
+          </a:xfrm>
+          <a:prstGeom prst="line">
+            <a:avLst/>
+          </a:prstGeom>
+          <a:ln w="19050">
+            <a:solidFill>
+              <a:srgbClr val="9CA3AF"/>
+            </a:solidFill>
+            <a:tailEnd type="triangle" w="med" len="med"/>
+          </a:ln>
+        </p:spPr>
+        <p:style>
+          <a:lnRef idx="2">
+            <a:schemeClr val="accent1"/>
+          </a:lnRef>
+          <a:fillRef idx="0">
+            <a:schemeClr val="accent1"/>
+          </a:fillRef>
+          <a:effectRef idx="1">
+            <a:schemeClr val="accent1"/>
+          </a:effectRef>
+          <a:fontRef idx="minor">
+            <a:schemeClr val="tx1"/>
+          </a:fontRef>
+        </p:style>
+      </p:cxnSp>
+      <p:sp>
+        <p:nvSpPr>
+          <p:cNvPr id="12" name="Rectangle 11"/>
+          <p:cNvSpPr/>
+          <p:nvPr/>
+        </p:nvSpPr>
+        <p:spPr>
+          <a:xfrm>
+            <a:off x="9189719" y="2194560"/>
+            <a:ext cx="2468880" cy="1737360"/>
+          </a:xfrm>
+          <a:prstGeom prst="rect">
+            <a:avLst/>
+          </a:prstGeom>
+          <a:solidFill>
+            <a:srgbClr val="F3F4F6"/>
+          </a:solidFill>
+          <a:ln w="15875">
+            <a:solidFill>
+              <a:srgbClr val="0F766E"/>
+            </a:solidFill>
+          </a:ln>
+          <a:effectLst/>
+        </p:spPr>
+        <p:style>
+          <a:lnRef idx="1">
+            <a:schemeClr val="accent1"/>
+          </a:lnRef>
+          <a:fillRef idx="3">
+            <a:schemeClr val="accent1"/>
+          </a:fillRef>
+          <a:effectRef idx="2">
+            <a:schemeClr val="accent1"/>
+          </a:effectRef>
+          <a:fontRef idx="minor">
+            <a:schemeClr val="lt1"/>
+          </a:fontRef>
+        </p:style>
+        <p:txBody>
+          <a:bodyPr rtlCol="0" anchor="ctr" wrap="square" lIns="73152" rIns="73152"/>
+          <a:lstStyle/>
+          <a:p>
+            <a:pPr algn="ctr">
+              <a:defRPr sz="1600" b="1">
                 <a:solidFill>
                   <a:srgbClr val="111827"/>
                 </a:solidFill>
@@ -10213,150 +10941,24 @@
               </a:defRPr>
             </a:pPr>
             <a:r>
-              <a:t>Controller-telemetry gap: 0 FlowMods with IPs or ports</a:t>
-            </a:r>
-          </a:p>
-        </p:txBody>
-      </p:sp>
-      <p:sp>
-        <p:nvSpPr>
-          <p:cNvPr id="10" name="TextBox 9"/>
-          <p:cNvSpPr txBox="1"/>
-          <p:nvPr/>
-        </p:nvSpPr>
-        <p:spPr>
-          <a:xfrm>
-            <a:off x="6217920" y="1737360"/>
-            <a:ext cx="2651760" cy="457200"/>
-          </a:xfrm>
-          <a:prstGeom prst="rect">
-            <a:avLst/>
-          </a:prstGeom>
-          <a:noFill/>
-        </p:spPr>
-        <p:txBody>
-          <a:bodyPr wrap="square" lIns="0" rIns="0" tIns="0" bIns="0">
-            <a:spAutoFit/>
-          </a:bodyPr>
-          <a:lstStyle/>
-          <a:p>
-            <a:pPr>
-              <a:defRPr sz="2000" b="1">
-                <a:solidFill>
-                  <a:srgbClr val="B91C1C"/>
-                </a:solidFill>
-                <a:latin typeface="Calibri"/>
-              </a:defRPr>
-            </a:pPr>
-            <a:r>
-              <a:t>Not done</a:t>
-            </a:r>
-          </a:p>
-        </p:txBody>
-      </p:sp>
-      <p:sp>
-        <p:nvSpPr>
-          <p:cNvPr id="11" name="TextBox 10"/>
-          <p:cNvSpPr txBox="1"/>
-          <p:nvPr/>
-        </p:nvSpPr>
-        <p:spPr>
-          <a:xfrm>
-            <a:off x="6217920" y="2377440"/>
-            <a:ext cx="2606040" cy="4114800"/>
-          </a:xfrm>
-          <a:prstGeom prst="rect">
-            <a:avLst/>
-          </a:prstGeom>
-          <a:noFill/>
-        </p:spPr>
-        <p:txBody>
-          <a:bodyPr wrap="square" lIns="0" rIns="0" tIns="0" bIns="0">
-            <a:spAutoFit/>
-          </a:bodyPr>
-          <a:lstStyle/>
-          <a:p>
-            <a:pPr>
-              <a:spcAft>
-                <a:spcPts val="1000"/>
-              </a:spcAft>
-              <a:defRPr sz="1300">
-                <a:solidFill>
-                  <a:srgbClr val="111827"/>
-                </a:solidFill>
-                <a:latin typeface="Calibri"/>
-              </a:defRPr>
-            </a:pPr>
-            <a:r>
-              <a:t>Interleaved benign and attack traffic in one session</a:t>
-            </a:r>
-          </a:p>
-          <a:p>
-            <a:pPr>
-              <a:spcAft>
-                <a:spcPts val="1000"/>
-              </a:spcAft>
-              <a:defRPr sz="1300">
-                <a:solidFill>
-                  <a:srgbClr val="111827"/>
-                </a:solidFill>
-                <a:latin typeface="Calibri"/>
-              </a:defRPr>
-            </a:pPr>
-            <a:r>
-              <a:t>A second SDN dataset or controller family</a:t>
-            </a:r>
-          </a:p>
-          <a:p>
-            <a:pPr>
-              <a:spcAft>
-                <a:spcPts val="1000"/>
-              </a:spcAft>
-              <a:defRPr sz="1300">
-                <a:solidFill>
-                  <a:srgbClr val="111827"/>
-                </a:solidFill>
-                <a:latin typeface="Calibri"/>
-              </a:defRPr>
-            </a:pPr>
-            <a:r>
-              <a:t>Unread InSDN papers not characterised</a:t>
-            </a:r>
-          </a:p>
-        </p:txBody>
-      </p:sp>
-      <p:sp>
-        <p:nvSpPr>
-          <p:cNvPr id="12" name="TextBox 11"/>
-          <p:cNvSpPr txBox="1"/>
-          <p:nvPr/>
-        </p:nvSpPr>
-        <p:spPr>
-          <a:xfrm>
-            <a:off x="9052560" y="1737360"/>
-            <a:ext cx="2651760" cy="457200"/>
-          </a:xfrm>
-          <a:prstGeom prst="rect">
-            <a:avLst/>
-          </a:prstGeom>
-          <a:noFill/>
-        </p:spPr>
-        <p:txBody>
-          <a:bodyPr wrap="square" lIns="0" rIns="0" tIns="0" bIns="0">
-            <a:spAutoFit/>
-          </a:bodyPr>
-          <a:lstStyle/>
-          <a:p>
-            <a:pPr>
-              <a:defRPr sz="2000" b="1">
-                <a:solidFill>
-                  <a:srgbClr val="111827"/>
-                </a:solidFill>
-                <a:latin typeface="Calibri"/>
-              </a:defRPr>
-            </a:pPr>
-            <a:r>
-              <a:t>Takeaways</a:t>
+              <a:t>Audit</a:t>
+            </a:r>
+          </a:p>
+          <a:p>
+            <a:pPr algn="ctr">
+              <a:defRPr sz="1200">
+                <a:solidFill>
+                  <a:srgbClr val="6B7280"/>
+                </a:solidFill>
+                <a:latin typeface="Calibri"/>
+              </a:defRPr>
+            </a:pPr>
+            <a:r>
+              <a:t>controls, leave-one-host-out,</a:t>
+            </a:r>
+            <a:br/>
+            <a:r>
+              <a:t>literature, replication</a:t>
             </a:r>
           </a:p>
         </p:txBody>
@@ -10369,65 +10971,30 @@
         </p:nvSpPr>
         <p:spPr>
           <a:xfrm>
-            <a:off x="9052560" y="2377440"/>
-            <a:ext cx="2606040" cy="4114800"/>
-          </a:xfrm>
-          <a:prstGeom prst="rect">
-            <a:avLst/>
-          </a:prstGeom>
-          <a:noFill/>
-        </p:spPr>
-        <p:txBody>
-          <a:bodyPr wrap="square" lIns="0" rIns="0" tIns="0" bIns="0">
-            <a:spAutoFit/>
-          </a:bodyPr>
-          <a:lstStyle/>
-          <a:p>
-            <a:pPr>
-              <a:spcAft>
-                <a:spcPts val="1000"/>
-              </a:spcAft>
-              <a:defRPr sz="1300">
-                <a:solidFill>
-                  <a:srgbClr val="111827"/>
-                </a:solidFill>
-                <a:latin typeface="Calibri"/>
-              </a:defRPr>
-            </a:pPr>
-            <a:r>
-              <a:t>Random-split scores on InSDN do not measure detection</a:t>
-            </a:r>
-          </a:p>
-          <a:p>
-            <a:pPr>
-              <a:spcAft>
-                <a:spcPts val="1000"/>
-              </a:spcAft>
-              <a:defRPr sz="1300">
-                <a:solidFill>
-                  <a:srgbClr val="111827"/>
-                </a:solidFill>
-                <a:latin typeface="Calibri"/>
-              </a:defRPr>
-            </a:pPr>
-            <a:r>
-              <a:t>What a controller sees depends on the forwarding app</a:t>
-            </a:r>
-          </a:p>
-          <a:p>
-            <a:pPr>
-              <a:spcAft>
-                <a:spcPts val="1000"/>
-              </a:spcAft>
-              <a:defRPr sz="1300">
-                <a:solidFill>
-                  <a:srgbClr val="111827"/>
-                </a:solidFill>
-                <a:latin typeface="Calibri"/>
-              </a:defRPr>
-            </a:pPr>
-            <a:r>
-              <a:t>On InSDN, controller-side scores are not detection accuracy</a:t>
+            <a:off x="548640" y="4572000"/>
+            <a:ext cx="11064240" cy="731520"/>
+          </a:xfrm>
+          <a:prstGeom prst="rect">
+            <a:avLst/>
+          </a:prstGeom>
+          <a:noFill/>
+        </p:spPr>
+        <p:txBody>
+          <a:bodyPr wrap="square" lIns="0" rIns="0" tIns="0" bIns="0">
+            <a:spAutoFit/>
+          </a:bodyPr>
+          <a:lstStyle/>
+          <a:p>
+            <a:pPr>
+              <a:defRPr sz="1600" b="0">
+                <a:solidFill>
+                  <a:srgbClr val="6B7280"/>
+                </a:solidFill>
+                <a:latin typeface="Calibri"/>
+              </a:defRPr>
+            </a:pPr>
+            <a:r>
+              <a:t>Every number comes from results/*.json, 10 seeds with 95% CIs; captures are SHA-256 hashed and the results rerun from one script.</a:t>
             </a:r>
           </a:p>
         </p:txBody>
@@ -10561,7 +11128,7 @@
               </a:defRPr>
             </a:pPr>
             <a:r>
-              <a:t>Proteus · What an SDN controller can observe</a:t>
+              <a:t>Evaluation Validity in SDN Intrusion Detection</a:t>
             </a:r>
           </a:p>
         </p:txBody>
@@ -10867,6 +11434,1040 @@
             </a:pPr>
             <a:r>
               <a:t>≠</a:t>
+            </a:r>
+          </a:p>
+        </p:txBody>
+      </p:sp>
+    </p:spTree>
+  </p:cSld>
+  <p:clrMapOvr>
+    <a:masterClrMapping/>
+  </p:clrMapOvr>
+</p:sld>
+</file>
+
+<file path=ppt/slides/slide20.xml><?xml version="1.0" encoding="utf-8"?>
+<p:sld xmlns:a="http://schemas.openxmlformats.org/drawingml/2006/main" xmlns:p="http://schemas.openxmlformats.org/presentationml/2006/main" xmlns:r="http://schemas.openxmlformats.org/officeDocument/2006/relationships">
+  <p:cSld>
+    <p:bg>
+      <p:bgPr>
+        <a:solidFill>
+          <a:srgbClr val="FFFFFF"/>
+        </a:solidFill>
+        <a:effectLst/>
+      </p:bgPr>
+    </p:bg>
+    <p:spTree>
+      <p:nvGrpSpPr>
+        <p:cNvPr id="1" name=""/>
+        <p:cNvGrpSpPr/>
+        <p:nvPr/>
+      </p:nvGrpSpPr>
+      <p:grpSpPr/>
+      <p:sp>
+        <p:nvSpPr>
+          <p:cNvPr id="2" name="TextBox 1"/>
+          <p:cNvSpPr txBox="1"/>
+          <p:nvPr/>
+        </p:nvSpPr>
+        <p:spPr>
+          <a:xfrm>
+            <a:off x="548640" y="365760"/>
+            <a:ext cx="8229600" cy="274320"/>
+          </a:xfrm>
+          <a:prstGeom prst="rect">
+            <a:avLst/>
+          </a:prstGeom>
+          <a:noFill/>
+        </p:spPr>
+        <p:txBody>
+          <a:bodyPr wrap="square" lIns="0" rIns="0" tIns="0" bIns="0">
+            <a:spAutoFit/>
+          </a:bodyPr>
+          <a:lstStyle/>
+          <a:p>
+            <a:pPr>
+              <a:defRPr sz="1200" b="1">
+                <a:solidFill>
+                  <a:srgbClr val="0F766E"/>
+                </a:solidFill>
+                <a:latin typeface="Calibri"/>
+              </a:defRPr>
+            </a:pPr>
+            <a:r>
+              <a:t>TAKEAWAYS</a:t>
+            </a:r>
+          </a:p>
+        </p:txBody>
+      </p:sp>
+      <p:sp>
+        <p:nvSpPr>
+          <p:cNvPr id="3" name="TextBox 2"/>
+          <p:cNvSpPr txBox="1"/>
+          <p:nvPr/>
+        </p:nvSpPr>
+        <p:spPr>
+          <a:xfrm>
+            <a:off x="548640" y="658368"/>
+            <a:ext cx="11064240" cy="822960"/>
+          </a:xfrm>
+          <a:prstGeom prst="rect">
+            <a:avLst/>
+          </a:prstGeom>
+          <a:noFill/>
+        </p:spPr>
+        <p:txBody>
+          <a:bodyPr wrap="square" lIns="0" rIns="0" tIns="0" bIns="0">
+            <a:spAutoFit/>
+          </a:bodyPr>
+          <a:lstStyle/>
+          <a:p>
+            <a:pPr>
+              <a:defRPr sz="2800" b="1">
+                <a:solidFill>
+                  <a:srgbClr val="111827"/>
+                </a:solidFill>
+                <a:latin typeface="Calibri"/>
+              </a:defRPr>
+            </a:pPr>
+            <a:r>
+              <a:t>Conclusion: what the paper defends</a:t>
+            </a:r>
+          </a:p>
+        </p:txBody>
+      </p:sp>
+      <p:sp>
+        <p:nvSpPr>
+          <p:cNvPr id="4" name="TextBox 3"/>
+          <p:cNvSpPr txBox="1"/>
+          <p:nvPr/>
+        </p:nvSpPr>
+        <p:spPr>
+          <a:xfrm>
+            <a:off x="548640" y="6446520"/>
+            <a:ext cx="7315200" cy="228600"/>
+          </a:xfrm>
+          <a:prstGeom prst="rect">
+            <a:avLst/>
+          </a:prstGeom>
+          <a:noFill/>
+        </p:spPr>
+        <p:txBody>
+          <a:bodyPr wrap="square" lIns="0" rIns="0" tIns="0" bIns="0">
+            <a:spAutoFit/>
+          </a:bodyPr>
+          <a:lstStyle/>
+          <a:p>
+            <a:pPr>
+              <a:defRPr sz="1000" b="0">
+                <a:solidFill>
+                  <a:srgbClr val="6B7280"/>
+                </a:solidFill>
+                <a:latin typeface="Calibri"/>
+              </a:defRPr>
+            </a:pPr>
+            <a:r>
+              <a:t>Evaluation Validity in SDN Intrusion Detection</a:t>
+            </a:r>
+          </a:p>
+        </p:txBody>
+      </p:sp>
+      <p:sp>
+        <p:nvSpPr>
+          <p:cNvPr id="5" name="TextBox 4"/>
+          <p:cNvSpPr txBox="1"/>
+          <p:nvPr/>
+        </p:nvSpPr>
+        <p:spPr>
+          <a:xfrm>
+            <a:off x="10972800" y="6446520"/>
+            <a:ext cx="667512" cy="228600"/>
+          </a:xfrm>
+          <a:prstGeom prst="rect">
+            <a:avLst/>
+          </a:prstGeom>
+          <a:noFill/>
+        </p:spPr>
+        <p:txBody>
+          <a:bodyPr wrap="square" lIns="0" rIns="0" tIns="0" bIns="0">
+            <a:spAutoFit/>
+          </a:bodyPr>
+          <a:lstStyle/>
+          <a:p>
+            <a:pPr algn="r">
+              <a:defRPr sz="1000" b="0">
+                <a:solidFill>
+                  <a:srgbClr val="6B7280"/>
+                </a:solidFill>
+                <a:latin typeface="Calibri"/>
+              </a:defRPr>
+            </a:pPr>
+            <a:r>
+              <a:t>14</a:t>
+            </a:r>
+          </a:p>
+        </p:txBody>
+      </p:sp>
+      <p:sp>
+        <p:nvSpPr>
+          <p:cNvPr id="6" name="TextBox 5"/>
+          <p:cNvSpPr txBox="1"/>
+          <p:nvPr/>
+        </p:nvSpPr>
+        <p:spPr>
+          <a:xfrm>
+            <a:off x="548640" y="1828800"/>
+            <a:ext cx="11064240" cy="4114800"/>
+          </a:xfrm>
+          <a:prstGeom prst="rect">
+            <a:avLst/>
+          </a:prstGeom>
+          <a:noFill/>
+        </p:spPr>
+        <p:txBody>
+          <a:bodyPr wrap="square" lIns="0" rIns="0" tIns="0" bIns="0">
+            <a:spAutoFit/>
+          </a:bodyPr>
+          <a:lstStyle/>
+          <a:p>
+            <a:pPr>
+              <a:spcAft>
+                <a:spcPts val="1800"/>
+              </a:spcAft>
+              <a:defRPr sz="2000">
+                <a:solidFill>
+                  <a:srgbClr val="111827"/>
+                </a:solidFill>
+                <a:latin typeface="Calibri"/>
+              </a:defRPr>
+            </a:pPr>
+            <a:r>
+              <a:t>A controller cannot read the dataset's 5-tuple flows: 0 of 3,827 FlowMods match IPs or ports.</a:t>
+            </a:r>
+          </a:p>
+          <a:p>
+            <a:pPr>
+              <a:spcAft>
+                <a:spcPts val="1800"/>
+              </a:spcAft>
+              <a:defRPr sz="2000">
+                <a:solidFill>
+                  <a:srgbClr val="111827"/>
+                </a:solidFill>
+                <a:latin typeface="Calibri"/>
+              </a:defRPr>
+            </a:pPr>
+            <a:r>
+              <a:t>Controller-side scores on InSDN are a validity threat, not detection accuracy.</a:t>
+            </a:r>
+          </a:p>
+          <a:p>
+            <a:pPr>
+              <a:spcAft>
+                <a:spcPts val="1800"/>
+              </a:spcAft>
+              <a:defRPr sz="2000">
+                <a:solidFill>
+                  <a:srgbClr val="111827"/>
+                </a:solidFill>
+                <a:latin typeface="Calibri"/>
+              </a:defRPr>
+            </a:pPr>
+            <a:r>
+              <a:t>Random splits inflate scores on InSDN and CICIDS2017; held-out hosts expose it.</a:t>
+            </a:r>
+          </a:p>
+          <a:p>
+            <a:pPr>
+              <a:spcAft>
+                <a:spcPts val="1800"/>
+              </a:spcAft>
+              <a:defRPr sz="2000">
+                <a:solidFill>
+                  <a:srgbClr val="111827"/>
+                </a:solidFill>
+                <a:latin typeface="Calibri"/>
+              </a:defRPr>
+            </a:pPr>
+            <a:r>
+              <a:t>Neither duplicates nor class absence alone explains the gap.</a:t>
+            </a:r>
+          </a:p>
+          <a:p>
+            <a:pPr>
+              <a:spcAft>
+                <a:spcPts val="1800"/>
+              </a:spcAft>
+              <a:defRPr sz="2000">
+                <a:solidFill>
+                  <a:srgbClr val="111827"/>
+                </a:solidFill>
+                <a:latin typeface="Calibri"/>
+              </a:defRPr>
+            </a:pPr>
+            <a:r>
+              <a:t>Report host-grouped splits with CIs; state the split.</a:t>
+            </a:r>
+          </a:p>
+        </p:txBody>
+      </p:sp>
+      <p:sp>
+        <p:nvSpPr>
+          <p:cNvPr id="7" name="TextBox 6"/>
+          <p:cNvSpPr txBox="1"/>
+          <p:nvPr/>
+        </p:nvSpPr>
+        <p:spPr>
+          <a:xfrm>
+            <a:off x="548640" y="5669280"/>
+            <a:ext cx="11064240" cy="457200"/>
+          </a:xfrm>
+          <a:prstGeom prst="rect">
+            <a:avLst/>
+          </a:prstGeom>
+          <a:noFill/>
+        </p:spPr>
+        <p:txBody>
+          <a:bodyPr wrap="square" lIns="0" rIns="0" tIns="0" bIns="0">
+            <a:spAutoFit/>
+          </a:bodyPr>
+          <a:lstStyle/>
+          <a:p>
+            <a:pPr>
+              <a:defRPr sz="1800" b="1">
+                <a:solidFill>
+                  <a:srgbClr val="0F766E"/>
+                </a:solidFill>
+                <a:latin typeface="Calibri"/>
+              </a:defRPr>
+            </a:pPr>
+            <a:r>
+              <a:t>We defend the measurement and the protocol, not a new detector.</a:t>
+            </a:r>
+          </a:p>
+        </p:txBody>
+      </p:sp>
+    </p:spTree>
+  </p:cSld>
+  <p:clrMapOvr>
+    <a:masterClrMapping/>
+  </p:clrMapOvr>
+</p:sld>
+</file>
+
+<file path=ppt/slides/slide21.xml><?xml version="1.0" encoding="utf-8"?>
+<p:sld xmlns:a="http://schemas.openxmlformats.org/drawingml/2006/main" xmlns:p="http://schemas.openxmlformats.org/presentationml/2006/main" xmlns:r="http://schemas.openxmlformats.org/officeDocument/2006/relationships">
+  <p:cSld>
+    <p:bg>
+      <p:bgPr>
+        <a:solidFill>
+          <a:srgbClr val="FFFFFF"/>
+        </a:solidFill>
+        <a:effectLst/>
+      </p:bgPr>
+    </p:bg>
+    <p:spTree>
+      <p:nvGrpSpPr>
+        <p:cNvPr id="1" name=""/>
+        <p:cNvGrpSpPr/>
+        <p:nvPr/>
+      </p:nvGrpSpPr>
+      <p:grpSpPr/>
+      <p:sp>
+        <p:nvSpPr>
+          <p:cNvPr id="2" name="TextBox 1"/>
+          <p:cNvSpPr txBox="1"/>
+          <p:nvPr/>
+        </p:nvSpPr>
+        <p:spPr>
+          <a:xfrm>
+            <a:off x="548640" y="365760"/>
+            <a:ext cx="8229600" cy="274320"/>
+          </a:xfrm>
+          <a:prstGeom prst="rect">
+            <a:avLst/>
+          </a:prstGeom>
+          <a:noFill/>
+        </p:spPr>
+        <p:txBody>
+          <a:bodyPr wrap="square" lIns="0" rIns="0" tIns="0" bIns="0">
+            <a:spAutoFit/>
+          </a:bodyPr>
+          <a:lstStyle/>
+          <a:p>
+            <a:pPr>
+              <a:defRPr sz="1200" b="1">
+                <a:solidFill>
+                  <a:srgbClr val="0F766E"/>
+                </a:solidFill>
+                <a:latin typeface="Calibri"/>
+              </a:defRPr>
+            </a:pPr>
+            <a:r>
+              <a:t>HONEST SCOPE</a:t>
+            </a:r>
+          </a:p>
+        </p:txBody>
+      </p:sp>
+      <p:sp>
+        <p:nvSpPr>
+          <p:cNvPr id="3" name="TextBox 2"/>
+          <p:cNvSpPr txBox="1"/>
+          <p:nvPr/>
+        </p:nvSpPr>
+        <p:spPr>
+          <a:xfrm>
+            <a:off x="548640" y="658368"/>
+            <a:ext cx="11064240" cy="822960"/>
+          </a:xfrm>
+          <a:prstGeom prst="rect">
+            <a:avLst/>
+          </a:prstGeom>
+          <a:noFill/>
+        </p:spPr>
+        <p:txBody>
+          <a:bodyPr wrap="square" lIns="0" rIns="0" tIns="0" bIns="0">
+            <a:spAutoFit/>
+          </a:bodyPr>
+          <a:lstStyle/>
+          <a:p>
+            <a:pPr>
+              <a:defRPr sz="2800" b="1">
+                <a:solidFill>
+                  <a:srgbClr val="111827"/>
+                </a:solidFill>
+                <a:latin typeface="Calibri"/>
+              </a:defRPr>
+            </a:pPr>
+            <a:r>
+              <a:t>Limitations we state ourselves</a:t>
+            </a:r>
+          </a:p>
+        </p:txBody>
+      </p:sp>
+      <p:sp>
+        <p:nvSpPr>
+          <p:cNvPr id="4" name="TextBox 3"/>
+          <p:cNvSpPr txBox="1"/>
+          <p:nvPr/>
+        </p:nvSpPr>
+        <p:spPr>
+          <a:xfrm>
+            <a:off x="548640" y="6446520"/>
+            <a:ext cx="7315200" cy="228600"/>
+          </a:xfrm>
+          <a:prstGeom prst="rect">
+            <a:avLst/>
+          </a:prstGeom>
+          <a:noFill/>
+        </p:spPr>
+        <p:txBody>
+          <a:bodyPr wrap="square" lIns="0" rIns="0" tIns="0" bIns="0">
+            <a:spAutoFit/>
+          </a:bodyPr>
+          <a:lstStyle/>
+          <a:p>
+            <a:pPr>
+              <a:defRPr sz="1000" b="0">
+                <a:solidFill>
+                  <a:srgbClr val="6B7280"/>
+                </a:solidFill>
+                <a:latin typeface="Calibri"/>
+              </a:defRPr>
+            </a:pPr>
+            <a:r>
+              <a:t>Evaluation Validity in SDN Intrusion Detection</a:t>
+            </a:r>
+          </a:p>
+        </p:txBody>
+      </p:sp>
+      <p:sp>
+        <p:nvSpPr>
+          <p:cNvPr id="5" name="TextBox 4"/>
+          <p:cNvSpPr txBox="1"/>
+          <p:nvPr/>
+        </p:nvSpPr>
+        <p:spPr>
+          <a:xfrm>
+            <a:off x="10972800" y="6446520"/>
+            <a:ext cx="667512" cy="228600"/>
+          </a:xfrm>
+          <a:prstGeom prst="rect">
+            <a:avLst/>
+          </a:prstGeom>
+          <a:noFill/>
+        </p:spPr>
+        <p:txBody>
+          <a:bodyPr wrap="square" lIns="0" rIns="0" tIns="0" bIns="0">
+            <a:spAutoFit/>
+          </a:bodyPr>
+          <a:lstStyle/>
+          <a:p>
+            <a:pPr algn="r">
+              <a:defRPr sz="1000" b="0">
+                <a:solidFill>
+                  <a:srgbClr val="6B7280"/>
+                </a:solidFill>
+                <a:latin typeface="Calibri"/>
+              </a:defRPr>
+            </a:pPr>
+            <a:r>
+              <a:t>13</a:t>
+            </a:r>
+          </a:p>
+        </p:txBody>
+      </p:sp>
+      <p:sp>
+        <p:nvSpPr>
+          <p:cNvPr id="6" name="TextBox 5"/>
+          <p:cNvSpPr txBox="1"/>
+          <p:nvPr/>
+        </p:nvSpPr>
+        <p:spPr>
+          <a:xfrm>
+            <a:off x="548640" y="1828800"/>
+            <a:ext cx="11064240" cy="4114800"/>
+          </a:xfrm>
+          <a:prstGeom prst="rect">
+            <a:avLst/>
+          </a:prstGeom>
+          <a:noFill/>
+        </p:spPr>
+        <p:txBody>
+          <a:bodyPr wrap="square" lIns="0" rIns="0" tIns="0" bIns="0">
+            <a:spAutoFit/>
+          </a:bodyPr>
+          <a:lstStyle/>
+          <a:p>
+            <a:pPr>
+              <a:spcAft>
+                <a:spcPts val="1400"/>
+              </a:spcAft>
+              <a:defRPr sz="1800">
+                <a:solidFill>
+                  <a:srgbClr val="111827"/>
+                </a:solidFill>
+                <a:latin typeface="Calibri"/>
+              </a:defRPr>
+            </a:pPr>
+            <a:r>
+              <a:t>Controller study: one dataset (InSDN) and one recorded controller (ONOS); Ryu is checked only on our own benign traffic.</a:t>
+            </a:r>
+          </a:p>
+          <a:p>
+            <a:pPr>
+              <a:spcAft>
+                <a:spcPts val="1400"/>
+              </a:spcAft>
+              <a:defRPr sz="1800">
+                <a:solidFill>
+                  <a:srgbClr val="111827"/>
+                </a:solidFill>
+                <a:latin typeface="Calibri"/>
+              </a:defRPr>
+            </a:pPr>
+            <a:r>
+              <a:t>We generated no attack traffic; benign and attack are never interleaved in one session.</a:t>
+            </a:r>
+          </a:p>
+          <a:p>
+            <a:pPr>
+              <a:spcAft>
+                <a:spcPts val="1400"/>
+              </a:spcAft>
+              <a:defRPr sz="1800">
+                <a:solidFill>
+                  <a:srgbClr val="111827"/>
+                </a:solidFill>
+                <a:latin typeface="Calibri"/>
+              </a:defRPr>
+            </a:pPr>
+            <a:r>
+              <a:t>Labels cover only part of the controller-visible traffic, so session identity and unlisted attacks cannot be separated.</a:t>
+            </a:r>
+          </a:p>
+          <a:p>
+            <a:pPr>
+              <a:spcAft>
+                <a:spcPts val="1400"/>
+              </a:spcAft>
+              <a:defRPr sz="1800">
+                <a:solidFill>
+                  <a:srgbClr val="111827"/>
+                </a:solidFill>
+                <a:latin typeface="Calibri"/>
+              </a:defRPr>
+            </a:pPr>
+            <a:r>
+              <a:t>Literature check: ten papers read in full; reported numbers are the authors' own, not re-run.</a:t>
+            </a:r>
+          </a:p>
+          <a:p>
+            <a:pPr>
+              <a:spcAft>
+                <a:spcPts val="1400"/>
+              </a:spcAft>
+              <a:defRPr sz="1800">
+                <a:solidFill>
+                  <a:srgbClr val="111827"/>
+                </a:solidFill>
+                <a:latin typeface="Calibri"/>
+              </a:defRPr>
+            </a:pPr>
+            <a:r>
+              <a:t>The split audit covers two datasets, one model family (XGBoost) and binary labels; UKMDDoSDN has no benign class and was unusable.</a:t>
+            </a:r>
+          </a:p>
+          <a:p>
+            <a:pPr>
+              <a:spcAft>
+                <a:spcPts val="1400"/>
+              </a:spcAft>
+              <a:defRPr sz="1800">
+                <a:solidFill>
+                  <a:srgbClr val="111827"/>
+                </a:solidFill>
+                <a:latin typeface="Calibri"/>
+              </a:defRPr>
+            </a:pPr>
+            <a:r>
+              <a:t>Our literature search (October 2026) is evidence, not proof, that no one has measured this on an SDN dataset.</a:t>
+            </a:r>
+          </a:p>
+        </p:txBody>
+      </p:sp>
+    </p:spTree>
+  </p:cSld>
+  <p:clrMapOvr>
+    <a:masterClrMapping/>
+  </p:clrMapOvr>
+</p:sld>
+</file>
+
+<file path=ppt/slides/slide22.xml><?xml version="1.0" encoding="utf-8"?>
+<p:sld xmlns:a="http://schemas.openxmlformats.org/drawingml/2006/main" xmlns:p="http://schemas.openxmlformats.org/presentationml/2006/main" xmlns:r="http://schemas.openxmlformats.org/officeDocument/2006/relationships">
+  <p:cSld>
+    <p:bg>
+      <p:bgPr>
+        <a:solidFill>
+          <a:srgbClr val="FFFFFF"/>
+        </a:solidFill>
+        <a:effectLst/>
+      </p:bgPr>
+    </p:bg>
+    <p:spTree>
+      <p:nvGrpSpPr>
+        <p:cNvPr id="1" name=""/>
+        <p:cNvGrpSpPr/>
+        <p:nvPr/>
+      </p:nvGrpSpPr>
+      <p:grpSpPr/>
+      <p:sp>
+        <p:nvSpPr>
+          <p:cNvPr id="2" name="TextBox 1"/>
+          <p:cNvSpPr txBox="1"/>
+          <p:nvPr/>
+        </p:nvSpPr>
+        <p:spPr>
+          <a:xfrm>
+            <a:off x="548640" y="365760"/>
+            <a:ext cx="8229600" cy="274320"/>
+          </a:xfrm>
+          <a:prstGeom prst="rect">
+            <a:avLst/>
+          </a:prstGeom>
+          <a:noFill/>
+        </p:spPr>
+        <p:txBody>
+          <a:bodyPr wrap="square" lIns="0" rIns="0" tIns="0" bIns="0">
+            <a:spAutoFit/>
+          </a:bodyPr>
+          <a:lstStyle/>
+          <a:p>
+            <a:pPr>
+              <a:defRPr sz="1200" b="1">
+                <a:solidFill>
+                  <a:srgbClr val="0F766E"/>
+                </a:solidFill>
+                <a:latin typeface="Calibri"/>
+              </a:defRPr>
+            </a:pPr>
+            <a:r>
+              <a:t>NOVELTY</a:t>
+            </a:r>
+          </a:p>
+        </p:txBody>
+      </p:sp>
+      <p:sp>
+        <p:nvSpPr>
+          <p:cNvPr id="3" name="TextBox 2"/>
+          <p:cNvSpPr txBox="1"/>
+          <p:nvPr/>
+        </p:nvSpPr>
+        <p:spPr>
+          <a:xfrm>
+            <a:off x="548640" y="658368"/>
+            <a:ext cx="11064240" cy="822960"/>
+          </a:xfrm>
+          <a:prstGeom prst="rect">
+            <a:avLst/>
+          </a:prstGeom>
+          <a:noFill/>
+        </p:spPr>
+        <p:txBody>
+          <a:bodyPr wrap="square" lIns="0" rIns="0" tIns="0" bIns="0">
+            <a:spAutoFit/>
+          </a:bodyPr>
+          <a:lstStyle/>
+          <a:p>
+            <a:pPr>
+              <a:defRPr sz="2800" b="1">
+                <a:solidFill>
+                  <a:srgbClr val="111827"/>
+                </a:solidFill>
+                <a:latin typeface="Calibri"/>
+              </a:defRPr>
+            </a:pPr>
+            <a:r>
+              <a:t>Contributions: what is new and what is already known</a:t>
+            </a:r>
+          </a:p>
+        </p:txBody>
+      </p:sp>
+      <p:sp>
+        <p:nvSpPr>
+          <p:cNvPr id="4" name="TextBox 3"/>
+          <p:cNvSpPr txBox="1"/>
+          <p:nvPr/>
+        </p:nvSpPr>
+        <p:spPr>
+          <a:xfrm>
+            <a:off x="548640" y="6446520"/>
+            <a:ext cx="7315200" cy="228600"/>
+          </a:xfrm>
+          <a:prstGeom prst="rect">
+            <a:avLst/>
+          </a:prstGeom>
+          <a:noFill/>
+        </p:spPr>
+        <p:txBody>
+          <a:bodyPr wrap="square" lIns="0" rIns="0" tIns="0" bIns="0">
+            <a:spAutoFit/>
+          </a:bodyPr>
+          <a:lstStyle/>
+          <a:p>
+            <a:pPr>
+              <a:defRPr sz="1000" b="0">
+                <a:solidFill>
+                  <a:srgbClr val="6B7280"/>
+                </a:solidFill>
+                <a:latin typeface="Calibri"/>
+              </a:defRPr>
+            </a:pPr>
+            <a:r>
+              <a:t>Evaluation Validity in SDN Intrusion Detection</a:t>
+            </a:r>
+          </a:p>
+        </p:txBody>
+      </p:sp>
+      <p:sp>
+        <p:nvSpPr>
+          <p:cNvPr id="5" name="TextBox 4"/>
+          <p:cNvSpPr txBox="1"/>
+          <p:nvPr/>
+        </p:nvSpPr>
+        <p:spPr>
+          <a:xfrm>
+            <a:off x="10972800" y="6446520"/>
+            <a:ext cx="667512" cy="228600"/>
+          </a:xfrm>
+          <a:prstGeom prst="rect">
+            <a:avLst/>
+          </a:prstGeom>
+          <a:noFill/>
+        </p:spPr>
+        <p:txBody>
+          <a:bodyPr wrap="square" lIns="0" rIns="0" tIns="0" bIns="0">
+            <a:spAutoFit/>
+          </a:bodyPr>
+          <a:lstStyle/>
+          <a:p>
+            <a:pPr algn="r">
+              <a:defRPr sz="1000" b="0">
+                <a:solidFill>
+                  <a:srgbClr val="6B7280"/>
+                </a:solidFill>
+                <a:latin typeface="Calibri"/>
+              </a:defRPr>
+            </a:pPr>
+            <a:r>
+              <a:t>3</a:t>
+            </a:r>
+          </a:p>
+        </p:txBody>
+      </p:sp>
+      <p:sp>
+        <p:nvSpPr>
+          <p:cNvPr id="6" name="TextBox 5"/>
+          <p:cNvSpPr txBox="1"/>
+          <p:nvPr/>
+        </p:nvSpPr>
+        <p:spPr>
+          <a:xfrm>
+            <a:off x="548640" y="1737360"/>
+            <a:ext cx="5303520" cy="457200"/>
+          </a:xfrm>
+          <a:prstGeom prst="rect">
+            <a:avLst/>
+          </a:prstGeom>
+          <a:noFill/>
+        </p:spPr>
+        <p:txBody>
+          <a:bodyPr wrap="square" lIns="0" rIns="0" tIns="0" bIns="0">
+            <a:spAutoFit/>
+          </a:bodyPr>
+          <a:lstStyle/>
+          <a:p>
+            <a:pPr>
+              <a:defRPr sz="2000" b="1">
+                <a:solidFill>
+                  <a:srgbClr val="6B7280"/>
+                </a:solidFill>
+                <a:latin typeface="Calibri"/>
+              </a:defRPr>
+            </a:pPr>
+            <a:r>
+              <a:t>Already known</a:t>
+            </a:r>
+          </a:p>
+        </p:txBody>
+      </p:sp>
+      <p:sp>
+        <p:nvSpPr>
+          <p:cNvPr id="7" name="TextBox 6"/>
+          <p:cNvSpPr txBox="1"/>
+          <p:nvPr/>
+        </p:nvSpPr>
+        <p:spPr>
+          <a:xfrm>
+            <a:off x="548640" y="2377440"/>
+            <a:ext cx="5303520" cy="4114800"/>
+          </a:xfrm>
+          <a:prstGeom prst="rect">
+            <a:avLst/>
+          </a:prstGeom>
+          <a:noFill/>
+        </p:spPr>
+        <p:txBody>
+          <a:bodyPr wrap="square" lIns="0" rIns="0" tIns="0" bIns="0">
+            <a:spAutoFit/>
+          </a:bodyPr>
+          <a:lstStyle/>
+          <a:p>
+            <a:pPr>
+              <a:spcAft>
+                <a:spcPts val="1400"/>
+              </a:spcAft>
+              <a:defRPr sz="1600">
+                <a:solidFill>
+                  <a:srgbClr val="111827"/>
+                </a:solidFill>
+                <a:latin typeface="Calibri"/>
+              </a:defRPr>
+            </a:pPr>
+            <a:r>
+              <a:t>Identifier columns are shortcut features (Engelen 2021)</a:t>
+            </a:r>
+          </a:p>
+          <a:p>
+            <a:pPr>
+              <a:spcAft>
+                <a:spcPts val="1400"/>
+              </a:spcAft>
+              <a:defRPr sz="1600">
+                <a:solidFill>
+                  <a:srgbClr val="111827"/>
+                </a:solidFill>
+                <a:latin typeface="Calibri"/>
+              </a:defRPr>
+            </a:pPr>
+            <a:r>
+              <a:t>Random splits leak on NIDS data (Flood 2024)</a:t>
+            </a:r>
+          </a:p>
+          <a:p>
+            <a:pPr>
+              <a:spcAft>
+                <a:spcPts val="1400"/>
+              </a:spcAft>
+              <a:defRPr sz="1600">
+                <a:solidFill>
+                  <a:srgbClr val="111827"/>
+                </a:solidFill>
+                <a:latin typeface="Calibri"/>
+              </a:defRPr>
+            </a:pPr>
+            <a:r>
+              <a:t>Control-plane telemetry datasets exist (LAN-SDN-NIDS)</a:t>
+            </a:r>
+          </a:p>
+        </p:txBody>
+      </p:sp>
+      <p:sp>
+        <p:nvSpPr>
+          <p:cNvPr id="8" name="TextBox 7"/>
+          <p:cNvSpPr txBox="1"/>
+          <p:nvPr/>
+        </p:nvSpPr>
+        <p:spPr>
+          <a:xfrm>
+            <a:off x="6309359" y="1737360"/>
+            <a:ext cx="5303520" cy="457200"/>
+          </a:xfrm>
+          <a:prstGeom prst="rect">
+            <a:avLst/>
+          </a:prstGeom>
+          <a:noFill/>
+        </p:spPr>
+        <p:txBody>
+          <a:bodyPr wrap="square" lIns="0" rIns="0" tIns="0" bIns="0">
+            <a:spAutoFit/>
+          </a:bodyPr>
+          <a:lstStyle/>
+          <a:p>
+            <a:pPr>
+              <a:defRPr sz="2000" b="1">
+                <a:solidFill>
+                  <a:srgbClr val="0F766E"/>
+                </a:solidFill>
+                <a:latin typeface="Calibri"/>
+              </a:defRPr>
+            </a:pPr>
+            <a:r>
+              <a:t>New here</a:t>
+            </a:r>
+          </a:p>
+        </p:txBody>
+      </p:sp>
+      <p:sp>
+        <p:nvSpPr>
+          <p:cNvPr id="9" name="TextBox 8"/>
+          <p:cNvSpPr txBox="1"/>
+          <p:nvPr/>
+        </p:nvSpPr>
+        <p:spPr>
+          <a:xfrm>
+            <a:off x="6309359" y="2377440"/>
+            <a:ext cx="5303520" cy="4114800"/>
+          </a:xfrm>
+          <a:prstGeom prst="rect">
+            <a:avLst/>
+          </a:prstGeom>
+          <a:noFill/>
+        </p:spPr>
+        <p:txBody>
+          <a:bodyPr wrap="square" lIns="0" rIns="0" tIns="0" bIns="0">
+            <a:spAutoFit/>
+          </a:bodyPr>
+          <a:lstStyle/>
+          <a:p>
+            <a:pPr>
+              <a:spcAft>
+                <a:spcPts val="1400"/>
+              </a:spcAft>
+              <a:defRPr sz="1600">
+                <a:solidFill>
+                  <a:srgbClr val="111827"/>
+                </a:solidFill>
+                <a:latin typeface="Calibri"/>
+              </a:defRPr>
+            </a:pPr>
+            <a:r>
+              <a:t>Controller-telemetry gap inside InSDN: 0 FlowMods match IPs or ports</a:t>
+            </a:r>
+          </a:p>
+          <a:p>
+            <a:pPr>
+              <a:spcAft>
+                <a:spcPts val="1400"/>
+              </a:spcAft>
+              <a:defRPr sz="1600">
+                <a:solidFill>
+                  <a:srgbClr val="111827"/>
+                </a:solidFill>
+                <a:latin typeface="Calibri"/>
+              </a:defRPr>
+            </a:pPr>
+            <a:r>
+              <a:t>Paired random vs host-held-out gap on InSDN and CICIDS2017, 10 seeds, CIs</a:t>
+            </a:r>
+          </a:p>
+          <a:p>
+            <a:pPr>
+              <a:spcAft>
+                <a:spcPts val="1400"/>
+              </a:spcAft>
+              <a:defRPr sz="1600">
+                <a:solidFill>
+                  <a:srgbClr val="111827"/>
+                </a:solidFill>
+                <a:latin typeface="Calibri"/>
+              </a:defRPr>
+            </a:pPr>
+            <a:r>
+              <a:t>Host structure and leave-one-host-out detection</a:t>
+            </a:r>
+          </a:p>
+          <a:p>
+            <a:pPr>
+              <a:spcAft>
+                <a:spcPts val="1400"/>
+              </a:spcAft>
+              <a:defRPr sz="1600">
+                <a:solidFill>
+                  <a:srgbClr val="111827"/>
+                </a:solidFill>
+                <a:latin typeface="Calibri"/>
+              </a:defRPr>
+            </a:pPr>
+            <a:r>
+              <a:t>Ten published papers read in full; none host-grouped</a:t>
+            </a:r>
+          </a:p>
+        </p:txBody>
+      </p:sp>
+      <p:sp>
+        <p:nvSpPr>
+          <p:cNvPr id="10" name="TextBox 9"/>
+          <p:cNvSpPr txBox="1"/>
+          <p:nvPr/>
+        </p:nvSpPr>
+        <p:spPr>
+          <a:xfrm>
+            <a:off x="548640" y="5669280"/>
+            <a:ext cx="11064240" cy="457200"/>
+          </a:xfrm>
+          <a:prstGeom prst="rect">
+            <a:avLst/>
+          </a:prstGeom>
+          <a:noFill/>
+        </p:spPr>
+        <p:txBody>
+          <a:bodyPr wrap="square" lIns="0" rIns="0" tIns="0" bIns="0">
+            <a:spAutoFit/>
+          </a:bodyPr>
+          <a:lstStyle/>
+          <a:p>
+            <a:pPr>
+              <a:defRPr sz="1500" b="0">
+                <a:solidFill>
+                  <a:srgbClr val="6B7280"/>
+                </a:solidFill>
+                <a:latin typeface="Calibri"/>
+              </a:defRPr>
+            </a:pPr>
+            <a:r>
+              <a:t>Not claimed: a new detector, or results on a second SDN dataset or controller family.</a:t>
             </a:r>
           </a:p>
         </p:txBody>
@@ -11000,7 +12601,7 @@
               </a:defRPr>
             </a:pPr>
             <a:r>
-              <a:t>Proteus · What an SDN controller can observe</a:t>
+              <a:t>Evaluation Validity in SDN Intrusion Detection</a:t>
             </a:r>
           </a:p>
         </p:txBody>
@@ -11773,7 +13374,7 @@
               </a:defRPr>
             </a:pPr>
             <a:r>
-              <a:t>Proteus · What an SDN controller can observe</a:t>
+              <a:t>Evaluation Validity in SDN Intrusion Detection</a:t>
             </a:r>
           </a:p>
         </p:txBody>
@@ -12462,7 +14063,7 @@
               </a:defRPr>
             </a:pPr>
             <a:r>
-              <a:t>Proteus · What an SDN controller can observe</a:t>
+              <a:t>Evaluation Validity in SDN Intrusion Detection</a:t>
             </a:r>
           </a:p>
         </p:txBody>
@@ -13387,7 +14988,7 @@
               </a:defRPr>
             </a:pPr>
             <a:r>
-              <a:t>Proteus · What an SDN controller can observe</a:t>
+              <a:t>Evaluation Validity in SDN Intrusion Detection</a:t>
             </a:r>
           </a:p>
         </p:txBody>
@@ -14862,7 +16463,7 @@
               </a:defRPr>
             </a:pPr>
             <a:r>
-              <a:t>Contribution 1 · The controller never saw the labelled flows</a:t>
+              <a:t>The controller never saw the labelled flows</a:t>
             </a:r>
           </a:p>
         </p:txBody>
@@ -14898,7 +16499,7 @@
               </a:defRPr>
             </a:pPr>
             <a:r>
-              <a:t>Proteus · What an SDN controller can observe</a:t>
+              <a:t>Evaluation Validity in SDN Intrusion Detection</a:t>
             </a:r>
           </a:p>
         </p:txBody>
@@ -14934,7 +16535,7 @@
               </a:defRPr>
             </a:pPr>
             <a:r>
-              <a:t>7</a:t>
+              <a:t>5</a:t>
             </a:r>
           </a:p>
         </p:txBody>
@@ -15230,7 +16831,7 @@
               </a:defRPr>
             </a:pPr>
             <a:r>
-              <a:t>Proteus · What an SDN controller can observe</a:t>
+              <a:t>Evaluation Validity in SDN Intrusion Detection</a:t>
             </a:r>
           </a:p>
         </p:txBody>
@@ -15541,7 +17142,7 @@
               </a:defRPr>
             </a:pPr>
             <a:r>
-              <a:t>Proteus · What an SDN controller can observe</a:t>
+              <a:t>Evaluation Validity in SDN Intrusion Detection</a:t>
             </a:r>
           </a:p>
         </p:txBody>

</xml_diff>